<commit_message>
Harden pipeline overview layout validation
</commit_message>
<xml_diff>
--- a/docs/assets/pipeline-overview.pptx
+++ b/docs/assets/pipeline-overview.pptx
@@ -3141,8 +3141,8 @@
         </p:nvSpPr>
         <p:spPr>
           <a:xfrm>
-            <a:off x="420624" y="749808"/>
-            <a:ext cx="11356848" cy="5413248"/>
+            <a:off x="493776" y="914400"/>
+            <a:ext cx="11192256" cy="5285232"/>
           </a:xfrm>
           <a:prstGeom prst="roundRect">
             <a:avLst/>
@@ -3186,8 +3186,8 @@
         </p:nvSpPr>
         <p:spPr>
           <a:xfrm>
-            <a:off x="566928" y="256032"/>
-            <a:ext cx="5303520" cy="347472"/>
+            <a:off x="585216" y="310896"/>
+            <a:ext cx="5760720" cy="365760"/>
           </a:xfrm>
           <a:prstGeom prst="rect">
             <a:avLst/>
@@ -3200,8 +3200,9 @@
           </a:bodyPr>
           <a:lstStyle/>
           <a:p>
-            <a:r>
-              <a:rPr sz="2400" b="1">
+            <a:pPr algn="l"/>
+            <a:r>
+              <a:rPr sz="2200" b="1">
                 <a:solidFill>
                   <a:srgbClr val="0F172A"/>
                 </a:solidFill>
@@ -3219,8 +3220,8 @@
         </p:nvSpPr>
         <p:spPr>
           <a:xfrm>
-            <a:off x="576072" y="585216"/>
-            <a:ext cx="7315200" cy="201168"/>
+            <a:off x="585216" y="621792"/>
+            <a:ext cx="7955279" cy="219456"/>
           </a:xfrm>
           <a:prstGeom prst="rect">
             <a:avLst/>
@@ -3233,8 +3234,9 @@
           </a:bodyPr>
           <a:lstStyle/>
           <a:p>
-            <a:r>
-              <a:rPr sz="1100" b="0">
+            <a:pPr algn="l"/>
+            <a:r>
+              <a:rPr sz="1000" b="0">
                 <a:solidFill>
                   <a:srgbClr val="475569"/>
                 </a:solidFill>
@@ -3252,8 +3254,8 @@
         </p:nvSpPr>
         <p:spPr>
           <a:xfrm>
-            <a:off x="713232" y="1024128"/>
-            <a:ext cx="2011680" cy="182880"/>
+            <a:off x="786384" y="1188720"/>
+            <a:ext cx="2011680" cy="201168"/>
           </a:xfrm>
           <a:prstGeom prst="rect">
             <a:avLst/>
@@ -3266,6 +3268,7 @@
           </a:bodyPr>
           <a:lstStyle/>
           <a:p>
+            <a:pPr algn="l"/>
             <a:r>
               <a:rPr sz="800" b="1">
                 <a:solidFill>
@@ -3285,8 +3288,8 @@
         </p:nvSpPr>
         <p:spPr>
           <a:xfrm>
-            <a:off x="4590288" y="1024128"/>
-            <a:ext cx="2743200" cy="182880"/>
+            <a:off x="4572000" y="1188720"/>
+            <a:ext cx="2816352" cy="201168"/>
           </a:xfrm>
           <a:prstGeom prst="rect">
             <a:avLst/>
@@ -3299,6 +3302,7 @@
           </a:bodyPr>
           <a:lstStyle/>
           <a:p>
+            <a:pPr algn="l"/>
             <a:r>
               <a:rPr sz="800" b="1">
                 <a:solidFill>
@@ -3318,8 +3322,8 @@
         </p:nvSpPr>
         <p:spPr>
           <a:xfrm>
-            <a:off x="9857232" y="1024128"/>
-            <a:ext cx="1463040" cy="182880"/>
+            <a:off x="9729216" y="1188720"/>
+            <a:ext cx="1463040" cy="201168"/>
           </a:xfrm>
           <a:prstGeom prst="rect">
             <a:avLst/>
@@ -3332,6 +3336,7 @@
           </a:bodyPr>
           <a:lstStyle/>
           <a:p>
+            <a:pPr algn="l"/>
             <a:r>
               <a:rPr sz="800" b="1">
                 <a:solidFill>
@@ -3351,8 +3356,8 @@
         </p:nvSpPr>
         <p:spPr>
           <a:xfrm>
-            <a:off x="749808" y="1389888"/>
-            <a:ext cx="1508760" cy="914400"/>
+            <a:off x="786384" y="1554480"/>
+            <a:ext cx="1664208" cy="1005840"/>
           </a:xfrm>
           <a:prstGeom prst="roundRect">
             <a:avLst/>
@@ -3396,7 +3401,7 @@
         </p:nvSpPr>
         <p:spPr>
           <a:xfrm>
-            <a:off x="896112" y="1554480"/>
+            <a:off x="932688" y="1719072"/>
             <a:ext cx="164592" cy="164592"/>
           </a:xfrm>
           <a:prstGeom prst="ellipse">
@@ -3441,8 +3446,8 @@
         </p:nvSpPr>
         <p:spPr>
           <a:xfrm>
-            <a:off x="1133856" y="1517904"/>
-            <a:ext cx="978407" cy="219456"/>
+            <a:off x="1170432" y="1673352"/>
+            <a:ext cx="1133856" cy="201168"/>
           </a:xfrm>
           <a:prstGeom prst="rect">
             <a:avLst/>
@@ -3455,8 +3460,9 @@
           </a:bodyPr>
           <a:lstStyle/>
           <a:p>
-            <a:r>
-              <a:rPr sz="1200" b="1">
+            <a:pPr algn="l"/>
+            <a:r>
+              <a:rPr sz="1100" b="1">
                 <a:solidFill>
                   <a:srgbClr val="111827"/>
                 </a:solidFill>
@@ -3474,8 +3480,8 @@
         </p:nvSpPr>
         <p:spPr>
           <a:xfrm>
-            <a:off x="950976" y="1865376"/>
-            <a:ext cx="1124712" cy="164592"/>
+            <a:off x="987552" y="1956816"/>
+            <a:ext cx="1280160" cy="146304"/>
           </a:xfrm>
           <a:prstGeom prst="rect">
             <a:avLst/>
@@ -3488,13 +3494,14 @@
           </a:bodyPr>
           <a:lstStyle/>
           <a:p>
+            <a:pPr algn="l"/>
             <a:r>
               <a:rPr sz="800" b="0">
                 <a:solidFill>
                   <a:srgbClr val="526071"/>
                 </a:solidFill>
               </a:rPr>
-              <a:t>headings, lists,</a:t>
+              <a:t>headings and lists</a:t>
             </a:r>
           </a:p>
         </p:txBody>
@@ -3507,8 +3514,8 @@
         </p:nvSpPr>
         <p:spPr>
           <a:xfrm>
-            <a:off x="950976" y="2057400"/>
-            <a:ext cx="1124712" cy="164592"/>
+            <a:off x="987552" y="2121408"/>
+            <a:ext cx="1280160" cy="146304"/>
           </a:xfrm>
           <a:prstGeom prst="rect">
             <a:avLst/>
@@ -3521,60 +3528,28 @@
           </a:bodyPr>
           <a:lstStyle/>
           <a:p>
+            <a:pPr algn="l"/>
             <a:r>
               <a:rPr sz="800" b="0">
                 <a:solidFill>
                   <a:srgbClr val="526071"/>
                 </a:solidFill>
               </a:rPr>
-              <a:t>tables, code,</a:t>
-            </a:r>
-          </a:p>
-        </p:txBody>
-      </p:sp>
-      <p:sp>
-        <p:nvSpPr>
-          <p:cNvPr id="14" name="markdown_line_2"/>
-          <p:cNvSpPr txBox="1"/>
-          <p:nvPr/>
-        </p:nvSpPr>
-        <p:spPr>
-          <a:xfrm>
-            <a:off x="950976" y="2249424"/>
-            <a:ext cx="1124712" cy="164592"/>
-          </a:xfrm>
-          <a:prstGeom prst="rect">
-            <a:avLst/>
-          </a:prstGeom>
-          <a:noFill/>
-        </p:spPr>
-        <p:txBody>
-          <a:bodyPr wrap="square" lIns="0" rIns="0" tIns="0" bIns="0">
-            <a:spAutoFit/>
-          </a:bodyPr>
-          <a:lstStyle/>
-          <a:p>
-            <a:r>
-              <a:rPr sz="800" b="0">
-                <a:solidFill>
-                  <a:srgbClr val="526071"/>
-                </a:solidFill>
-              </a:rPr>
-              <a:t>images</a:t>
-            </a:r>
-          </a:p>
-        </p:txBody>
-      </p:sp>
-      <p:sp>
-        <p:nvSpPr>
-          <p:cNvPr id="15" name="splitter_card"/>
+              <a:t>tables, code, images</a:t>
+            </a:r>
+          </a:p>
+        </p:txBody>
+      </p:sp>
+      <p:sp>
+        <p:nvSpPr>
+          <p:cNvPr id="14" name="splitter_card"/>
           <p:cNvSpPr/>
           <p:nvPr/>
         </p:nvSpPr>
         <p:spPr>
           <a:xfrm>
-            <a:off x="2615184" y="1389888"/>
-            <a:ext cx="1664208" cy="914400"/>
+            <a:off x="2816352" y="1554480"/>
+            <a:ext cx="1874519" cy="1005840"/>
           </a:xfrm>
           <a:prstGeom prst="roundRect">
             <a:avLst/>
@@ -3612,13 +3587,13 @@
       </p:sp>
       <p:sp>
         <p:nvSpPr>
-          <p:cNvPr id="16" name="splitter_dot"/>
+          <p:cNvPr id="15" name="splitter_dot"/>
           <p:cNvSpPr/>
           <p:nvPr/>
         </p:nvSpPr>
         <p:spPr>
           <a:xfrm>
-            <a:off x="2761488" y="1554480"/>
+            <a:off x="2962656" y="1719072"/>
             <a:ext cx="164592" cy="164592"/>
           </a:xfrm>
           <a:prstGeom prst="ellipse">
@@ -3657,14 +3632,14 @@
       </p:sp>
       <p:sp>
         <p:nvSpPr>
-          <p:cNvPr id="17" name="splitter_title"/>
+          <p:cNvPr id="16" name="splitter_title"/>
           <p:cNvSpPr txBox="1"/>
           <p:nvPr/>
         </p:nvSpPr>
         <p:spPr>
           <a:xfrm>
-            <a:off x="2999232" y="1517904"/>
-            <a:ext cx="1133856" cy="219456"/>
+            <a:off x="3200400" y="1673352"/>
+            <a:ext cx="1344167" cy="201168"/>
           </a:xfrm>
           <a:prstGeom prst="rect">
             <a:avLst/>
@@ -3677,8 +3652,9 @@
           </a:bodyPr>
           <a:lstStyle/>
           <a:p>
-            <a:r>
-              <a:rPr sz="1200" b="1">
+            <a:pPr algn="l"/>
+            <a:r>
+              <a:rPr sz="1100" b="1">
                 <a:solidFill>
                   <a:srgbClr val="111827"/>
                 </a:solidFill>
@@ -3690,14 +3666,14 @@
       </p:sp>
       <p:sp>
         <p:nvSpPr>
-          <p:cNvPr id="18" name="splitter_line_0"/>
+          <p:cNvPr id="17" name="splitter_line_0"/>
           <p:cNvSpPr txBox="1"/>
           <p:nvPr/>
         </p:nvSpPr>
         <p:spPr>
           <a:xfrm>
-            <a:off x="2816352" y="1865376"/>
-            <a:ext cx="1280160" cy="164592"/>
+            <a:off x="3017520" y="1956816"/>
+            <a:ext cx="1490472" cy="146303"/>
           </a:xfrm>
           <a:prstGeom prst="rect">
             <a:avLst/>
@@ -3710,27 +3686,28 @@
           </a:bodyPr>
           <a:lstStyle/>
           <a:p>
+            <a:pPr algn="l"/>
             <a:r>
               <a:rPr sz="800" b="0">
                 <a:solidFill>
                   <a:srgbClr val="526071"/>
                 </a:solidFill>
               </a:rPr>
-              <a:t>slides, elements,</a:t>
-            </a:r>
-          </a:p>
-        </p:txBody>
-      </p:sp>
-      <p:sp>
-        <p:nvSpPr>
-          <p:cNvPr id="19" name="splitter_line_1"/>
+              <a:t>slides and elements</a:t>
+            </a:r>
+          </a:p>
+        </p:txBody>
+      </p:sp>
+      <p:sp>
+        <p:nvSpPr>
+          <p:cNvPr id="18" name="splitter_line_1"/>
           <p:cNvSpPr txBox="1"/>
           <p:nvPr/>
         </p:nvSpPr>
         <p:spPr>
           <a:xfrm>
-            <a:off x="2816352" y="2057400"/>
-            <a:ext cx="1280160" cy="164592"/>
+            <a:off x="3017520" y="2121408"/>
+            <a:ext cx="1490472" cy="146303"/>
           </a:xfrm>
           <a:prstGeom prst="rect">
             <a:avLst/>
@@ -3743,27 +3720,28 @@
           </a:bodyPr>
           <a:lstStyle/>
           <a:p>
+            <a:pPr algn="l"/>
             <a:r>
               <a:rPr sz="800" b="0">
                 <a:solidFill>
                   <a:srgbClr val="526071"/>
                 </a:solidFill>
               </a:rPr>
-              <a:t>semantic structure,</a:t>
-            </a:r>
-          </a:p>
-        </p:txBody>
-      </p:sp>
-      <p:sp>
-        <p:nvSpPr>
-          <p:cNvPr id="20" name="splitter_line_2"/>
+              <a:t>semantic structure</a:t>
+            </a:r>
+          </a:p>
+        </p:txBody>
+      </p:sp>
+      <p:sp>
+        <p:nvSpPr>
+          <p:cNvPr id="19" name="splitter_line_2"/>
           <p:cNvSpPr txBox="1"/>
           <p:nvPr/>
         </p:nvSpPr>
         <p:spPr>
           <a:xfrm>
-            <a:off x="2816352" y="2249424"/>
-            <a:ext cx="1280160" cy="164592"/>
+            <a:off x="3017520" y="2286000"/>
+            <a:ext cx="1490472" cy="146303"/>
           </a:xfrm>
           <a:prstGeom prst="rect">
             <a:avLst/>
@@ -3776,6 +3754,7 @@
           </a:bodyPr>
           <a:lstStyle/>
           <a:p>
+            <a:pPr algn="l"/>
             <a:r>
               <a:rPr sz="800" b="0">
                 <a:solidFill>
@@ -3789,14 +3768,14 @@
       </p:sp>
       <p:sp>
         <p:nvSpPr>
-          <p:cNvPr id="21" name="ir_card"/>
+          <p:cNvPr id="20" name="ir_card"/>
           <p:cNvSpPr/>
           <p:nvPr/>
         </p:nvSpPr>
         <p:spPr>
           <a:xfrm>
-            <a:off x="4626864" y="1389888"/>
-            <a:ext cx="1700784" cy="914400"/>
+            <a:off x="5047488" y="1554480"/>
+            <a:ext cx="1847088" cy="1005840"/>
           </a:xfrm>
           <a:prstGeom prst="roundRect">
             <a:avLst/>
@@ -3834,13 +3813,13 @@
       </p:sp>
       <p:sp>
         <p:nvSpPr>
-          <p:cNvPr id="22" name="ir_dot"/>
+          <p:cNvPr id="21" name="ir_dot"/>
           <p:cNvSpPr/>
           <p:nvPr/>
         </p:nvSpPr>
         <p:spPr>
           <a:xfrm>
-            <a:off x="4773168" y="1554480"/>
+            <a:off x="5193792" y="1719072"/>
             <a:ext cx="164592" cy="164592"/>
           </a:xfrm>
           <a:prstGeom prst="ellipse">
@@ -3879,14 +3858,14 @@
       </p:sp>
       <p:sp>
         <p:nvSpPr>
-          <p:cNvPr id="23" name="ir_title"/>
+          <p:cNvPr id="22" name="ir_title"/>
           <p:cNvSpPr txBox="1"/>
           <p:nvPr/>
         </p:nvSpPr>
         <p:spPr>
           <a:xfrm>
-            <a:off x="5010912" y="1517904"/>
-            <a:ext cx="1170432" cy="219456"/>
+            <a:off x="5431536" y="1673352"/>
+            <a:ext cx="1316736" cy="201168"/>
           </a:xfrm>
           <a:prstGeom prst="rect">
             <a:avLst/>
@@ -3899,8 +3878,9 @@
           </a:bodyPr>
           <a:lstStyle/>
           <a:p>
-            <a:r>
-              <a:rPr sz="1200" b="1">
+            <a:pPr algn="l"/>
+            <a:r>
+              <a:rPr sz="1100" b="1">
                 <a:solidFill>
                   <a:srgbClr val="111827"/>
                 </a:solidFill>
@@ -3912,14 +3892,14 @@
       </p:sp>
       <p:sp>
         <p:nvSpPr>
-          <p:cNvPr id="24" name="ir_line_0"/>
+          <p:cNvPr id="23" name="ir_line_0"/>
           <p:cNvSpPr txBox="1"/>
           <p:nvPr/>
         </p:nvSpPr>
         <p:spPr>
           <a:xfrm>
-            <a:off x="4828031" y="1865376"/>
-            <a:ext cx="1316736" cy="164592"/>
+            <a:off x="5248655" y="1956816"/>
+            <a:ext cx="1463040" cy="146304"/>
           </a:xfrm>
           <a:prstGeom prst="rect">
             <a:avLst/>
@@ -3932,27 +3912,28 @@
           </a:bodyPr>
           <a:lstStyle/>
           <a:p>
+            <a:pPr algn="l"/>
             <a:r>
               <a:rPr sz="800" b="0">
                 <a:solidFill>
                   <a:srgbClr val="526071"/>
                 </a:solidFill>
               </a:rPr>
-              <a:t>content-only</a:t>
-            </a:r>
-          </a:p>
-        </p:txBody>
-      </p:sp>
-      <p:sp>
-        <p:nvSpPr>
-          <p:cNvPr id="25" name="ir_line_1"/>
+              <a:t>content-only contract</a:t>
+            </a:r>
+          </a:p>
+        </p:txBody>
+      </p:sp>
+      <p:sp>
+        <p:nvSpPr>
+          <p:cNvPr id="24" name="ir_line_1"/>
           <p:cNvSpPr txBox="1"/>
           <p:nvPr/>
         </p:nvSpPr>
         <p:spPr>
           <a:xfrm>
-            <a:off x="4828031" y="2057400"/>
-            <a:ext cx="1316736" cy="164592"/>
+            <a:off x="5248655" y="2121408"/>
+            <a:ext cx="1463040" cy="146304"/>
           </a:xfrm>
           <a:prstGeom prst="rect">
             <a:avLst/>
@@ -3965,27 +3946,28 @@
           </a:bodyPr>
           <a:lstStyle/>
           <a:p>
+            <a:pPr algn="l"/>
             <a:r>
               <a:rPr sz="800" b="0">
                 <a:solidFill>
                   <a:srgbClr val="526071"/>
                 </a:solidFill>
               </a:rPr>
-              <a:t>contract for rules</a:t>
+              <a:t>for downstream rules</a:t>
             </a:r>
           </a:p>
         </p:txBody>
       </p:sp>
       <p:cxnSp>
         <p:nvCxnSpPr>
-          <p:cNvPr id="26" name="arrow_markdown_splitter"/>
+          <p:cNvPr id="25" name="arrow_markdown_splitter"/>
           <p:cNvCxnSpPr/>
           <p:nvPr/>
         </p:nvCxnSpPr>
         <p:spPr>
           <a:xfrm>
-            <a:off x="2267712" y="1847088"/>
-            <a:ext cx="329184" cy="0"/>
+            <a:off x="2450592" y="2057400"/>
+            <a:ext cx="347472" cy="0"/>
           </a:xfrm>
           <a:prstGeom prst="line">
             <a:avLst/>
@@ -4013,13 +3995,13 @@
       </p:cxnSp>
       <p:cxnSp>
         <p:nvCxnSpPr>
-          <p:cNvPr id="27" name="arrow_splitter_ir"/>
+          <p:cNvPr id="26" name="arrow_splitter_ir"/>
           <p:cNvCxnSpPr/>
           <p:nvPr/>
         </p:nvCxnSpPr>
         <p:spPr>
           <a:xfrm>
-            <a:off x="4297680" y="1847088"/>
+            <a:off x="4700016" y="2057400"/>
             <a:ext cx="310896" cy="0"/>
           </a:xfrm>
           <a:prstGeom prst="line">
@@ -4048,14 +4030,14 @@
       </p:cxnSp>
       <p:sp>
         <p:nvSpPr>
-          <p:cNvPr id="28" name="llm_card"/>
+          <p:cNvPr id="27" name="llm_card"/>
           <p:cNvSpPr/>
           <p:nvPr/>
         </p:nvSpPr>
         <p:spPr>
           <a:xfrm>
-            <a:off x="2487168" y="2852928"/>
-            <a:ext cx="2670048" cy="1042415"/>
+            <a:off x="2615184" y="3127248"/>
+            <a:ext cx="2852928" cy="1051560"/>
           </a:xfrm>
           <a:prstGeom prst="roundRect">
             <a:avLst/>
@@ -4093,14 +4075,14 @@
       </p:sp>
       <p:sp>
         <p:nvSpPr>
-          <p:cNvPr id="29" name="llm_title"/>
+          <p:cNvPr id="28" name="llm_title"/>
           <p:cNvSpPr txBox="1"/>
           <p:nvPr/>
         </p:nvSpPr>
         <p:spPr>
           <a:xfrm>
-            <a:off x="2724912" y="3054096"/>
-            <a:ext cx="1554480" cy="219456"/>
+            <a:off x="2852928" y="3337560"/>
+            <a:ext cx="1572768" cy="219456"/>
           </a:xfrm>
           <a:prstGeom prst="rect">
             <a:avLst/>
@@ -4113,8 +4095,9 @@
           </a:bodyPr>
           <a:lstStyle/>
           <a:p>
-            <a:r>
-              <a:rPr sz="1300" b="1">
+            <a:pPr algn="l"/>
+            <a:r>
+              <a:rPr sz="1200" b="1">
                 <a:solidFill>
                   <a:srgbClr val="111827"/>
                 </a:solidFill>
@@ -4126,14 +4109,14 @@
       </p:sp>
       <p:sp>
         <p:nvSpPr>
-          <p:cNvPr id="30" name="llm_body"/>
+          <p:cNvPr id="29" name="llm_body"/>
           <p:cNvSpPr txBox="1"/>
           <p:nvPr/>
         </p:nvSpPr>
         <p:spPr>
           <a:xfrm>
-            <a:off x="2724912" y="3346704"/>
-            <a:ext cx="2011680" cy="347472"/>
+            <a:off x="2852928" y="3621024"/>
+            <a:ext cx="2139696" cy="201168"/>
           </a:xfrm>
           <a:prstGeom prst="rect">
             <a:avLst/>
@@ -4146,6 +4129,7 @@
           </a:bodyPr>
           <a:lstStyle/>
           <a:p>
+            <a:pPr algn="l"/>
             <a:r>
               <a:rPr sz="800" b="0">
                 <a:solidFill>
@@ -4159,13 +4143,13 @@
       </p:sp>
       <p:sp>
         <p:nvSpPr>
-          <p:cNvPr id="31" name="llm_badge"/>
+          <p:cNvPr id="30" name="llm_badge"/>
           <p:cNvSpPr/>
           <p:nvPr/>
         </p:nvSpPr>
         <p:spPr>
           <a:xfrm>
-            <a:off x="4169663" y="2999232"/>
+            <a:off x="4462272" y="3273552"/>
             <a:ext cx="713232" cy="219456"/>
           </a:xfrm>
           <a:prstGeom prst="roundRect">
@@ -4204,13 +4188,13 @@
       </p:sp>
       <p:sp>
         <p:nvSpPr>
-          <p:cNvPr id="32" name="llm_badge_text"/>
+          <p:cNvPr id="31" name="llm_badge_text"/>
           <p:cNvSpPr txBox="1"/>
           <p:nvPr/>
         </p:nvSpPr>
         <p:spPr>
           <a:xfrm>
-            <a:off x="4315968" y="3054096"/>
+            <a:off x="4608576" y="3328416"/>
             <a:ext cx="438912" cy="109728"/>
           </a:xfrm>
           <a:prstGeom prst="rect">
@@ -4224,6 +4208,7 @@
           </a:bodyPr>
           <a:lstStyle/>
           <a:p>
+            <a:pPr algn="l"/>
             <a:r>
               <a:rPr sz="800" b="1">
                 <a:solidFill>
@@ -4237,14 +4222,14 @@
       </p:sp>
       <p:sp>
         <p:nvSpPr>
-          <p:cNvPr id="33" name="llm_boundary"/>
+          <p:cNvPr id="32" name="llm_boundary"/>
           <p:cNvSpPr txBox="1"/>
           <p:nvPr/>
         </p:nvSpPr>
         <p:spPr>
           <a:xfrm>
-            <a:off x="2724912" y="3685032"/>
-            <a:ext cx="2057400" cy="164592"/>
+            <a:off x="2852928" y="3895344"/>
+            <a:ext cx="2286000" cy="164592"/>
           </a:xfrm>
           <a:prstGeom prst="rect">
             <a:avLst/>
@@ -4257,6 +4242,7 @@
           </a:bodyPr>
           <a:lstStyle/>
           <a:p>
+            <a:pPr algn="l"/>
             <a:r>
               <a:rPr sz="800" b="1">
                 <a:solidFill>
@@ -4270,14 +4256,14 @@
       </p:sp>
       <p:cxnSp>
         <p:nvCxnSpPr>
-          <p:cNvPr id="34" name="hint_ir_llm"/>
+          <p:cNvPr id="33" name="hint_ir_llm"/>
           <p:cNvCxnSpPr/>
           <p:nvPr/>
         </p:nvCxnSpPr>
         <p:spPr>
           <a:xfrm flipH="1">
-            <a:off x="4754880" y="2359152"/>
-            <a:ext cx="713232" cy="0"/>
+            <a:off x="5029200" y="2615184"/>
+            <a:ext cx="786384" cy="0"/>
           </a:xfrm>
           <a:prstGeom prst="line">
             <a:avLst/>
@@ -4306,14 +4292,14 @@
       </p:cxnSp>
       <p:cxnSp>
         <p:nvCxnSpPr>
-          <p:cNvPr id="35" name="hint_llm_rules"/>
+          <p:cNvPr id="34" name="hint_llm_rules"/>
           <p:cNvCxnSpPr/>
           <p:nvPr/>
         </p:nvCxnSpPr>
         <p:spPr>
           <a:xfrm>
-            <a:off x="5157216" y="3383280"/>
-            <a:ext cx="640080" cy="0"/>
+            <a:off x="5468112" y="3657600"/>
+            <a:ext cx="585216" cy="0"/>
           </a:xfrm>
           <a:prstGeom prst="line">
             <a:avLst/>
@@ -4342,14 +4328,14 @@
       </p:cxnSp>
       <p:sp>
         <p:nvSpPr>
-          <p:cNvPr id="36" name="rule_boundary"/>
+          <p:cNvPr id="35" name="rule_boundary"/>
           <p:cNvSpPr/>
           <p:nvPr/>
         </p:nvSpPr>
         <p:spPr>
           <a:xfrm>
-            <a:off x="6254496" y="1335024"/>
-            <a:ext cx="3182112" cy="2999232"/>
+            <a:off x="6309360" y="1481328"/>
+            <a:ext cx="3328416" cy="3054096"/>
           </a:xfrm>
           <a:prstGeom prst="roundRect">
             <a:avLst/>
@@ -4387,14 +4373,14 @@
       </p:sp>
       <p:sp>
         <p:nvSpPr>
-          <p:cNvPr id="37" name="rule_boundary_title"/>
+          <p:cNvPr id="36" name="rule_boundary_title"/>
           <p:cNvSpPr txBox="1"/>
           <p:nvPr/>
         </p:nvSpPr>
         <p:spPr>
           <a:xfrm>
-            <a:off x="6510528" y="1609344"/>
-            <a:ext cx="2487168" cy="182880"/>
+            <a:off x="6583680" y="1783080"/>
+            <a:ext cx="2706624" cy="201168"/>
           </a:xfrm>
           <a:prstGeom prst="rect">
             <a:avLst/>
@@ -4407,6 +4393,7 @@
           </a:bodyPr>
           <a:lstStyle/>
           <a:p>
+            <a:pPr algn="l"/>
             <a:r>
               <a:rPr sz="800" b="1">
                 <a:solidFill>
@@ -4420,14 +4407,14 @@
       </p:sp>
       <p:sp>
         <p:nvSpPr>
-          <p:cNvPr id="38" name="features_card"/>
+          <p:cNvPr id="37" name="features_card"/>
           <p:cNvSpPr/>
           <p:nvPr/>
         </p:nvSpPr>
         <p:spPr>
           <a:xfrm>
-            <a:off x="6473952" y="1883664"/>
-            <a:ext cx="1316736" cy="658368"/>
+            <a:off x="6565392" y="2139696"/>
+            <a:ext cx="1389888" cy="713232"/>
           </a:xfrm>
           <a:prstGeom prst="roundRect">
             <a:avLst/>
@@ -4465,13 +4452,13 @@
       </p:sp>
       <p:sp>
         <p:nvSpPr>
-          <p:cNvPr id="39" name="features_dot"/>
+          <p:cNvPr id="38" name="features_dot"/>
           <p:cNvSpPr/>
           <p:nvPr/>
         </p:nvSpPr>
         <p:spPr>
           <a:xfrm>
-            <a:off x="6620256" y="2048256"/>
+            <a:off x="6711696" y="2304288"/>
             <a:ext cx="164592" cy="164592"/>
           </a:xfrm>
           <a:prstGeom prst="ellipse">
@@ -4510,14 +4497,14 @@
       </p:sp>
       <p:sp>
         <p:nvSpPr>
-          <p:cNvPr id="40" name="features_title"/>
+          <p:cNvPr id="39" name="features_title"/>
           <p:cNvSpPr txBox="1"/>
           <p:nvPr/>
         </p:nvSpPr>
         <p:spPr>
           <a:xfrm>
-            <a:off x="6858000" y="2011680"/>
-            <a:ext cx="786384" cy="219456"/>
+            <a:off x="6949440" y="2258568"/>
+            <a:ext cx="859536" cy="201168"/>
           </a:xfrm>
           <a:prstGeom prst="rect">
             <a:avLst/>
@@ -4530,8 +4517,9 @@
           </a:bodyPr>
           <a:lstStyle/>
           <a:p>
-            <a:r>
-              <a:rPr sz="1200" b="1">
+            <a:pPr algn="l"/>
+            <a:r>
+              <a:rPr sz="1100" b="1">
                 <a:solidFill>
                   <a:srgbClr val="111827"/>
                 </a:solidFill>
@@ -4543,14 +4531,14 @@
       </p:sp>
       <p:sp>
         <p:nvSpPr>
-          <p:cNvPr id="41" name="features_line_0"/>
+          <p:cNvPr id="40" name="features_line_0"/>
           <p:cNvSpPr txBox="1"/>
           <p:nvPr/>
         </p:nvSpPr>
         <p:spPr>
           <a:xfrm>
-            <a:off x="6675120" y="2359152"/>
-            <a:ext cx="932688" cy="164592"/>
+            <a:off x="6766559" y="2542032"/>
+            <a:ext cx="1005840" cy="109728"/>
           </a:xfrm>
           <a:prstGeom prst="rect">
             <a:avLst/>
@@ -4563,27 +4551,28 @@
           </a:bodyPr>
           <a:lstStyle/>
           <a:p>
+            <a:pPr algn="l"/>
             <a:r>
               <a:rPr sz="800" b="0">
                 <a:solidFill>
                   <a:srgbClr val="526071"/>
                 </a:solidFill>
               </a:rPr>
-              <a:t>density, mix</a:t>
-            </a:r>
-          </a:p>
-        </p:txBody>
-      </p:sp>
-      <p:sp>
-        <p:nvSpPr>
-          <p:cNvPr id="42" name="features_line_1"/>
+              <a:t>density and mix</a:t>
+            </a:r>
+          </a:p>
+        </p:txBody>
+      </p:sp>
+      <p:sp>
+        <p:nvSpPr>
+          <p:cNvPr id="41" name="features_line_1"/>
           <p:cNvSpPr txBox="1"/>
           <p:nvPr/>
         </p:nvSpPr>
         <p:spPr>
           <a:xfrm>
-            <a:off x="6675120" y="2551176"/>
-            <a:ext cx="932688" cy="164592"/>
+            <a:off x="6766559" y="2651760"/>
+            <a:ext cx="1005840" cy="109728"/>
           </a:xfrm>
           <a:prstGeom prst="rect">
             <a:avLst/>
@@ -4596,6 +4585,7 @@
           </a:bodyPr>
           <a:lstStyle/>
           <a:p>
+            <a:pPr algn="l"/>
             <a:r>
               <a:rPr sz="800" b="0">
                 <a:solidFill>
@@ -4609,14 +4599,14 @@
       </p:sp>
       <p:sp>
         <p:nvSpPr>
-          <p:cNvPr id="43" name="rules_card"/>
+          <p:cNvPr id="42" name="rules_card"/>
           <p:cNvSpPr/>
           <p:nvPr/>
         </p:nvSpPr>
         <p:spPr>
           <a:xfrm>
-            <a:off x="7918704" y="1883664"/>
-            <a:ext cx="1316736" cy="658368"/>
+            <a:off x="8138160" y="2139696"/>
+            <a:ext cx="1261872" cy="713232"/>
           </a:xfrm>
           <a:prstGeom prst="roundRect">
             <a:avLst/>
@@ -4654,13 +4644,13 @@
       </p:sp>
       <p:sp>
         <p:nvSpPr>
-          <p:cNvPr id="44" name="rules_dot"/>
+          <p:cNvPr id="43" name="rules_dot"/>
           <p:cNvSpPr/>
           <p:nvPr/>
         </p:nvSpPr>
         <p:spPr>
           <a:xfrm>
-            <a:off x="8065008" y="2048256"/>
+            <a:off x="8284464" y="2304288"/>
             <a:ext cx="164592" cy="164592"/>
           </a:xfrm>
           <a:prstGeom prst="ellipse">
@@ -4699,14 +4689,14 @@
       </p:sp>
       <p:sp>
         <p:nvSpPr>
-          <p:cNvPr id="45" name="rules_title"/>
+          <p:cNvPr id="44" name="rules_title"/>
           <p:cNvSpPr txBox="1"/>
           <p:nvPr/>
         </p:nvSpPr>
         <p:spPr>
           <a:xfrm>
-            <a:off x="8302752" y="2011680"/>
-            <a:ext cx="786384" cy="219456"/>
+            <a:off x="8522208" y="2258568"/>
+            <a:ext cx="731519" cy="201168"/>
           </a:xfrm>
           <a:prstGeom prst="rect">
             <a:avLst/>
@@ -4719,8 +4709,9 @@
           </a:bodyPr>
           <a:lstStyle/>
           <a:p>
-            <a:r>
-              <a:rPr sz="1200" b="1">
+            <a:pPr algn="l"/>
+            <a:r>
+              <a:rPr sz="1100" b="1">
                 <a:solidFill>
                   <a:srgbClr val="111827"/>
                 </a:solidFill>
@@ -4732,14 +4723,14 @@
       </p:sp>
       <p:sp>
         <p:nvSpPr>
-          <p:cNvPr id="46" name="rules_line_0"/>
+          <p:cNvPr id="45" name="rules_line_0"/>
           <p:cNvSpPr txBox="1"/>
           <p:nvPr/>
         </p:nvSpPr>
         <p:spPr>
           <a:xfrm>
-            <a:off x="8119872" y="2359152"/>
-            <a:ext cx="932688" cy="164592"/>
+            <a:off x="8339328" y="2542032"/>
+            <a:ext cx="877824" cy="109728"/>
           </a:xfrm>
           <a:prstGeom prst="rect">
             <a:avLst/>
@@ -4752,6 +4743,7 @@
           </a:bodyPr>
           <a:lstStyle/>
           <a:p>
+            <a:pPr algn="l"/>
             <a:r>
               <a:rPr sz="800" b="0">
                 <a:solidFill>
@@ -4765,14 +4757,14 @@
       </p:sp>
       <p:sp>
         <p:nvSpPr>
-          <p:cNvPr id="47" name="rules_line_1"/>
+          <p:cNvPr id="46" name="rules_line_1"/>
           <p:cNvSpPr txBox="1"/>
           <p:nvPr/>
         </p:nvSpPr>
         <p:spPr>
           <a:xfrm>
-            <a:off x="8119872" y="2551176"/>
-            <a:ext cx="932688" cy="164592"/>
+            <a:off x="8339328" y="2651760"/>
+            <a:ext cx="877824" cy="109728"/>
           </a:xfrm>
           <a:prstGeom prst="rect">
             <a:avLst/>
@@ -4785,6 +4777,7 @@
           </a:bodyPr>
           <a:lstStyle/>
           <a:p>
+            <a:pPr algn="l"/>
             <a:r>
               <a:rPr sz="800" b="0">
                 <a:solidFill>
@@ -4798,14 +4791,14 @@
       </p:sp>
       <p:sp>
         <p:nvSpPr>
-          <p:cNvPr id="48" name="compose_card"/>
+          <p:cNvPr id="47" name="compose_card"/>
           <p:cNvSpPr/>
           <p:nvPr/>
         </p:nvSpPr>
         <p:spPr>
           <a:xfrm>
-            <a:off x="6473952" y="2999232"/>
-            <a:ext cx="1316736" cy="658368"/>
+            <a:off x="6565392" y="3291840"/>
+            <a:ext cx="1389888" cy="713232"/>
           </a:xfrm>
           <a:prstGeom prst="roundRect">
             <a:avLst/>
@@ -4843,13 +4836,13 @@
       </p:sp>
       <p:sp>
         <p:nvSpPr>
-          <p:cNvPr id="49" name="compose_dot"/>
+          <p:cNvPr id="48" name="compose_dot"/>
           <p:cNvSpPr/>
           <p:nvPr/>
         </p:nvSpPr>
         <p:spPr>
           <a:xfrm>
-            <a:off x="6620256" y="3163824"/>
+            <a:off x="6711696" y="3456432"/>
             <a:ext cx="164592" cy="164592"/>
           </a:xfrm>
           <a:prstGeom prst="ellipse">
@@ -4888,14 +4881,14 @@
       </p:sp>
       <p:sp>
         <p:nvSpPr>
-          <p:cNvPr id="50" name="compose_title"/>
+          <p:cNvPr id="49" name="compose_title"/>
           <p:cNvSpPr txBox="1"/>
           <p:nvPr/>
         </p:nvSpPr>
         <p:spPr>
           <a:xfrm>
-            <a:off x="6858000" y="3127248"/>
-            <a:ext cx="786384" cy="219456"/>
+            <a:off x="6949440" y="3410712"/>
+            <a:ext cx="859536" cy="201168"/>
           </a:xfrm>
           <a:prstGeom prst="rect">
             <a:avLst/>
@@ -4908,8 +4901,9 @@
           </a:bodyPr>
           <a:lstStyle/>
           <a:p>
-            <a:r>
-              <a:rPr sz="1200" b="1">
+            <a:pPr algn="l"/>
+            <a:r>
+              <a:rPr sz="1100" b="1">
                 <a:solidFill>
                   <a:srgbClr val="111827"/>
                 </a:solidFill>
@@ -4921,14 +4915,14 @@
       </p:sp>
       <p:sp>
         <p:nvSpPr>
-          <p:cNvPr id="51" name="compose_line_0"/>
+          <p:cNvPr id="50" name="compose_line_0"/>
           <p:cNvSpPr txBox="1"/>
           <p:nvPr/>
         </p:nvSpPr>
         <p:spPr>
           <a:xfrm>
-            <a:off x="6675120" y="3474720"/>
-            <a:ext cx="932688" cy="164592"/>
+            <a:off x="6766559" y="3694176"/>
+            <a:ext cx="1005840" cy="109728"/>
           </a:xfrm>
           <a:prstGeom prst="rect">
             <a:avLst/>
@@ -4941,6 +4935,7 @@
           </a:bodyPr>
           <a:lstStyle/>
           <a:p>
+            <a:pPr algn="l"/>
             <a:r>
               <a:rPr sz="800" b="0">
                 <a:solidFill>
@@ -4954,14 +4949,14 @@
       </p:sp>
       <p:sp>
         <p:nvSpPr>
-          <p:cNvPr id="52" name="compose_line_1"/>
+          <p:cNvPr id="51" name="compose_line_1"/>
           <p:cNvSpPr txBox="1"/>
           <p:nvPr/>
         </p:nvSpPr>
         <p:spPr>
           <a:xfrm>
-            <a:off x="6675120" y="3666744"/>
-            <a:ext cx="932688" cy="164592"/>
+            <a:off x="6766559" y="3803904"/>
+            <a:ext cx="1005840" cy="109728"/>
           </a:xfrm>
           <a:prstGeom prst="rect">
             <a:avLst/>
@@ -4974,6 +4969,7 @@
           </a:bodyPr>
           <a:lstStyle/>
           <a:p>
+            <a:pPr algn="l"/>
             <a:r>
               <a:rPr sz="800" b="0">
                 <a:solidFill>
@@ -4987,14 +4983,14 @@
       </p:sp>
       <p:sp>
         <p:nvSpPr>
-          <p:cNvPr id="53" name="decorate_card"/>
+          <p:cNvPr id="52" name="decorate_card"/>
           <p:cNvSpPr/>
           <p:nvPr/>
         </p:nvSpPr>
         <p:spPr>
           <a:xfrm>
-            <a:off x="7918704" y="2999232"/>
-            <a:ext cx="1316736" cy="658368"/>
+            <a:off x="8138160" y="3291840"/>
+            <a:ext cx="1261872" cy="713232"/>
           </a:xfrm>
           <a:prstGeom prst="roundRect">
             <a:avLst/>
@@ -5032,13 +5028,13 @@
       </p:sp>
       <p:sp>
         <p:nvSpPr>
-          <p:cNvPr id="54" name="decorate_dot"/>
+          <p:cNvPr id="53" name="decorate_dot"/>
           <p:cNvSpPr/>
           <p:nvPr/>
         </p:nvSpPr>
         <p:spPr>
           <a:xfrm>
-            <a:off x="8065008" y="3163824"/>
+            <a:off x="8284464" y="3456432"/>
             <a:ext cx="164592" cy="164592"/>
           </a:xfrm>
           <a:prstGeom prst="ellipse">
@@ -5077,14 +5073,14 @@
       </p:sp>
       <p:sp>
         <p:nvSpPr>
-          <p:cNvPr id="55" name="decorate_title"/>
+          <p:cNvPr id="54" name="decorate_title"/>
           <p:cNvSpPr txBox="1"/>
           <p:nvPr/>
         </p:nvSpPr>
         <p:spPr>
           <a:xfrm>
-            <a:off x="8302752" y="3127248"/>
-            <a:ext cx="786384" cy="219456"/>
+            <a:off x="8522208" y="3410712"/>
+            <a:ext cx="731519" cy="201168"/>
           </a:xfrm>
           <a:prstGeom prst="rect">
             <a:avLst/>
@@ -5097,8 +5093,9 @@
           </a:bodyPr>
           <a:lstStyle/>
           <a:p>
-            <a:r>
-              <a:rPr sz="1200" b="1">
+            <a:pPr algn="l"/>
+            <a:r>
+              <a:rPr sz="1100" b="1">
                 <a:solidFill>
                   <a:srgbClr val="111827"/>
                 </a:solidFill>
@@ -5110,14 +5107,14 @@
       </p:sp>
       <p:sp>
         <p:nvSpPr>
-          <p:cNvPr id="56" name="decorate_line_0"/>
+          <p:cNvPr id="55" name="decorate_line_0"/>
           <p:cNvSpPr txBox="1"/>
           <p:nvPr/>
         </p:nvSpPr>
         <p:spPr>
           <a:xfrm>
-            <a:off x="8119872" y="3474720"/>
-            <a:ext cx="932688" cy="164592"/>
+            <a:off x="8339328" y="3694176"/>
+            <a:ext cx="877824" cy="109728"/>
           </a:xfrm>
           <a:prstGeom prst="rect">
             <a:avLst/>
@@ -5130,6 +5127,7 @@
           </a:bodyPr>
           <a:lstStyle/>
           <a:p>
+            <a:pPr algn="l"/>
             <a:r>
               <a:rPr sz="800" b="0">
                 <a:solidFill>
@@ -5143,14 +5141,14 @@
       </p:sp>
       <p:sp>
         <p:nvSpPr>
-          <p:cNvPr id="57" name="decorate_line_1"/>
+          <p:cNvPr id="56" name="decorate_line_1"/>
           <p:cNvSpPr txBox="1"/>
           <p:nvPr/>
         </p:nvSpPr>
         <p:spPr>
           <a:xfrm>
-            <a:off x="8119872" y="3666744"/>
-            <a:ext cx="932688" cy="164592"/>
+            <a:off x="8339328" y="3803904"/>
+            <a:ext cx="877824" cy="109728"/>
           </a:xfrm>
           <a:prstGeom prst="rect">
             <a:avLst/>
@@ -5163,6 +5161,7 @@
           </a:bodyPr>
           <a:lstStyle/>
           <a:p>
+            <a:pPr algn="l"/>
             <a:r>
               <a:rPr sz="800" b="0">
                 <a:solidFill>
@@ -5176,14 +5175,14 @@
       </p:sp>
       <p:cxnSp>
         <p:nvCxnSpPr>
-          <p:cNvPr id="58" name="arrow_ir_rule"/>
+          <p:cNvPr id="57" name="arrow_ir_rule"/>
           <p:cNvCxnSpPr/>
           <p:nvPr/>
         </p:nvCxnSpPr>
         <p:spPr>
           <a:xfrm>
-            <a:off x="6327648" y="1847088"/>
-            <a:ext cx="256032" cy="0"/>
+            <a:off x="6894576" y="2057400"/>
+            <a:ext cx="310896" cy="0"/>
           </a:xfrm>
           <a:prstGeom prst="line">
             <a:avLst/>
@@ -5211,14 +5210,14 @@
       </p:cxnSp>
       <p:cxnSp>
         <p:nvCxnSpPr>
-          <p:cNvPr id="59" name="rule_arrow_1"/>
+          <p:cNvPr id="58" name="rule_arrow_1"/>
           <p:cNvCxnSpPr/>
           <p:nvPr/>
         </p:nvCxnSpPr>
         <p:spPr>
           <a:xfrm>
-            <a:off x="7790688" y="2212848"/>
-            <a:ext cx="128016" cy="0"/>
+            <a:off x="7955279" y="2487168"/>
+            <a:ext cx="164592" cy="0"/>
           </a:xfrm>
           <a:prstGeom prst="line">
             <a:avLst/>
@@ -5246,13 +5245,13 @@
       </p:cxnSp>
       <p:cxnSp>
         <p:nvCxnSpPr>
-          <p:cNvPr id="60" name="rule_arrow_2"/>
+          <p:cNvPr id="59" name="rule_arrow_2"/>
           <p:cNvCxnSpPr/>
           <p:nvPr/>
         </p:nvCxnSpPr>
         <p:spPr>
           <a:xfrm>
-            <a:off x="8577072" y="2542032"/>
+            <a:off x="8759952" y="2852928"/>
             <a:ext cx="0" cy="0"/>
           </a:xfrm>
           <a:prstGeom prst="line">
@@ -5281,14 +5280,14 @@
       </p:cxnSp>
       <p:sp>
         <p:nvSpPr>
-          <p:cNvPr id="61" name="lint_pill"/>
+          <p:cNvPr id="60" name="lint_pill"/>
           <p:cNvSpPr/>
           <p:nvPr/>
         </p:nvSpPr>
         <p:spPr>
           <a:xfrm>
-            <a:off x="6656832" y="3895344"/>
-            <a:ext cx="2340864" cy="237744"/>
+            <a:off x="6748272" y="4187952"/>
+            <a:ext cx="2322576" cy="237744"/>
           </a:xfrm>
           <a:prstGeom prst="roundRect">
             <a:avLst/>
@@ -5326,14 +5325,14 @@
       </p:sp>
       <p:sp>
         <p:nvSpPr>
-          <p:cNvPr id="62" name="lint_text"/>
+          <p:cNvPr id="61" name="lint_text"/>
           <p:cNvSpPr txBox="1"/>
           <p:nvPr/>
         </p:nvSpPr>
         <p:spPr>
           <a:xfrm>
-            <a:off x="7004304" y="3968496"/>
-            <a:ext cx="1645920" cy="91440"/>
+            <a:off x="7077456" y="4261104"/>
+            <a:ext cx="1664208" cy="91440"/>
           </a:xfrm>
           <a:prstGeom prst="rect">
             <a:avLst/>
@@ -5346,6 +5345,7 @@
           </a:bodyPr>
           <a:lstStyle/>
           <a:p>
+            <a:pPr algn="l"/>
             <a:r>
               <a:rPr sz="800" b="1">
                 <a:solidFill>
@@ -5359,14 +5359,14 @@
       </p:sp>
       <p:sp>
         <p:nvSpPr>
-          <p:cNvPr id="63" name="styled_ir_card"/>
+          <p:cNvPr id="62" name="styled_ir_card"/>
           <p:cNvSpPr/>
           <p:nvPr/>
         </p:nvSpPr>
         <p:spPr>
           <a:xfrm>
-            <a:off x="9857232" y="1682496"/>
-            <a:ext cx="1499616" cy="822960"/>
+            <a:off x="9985248" y="1792224"/>
+            <a:ext cx="1481328" cy="841248"/>
           </a:xfrm>
           <a:prstGeom prst="roundRect">
             <a:avLst/>
@@ -5404,13 +5404,13 @@
       </p:sp>
       <p:sp>
         <p:nvSpPr>
-          <p:cNvPr id="64" name="styled_ir_dot"/>
+          <p:cNvPr id="63" name="styled_ir_dot"/>
           <p:cNvSpPr/>
           <p:nvPr/>
         </p:nvSpPr>
         <p:spPr>
           <a:xfrm>
-            <a:off x="10003536" y="1847088"/>
+            <a:off x="10131552" y="1956816"/>
             <a:ext cx="164592" cy="164592"/>
           </a:xfrm>
           <a:prstGeom prst="ellipse">
@@ -5449,14 +5449,14 @@
       </p:sp>
       <p:sp>
         <p:nvSpPr>
-          <p:cNvPr id="65" name="styled_ir_title"/>
+          <p:cNvPr id="64" name="styled_ir_title"/>
           <p:cNvSpPr txBox="1"/>
           <p:nvPr/>
         </p:nvSpPr>
         <p:spPr>
           <a:xfrm>
-            <a:off x="10241280" y="1810512"/>
-            <a:ext cx="969264" cy="219456"/>
+            <a:off x="10369296" y="1911095"/>
+            <a:ext cx="950976" cy="201168"/>
           </a:xfrm>
           <a:prstGeom prst="rect">
             <a:avLst/>
@@ -5469,8 +5469,9 @@
           </a:bodyPr>
           <a:lstStyle/>
           <a:p>
-            <a:r>
-              <a:rPr sz="1200" b="1">
+            <a:pPr algn="l"/>
+            <a:r>
+              <a:rPr sz="1100" b="1">
                 <a:solidFill>
                   <a:srgbClr val="111827"/>
                 </a:solidFill>
@@ -5482,14 +5483,14 @@
       </p:sp>
       <p:sp>
         <p:nvSpPr>
-          <p:cNvPr id="66" name="styled_ir_line_0"/>
+          <p:cNvPr id="65" name="styled_ir_line_0"/>
           <p:cNvSpPr txBox="1"/>
           <p:nvPr/>
         </p:nvSpPr>
         <p:spPr>
           <a:xfrm>
-            <a:off x="10058400" y="2157984"/>
-            <a:ext cx="1115568" cy="164592"/>
+            <a:off x="10186416" y="2194560"/>
+            <a:ext cx="1097280" cy="146303"/>
           </a:xfrm>
           <a:prstGeom prst="rect">
             <a:avLst/>
@@ -5502,6 +5503,7 @@
           </a:bodyPr>
           <a:lstStyle/>
           <a:p>
+            <a:pPr algn="l"/>
             <a:r>
               <a:rPr sz="800" b="0">
                 <a:solidFill>
@@ -5515,14 +5517,14 @@
       </p:sp>
       <p:sp>
         <p:nvSpPr>
-          <p:cNvPr id="67" name="styled_ir_line_1"/>
+          <p:cNvPr id="66" name="styled_ir_line_1"/>
           <p:cNvSpPr txBox="1"/>
           <p:nvPr/>
         </p:nvSpPr>
         <p:spPr>
           <a:xfrm>
-            <a:off x="10058400" y="2350008"/>
-            <a:ext cx="1115568" cy="164592"/>
+            <a:off x="10186416" y="2359152"/>
+            <a:ext cx="1097280" cy="146303"/>
           </a:xfrm>
           <a:prstGeom prst="rect">
             <a:avLst/>
@@ -5535,6 +5537,7 @@
           </a:bodyPr>
           <a:lstStyle/>
           <a:p>
+            <a:pPr algn="l"/>
             <a:r>
               <a:rPr sz="800" b="0">
                 <a:solidFill>
@@ -5548,14 +5551,14 @@
       </p:sp>
       <p:sp>
         <p:nvSpPr>
-          <p:cNvPr id="68" name="renderers_card"/>
+          <p:cNvPr id="67" name="renderers_card"/>
           <p:cNvSpPr/>
           <p:nvPr/>
         </p:nvSpPr>
         <p:spPr>
           <a:xfrm>
-            <a:off x="9857232" y="2980944"/>
-            <a:ext cx="1499616" cy="987552"/>
+            <a:off x="9985248" y="3182112"/>
+            <a:ext cx="1481328" cy="1005840"/>
           </a:xfrm>
           <a:prstGeom prst="roundRect">
             <a:avLst/>
@@ -5593,13 +5596,13 @@
       </p:sp>
       <p:sp>
         <p:nvSpPr>
-          <p:cNvPr id="69" name="renderers_dot"/>
+          <p:cNvPr id="68" name="renderers_dot"/>
           <p:cNvSpPr/>
           <p:nvPr/>
         </p:nvSpPr>
         <p:spPr>
           <a:xfrm>
-            <a:off x="10003536" y="3145536"/>
+            <a:off x="10131552" y="3346704"/>
             <a:ext cx="164592" cy="164592"/>
           </a:xfrm>
           <a:prstGeom prst="ellipse">
@@ -5638,14 +5641,14 @@
       </p:sp>
       <p:sp>
         <p:nvSpPr>
-          <p:cNvPr id="70" name="renderers_title"/>
+          <p:cNvPr id="69" name="renderers_title"/>
           <p:cNvSpPr txBox="1"/>
           <p:nvPr/>
         </p:nvSpPr>
         <p:spPr>
           <a:xfrm>
-            <a:off x="10241280" y="3108960"/>
-            <a:ext cx="969264" cy="219456"/>
+            <a:off x="10369296" y="3300984"/>
+            <a:ext cx="950976" cy="201168"/>
           </a:xfrm>
           <a:prstGeom prst="rect">
             <a:avLst/>
@@ -5658,8 +5661,9 @@
           </a:bodyPr>
           <a:lstStyle/>
           <a:p>
-            <a:r>
-              <a:rPr sz="1200" b="1">
+            <a:pPr algn="l"/>
+            <a:r>
+              <a:rPr sz="1100" b="1">
                 <a:solidFill>
                   <a:srgbClr val="111827"/>
                 </a:solidFill>
@@ -5671,14 +5675,14 @@
       </p:sp>
       <p:sp>
         <p:nvSpPr>
-          <p:cNvPr id="71" name="renderers_line_0"/>
+          <p:cNvPr id="70" name="renderers_line_0"/>
           <p:cNvSpPr txBox="1"/>
           <p:nvPr/>
         </p:nvSpPr>
         <p:spPr>
           <a:xfrm>
-            <a:off x="10058400" y="3456432"/>
-            <a:ext cx="1115568" cy="164592"/>
+            <a:off x="10186416" y="3584448"/>
+            <a:ext cx="1097280" cy="146304"/>
           </a:xfrm>
           <a:prstGeom prst="rect">
             <a:avLst/>
@@ -5691,6 +5695,7 @@
           </a:bodyPr>
           <a:lstStyle/>
           <a:p>
+            <a:pPr algn="l"/>
             <a:r>
               <a:rPr sz="800" b="0">
                 <a:solidFill>
@@ -5704,14 +5709,14 @@
       </p:sp>
       <p:sp>
         <p:nvSpPr>
-          <p:cNvPr id="72" name="renderers_line_1"/>
+          <p:cNvPr id="71" name="renderers_line_1"/>
           <p:cNvSpPr txBox="1"/>
           <p:nvPr/>
         </p:nvSpPr>
         <p:spPr>
           <a:xfrm>
-            <a:off x="10058400" y="3648456"/>
-            <a:ext cx="1115568" cy="164592"/>
+            <a:off x="10186416" y="3749039"/>
+            <a:ext cx="1097280" cy="146304"/>
           </a:xfrm>
           <a:prstGeom prst="rect">
             <a:avLst/>
@@ -5724,6 +5729,7 @@
           </a:bodyPr>
           <a:lstStyle/>
           <a:p>
+            <a:pPr algn="l"/>
             <a:r>
               <a:rPr sz="800" b="0">
                 <a:solidFill>
@@ -5737,14 +5743,14 @@
       </p:sp>
       <p:sp>
         <p:nvSpPr>
-          <p:cNvPr id="73" name="renderers_line_2"/>
+          <p:cNvPr id="72" name="renderers_line_2"/>
           <p:cNvSpPr txBox="1"/>
           <p:nvPr/>
         </p:nvSpPr>
         <p:spPr>
           <a:xfrm>
-            <a:off x="10058400" y="3840480"/>
-            <a:ext cx="1115568" cy="164592"/>
+            <a:off x="10186416" y="3913632"/>
+            <a:ext cx="1097280" cy="146304"/>
           </a:xfrm>
           <a:prstGeom prst="rect">
             <a:avLst/>
@@ -5757,6 +5763,7 @@
           </a:bodyPr>
           <a:lstStyle/>
           <a:p>
+            <a:pPr algn="l"/>
             <a:r>
               <a:rPr sz="800" b="0">
                 <a:solidFill>
@@ -5770,14 +5777,14 @@
       </p:sp>
       <p:cxnSp>
         <p:nvCxnSpPr>
-          <p:cNvPr id="74" name="arrow_rule_output"/>
+          <p:cNvPr id="73" name="arrow_rule_output"/>
           <p:cNvCxnSpPr/>
           <p:nvPr/>
         </p:nvCxnSpPr>
         <p:spPr>
           <a:xfrm>
-            <a:off x="9436608" y="2231136"/>
-            <a:ext cx="384048" cy="0"/>
+            <a:off x="9637776" y="2359152"/>
+            <a:ext cx="329183" cy="0"/>
           </a:xfrm>
           <a:prstGeom prst="line">
             <a:avLst/>
@@ -5805,13 +5812,13 @@
       </p:cxnSp>
       <p:cxnSp>
         <p:nvCxnSpPr>
-          <p:cNvPr id="75" name="arrow_ir_renderers"/>
+          <p:cNvPr id="74" name="arrow_ir_renderers"/>
           <p:cNvCxnSpPr/>
           <p:nvPr/>
         </p:nvCxnSpPr>
         <p:spPr>
           <a:xfrm>
-            <a:off x="10479024" y="2505456"/>
+            <a:off x="10735056" y="2633472"/>
             <a:ext cx="0" cy="0"/>
           </a:xfrm>
           <a:prstGeom prst="line">
@@ -5840,14 +5847,14 @@
       </p:cxnSp>
       <p:sp>
         <p:nvSpPr>
-          <p:cNvPr id="76" name="responsibility"/>
+          <p:cNvPr id="75" name="responsibility"/>
           <p:cNvSpPr/>
           <p:nvPr/>
         </p:nvSpPr>
         <p:spPr>
           <a:xfrm>
-            <a:off x="768096" y="4901184"/>
-            <a:ext cx="10607040" cy="694944"/>
+            <a:off x="804672" y="5102352"/>
+            <a:ext cx="10497312" cy="658368"/>
           </a:xfrm>
           <a:prstGeom prst="roundRect">
             <a:avLst/>
@@ -5885,14 +5892,14 @@
       </p:sp>
       <p:sp>
         <p:nvSpPr>
-          <p:cNvPr id="77" name="responsibility_title"/>
+          <p:cNvPr id="76" name="responsibility_title"/>
           <p:cNvSpPr txBox="1"/>
           <p:nvPr/>
         </p:nvSpPr>
         <p:spPr>
           <a:xfrm>
-            <a:off x="1005840" y="5102352"/>
-            <a:ext cx="1463040" cy="164592"/>
+            <a:off x="1024128" y="5303520"/>
+            <a:ext cx="1426464" cy="164592"/>
           </a:xfrm>
           <a:prstGeom prst="rect">
             <a:avLst/>
@@ -5905,8 +5912,9 @@
           </a:bodyPr>
           <a:lstStyle/>
           <a:p>
-            <a:r>
-              <a:rPr sz="1200" b="1">
+            <a:pPr algn="l"/>
+            <a:r>
+              <a:rPr sz="1100" b="1">
                 <a:solidFill>
                   <a:srgbClr val="111827"/>
                 </a:solidFill>
@@ -5918,14 +5926,14 @@
       </p:sp>
       <p:sp>
         <p:nvSpPr>
-          <p:cNvPr id="78" name="responsibility_body"/>
+          <p:cNvPr id="77" name="responsibility_body"/>
           <p:cNvSpPr txBox="1"/>
           <p:nvPr/>
         </p:nvSpPr>
         <p:spPr>
           <a:xfrm>
-            <a:off x="2487168" y="5084064"/>
-            <a:ext cx="6035040" cy="256032"/>
+            <a:off x="2505456" y="5303520"/>
+            <a:ext cx="6309360" cy="201168"/>
           </a:xfrm>
           <a:prstGeom prst="rect">
             <a:avLst/>
@@ -5938,6 +5946,7 @@
           </a:bodyPr>
           <a:lstStyle/>
           <a:p>
+            <a:pPr algn="l"/>
             <a:r>
               <a:rPr sz="800" b="0">
                 <a:solidFill>
@@ -5951,14 +5960,14 @@
       </p:sp>
       <p:sp>
         <p:nvSpPr>
-          <p:cNvPr id="79" name="font_badge"/>
+          <p:cNvPr id="78" name="font_badge"/>
           <p:cNvSpPr/>
           <p:nvPr/>
         </p:nvSpPr>
         <p:spPr>
           <a:xfrm>
-            <a:off x="9747504" y="5065776"/>
-            <a:ext cx="1207008" cy="237744"/>
+            <a:off x="9802368" y="5285232"/>
+            <a:ext cx="1170432" cy="237744"/>
           </a:xfrm>
           <a:prstGeom prst="roundRect">
             <a:avLst/>
@@ -5996,14 +6005,14 @@
       </p:sp>
       <p:sp>
         <p:nvSpPr>
-          <p:cNvPr id="80" name="font_badge_text"/>
+          <p:cNvPr id="79" name="font_badge_text"/>
           <p:cNvSpPr txBox="1"/>
           <p:nvPr/>
         </p:nvSpPr>
         <p:spPr>
           <a:xfrm>
-            <a:off x="9912096" y="5138928"/>
-            <a:ext cx="896112" cy="91440"/>
+            <a:off x="9966960" y="5358384"/>
+            <a:ext cx="859536" cy="91440"/>
           </a:xfrm>
           <a:prstGeom prst="rect">
             <a:avLst/>
@@ -6016,6 +6025,7 @@
           </a:bodyPr>
           <a:lstStyle/>
           <a:p>
+            <a:pPr algn="l"/>
             <a:r>
               <a:rPr sz="800" b="1">
                 <a:solidFill>

</xml_diff>

<commit_message>
Redesign pipeline overview regions
</commit_message>
<xml_diff>
--- a/docs/assets/pipeline-overview.pptx
+++ b/docs/assets/pipeline-overview.pptx
@@ -3187,7 +3187,7 @@
         <p:spPr>
           <a:xfrm>
             <a:off x="585216" y="310896"/>
-            <a:ext cx="5760720" cy="365760"/>
+            <a:ext cx="6126480" cy="384048"/>
           </a:xfrm>
           <a:prstGeom prst="rect">
             <a:avLst/>
@@ -3202,7 +3202,7 @@
           <a:p>
             <a:pPr algn="l"/>
             <a:r>
-              <a:rPr sz="2200" b="1">
+              <a:rPr sz="2300" b="1">
                 <a:solidFill>
                   <a:srgbClr val="0F172A"/>
                 </a:solidFill>
@@ -3220,8 +3220,8 @@
         </p:nvSpPr>
         <p:spPr>
           <a:xfrm>
-            <a:off x="585216" y="621792"/>
-            <a:ext cx="7955279" cy="219456"/>
+            <a:off x="585216" y="640080"/>
+            <a:ext cx="8092440" cy="219456"/>
           </a:xfrm>
           <a:prstGeom prst="rect">
             <a:avLst/>
@@ -3236,26 +3236,71 @@
           <a:p>
             <a:pPr algn="l"/>
             <a:r>
-              <a:rPr sz="1000" b="0">
+              <a:rPr sz="900" b="0">
                 <a:solidFill>
                   <a:srgbClr val="475569"/>
                 </a:solidFill>
               </a:rPr>
-              <a:t>LLM hints semantic intent only. Deterministic rules own design decisions and editable rendering.</a:t>
-            </a:r>
-          </a:p>
-        </p:txBody>
-      </p:sp>
-      <p:sp>
-        <p:nvSpPr>
-          <p:cNvPr id="6" name="section_input"/>
+              <a:t>Content is split by MDPR. LLM reasoning supplies hints. Deterministic rules own layout, styling, z-order, and editable rendering.</a:t>
+            </a:r>
+          </a:p>
+        </p:txBody>
+      </p:sp>
+      <p:sp>
+        <p:nvSpPr>
+          <p:cNvPr id="6" name="zone_content_panel"/>
+          <p:cNvSpPr/>
+          <p:nvPr/>
+        </p:nvSpPr>
+        <p:spPr>
+          <a:xfrm>
+            <a:off x="749808" y="1115568"/>
+            <a:ext cx="2331720" cy="3493008"/>
+          </a:xfrm>
+          <a:prstGeom prst="roundRect">
+            <a:avLst/>
+          </a:prstGeom>
+          <a:solidFill>
+            <a:srgbClr val="F8FAFC"/>
+          </a:solidFill>
+          <a:ln>
+            <a:solidFill>
+              <a:srgbClr val="D7E1EE"/>
+            </a:solidFill>
+          </a:ln>
+        </p:spPr>
+        <p:style>
+          <a:lnRef idx="1">
+            <a:schemeClr val="accent1"/>
+          </a:lnRef>
+          <a:fillRef idx="3">
+            <a:schemeClr val="accent1"/>
+          </a:fillRef>
+          <a:effectRef idx="2">
+            <a:schemeClr val="accent1"/>
+          </a:effectRef>
+          <a:fontRef idx="minor">
+            <a:schemeClr val="lt1"/>
+          </a:fontRef>
+        </p:style>
+        <p:txBody>
+          <a:bodyPr rtlCol="0" anchor="ctr"/>
+          <a:lstStyle/>
+          <a:p>
+            <a:pPr algn="ctr"/>
+          </a:p>
+        </p:txBody>
+      </p:sp>
+      <p:sp>
+        <p:nvSpPr>
+          <p:cNvPr id="7" name="zone_content_title"/>
           <p:cNvSpPr txBox="1"/>
           <p:nvPr/>
         </p:nvSpPr>
         <p:spPr>
           <a:xfrm>
-            <a:off x="786384" y="1188720"/>
-            <a:ext cx="2011680" cy="201168"/>
+            <a:off x="914400" y="1280160"/>
+            <a:ext cx="2002536" cy="201168"/>
           </a:xfrm>
           <a:prstGeom prst="rect">
             <a:avLst/>
@@ -3270,26 +3315,105 @@
           <a:p>
             <a:pPr algn="l"/>
             <a:r>
-              <a:rPr sz="800" b="1">
+              <a:rPr sz="1000" b="1">
+                <a:solidFill>
+                  <a:srgbClr val="334155"/>
+                </a:solidFill>
+              </a:rPr>
+              <a:t>1. Content Contract</a:t>
+            </a:r>
+          </a:p>
+        </p:txBody>
+      </p:sp>
+      <p:sp>
+        <p:nvSpPr>
+          <p:cNvPr id="8" name="zone_content_subtitle"/>
+          <p:cNvSpPr txBox="1"/>
+          <p:nvPr/>
+        </p:nvSpPr>
+        <p:spPr>
+          <a:xfrm>
+            <a:off x="914400" y="1508760"/>
+            <a:ext cx="2002536" cy="164592"/>
+          </a:xfrm>
+          <a:prstGeom prst="rect">
+            <a:avLst/>
+          </a:prstGeom>
+          <a:noFill/>
+        </p:spPr>
+        <p:txBody>
+          <a:bodyPr wrap="square" lIns="0" rIns="0" tIns="0" bIns="0">
+            <a:spAutoFit/>
+          </a:bodyPr>
+          <a:lstStyle/>
+          <a:p>
+            <a:pPr algn="l"/>
+            <a:r>
+              <a:rPr sz="800" b="0">
                 <a:solidFill>
                   <a:srgbClr val="64748B"/>
                 </a:solidFill>
               </a:rPr>
-              <a:t>INPUT AND STRUCTURE</a:t>
-            </a:r>
-          </a:p>
-        </p:txBody>
-      </p:sp>
-      <p:sp>
-        <p:nvSpPr>
-          <p:cNvPr id="7" name="section_rule"/>
+              <a:t>MDPR creates semantic structure only</a:t>
+            </a:r>
+          </a:p>
+        </p:txBody>
+      </p:sp>
+      <p:sp>
+        <p:nvSpPr>
+          <p:cNvPr id="9" name="zone_reasoning_panel"/>
+          <p:cNvSpPr/>
+          <p:nvPr/>
+        </p:nvSpPr>
+        <p:spPr>
+          <a:xfrm>
+            <a:off x="3273552" y="1115568"/>
+            <a:ext cx="2340864" cy="3493008"/>
+          </a:xfrm>
+          <a:prstGeom prst="roundRect">
+            <a:avLst/>
+          </a:prstGeom>
+          <a:solidFill>
+            <a:srgbClr val="EFF6FF"/>
+          </a:solidFill>
+          <a:ln>
+            <a:solidFill>
+              <a:srgbClr val="93C5FD"/>
+            </a:solidFill>
+          </a:ln>
+        </p:spPr>
+        <p:style>
+          <a:lnRef idx="1">
+            <a:schemeClr val="accent1"/>
+          </a:lnRef>
+          <a:fillRef idx="3">
+            <a:schemeClr val="accent1"/>
+          </a:fillRef>
+          <a:effectRef idx="2">
+            <a:schemeClr val="accent1"/>
+          </a:effectRef>
+          <a:fontRef idx="minor">
+            <a:schemeClr val="lt1"/>
+          </a:fontRef>
+        </p:style>
+        <p:txBody>
+          <a:bodyPr rtlCol="0" anchor="ctr"/>
+          <a:lstStyle/>
+          <a:p>
+            <a:pPr algn="ctr"/>
+          </a:p>
+        </p:txBody>
+      </p:sp>
+      <p:sp>
+        <p:nvSpPr>
+          <p:cNvPr id="10" name="zone_reasoning_title"/>
           <p:cNvSpPr txBox="1"/>
           <p:nvPr/>
         </p:nvSpPr>
         <p:spPr>
           <a:xfrm>
-            <a:off x="4572000" y="1188720"/>
-            <a:ext cx="2816352" cy="201168"/>
+            <a:off x="3438144" y="1280160"/>
+            <a:ext cx="2011680" cy="201168"/>
           </a:xfrm>
           <a:prstGeom prst="rect">
             <a:avLst/>
@@ -3304,26 +3428,139 @@
           <a:p>
             <a:pPr algn="l"/>
             <a:r>
-              <a:rPr sz="800" b="1">
+              <a:rPr sz="1000" b="1">
+                <a:solidFill>
+                  <a:srgbClr val="1D4ED8"/>
+                </a:solidFill>
+              </a:rPr>
+              <a:t>2. LLM Reasoning</a:t>
+            </a:r>
+          </a:p>
+        </p:txBody>
+      </p:sp>
+      <p:sp>
+        <p:nvSpPr>
+          <p:cNvPr id="11" name="zone_reasoning_subtitle"/>
+          <p:cNvSpPr txBox="1"/>
+          <p:nvPr/>
+        </p:nvSpPr>
+        <p:spPr>
+          <a:xfrm>
+            <a:off x="3438144" y="1508760"/>
+            <a:ext cx="2011680" cy="164592"/>
+          </a:xfrm>
+          <a:prstGeom prst="rect">
+            <a:avLst/>
+          </a:prstGeom>
+          <a:noFill/>
+        </p:spPr>
+        <p:txBody>
+          <a:bodyPr wrap="square" lIns="0" rIns="0" tIns="0" bIns="0">
+            <a:spAutoFit/>
+          </a:bodyPr>
+          <a:lstStyle/>
+          <a:p>
+            <a:pPr algn="l"/>
+            <a:r>
+              <a:rPr sz="800" b="0">
+                <a:solidFill>
+                  <a:srgbClr val="64748B"/>
+                </a:solidFill>
+              </a:rPr>
+              <a:t>optional intent and grouping hints</a:t>
+            </a:r>
+          </a:p>
+        </p:txBody>
+      </p:sp>
+      <p:sp>
+        <p:nvSpPr>
+          <p:cNvPr id="12" name="zone_rules_panel"/>
+          <p:cNvSpPr/>
+          <p:nvPr/>
+        </p:nvSpPr>
+        <p:spPr>
+          <a:xfrm>
+            <a:off x="5815584" y="1115568"/>
+            <a:ext cx="3310128" cy="3493008"/>
+          </a:xfrm>
+          <a:prstGeom prst="roundRect">
+            <a:avLst/>
+          </a:prstGeom>
+          <a:solidFill>
+            <a:srgbClr val="EEF7F1"/>
+          </a:solidFill>
+          <a:ln>
+            <a:solidFill>
+              <a:srgbClr val="86EFAC"/>
+            </a:solidFill>
+          </a:ln>
+        </p:spPr>
+        <p:style>
+          <a:lnRef idx="1">
+            <a:schemeClr val="accent1"/>
+          </a:lnRef>
+          <a:fillRef idx="3">
+            <a:schemeClr val="accent1"/>
+          </a:fillRef>
+          <a:effectRef idx="2">
+            <a:schemeClr val="accent1"/>
+          </a:effectRef>
+          <a:fontRef idx="minor">
+            <a:schemeClr val="lt1"/>
+          </a:fontRef>
+        </p:style>
+        <p:txBody>
+          <a:bodyPr rtlCol="0" anchor="ctr"/>
+          <a:lstStyle/>
+          <a:p>
+            <a:pPr algn="ctr"/>
+          </a:p>
+        </p:txBody>
+      </p:sp>
+      <p:sp>
+        <p:nvSpPr>
+          <p:cNvPr id="13" name="zone_rules_title"/>
+          <p:cNvSpPr txBox="1"/>
+          <p:nvPr/>
+        </p:nvSpPr>
+        <p:spPr>
+          <a:xfrm>
+            <a:off x="5980176" y="1280160"/>
+            <a:ext cx="2980944" cy="201168"/>
+          </a:xfrm>
+          <a:prstGeom prst="rect">
+            <a:avLst/>
+          </a:prstGeom>
+          <a:noFill/>
+        </p:spPr>
+        <p:txBody>
+          <a:bodyPr wrap="square" lIns="0" rIns="0" tIns="0" bIns="0">
+            <a:spAutoFit/>
+          </a:bodyPr>
+          <a:lstStyle/>
+          <a:p>
+            <a:pPr algn="l"/>
+            <a:r>
+              <a:rPr sz="1000" b="1">
                 <a:solidFill>
                   <a:srgbClr val="15803D"/>
                 </a:solidFill>
               </a:rPr>
-              <a:t>RULE-BASED DETERMINISTIC BOUNDARY</a:t>
-            </a:r>
-          </a:p>
-        </p:txBody>
-      </p:sp>
-      <p:sp>
-        <p:nvSpPr>
-          <p:cNvPr id="8" name="section_output"/>
+              <a:t>3. Deterministic Design</a:t>
+            </a:r>
+          </a:p>
+        </p:txBody>
+      </p:sp>
+      <p:sp>
+        <p:nvSpPr>
+          <p:cNvPr id="14" name="zone_rules_subtitle"/>
           <p:cNvSpPr txBox="1"/>
           <p:nvPr/>
         </p:nvSpPr>
         <p:spPr>
           <a:xfrm>
-            <a:off x="9729216" y="1188720"/>
-            <a:ext cx="1463040" cy="201168"/>
+            <a:off x="5980176" y="1508760"/>
+            <a:ext cx="2980944" cy="164592"/>
           </a:xfrm>
           <a:prstGeom prst="rect">
             <a:avLst/>
@@ -3338,26 +3575,218 @@
           <a:p>
             <a:pPr algn="l"/>
             <a:r>
-              <a:rPr sz="800" b="1">
+              <a:rPr sz="800" b="0">
                 <a:solidFill>
                   <a:srgbClr val="64748B"/>
                 </a:solidFill>
               </a:rPr>
-              <a:t>OUTPUTS</a:t>
-            </a:r>
-          </a:p>
-        </p:txBody>
-      </p:sp>
-      <p:sp>
-        <p:nvSpPr>
-          <p:cNvPr id="9" name="markdown_card"/>
+              <a:t>final visual choices happen here</a:t>
+            </a:r>
+          </a:p>
+        </p:txBody>
+      </p:sp>
+      <p:sp>
+        <p:nvSpPr>
+          <p:cNvPr id="15" name="zone_outputs_panel"/>
           <p:cNvSpPr/>
           <p:nvPr/>
         </p:nvSpPr>
         <p:spPr>
           <a:xfrm>
-            <a:off x="786384" y="1554480"/>
-            <a:ext cx="1664208" cy="1005840"/>
+            <a:off x="9326880" y="1115568"/>
+            <a:ext cx="2048256" cy="3493008"/>
+          </a:xfrm>
+          <a:prstGeom prst="roundRect">
+            <a:avLst/>
+          </a:prstGeom>
+          <a:solidFill>
+            <a:srgbClr val="F8FAFC"/>
+          </a:solidFill>
+          <a:ln>
+            <a:solidFill>
+              <a:srgbClr val="D7E1EE"/>
+            </a:solidFill>
+          </a:ln>
+        </p:spPr>
+        <p:style>
+          <a:lnRef idx="1">
+            <a:schemeClr val="accent1"/>
+          </a:lnRef>
+          <a:fillRef idx="3">
+            <a:schemeClr val="accent1"/>
+          </a:fillRef>
+          <a:effectRef idx="2">
+            <a:schemeClr val="accent1"/>
+          </a:effectRef>
+          <a:fontRef idx="minor">
+            <a:schemeClr val="lt1"/>
+          </a:fontRef>
+        </p:style>
+        <p:txBody>
+          <a:bodyPr rtlCol="0" anchor="ctr"/>
+          <a:lstStyle/>
+          <a:p>
+            <a:pPr algn="ctr"/>
+          </a:p>
+        </p:txBody>
+      </p:sp>
+      <p:sp>
+        <p:nvSpPr>
+          <p:cNvPr id="16" name="zone_outputs_title"/>
+          <p:cNvSpPr txBox="1"/>
+          <p:nvPr/>
+        </p:nvSpPr>
+        <p:spPr>
+          <a:xfrm>
+            <a:off x="9491472" y="1280160"/>
+            <a:ext cx="1719072" cy="201168"/>
+          </a:xfrm>
+          <a:prstGeom prst="rect">
+            <a:avLst/>
+          </a:prstGeom>
+          <a:noFill/>
+        </p:spPr>
+        <p:txBody>
+          <a:bodyPr wrap="square" lIns="0" rIns="0" tIns="0" bIns="0">
+            <a:spAutoFit/>
+          </a:bodyPr>
+          <a:lstStyle/>
+          <a:p>
+            <a:pPr algn="l"/>
+            <a:r>
+              <a:rPr sz="1000" b="1">
+                <a:solidFill>
+                  <a:srgbClr val="334155"/>
+                </a:solidFill>
+              </a:rPr>
+              <a:t>4. Editable Outputs</a:t>
+            </a:r>
+          </a:p>
+        </p:txBody>
+      </p:sp>
+      <p:sp>
+        <p:nvSpPr>
+          <p:cNvPr id="17" name="zone_outputs_subtitle"/>
+          <p:cNvSpPr txBox="1"/>
+          <p:nvPr/>
+        </p:nvSpPr>
+        <p:spPr>
+          <a:xfrm>
+            <a:off x="9491472" y="1508760"/>
+            <a:ext cx="1719072" cy="164592"/>
+          </a:xfrm>
+          <a:prstGeom prst="rect">
+            <a:avLst/>
+          </a:prstGeom>
+          <a:noFill/>
+        </p:spPr>
+        <p:txBody>
+          <a:bodyPr wrap="square" lIns="0" rIns="0" tIns="0" bIns="0">
+            <a:spAutoFit/>
+          </a:bodyPr>
+          <a:lstStyle/>
+          <a:p>
+            <a:pPr algn="l"/>
+            <a:r>
+              <a:rPr sz="800" b="0">
+                <a:solidFill>
+                  <a:srgbClr val="64748B"/>
+                </a:solidFill>
+              </a:rPr>
+              <a:t>PPTX, HTML, PDF, and checks</a:t>
+            </a:r>
+          </a:p>
+        </p:txBody>
+      </p:sp>
+      <p:sp>
+        <p:nvSpPr>
+          <p:cNvPr id="18" name="start_flag"/>
+          <p:cNvSpPr/>
+          <p:nvPr/>
+        </p:nvSpPr>
+        <p:spPr>
+          <a:xfrm>
+            <a:off x="960120" y="1627632"/>
+            <a:ext cx="676656" cy="237744"/>
+          </a:xfrm>
+          <a:prstGeom prst="roundRect">
+            <a:avLst/>
+          </a:prstGeom>
+          <a:solidFill>
+            <a:srgbClr val="111827"/>
+          </a:solidFill>
+          <a:ln>
+            <a:solidFill>
+              <a:srgbClr val="111827"/>
+            </a:solidFill>
+          </a:ln>
+        </p:spPr>
+        <p:style>
+          <a:lnRef idx="1">
+            <a:schemeClr val="accent1"/>
+          </a:lnRef>
+          <a:fillRef idx="3">
+            <a:schemeClr val="accent1"/>
+          </a:fillRef>
+          <a:effectRef idx="2">
+            <a:schemeClr val="accent1"/>
+          </a:effectRef>
+          <a:fontRef idx="minor">
+            <a:schemeClr val="lt1"/>
+          </a:fontRef>
+        </p:style>
+        <p:txBody>
+          <a:bodyPr rtlCol="0" anchor="ctr"/>
+          <a:lstStyle/>
+          <a:p>
+            <a:pPr algn="ctr"/>
+          </a:p>
+        </p:txBody>
+      </p:sp>
+      <p:sp>
+        <p:nvSpPr>
+          <p:cNvPr id="19" name="start_flag_text"/>
+          <p:cNvSpPr txBox="1"/>
+          <p:nvPr/>
+        </p:nvSpPr>
+        <p:spPr>
+          <a:xfrm>
+            <a:off x="1097280" y="1700784"/>
+            <a:ext cx="402336" cy="91440"/>
+          </a:xfrm>
+          <a:prstGeom prst="rect">
+            <a:avLst/>
+          </a:prstGeom>
+          <a:noFill/>
+        </p:spPr>
+        <p:txBody>
+          <a:bodyPr wrap="square" lIns="0" rIns="0" tIns="0" bIns="0">
+            <a:spAutoFit/>
+          </a:bodyPr>
+          <a:lstStyle/>
+          <a:p>
+            <a:pPr algn="l"/>
+            <a:r>
+              <a:rPr sz="800" b="1">
+                <a:solidFill>
+                  <a:srgbClr val="FFFFFF"/>
+                </a:solidFill>
+              </a:rPr>
+              <a:t>start</a:t>
+            </a:r>
+          </a:p>
+        </p:txBody>
+      </p:sp>
+      <p:sp>
+        <p:nvSpPr>
+          <p:cNvPr id="20" name="markdown_card"/>
+          <p:cNvSpPr/>
+          <p:nvPr/>
+        </p:nvSpPr>
+        <p:spPr>
+          <a:xfrm>
+            <a:off x="932688" y="1975104"/>
+            <a:ext cx="1810512" cy="841248"/>
           </a:xfrm>
           <a:prstGeom prst="roundRect">
             <a:avLst/>
@@ -3395,13 +3824,13 @@
       </p:sp>
       <p:sp>
         <p:nvSpPr>
-          <p:cNvPr id="10" name="markdown_dot"/>
+          <p:cNvPr id="21" name="markdown_dot"/>
           <p:cNvSpPr/>
           <p:nvPr/>
         </p:nvSpPr>
         <p:spPr>
           <a:xfrm>
-            <a:off x="932688" y="1719072"/>
+            <a:off x="1078992" y="2139696"/>
             <a:ext cx="164592" cy="164592"/>
           </a:xfrm>
           <a:prstGeom prst="ellipse">
@@ -3440,14 +3869,14 @@
       </p:sp>
       <p:sp>
         <p:nvSpPr>
-          <p:cNvPr id="11" name="markdown_title"/>
+          <p:cNvPr id="22" name="markdown_title"/>
           <p:cNvSpPr txBox="1"/>
           <p:nvPr/>
         </p:nvSpPr>
         <p:spPr>
           <a:xfrm>
-            <a:off x="1170432" y="1673352"/>
-            <a:ext cx="1133856" cy="201168"/>
+            <a:off x="1316736" y="2093976"/>
+            <a:ext cx="1280160" cy="201168"/>
           </a:xfrm>
           <a:prstGeom prst="rect">
             <a:avLst/>
@@ -3474,14 +3903,14 @@
       </p:sp>
       <p:sp>
         <p:nvSpPr>
-          <p:cNvPr id="12" name="markdown_line_0"/>
+          <p:cNvPr id="23" name="markdown_line_0"/>
           <p:cNvSpPr txBox="1"/>
           <p:nvPr/>
         </p:nvSpPr>
         <p:spPr>
           <a:xfrm>
-            <a:off x="987552" y="1956816"/>
-            <a:ext cx="1280160" cy="146304"/>
+            <a:off x="1133856" y="2377440"/>
+            <a:ext cx="1426464" cy="146303"/>
           </a:xfrm>
           <a:prstGeom prst="rect">
             <a:avLst/>
@@ -3501,21 +3930,21 @@
                   <a:srgbClr val="526071"/>
                 </a:solidFill>
               </a:rPr>
-              <a:t>headings and lists</a:t>
-            </a:r>
-          </a:p>
-        </p:txBody>
-      </p:sp>
-      <p:sp>
-        <p:nvSpPr>
-          <p:cNvPr id="13" name="markdown_line_1"/>
+              <a:t>text, tables, code</a:t>
+            </a:r>
+          </a:p>
+        </p:txBody>
+      </p:sp>
+      <p:sp>
+        <p:nvSpPr>
+          <p:cNvPr id="24" name="markdown_line_1"/>
           <p:cNvSpPr txBox="1"/>
           <p:nvPr/>
         </p:nvSpPr>
         <p:spPr>
           <a:xfrm>
-            <a:off x="987552" y="2121408"/>
-            <a:ext cx="1280160" cy="146304"/>
+            <a:off x="1133856" y="2542032"/>
+            <a:ext cx="1426464" cy="146303"/>
           </a:xfrm>
           <a:prstGeom prst="rect">
             <a:avLst/>
@@ -3535,21 +3964,21 @@
                   <a:srgbClr val="526071"/>
                 </a:solidFill>
               </a:rPr>
-              <a:t>tables, code, images</a:t>
-            </a:r>
-          </a:p>
-        </p:txBody>
-      </p:sp>
-      <p:sp>
-        <p:nvSpPr>
-          <p:cNvPr id="14" name="splitter_card"/>
+              <a:t>images and notes</a:t>
+            </a:r>
+          </a:p>
+        </p:txBody>
+      </p:sp>
+      <p:sp>
+        <p:nvSpPr>
+          <p:cNvPr id="25" name="splitter_card"/>
           <p:cNvSpPr/>
           <p:nvPr/>
         </p:nvSpPr>
         <p:spPr>
           <a:xfrm>
-            <a:off x="2816352" y="1554480"/>
-            <a:ext cx="1874519" cy="1005840"/>
+            <a:off x="932688" y="3127248"/>
+            <a:ext cx="1810512" cy="932688"/>
           </a:xfrm>
           <a:prstGeom prst="roundRect">
             <a:avLst/>
@@ -3587,13 +4016,13 @@
       </p:sp>
       <p:sp>
         <p:nvSpPr>
-          <p:cNvPr id="15" name="splitter_dot"/>
+          <p:cNvPr id="26" name="splitter_dot"/>
           <p:cNvSpPr/>
           <p:nvPr/>
         </p:nvSpPr>
         <p:spPr>
           <a:xfrm>
-            <a:off x="2962656" y="1719072"/>
+            <a:off x="1078992" y="3291840"/>
             <a:ext cx="164592" cy="164592"/>
           </a:xfrm>
           <a:prstGeom prst="ellipse">
@@ -3632,14 +4061,14 @@
       </p:sp>
       <p:sp>
         <p:nvSpPr>
-          <p:cNvPr id="16" name="splitter_title"/>
+          <p:cNvPr id="27" name="splitter_title"/>
           <p:cNvSpPr txBox="1"/>
           <p:nvPr/>
         </p:nvSpPr>
         <p:spPr>
           <a:xfrm>
-            <a:off x="3200400" y="1673352"/>
-            <a:ext cx="1344167" cy="201168"/>
+            <a:off x="1316736" y="3246120"/>
+            <a:ext cx="1280160" cy="201168"/>
           </a:xfrm>
           <a:prstGeom prst="rect">
             <a:avLst/>
@@ -3666,14 +4095,14 @@
       </p:sp>
       <p:sp>
         <p:nvSpPr>
-          <p:cNvPr id="17" name="splitter_line_0"/>
+          <p:cNvPr id="28" name="splitter_line_0"/>
           <p:cNvSpPr txBox="1"/>
           <p:nvPr/>
         </p:nvSpPr>
         <p:spPr>
           <a:xfrm>
-            <a:off x="3017520" y="1956816"/>
-            <a:ext cx="1490472" cy="146303"/>
+            <a:off x="1133856" y="3529584"/>
+            <a:ext cx="1426464" cy="146304"/>
           </a:xfrm>
           <a:prstGeom prst="rect">
             <a:avLst/>
@@ -3693,55 +4122,21 @@
                   <a:srgbClr val="526071"/>
                 </a:solidFill>
               </a:rPr>
-              <a:t>slides and elements</a:t>
-            </a:r>
-          </a:p>
-        </p:txBody>
-      </p:sp>
-      <p:sp>
-        <p:nvSpPr>
-          <p:cNvPr id="18" name="splitter_line_1"/>
+              <a:t>slide and object split</a:t>
+            </a:r>
+          </a:p>
+        </p:txBody>
+      </p:sp>
+      <p:sp>
+        <p:nvSpPr>
+          <p:cNvPr id="29" name="splitter_line_1"/>
           <p:cNvSpPr txBox="1"/>
           <p:nvPr/>
         </p:nvSpPr>
         <p:spPr>
           <a:xfrm>
-            <a:off x="3017520" y="2121408"/>
-            <a:ext cx="1490472" cy="146303"/>
-          </a:xfrm>
-          <a:prstGeom prst="rect">
-            <a:avLst/>
-          </a:prstGeom>
-          <a:noFill/>
-        </p:spPr>
-        <p:txBody>
-          <a:bodyPr wrap="square" lIns="0" rIns="0" tIns="0" bIns="0">
-            <a:spAutoFit/>
-          </a:bodyPr>
-          <a:lstStyle/>
-          <a:p>
-            <a:pPr algn="l"/>
-            <a:r>
-              <a:rPr sz="800" b="0">
-                <a:solidFill>
-                  <a:srgbClr val="526071"/>
-                </a:solidFill>
-              </a:rPr>
-              <a:t>semantic structure</a:t>
-            </a:r>
-          </a:p>
-        </p:txBody>
-      </p:sp>
-      <p:sp>
-        <p:nvSpPr>
-          <p:cNvPr id="19" name="splitter_line_2"/>
-          <p:cNvSpPr txBox="1"/>
-          <p:nvPr/>
-        </p:nvSpPr>
-        <p:spPr>
-          <a:xfrm>
-            <a:off x="3017520" y="2286000"/>
-            <a:ext cx="1490472" cy="146303"/>
+            <a:off x="1133856" y="3694176"/>
+            <a:ext cx="1426464" cy="146304"/>
           </a:xfrm>
           <a:prstGeom prst="rect">
             <a:avLst/>
@@ -3766,16 +4161,1588 @@
           </a:p>
         </p:txBody>
       </p:sp>
-      <p:sp>
-        <p:nvSpPr>
-          <p:cNvPr id="20" name="ir_card"/>
+      <p:cxnSp>
+        <p:nvCxnSpPr>
+          <p:cNvPr id="30" name="main_start_markdown"/>
+          <p:cNvCxnSpPr/>
+          <p:nvPr/>
+        </p:nvCxnSpPr>
+        <p:spPr>
+          <a:xfrm>
+            <a:off x="1280160" y="1865376"/>
+            <a:ext cx="0" cy="109728"/>
+          </a:xfrm>
+          <a:prstGeom prst="line">
+            <a:avLst/>
+          </a:prstGeom>
+          <a:ln w="30480">
+            <a:solidFill>
+              <a:srgbClr val="111827"/>
+            </a:solidFill>
+          </a:ln>
+        </p:spPr>
+        <p:style>
+          <a:lnRef idx="2">
+            <a:schemeClr val="accent1"/>
+          </a:lnRef>
+          <a:fillRef idx="0">
+            <a:schemeClr val="accent1"/>
+          </a:fillRef>
+          <a:effectRef idx="1">
+            <a:schemeClr val="accent1"/>
+          </a:effectRef>
+          <a:fontRef idx="minor">
+            <a:schemeClr val="tx1"/>
+          </a:fontRef>
+        </p:style>
+      </p:cxnSp>
+      <p:cxnSp>
+        <p:nvCxnSpPr>
+          <p:cNvPr id="31" name="main_markdown_splitter"/>
+          <p:cNvCxnSpPr/>
+          <p:nvPr/>
+        </p:nvCxnSpPr>
+        <p:spPr>
+          <a:xfrm>
+            <a:off x="1847088" y="2816352"/>
+            <a:ext cx="0" cy="310896"/>
+          </a:xfrm>
+          <a:prstGeom prst="line">
+            <a:avLst/>
+          </a:prstGeom>
+          <a:ln w="38100">
+            <a:solidFill>
+              <a:srgbClr val="475569"/>
+            </a:solidFill>
+          </a:ln>
+        </p:spPr>
+        <p:style>
+          <a:lnRef idx="2">
+            <a:schemeClr val="accent1"/>
+          </a:lnRef>
+          <a:fillRef idx="0">
+            <a:schemeClr val="accent1"/>
+          </a:fillRef>
+          <a:effectRef idx="1">
+            <a:schemeClr val="accent1"/>
+          </a:effectRef>
+          <a:fontRef idx="minor">
+            <a:schemeClr val="tx1"/>
+          </a:fontRef>
+        </p:style>
+      </p:cxnSp>
+      <p:sp>
+        <p:nvSpPr>
+          <p:cNvPr id="32" name="ir_core"/>
           <p:cNvSpPr/>
           <p:nvPr/>
         </p:nvSpPr>
         <p:spPr>
           <a:xfrm>
-            <a:off x="5047488" y="1554480"/>
-            <a:ext cx="1847088" cy="1005840"/>
+            <a:off x="3529584" y="1627632"/>
+            <a:ext cx="1792224" cy="859536"/>
+          </a:xfrm>
+          <a:prstGeom prst="roundRect">
+            <a:avLst/>
+          </a:prstGeom>
+          <a:solidFill>
+            <a:srgbClr val="FFFFFF"/>
+          </a:solidFill>
+          <a:ln>
+            <a:solidFill>
+              <a:srgbClr val="93C5FD"/>
+            </a:solidFill>
+          </a:ln>
+        </p:spPr>
+        <p:style>
+          <a:lnRef idx="1">
+            <a:schemeClr val="accent1"/>
+          </a:lnRef>
+          <a:fillRef idx="3">
+            <a:schemeClr val="accent1"/>
+          </a:fillRef>
+          <a:effectRef idx="2">
+            <a:schemeClr val="accent1"/>
+          </a:effectRef>
+          <a:fontRef idx="minor">
+            <a:schemeClr val="lt1"/>
+          </a:fontRef>
+        </p:style>
+        <p:txBody>
+          <a:bodyPr rtlCol="0" anchor="ctr"/>
+          <a:lstStyle/>
+          <a:p>
+            <a:pPr algn="ctr"/>
+          </a:p>
+        </p:txBody>
+      </p:sp>
+      <p:sp>
+        <p:nvSpPr>
+          <p:cNvPr id="33" name="ir_core_title"/>
+          <p:cNvSpPr txBox="1"/>
+          <p:nvPr/>
+        </p:nvSpPr>
+        <p:spPr>
+          <a:xfrm>
+            <a:off x="3730752" y="1810512"/>
+            <a:ext cx="1225296" cy="182880"/>
+          </a:xfrm>
+          <a:prstGeom prst="rect">
+            <a:avLst/>
+          </a:prstGeom>
+          <a:noFill/>
+        </p:spPr>
+        <p:txBody>
+          <a:bodyPr wrap="square" lIns="0" rIns="0" tIns="0" bIns="0">
+            <a:spAutoFit/>
+          </a:bodyPr>
+          <a:lstStyle/>
+          <a:p>
+            <a:pPr algn="l"/>
+            <a:r>
+              <a:rPr sz="1200" b="1">
+                <a:solidFill>
+                  <a:srgbClr val="111827"/>
+                </a:solidFill>
+              </a:rPr>
+              <a:t>Slide Element IR</a:t>
+            </a:r>
+          </a:p>
+        </p:txBody>
+      </p:sp>
+      <p:sp>
+        <p:nvSpPr>
+          <p:cNvPr id="34" name="ir_core_body"/>
+          <p:cNvSpPr txBox="1"/>
+          <p:nvPr/>
+        </p:nvSpPr>
+        <p:spPr>
+          <a:xfrm>
+            <a:off x="3730752" y="2084831"/>
+            <a:ext cx="1316736" cy="146304"/>
+          </a:xfrm>
+          <a:prstGeom prst="rect">
+            <a:avLst/>
+          </a:prstGeom>
+          <a:noFill/>
+        </p:spPr>
+        <p:txBody>
+          <a:bodyPr wrap="square" lIns="0" rIns="0" tIns="0" bIns="0">
+            <a:spAutoFit/>
+          </a:bodyPr>
+          <a:lstStyle/>
+          <a:p>
+            <a:pPr algn="l"/>
+            <a:r>
+              <a:rPr sz="800" b="0">
+                <a:solidFill>
+                  <a:srgbClr val="526071"/>
+                </a:solidFill>
+              </a:rPr>
+              <a:t>content-only object contract</a:t>
+            </a:r>
+          </a:p>
+        </p:txBody>
+      </p:sp>
+      <p:sp>
+        <p:nvSpPr>
+          <p:cNvPr id="35" name="reasoning_card"/>
+          <p:cNvSpPr/>
+          <p:nvPr/>
+        </p:nvSpPr>
+        <p:spPr>
+          <a:xfrm>
+            <a:off x="3511296" y="2743200"/>
+            <a:ext cx="1828800" cy="1298448"/>
+          </a:xfrm>
+          <a:prstGeom prst="roundRect">
+            <a:avLst/>
+          </a:prstGeom>
+          <a:solidFill>
+            <a:srgbClr val="FFFFFF"/>
+          </a:solidFill>
+          <a:ln>
+            <a:solidFill>
+              <a:srgbClr val="93C5FD"/>
+            </a:solidFill>
+          </a:ln>
+        </p:spPr>
+        <p:style>
+          <a:lnRef idx="1">
+            <a:schemeClr val="accent1"/>
+          </a:lnRef>
+          <a:fillRef idx="3">
+            <a:schemeClr val="accent1"/>
+          </a:fillRef>
+          <a:effectRef idx="2">
+            <a:schemeClr val="accent1"/>
+          </a:effectRef>
+          <a:fontRef idx="minor">
+            <a:schemeClr val="lt1"/>
+          </a:fontRef>
+        </p:style>
+        <p:txBody>
+          <a:bodyPr rtlCol="0" anchor="ctr"/>
+          <a:lstStyle/>
+          <a:p>
+            <a:pPr algn="ctr"/>
+          </a:p>
+        </p:txBody>
+      </p:sp>
+      <p:sp>
+        <p:nvSpPr>
+          <p:cNvPr id="36" name="reasoning_title"/>
+          <p:cNvSpPr txBox="1"/>
+          <p:nvPr/>
+        </p:nvSpPr>
+        <p:spPr>
+          <a:xfrm>
+            <a:off x="3712463" y="2907792"/>
+            <a:ext cx="1298448" cy="219456"/>
+          </a:xfrm>
+          <a:prstGeom prst="rect">
+            <a:avLst/>
+          </a:prstGeom>
+          <a:noFill/>
+        </p:spPr>
+        <p:txBody>
+          <a:bodyPr wrap="square" lIns="0" rIns="0" tIns="0" bIns="0">
+            <a:spAutoFit/>
+          </a:bodyPr>
+          <a:lstStyle/>
+          <a:p>
+            <a:pPr algn="l"/>
+            <a:r>
+              <a:rPr sz="1200" b="1">
+                <a:solidFill>
+                  <a:srgbClr val="111827"/>
+                </a:solidFill>
+              </a:rPr>
+              <a:t>Reasoning Result</a:t>
+            </a:r>
+          </a:p>
+        </p:txBody>
+      </p:sp>
+      <p:sp>
+        <p:nvSpPr>
+          <p:cNvPr id="37" name="reasoning_body"/>
+          <p:cNvSpPr txBox="1"/>
+          <p:nvPr/>
+        </p:nvSpPr>
+        <p:spPr>
+          <a:xfrm>
+            <a:off x="3712463" y="3218688"/>
+            <a:ext cx="1335024" cy="182880"/>
+          </a:xfrm>
+          <a:prstGeom prst="rect">
+            <a:avLst/>
+          </a:prstGeom>
+          <a:noFill/>
+        </p:spPr>
+        <p:txBody>
+          <a:bodyPr wrap="square" lIns="0" rIns="0" tIns="0" bIns="0">
+            <a:spAutoFit/>
+          </a:bodyPr>
+          <a:lstStyle/>
+          <a:p>
+            <a:pPr algn="l"/>
+            <a:r>
+              <a:rPr sz="800" b="0">
+                <a:solidFill>
+                  <a:srgbClr val="526071"/>
+                </a:solidFill>
+              </a:rPr>
+              <a:t>intent, grouping, importance</a:t>
+            </a:r>
+          </a:p>
+        </p:txBody>
+      </p:sp>
+      <p:sp>
+        <p:nvSpPr>
+          <p:cNvPr id="38" name="reasoning_badge"/>
+          <p:cNvSpPr/>
+          <p:nvPr/>
+        </p:nvSpPr>
+        <p:spPr>
+          <a:xfrm>
+            <a:off x="3712463" y="3547872"/>
+            <a:ext cx="1353312" cy="219456"/>
+          </a:xfrm>
+          <a:prstGeom prst="roundRect">
+            <a:avLst/>
+          </a:prstGeom>
+          <a:solidFill>
+            <a:srgbClr val="DBEAFE"/>
+          </a:solidFill>
+          <a:ln>
+            <a:solidFill>
+              <a:srgbClr val="93C5FD"/>
+            </a:solidFill>
+          </a:ln>
+        </p:spPr>
+        <p:style>
+          <a:lnRef idx="1">
+            <a:schemeClr val="accent1"/>
+          </a:lnRef>
+          <a:fillRef idx="3">
+            <a:schemeClr val="accent1"/>
+          </a:fillRef>
+          <a:effectRef idx="2">
+            <a:schemeClr val="accent1"/>
+          </a:effectRef>
+          <a:fontRef idx="minor">
+            <a:schemeClr val="lt1"/>
+          </a:fontRef>
+        </p:style>
+        <p:txBody>
+          <a:bodyPr rtlCol="0" anchor="ctr"/>
+          <a:lstStyle/>
+          <a:p>
+            <a:pPr algn="ctr"/>
+          </a:p>
+        </p:txBody>
+      </p:sp>
+      <p:sp>
+        <p:nvSpPr>
+          <p:cNvPr id="39" name="reasoning_badge_text"/>
+          <p:cNvSpPr txBox="1"/>
+          <p:nvPr/>
+        </p:nvSpPr>
+        <p:spPr>
+          <a:xfrm>
+            <a:off x="3877056" y="3621024"/>
+            <a:ext cx="987552" cy="91440"/>
+          </a:xfrm>
+          <a:prstGeom prst="rect">
+            <a:avLst/>
+          </a:prstGeom>
+          <a:noFill/>
+        </p:spPr>
+        <p:txBody>
+          <a:bodyPr wrap="square" lIns="0" rIns="0" tIns="0" bIns="0">
+            <a:spAutoFit/>
+          </a:bodyPr>
+          <a:lstStyle/>
+          <a:p>
+            <a:pPr algn="l"/>
+            <a:r>
+              <a:rPr sz="800" b="1">
+                <a:solidFill>
+                  <a:srgbClr val="1D4ED8"/>
+                </a:solidFill>
+              </a:rPr>
+              <a:t>hints only</a:t>
+            </a:r>
+          </a:p>
+        </p:txBody>
+      </p:sp>
+      <p:sp>
+        <p:nvSpPr>
+          <p:cNvPr id="40" name="reasoning_guardrail"/>
+          <p:cNvSpPr txBox="1"/>
+          <p:nvPr/>
+        </p:nvSpPr>
+        <p:spPr>
+          <a:xfrm>
+            <a:off x="3712463" y="3840480"/>
+            <a:ext cx="1353312" cy="146304"/>
+          </a:xfrm>
+          <a:prstGeom prst="rect">
+            <a:avLst/>
+          </a:prstGeom>
+          <a:noFill/>
+        </p:spPr>
+        <p:txBody>
+          <a:bodyPr wrap="square" lIns="0" rIns="0" tIns="0" bIns="0">
+            <a:spAutoFit/>
+          </a:bodyPr>
+          <a:lstStyle/>
+          <a:p>
+            <a:pPr algn="l"/>
+            <a:r>
+              <a:rPr sz="800" b="1">
+                <a:solidFill>
+                  <a:srgbClr val="64748B"/>
+                </a:solidFill>
+              </a:rPr>
+              <a:t>no coordinates or styles</a:t>
+            </a:r>
+          </a:p>
+        </p:txBody>
+      </p:sp>
+      <p:cxnSp>
+        <p:nvCxnSpPr>
+          <p:cNvPr id="41" name="main_splitter_ir"/>
+          <p:cNvCxnSpPr/>
+          <p:nvPr/>
+        </p:nvCxnSpPr>
+        <p:spPr>
+          <a:xfrm flipV="1">
+            <a:off x="2743200" y="2066543"/>
+            <a:ext cx="786384" cy="1517905"/>
+          </a:xfrm>
+          <a:prstGeom prst="line">
+            <a:avLst/>
+          </a:prstGeom>
+          <a:ln w="43180">
+            <a:solidFill>
+              <a:srgbClr val="475569"/>
+            </a:solidFill>
+          </a:ln>
+        </p:spPr>
+        <p:style>
+          <a:lnRef idx="2">
+            <a:schemeClr val="accent1"/>
+          </a:lnRef>
+          <a:fillRef idx="0">
+            <a:schemeClr val="accent1"/>
+          </a:fillRef>
+          <a:effectRef idx="1">
+            <a:schemeClr val="accent1"/>
+          </a:effectRef>
+          <a:fontRef idx="minor">
+            <a:schemeClr val="tx1"/>
+          </a:fontRef>
+        </p:style>
+      </p:cxnSp>
+      <p:cxnSp>
+        <p:nvCxnSpPr>
+          <p:cNvPr id="42" name="hint_ir_reasoning"/>
+          <p:cNvCxnSpPr/>
+          <p:nvPr/>
+        </p:nvCxnSpPr>
+        <p:spPr>
+          <a:xfrm>
+            <a:off x="4443984" y="2487168"/>
+            <a:ext cx="0" cy="256032"/>
+          </a:xfrm>
+          <a:prstGeom prst="line">
+            <a:avLst/>
+          </a:prstGeom>
+          <a:ln w="25400">
+            <a:solidFill>
+              <a:srgbClr val="2563EB"/>
+            </a:solidFill>
+            <a:prstDash val="dash"/>
+          </a:ln>
+        </p:spPr>
+        <p:style>
+          <a:lnRef idx="2">
+            <a:schemeClr val="accent1"/>
+          </a:lnRef>
+          <a:fillRef idx="0">
+            <a:schemeClr val="accent1"/>
+          </a:fillRef>
+          <a:effectRef idx="1">
+            <a:schemeClr val="accent1"/>
+          </a:effectRef>
+          <a:fontRef idx="minor">
+            <a:schemeClr val="tx1"/>
+          </a:fontRef>
+        </p:style>
+      </p:cxnSp>
+      <p:sp>
+        <p:nvSpPr>
+          <p:cNvPr id="43" name="rule_engine"/>
+          <p:cNvSpPr/>
+          <p:nvPr/>
+        </p:nvSpPr>
+        <p:spPr>
+          <a:xfrm>
+            <a:off x="6089904" y="1609344"/>
+            <a:ext cx="2670048" cy="676656"/>
+          </a:xfrm>
+          <a:prstGeom prst="roundRect">
+            <a:avLst/>
+          </a:prstGeom>
+          <a:solidFill>
+            <a:srgbClr val="DCFCE7"/>
+          </a:solidFill>
+          <a:ln>
+            <a:solidFill>
+              <a:srgbClr val="86EFAC"/>
+            </a:solidFill>
+          </a:ln>
+        </p:spPr>
+        <p:style>
+          <a:lnRef idx="1">
+            <a:schemeClr val="accent1"/>
+          </a:lnRef>
+          <a:fillRef idx="3">
+            <a:schemeClr val="accent1"/>
+          </a:fillRef>
+          <a:effectRef idx="2">
+            <a:schemeClr val="accent1"/>
+          </a:effectRef>
+          <a:fontRef idx="minor">
+            <a:schemeClr val="lt1"/>
+          </a:fontRef>
+        </p:style>
+        <p:txBody>
+          <a:bodyPr rtlCol="0" anchor="ctr"/>
+          <a:lstStyle/>
+          <a:p>
+            <a:pPr algn="ctr"/>
+          </a:p>
+        </p:txBody>
+      </p:sp>
+      <p:sp>
+        <p:nvSpPr>
+          <p:cNvPr id="44" name="rule_engine_title"/>
+          <p:cNvSpPr txBox="1"/>
+          <p:nvPr/>
+        </p:nvSpPr>
+        <p:spPr>
+          <a:xfrm>
+            <a:off x="6309360" y="1773936"/>
+            <a:ext cx="1828800" cy="201168"/>
+          </a:xfrm>
+          <a:prstGeom prst="rect">
+            <a:avLst/>
+          </a:prstGeom>
+          <a:noFill/>
+        </p:spPr>
+        <p:txBody>
+          <a:bodyPr wrap="square" lIns="0" rIns="0" tIns="0" bIns="0">
+            <a:spAutoFit/>
+          </a:bodyPr>
+          <a:lstStyle/>
+          <a:p>
+            <a:pPr algn="l"/>
+            <a:r>
+              <a:rPr sz="1300" b="1">
+                <a:solidFill>
+                  <a:srgbClr val="14532D"/>
+                </a:solidFill>
+              </a:rPr>
+              <a:t>Rule Engine Boundary</a:t>
+            </a:r>
+          </a:p>
+        </p:txBody>
+      </p:sp>
+      <p:sp>
+        <p:nvSpPr>
+          <p:cNvPr id="45" name="rule_engine_body"/>
+          <p:cNvSpPr txBox="1"/>
+          <p:nvPr/>
+        </p:nvSpPr>
+        <p:spPr>
+          <a:xfrm>
+            <a:off x="6309360" y="2057400"/>
+            <a:ext cx="2029968" cy="109728"/>
+          </a:xfrm>
+          <a:prstGeom prst="rect">
+            <a:avLst/>
+          </a:prstGeom>
+          <a:noFill/>
+        </p:spPr>
+        <p:txBody>
+          <a:bodyPr wrap="square" lIns="0" rIns="0" tIns="0" bIns="0">
+            <a:spAutoFit/>
+          </a:bodyPr>
+          <a:lstStyle/>
+          <a:p>
+            <a:pPr algn="l"/>
+            <a:r>
+              <a:rPr sz="800" b="0">
+                <a:solidFill>
+                  <a:srgbClr val="166534"/>
+                </a:solidFill>
+              </a:rPr>
+              <a:t>recipes, variants, coordinates, z-order</a:t>
+            </a:r>
+          </a:p>
+        </p:txBody>
+      </p:sp>
+      <p:sp>
+        <p:nvSpPr>
+          <p:cNvPr id="46" name="features_card"/>
+          <p:cNvSpPr/>
+          <p:nvPr/>
+        </p:nvSpPr>
+        <p:spPr>
+          <a:xfrm>
+            <a:off x="6089904" y="2596896"/>
+            <a:ext cx="1243584" cy="713232"/>
+          </a:xfrm>
+          <a:prstGeom prst="roundRect">
+            <a:avLst/>
+          </a:prstGeom>
+          <a:solidFill>
+            <a:srgbClr val="F8FAFC"/>
+          </a:solidFill>
+          <a:ln>
+            <a:solidFill>
+              <a:srgbClr val="BBF7D0"/>
+            </a:solidFill>
+          </a:ln>
+        </p:spPr>
+        <p:style>
+          <a:lnRef idx="1">
+            <a:schemeClr val="accent1"/>
+          </a:lnRef>
+          <a:fillRef idx="3">
+            <a:schemeClr val="accent1"/>
+          </a:fillRef>
+          <a:effectRef idx="2">
+            <a:schemeClr val="accent1"/>
+          </a:effectRef>
+          <a:fontRef idx="minor">
+            <a:schemeClr val="lt1"/>
+          </a:fontRef>
+        </p:style>
+        <p:txBody>
+          <a:bodyPr rtlCol="0" anchor="ctr"/>
+          <a:lstStyle/>
+          <a:p>
+            <a:pPr algn="ctr"/>
+          </a:p>
+        </p:txBody>
+      </p:sp>
+      <p:sp>
+        <p:nvSpPr>
+          <p:cNvPr id="47" name="features_dot"/>
+          <p:cNvSpPr/>
+          <p:nvPr/>
+        </p:nvSpPr>
+        <p:spPr>
+          <a:xfrm>
+            <a:off x="6236208" y="2761488"/>
+            <a:ext cx="164592" cy="164592"/>
+          </a:xfrm>
+          <a:prstGeom prst="ellipse">
+            <a:avLst/>
+          </a:prstGeom>
+          <a:solidFill>
+            <a:srgbClr val="86EFAC"/>
+          </a:solidFill>
+          <a:ln>
+            <a:solidFill>
+              <a:srgbClr val="86EFAC"/>
+            </a:solidFill>
+          </a:ln>
+        </p:spPr>
+        <p:style>
+          <a:lnRef idx="1">
+            <a:schemeClr val="accent1"/>
+          </a:lnRef>
+          <a:fillRef idx="3">
+            <a:schemeClr val="accent1"/>
+          </a:fillRef>
+          <a:effectRef idx="2">
+            <a:schemeClr val="accent1"/>
+          </a:effectRef>
+          <a:fontRef idx="minor">
+            <a:schemeClr val="lt1"/>
+          </a:fontRef>
+        </p:style>
+        <p:txBody>
+          <a:bodyPr rtlCol="0" anchor="ctr"/>
+          <a:lstStyle/>
+          <a:p>
+            <a:pPr algn="ctr"/>
+          </a:p>
+        </p:txBody>
+      </p:sp>
+      <p:sp>
+        <p:nvSpPr>
+          <p:cNvPr id="48" name="features_title"/>
+          <p:cNvSpPr txBox="1"/>
+          <p:nvPr/>
+        </p:nvSpPr>
+        <p:spPr>
+          <a:xfrm>
+            <a:off x="6473952" y="2715768"/>
+            <a:ext cx="713232" cy="201168"/>
+          </a:xfrm>
+          <a:prstGeom prst="rect">
+            <a:avLst/>
+          </a:prstGeom>
+          <a:noFill/>
+        </p:spPr>
+        <p:txBody>
+          <a:bodyPr wrap="square" lIns="0" rIns="0" tIns="0" bIns="0">
+            <a:spAutoFit/>
+          </a:bodyPr>
+          <a:lstStyle/>
+          <a:p>
+            <a:pPr algn="l"/>
+            <a:r>
+              <a:rPr sz="1100" b="1">
+                <a:solidFill>
+                  <a:srgbClr val="111827"/>
+                </a:solidFill>
+              </a:rPr>
+              <a:t>Features</a:t>
+            </a:r>
+          </a:p>
+        </p:txBody>
+      </p:sp>
+      <p:sp>
+        <p:nvSpPr>
+          <p:cNvPr id="49" name="features_line_0"/>
+          <p:cNvSpPr txBox="1"/>
+          <p:nvPr/>
+        </p:nvSpPr>
+        <p:spPr>
+          <a:xfrm>
+            <a:off x="6291072" y="2999232"/>
+            <a:ext cx="859536" cy="109728"/>
+          </a:xfrm>
+          <a:prstGeom prst="rect">
+            <a:avLst/>
+          </a:prstGeom>
+          <a:noFill/>
+        </p:spPr>
+        <p:txBody>
+          <a:bodyPr wrap="square" lIns="0" rIns="0" tIns="0" bIns="0">
+            <a:spAutoFit/>
+          </a:bodyPr>
+          <a:lstStyle/>
+          <a:p>
+            <a:pPr algn="l"/>
+            <a:r>
+              <a:rPr sz="800" b="0">
+                <a:solidFill>
+                  <a:srgbClr val="526071"/>
+                </a:solidFill>
+              </a:rPr>
+              <a:t>density, mix</a:t>
+            </a:r>
+          </a:p>
+        </p:txBody>
+      </p:sp>
+      <p:sp>
+        <p:nvSpPr>
+          <p:cNvPr id="50" name="features_line_1"/>
+          <p:cNvSpPr txBox="1"/>
+          <p:nvPr/>
+        </p:nvSpPr>
+        <p:spPr>
+          <a:xfrm>
+            <a:off x="6291072" y="3108960"/>
+            <a:ext cx="859536" cy="109728"/>
+          </a:xfrm>
+          <a:prstGeom prst="rect">
+            <a:avLst/>
+          </a:prstGeom>
+          <a:noFill/>
+        </p:spPr>
+        <p:txBody>
+          <a:bodyPr wrap="square" lIns="0" rIns="0" tIns="0" bIns="0">
+            <a:spAutoFit/>
+          </a:bodyPr>
+          <a:lstStyle/>
+          <a:p>
+            <a:pPr algn="l"/>
+            <a:r>
+              <a:rPr sz="800" b="0">
+                <a:solidFill>
+                  <a:srgbClr val="526071"/>
+                </a:solidFill>
+              </a:rPr>
+              <a:t>size risk</a:t>
+            </a:r>
+          </a:p>
+        </p:txBody>
+      </p:sp>
+      <p:sp>
+        <p:nvSpPr>
+          <p:cNvPr id="51" name="recipes_card"/>
+          <p:cNvSpPr/>
+          <p:nvPr/>
+        </p:nvSpPr>
+        <p:spPr>
+          <a:xfrm>
+            <a:off x="7571231" y="2596896"/>
+            <a:ext cx="1243584" cy="713232"/>
+          </a:xfrm>
+          <a:prstGeom prst="roundRect">
+            <a:avLst/>
+          </a:prstGeom>
+          <a:solidFill>
+            <a:srgbClr val="F8FAFC"/>
+          </a:solidFill>
+          <a:ln>
+            <a:solidFill>
+              <a:srgbClr val="BBF7D0"/>
+            </a:solidFill>
+          </a:ln>
+        </p:spPr>
+        <p:style>
+          <a:lnRef idx="1">
+            <a:schemeClr val="accent1"/>
+          </a:lnRef>
+          <a:fillRef idx="3">
+            <a:schemeClr val="accent1"/>
+          </a:fillRef>
+          <a:effectRef idx="2">
+            <a:schemeClr val="accent1"/>
+          </a:effectRef>
+          <a:fontRef idx="minor">
+            <a:schemeClr val="lt1"/>
+          </a:fontRef>
+        </p:style>
+        <p:txBody>
+          <a:bodyPr rtlCol="0" anchor="ctr"/>
+          <a:lstStyle/>
+          <a:p>
+            <a:pPr algn="ctr"/>
+          </a:p>
+        </p:txBody>
+      </p:sp>
+      <p:sp>
+        <p:nvSpPr>
+          <p:cNvPr id="52" name="recipes_dot"/>
+          <p:cNvSpPr/>
+          <p:nvPr/>
+        </p:nvSpPr>
+        <p:spPr>
+          <a:xfrm>
+            <a:off x="7717536" y="2761488"/>
+            <a:ext cx="164592" cy="164592"/>
+          </a:xfrm>
+          <a:prstGeom prst="ellipse">
+            <a:avLst/>
+          </a:prstGeom>
+          <a:solidFill>
+            <a:srgbClr val="86EFAC"/>
+          </a:solidFill>
+          <a:ln>
+            <a:solidFill>
+              <a:srgbClr val="86EFAC"/>
+            </a:solidFill>
+          </a:ln>
+        </p:spPr>
+        <p:style>
+          <a:lnRef idx="1">
+            <a:schemeClr val="accent1"/>
+          </a:lnRef>
+          <a:fillRef idx="3">
+            <a:schemeClr val="accent1"/>
+          </a:fillRef>
+          <a:effectRef idx="2">
+            <a:schemeClr val="accent1"/>
+          </a:effectRef>
+          <a:fontRef idx="minor">
+            <a:schemeClr val="lt1"/>
+          </a:fontRef>
+        </p:style>
+        <p:txBody>
+          <a:bodyPr rtlCol="0" anchor="ctr"/>
+          <a:lstStyle/>
+          <a:p>
+            <a:pPr algn="ctr"/>
+          </a:p>
+        </p:txBody>
+      </p:sp>
+      <p:sp>
+        <p:nvSpPr>
+          <p:cNvPr id="53" name="recipes_title"/>
+          <p:cNvSpPr txBox="1"/>
+          <p:nvPr/>
+        </p:nvSpPr>
+        <p:spPr>
+          <a:xfrm>
+            <a:off x="7955279" y="2715768"/>
+            <a:ext cx="713232" cy="201168"/>
+          </a:xfrm>
+          <a:prstGeom prst="rect">
+            <a:avLst/>
+          </a:prstGeom>
+          <a:noFill/>
+        </p:spPr>
+        <p:txBody>
+          <a:bodyPr wrap="square" lIns="0" rIns="0" tIns="0" bIns="0">
+            <a:spAutoFit/>
+          </a:bodyPr>
+          <a:lstStyle/>
+          <a:p>
+            <a:pPr algn="l"/>
+            <a:r>
+              <a:rPr sz="1100" b="1">
+                <a:solidFill>
+                  <a:srgbClr val="111827"/>
+                </a:solidFill>
+              </a:rPr>
+              <a:t>Recipes</a:t>
+            </a:r>
+          </a:p>
+        </p:txBody>
+      </p:sp>
+      <p:sp>
+        <p:nvSpPr>
+          <p:cNvPr id="54" name="recipes_line_0"/>
+          <p:cNvSpPr txBox="1"/>
+          <p:nvPr/>
+        </p:nvSpPr>
+        <p:spPr>
+          <a:xfrm>
+            <a:off x="7772400" y="2999232"/>
+            <a:ext cx="859536" cy="109728"/>
+          </a:xfrm>
+          <a:prstGeom prst="rect">
+            <a:avLst/>
+          </a:prstGeom>
+          <a:noFill/>
+        </p:spPr>
+        <p:txBody>
+          <a:bodyPr wrap="square" lIns="0" rIns="0" tIns="0" bIns="0">
+            <a:spAutoFit/>
+          </a:bodyPr>
+          <a:lstStyle/>
+          <a:p>
+            <a:pPr algn="l"/>
+            <a:r>
+              <a:rPr sz="800" b="0">
+                <a:solidFill>
+                  <a:srgbClr val="526071"/>
+                </a:solidFill>
+              </a:rPr>
+              <a:t>profile match</a:t>
+            </a:r>
+          </a:p>
+        </p:txBody>
+      </p:sp>
+      <p:sp>
+        <p:nvSpPr>
+          <p:cNvPr id="55" name="recipes_line_1"/>
+          <p:cNvSpPr txBox="1"/>
+          <p:nvPr/>
+        </p:nvSpPr>
+        <p:spPr>
+          <a:xfrm>
+            <a:off x="7772400" y="3108960"/>
+            <a:ext cx="859536" cy="109728"/>
+          </a:xfrm>
+          <a:prstGeom prst="rect">
+            <a:avLst/>
+          </a:prstGeom>
+          <a:noFill/>
+        </p:spPr>
+        <p:txBody>
+          <a:bodyPr wrap="square" lIns="0" rIns="0" tIns="0" bIns="0">
+            <a:spAutoFit/>
+          </a:bodyPr>
+          <a:lstStyle/>
+          <a:p>
+            <a:pPr algn="l"/>
+            <a:r>
+              <a:rPr sz="800" b="0">
+                <a:solidFill>
+                  <a:srgbClr val="526071"/>
+                </a:solidFill>
+              </a:rPr>
+              <a:t>component variant</a:t>
+            </a:r>
+          </a:p>
+        </p:txBody>
+      </p:sp>
+      <p:sp>
+        <p:nvSpPr>
+          <p:cNvPr id="56" name="compose_card"/>
+          <p:cNvSpPr/>
+          <p:nvPr/>
+        </p:nvSpPr>
+        <p:spPr>
+          <a:xfrm>
+            <a:off x="6089904" y="3566160"/>
+            <a:ext cx="1243584" cy="713232"/>
+          </a:xfrm>
+          <a:prstGeom prst="roundRect">
+            <a:avLst/>
+          </a:prstGeom>
+          <a:solidFill>
+            <a:srgbClr val="F8FAFC"/>
+          </a:solidFill>
+          <a:ln>
+            <a:solidFill>
+              <a:srgbClr val="BBF7D0"/>
+            </a:solidFill>
+          </a:ln>
+        </p:spPr>
+        <p:style>
+          <a:lnRef idx="1">
+            <a:schemeClr val="accent1"/>
+          </a:lnRef>
+          <a:fillRef idx="3">
+            <a:schemeClr val="accent1"/>
+          </a:fillRef>
+          <a:effectRef idx="2">
+            <a:schemeClr val="accent1"/>
+          </a:effectRef>
+          <a:fontRef idx="minor">
+            <a:schemeClr val="lt1"/>
+          </a:fontRef>
+        </p:style>
+        <p:txBody>
+          <a:bodyPr rtlCol="0" anchor="ctr"/>
+          <a:lstStyle/>
+          <a:p>
+            <a:pPr algn="ctr"/>
+          </a:p>
+        </p:txBody>
+      </p:sp>
+      <p:sp>
+        <p:nvSpPr>
+          <p:cNvPr id="57" name="compose_dot"/>
+          <p:cNvSpPr/>
+          <p:nvPr/>
+        </p:nvSpPr>
+        <p:spPr>
+          <a:xfrm>
+            <a:off x="6236208" y="3730752"/>
+            <a:ext cx="164592" cy="164592"/>
+          </a:xfrm>
+          <a:prstGeom prst="ellipse">
+            <a:avLst/>
+          </a:prstGeom>
+          <a:solidFill>
+            <a:srgbClr val="86EFAC"/>
+          </a:solidFill>
+          <a:ln>
+            <a:solidFill>
+              <a:srgbClr val="86EFAC"/>
+            </a:solidFill>
+          </a:ln>
+        </p:spPr>
+        <p:style>
+          <a:lnRef idx="1">
+            <a:schemeClr val="accent1"/>
+          </a:lnRef>
+          <a:fillRef idx="3">
+            <a:schemeClr val="accent1"/>
+          </a:fillRef>
+          <a:effectRef idx="2">
+            <a:schemeClr val="accent1"/>
+          </a:effectRef>
+          <a:fontRef idx="minor">
+            <a:schemeClr val="lt1"/>
+          </a:fontRef>
+        </p:style>
+        <p:txBody>
+          <a:bodyPr rtlCol="0" anchor="ctr"/>
+          <a:lstStyle/>
+          <a:p>
+            <a:pPr algn="ctr"/>
+          </a:p>
+        </p:txBody>
+      </p:sp>
+      <p:sp>
+        <p:nvSpPr>
+          <p:cNvPr id="58" name="compose_title"/>
+          <p:cNvSpPr txBox="1"/>
+          <p:nvPr/>
+        </p:nvSpPr>
+        <p:spPr>
+          <a:xfrm>
+            <a:off x="6473952" y="3685032"/>
+            <a:ext cx="713232" cy="201168"/>
+          </a:xfrm>
+          <a:prstGeom prst="rect">
+            <a:avLst/>
+          </a:prstGeom>
+          <a:noFill/>
+        </p:spPr>
+        <p:txBody>
+          <a:bodyPr wrap="square" lIns="0" rIns="0" tIns="0" bIns="0">
+            <a:spAutoFit/>
+          </a:bodyPr>
+          <a:lstStyle/>
+          <a:p>
+            <a:pPr algn="l"/>
+            <a:r>
+              <a:rPr sz="1100" b="1">
+                <a:solidFill>
+                  <a:srgbClr val="111827"/>
+                </a:solidFill>
+              </a:rPr>
+              <a:t>Compose</a:t>
+            </a:r>
+          </a:p>
+        </p:txBody>
+      </p:sp>
+      <p:sp>
+        <p:nvSpPr>
+          <p:cNvPr id="59" name="compose_line_0"/>
+          <p:cNvSpPr txBox="1"/>
+          <p:nvPr/>
+        </p:nvSpPr>
+        <p:spPr>
+          <a:xfrm>
+            <a:off x="6291072" y="3968496"/>
+            <a:ext cx="859536" cy="109728"/>
+          </a:xfrm>
+          <a:prstGeom prst="rect">
+            <a:avLst/>
+          </a:prstGeom>
+          <a:noFill/>
+        </p:spPr>
+        <p:txBody>
+          <a:bodyPr wrap="square" lIns="0" rIns="0" tIns="0" bIns="0">
+            <a:spAutoFit/>
+          </a:bodyPr>
+          <a:lstStyle/>
+          <a:p>
+            <a:pPr algn="l"/>
+            <a:r>
+              <a:rPr sz="800" b="0">
+                <a:solidFill>
+                  <a:srgbClr val="526071"/>
+                </a:solidFill>
+              </a:rPr>
+              <a:t>regions, fit</a:t>
+            </a:r>
+          </a:p>
+        </p:txBody>
+      </p:sp>
+      <p:sp>
+        <p:nvSpPr>
+          <p:cNvPr id="60" name="compose_line_1"/>
+          <p:cNvSpPr txBox="1"/>
+          <p:nvPr/>
+        </p:nvSpPr>
+        <p:spPr>
+          <a:xfrm>
+            <a:off x="6291072" y="4078224"/>
+            <a:ext cx="859536" cy="109728"/>
+          </a:xfrm>
+          <a:prstGeom prst="rect">
+            <a:avLst/>
+          </a:prstGeom>
+          <a:noFill/>
+        </p:spPr>
+        <p:txBody>
+          <a:bodyPr wrap="square" lIns="0" rIns="0" tIns="0" bIns="0">
+            <a:spAutoFit/>
+          </a:bodyPr>
+          <a:lstStyle/>
+          <a:p>
+            <a:pPr algn="l"/>
+            <a:r>
+              <a:rPr sz="800" b="0">
+                <a:solidFill>
+                  <a:srgbClr val="526071"/>
+                </a:solidFill>
+              </a:rPr>
+              <a:t>overflow policy</a:t>
+            </a:r>
+          </a:p>
+        </p:txBody>
+      </p:sp>
+      <p:sp>
+        <p:nvSpPr>
+          <p:cNvPr id="61" name="decorate_card"/>
+          <p:cNvSpPr/>
+          <p:nvPr/>
+        </p:nvSpPr>
+        <p:spPr>
+          <a:xfrm>
+            <a:off x="7571231" y="3566160"/>
+            <a:ext cx="1243584" cy="713232"/>
+          </a:xfrm>
+          <a:prstGeom prst="roundRect">
+            <a:avLst/>
+          </a:prstGeom>
+          <a:solidFill>
+            <a:srgbClr val="F8FAFC"/>
+          </a:solidFill>
+          <a:ln>
+            <a:solidFill>
+              <a:srgbClr val="BBF7D0"/>
+            </a:solidFill>
+          </a:ln>
+        </p:spPr>
+        <p:style>
+          <a:lnRef idx="1">
+            <a:schemeClr val="accent1"/>
+          </a:lnRef>
+          <a:fillRef idx="3">
+            <a:schemeClr val="accent1"/>
+          </a:fillRef>
+          <a:effectRef idx="2">
+            <a:schemeClr val="accent1"/>
+          </a:effectRef>
+          <a:fontRef idx="minor">
+            <a:schemeClr val="lt1"/>
+          </a:fontRef>
+        </p:style>
+        <p:txBody>
+          <a:bodyPr rtlCol="0" anchor="ctr"/>
+          <a:lstStyle/>
+          <a:p>
+            <a:pPr algn="ctr"/>
+          </a:p>
+        </p:txBody>
+      </p:sp>
+      <p:sp>
+        <p:nvSpPr>
+          <p:cNvPr id="62" name="decorate_dot"/>
+          <p:cNvSpPr/>
+          <p:nvPr/>
+        </p:nvSpPr>
+        <p:spPr>
+          <a:xfrm>
+            <a:off x="7717536" y="3730752"/>
+            <a:ext cx="164592" cy="164592"/>
+          </a:xfrm>
+          <a:prstGeom prst="ellipse">
+            <a:avLst/>
+          </a:prstGeom>
+          <a:solidFill>
+            <a:srgbClr val="86EFAC"/>
+          </a:solidFill>
+          <a:ln>
+            <a:solidFill>
+              <a:srgbClr val="86EFAC"/>
+            </a:solidFill>
+          </a:ln>
+        </p:spPr>
+        <p:style>
+          <a:lnRef idx="1">
+            <a:schemeClr val="accent1"/>
+          </a:lnRef>
+          <a:fillRef idx="3">
+            <a:schemeClr val="accent1"/>
+          </a:fillRef>
+          <a:effectRef idx="2">
+            <a:schemeClr val="accent1"/>
+          </a:effectRef>
+          <a:fontRef idx="minor">
+            <a:schemeClr val="lt1"/>
+          </a:fontRef>
+        </p:style>
+        <p:txBody>
+          <a:bodyPr rtlCol="0" anchor="ctr"/>
+          <a:lstStyle/>
+          <a:p>
+            <a:pPr algn="ctr"/>
+          </a:p>
+        </p:txBody>
+      </p:sp>
+      <p:sp>
+        <p:nvSpPr>
+          <p:cNvPr id="63" name="decorate_title"/>
+          <p:cNvSpPr txBox="1"/>
+          <p:nvPr/>
+        </p:nvSpPr>
+        <p:spPr>
+          <a:xfrm>
+            <a:off x="7955279" y="3685032"/>
+            <a:ext cx="713232" cy="201168"/>
+          </a:xfrm>
+          <a:prstGeom prst="rect">
+            <a:avLst/>
+          </a:prstGeom>
+          <a:noFill/>
+        </p:spPr>
+        <p:txBody>
+          <a:bodyPr wrap="square" lIns="0" rIns="0" tIns="0" bIns="0">
+            <a:spAutoFit/>
+          </a:bodyPr>
+          <a:lstStyle/>
+          <a:p>
+            <a:pPr algn="l"/>
+            <a:r>
+              <a:rPr sz="1100" b="1">
+                <a:solidFill>
+                  <a:srgbClr val="111827"/>
+                </a:solidFill>
+              </a:rPr>
+              <a:t>Decorate</a:t>
+            </a:r>
+          </a:p>
+        </p:txBody>
+      </p:sp>
+      <p:sp>
+        <p:nvSpPr>
+          <p:cNvPr id="64" name="decorate_line_0"/>
+          <p:cNvSpPr txBox="1"/>
+          <p:nvPr/>
+        </p:nvSpPr>
+        <p:spPr>
+          <a:xfrm>
+            <a:off x="7772400" y="3968496"/>
+            <a:ext cx="859536" cy="109728"/>
+          </a:xfrm>
+          <a:prstGeom prst="rect">
+            <a:avLst/>
+          </a:prstGeom>
+          <a:noFill/>
+        </p:spPr>
+        <p:txBody>
+          <a:bodyPr wrap="square" lIns="0" rIns="0" tIns="0" bIns="0">
+            <a:spAutoFit/>
+          </a:bodyPr>
+          <a:lstStyle/>
+          <a:p>
+            <a:pPr algn="l"/>
+            <a:r>
+              <a:rPr sz="800" b="0">
+                <a:solidFill>
+                  <a:srgbClr val="526071"/>
+                </a:solidFill>
+              </a:rPr>
+              <a:t>type, radius</a:t>
+            </a:r>
+          </a:p>
+        </p:txBody>
+      </p:sp>
+      <p:sp>
+        <p:nvSpPr>
+          <p:cNvPr id="65" name="decorate_line_1"/>
+          <p:cNvSpPr txBox="1"/>
+          <p:nvPr/>
+        </p:nvSpPr>
+        <p:spPr>
+          <a:xfrm>
+            <a:off x="7772400" y="4078224"/>
+            <a:ext cx="859536" cy="109728"/>
+          </a:xfrm>
+          <a:prstGeom prst="rect">
+            <a:avLst/>
+          </a:prstGeom>
+          <a:noFill/>
+        </p:spPr>
+        <p:txBody>
+          <a:bodyPr wrap="square" lIns="0" rIns="0" tIns="0" bIns="0">
+            <a:spAutoFit/>
+          </a:bodyPr>
+          <a:lstStyle/>
+          <a:p>
+            <a:pPr algn="l"/>
+            <a:r>
+              <a:rPr sz="800" b="0">
+                <a:solidFill>
+                  <a:srgbClr val="526071"/>
+                </a:solidFill>
+              </a:rPr>
+              <a:t>shadow, effects</a:t>
+            </a:r>
+          </a:p>
+        </p:txBody>
+      </p:sp>
+      <p:cxnSp>
+        <p:nvCxnSpPr>
+          <p:cNvPr id="66" name="main_ir_rules"/>
+          <p:cNvCxnSpPr/>
+          <p:nvPr/>
+        </p:nvCxnSpPr>
+        <p:spPr>
+          <a:xfrm>
+            <a:off x="5321808" y="1993392"/>
+            <a:ext cx="768096" cy="0"/>
+          </a:xfrm>
+          <a:prstGeom prst="line">
+            <a:avLst/>
+          </a:prstGeom>
+          <a:ln w="53340">
+            <a:solidFill>
+              <a:srgbClr val="111827"/>
+            </a:solidFill>
+          </a:ln>
+        </p:spPr>
+        <p:style>
+          <a:lnRef idx="2">
+            <a:schemeClr val="accent1"/>
+          </a:lnRef>
+          <a:fillRef idx="0">
+            <a:schemeClr val="accent1"/>
+          </a:fillRef>
+          <a:effectRef idx="1">
+            <a:schemeClr val="accent1"/>
+          </a:effectRef>
+          <a:fontRef idx="minor">
+            <a:schemeClr val="tx1"/>
+          </a:fontRef>
+        </p:style>
+      </p:cxnSp>
+      <p:cxnSp>
+        <p:nvCxnSpPr>
+          <p:cNvPr id="67" name="hint_reasoning_rules"/>
+          <p:cNvCxnSpPr/>
+          <p:nvPr/>
+        </p:nvCxnSpPr>
+        <p:spPr>
+          <a:xfrm flipV="1">
+            <a:off x="5340096" y="2962656"/>
+            <a:ext cx="749808" cy="384048"/>
+          </a:xfrm>
+          <a:prstGeom prst="line">
+            <a:avLst/>
+          </a:prstGeom>
+          <a:ln w="27940">
+            <a:solidFill>
+              <a:srgbClr val="2563EB"/>
+            </a:solidFill>
+            <a:prstDash val="dash"/>
+          </a:ln>
+        </p:spPr>
+        <p:style>
+          <a:lnRef idx="2">
+            <a:schemeClr val="accent1"/>
+          </a:lnRef>
+          <a:fillRef idx="0">
+            <a:schemeClr val="accent1"/>
+          </a:fillRef>
+          <a:effectRef idx="1">
+            <a:schemeClr val="accent1"/>
+          </a:effectRef>
+          <a:fontRef idx="minor">
+            <a:schemeClr val="tx1"/>
+          </a:fontRef>
+        </p:style>
+      </p:cxnSp>
+      <p:cxnSp>
+        <p:nvCxnSpPr>
+          <p:cNvPr id="68" name="rule_features_recipes"/>
+          <p:cNvCxnSpPr/>
+          <p:nvPr/>
+        </p:nvCxnSpPr>
+        <p:spPr>
+          <a:xfrm>
+            <a:off x="7333488" y="2953512"/>
+            <a:ext cx="237743" cy="0"/>
+          </a:xfrm>
+          <a:prstGeom prst="line">
+            <a:avLst/>
+          </a:prstGeom>
+          <a:ln w="21590">
+            <a:solidFill>
+              <a:srgbClr val="16A34A"/>
+            </a:solidFill>
+          </a:ln>
+        </p:spPr>
+        <p:style>
+          <a:lnRef idx="2">
+            <a:schemeClr val="accent1"/>
+          </a:lnRef>
+          <a:fillRef idx="0">
+            <a:schemeClr val="accent1"/>
+          </a:fillRef>
+          <a:effectRef idx="1">
+            <a:schemeClr val="accent1"/>
+          </a:effectRef>
+          <a:fontRef idx="minor">
+            <a:schemeClr val="tx1"/>
+          </a:fontRef>
+        </p:style>
+      </p:cxnSp>
+      <p:cxnSp>
+        <p:nvCxnSpPr>
+          <p:cNvPr id="69" name="rule_features_compose"/>
+          <p:cNvCxnSpPr/>
+          <p:nvPr/>
+        </p:nvCxnSpPr>
+        <p:spPr>
+          <a:xfrm>
+            <a:off x="6711696" y="3310128"/>
+            <a:ext cx="0" cy="256032"/>
+          </a:xfrm>
+          <a:prstGeom prst="line">
+            <a:avLst/>
+          </a:prstGeom>
+          <a:ln w="17780">
+            <a:solidFill>
+              <a:srgbClr val="16A34A"/>
+            </a:solidFill>
+          </a:ln>
+        </p:spPr>
+        <p:style>
+          <a:lnRef idx="2">
+            <a:schemeClr val="accent1"/>
+          </a:lnRef>
+          <a:fillRef idx="0">
+            <a:schemeClr val="accent1"/>
+          </a:fillRef>
+          <a:effectRef idx="1">
+            <a:schemeClr val="accent1"/>
+          </a:effectRef>
+          <a:fontRef idx="minor">
+            <a:schemeClr val="tx1"/>
+          </a:fontRef>
+        </p:style>
+      </p:cxnSp>
+      <p:cxnSp>
+        <p:nvCxnSpPr>
+          <p:cNvPr id="70" name="rule_recipes_decorate"/>
+          <p:cNvCxnSpPr/>
+          <p:nvPr/>
+        </p:nvCxnSpPr>
+        <p:spPr>
+          <a:xfrm>
+            <a:off x="8193024" y="3310128"/>
+            <a:ext cx="0" cy="256032"/>
+          </a:xfrm>
+          <a:prstGeom prst="line">
+            <a:avLst/>
+          </a:prstGeom>
+          <a:ln w="17780">
+            <a:solidFill>
+              <a:srgbClr val="16A34A"/>
+            </a:solidFill>
+          </a:ln>
+        </p:spPr>
+        <p:style>
+          <a:lnRef idx="2">
+            <a:schemeClr val="accent1"/>
+          </a:lnRef>
+          <a:fillRef idx="0">
+            <a:schemeClr val="accent1"/>
+          </a:fillRef>
+          <a:effectRef idx="1">
+            <a:schemeClr val="accent1"/>
+          </a:effectRef>
+          <a:fontRef idx="minor">
+            <a:schemeClr val="tx1"/>
+          </a:fontRef>
+        </p:style>
+      </p:cxnSp>
+      <p:cxnSp>
+        <p:nvCxnSpPr>
+          <p:cNvPr id="71" name="rule_compose_decorate"/>
+          <p:cNvCxnSpPr/>
+          <p:nvPr/>
+        </p:nvCxnSpPr>
+        <p:spPr>
+          <a:xfrm>
+            <a:off x="7333488" y="3922776"/>
+            <a:ext cx="237743" cy="0"/>
+          </a:xfrm>
+          <a:prstGeom prst="line">
+            <a:avLst/>
+          </a:prstGeom>
+          <a:ln w="21590">
+            <a:solidFill>
+              <a:srgbClr val="16A34A"/>
+            </a:solidFill>
+          </a:ln>
+        </p:spPr>
+        <p:style>
+          <a:lnRef idx="2">
+            <a:schemeClr val="accent1"/>
+          </a:lnRef>
+          <a:fillRef idx="0">
+            <a:schemeClr val="accent1"/>
+          </a:fillRef>
+          <a:effectRef idx="1">
+            <a:schemeClr val="accent1"/>
+          </a:effectRef>
+          <a:fontRef idx="minor">
+            <a:schemeClr val="tx1"/>
+          </a:fontRef>
+        </p:style>
+      </p:cxnSp>
+      <p:sp>
+        <p:nvSpPr>
+          <p:cNvPr id="72" name="styled_ir_card"/>
+          <p:cNvSpPr/>
+          <p:nvPr/>
+        </p:nvSpPr>
+        <p:spPr>
+          <a:xfrm>
+            <a:off x="9528048" y="1664208"/>
+            <a:ext cx="1517904" cy="841248"/>
           </a:xfrm>
           <a:prstGeom prst="roundRect">
             <a:avLst/>
@@ -3813,13 +5780,13 @@
       </p:sp>
       <p:sp>
         <p:nvSpPr>
-          <p:cNvPr id="21" name="ir_dot"/>
+          <p:cNvPr id="73" name="styled_ir_dot"/>
           <p:cNvSpPr/>
           <p:nvPr/>
         </p:nvSpPr>
         <p:spPr>
           <a:xfrm>
-            <a:off x="5193792" y="1719072"/>
+            <a:off x="9674352" y="1828800"/>
             <a:ext cx="164592" cy="164592"/>
           </a:xfrm>
           <a:prstGeom prst="ellipse">
@@ -3858,14 +5825,14 @@
       </p:sp>
       <p:sp>
         <p:nvSpPr>
-          <p:cNvPr id="22" name="ir_title"/>
+          <p:cNvPr id="74" name="styled_ir_title"/>
           <p:cNvSpPr txBox="1"/>
           <p:nvPr/>
         </p:nvSpPr>
         <p:spPr>
           <a:xfrm>
-            <a:off x="5431536" y="1673352"/>
-            <a:ext cx="1316736" cy="201168"/>
+            <a:off x="9912096" y="1783080"/>
+            <a:ext cx="987552" cy="201168"/>
           </a:xfrm>
           <a:prstGeom prst="rect">
             <a:avLst/>
@@ -3885,21 +5852,21 @@
                   <a:srgbClr val="111827"/>
                 </a:solidFill>
               </a:rPr>
-              <a:t>Slide Element IR</a:t>
-            </a:r>
-          </a:p>
-        </p:txBody>
-      </p:sp>
-      <p:sp>
-        <p:nvSpPr>
-          <p:cNvPr id="23" name="ir_line_0"/>
+              <a:t>Styled Deck IR</a:t>
+            </a:r>
+          </a:p>
+        </p:txBody>
+      </p:sp>
+      <p:sp>
+        <p:nvSpPr>
+          <p:cNvPr id="75" name="styled_ir_line_0"/>
           <p:cNvSpPr txBox="1"/>
           <p:nvPr/>
         </p:nvSpPr>
         <p:spPr>
           <a:xfrm>
-            <a:off x="5248655" y="1956816"/>
-            <a:ext cx="1463040" cy="146304"/>
+            <a:off x="9729216" y="2066544"/>
+            <a:ext cx="1133856" cy="146303"/>
           </a:xfrm>
           <a:prstGeom prst="rect">
             <a:avLst/>
@@ -3919,21 +5886,21 @@
                   <a:srgbClr val="526071"/>
                 </a:solidFill>
               </a:rPr>
-              <a:t>content-only contract</a:t>
-            </a:r>
-          </a:p>
-        </p:txBody>
-      </p:sp>
-      <p:sp>
-        <p:nvSpPr>
-          <p:cNvPr id="24" name="ir_line_1"/>
+              <a:t>renderer-neutral</a:t>
+            </a:r>
+          </a:p>
+        </p:txBody>
+      </p:sp>
+      <p:sp>
+        <p:nvSpPr>
+          <p:cNvPr id="76" name="styled_ir_line_1"/>
           <p:cNvSpPr txBox="1"/>
           <p:nvPr/>
         </p:nvSpPr>
         <p:spPr>
           <a:xfrm>
-            <a:off x="5248655" y="2121408"/>
-            <a:ext cx="1463040" cy="146304"/>
+            <a:off x="9729216" y="2231136"/>
+            <a:ext cx="1133856" cy="146303"/>
           </a:xfrm>
           <a:prstGeom prst="rect">
             <a:avLst/>
@@ -3953,28 +5920,299 @@
                   <a:srgbClr val="526071"/>
                 </a:solidFill>
               </a:rPr>
-              <a:t>for downstream rules</a:t>
+              <a:t>visual contract</a:t>
+            </a:r>
+          </a:p>
+        </p:txBody>
+      </p:sp>
+      <p:sp>
+        <p:nvSpPr>
+          <p:cNvPr id="77" name="renderers_card"/>
+          <p:cNvSpPr/>
+          <p:nvPr/>
+        </p:nvSpPr>
+        <p:spPr>
+          <a:xfrm>
+            <a:off x="9528048" y="2816352"/>
+            <a:ext cx="1517904" cy="859536"/>
+          </a:xfrm>
+          <a:prstGeom prst="roundRect">
+            <a:avLst/>
+          </a:prstGeom>
+          <a:solidFill>
+            <a:srgbClr val="F8FAFC"/>
+          </a:solidFill>
+          <a:ln>
+            <a:solidFill>
+              <a:srgbClr val="CBD5E1"/>
+            </a:solidFill>
+          </a:ln>
+        </p:spPr>
+        <p:style>
+          <a:lnRef idx="1">
+            <a:schemeClr val="accent1"/>
+          </a:lnRef>
+          <a:fillRef idx="3">
+            <a:schemeClr val="accent1"/>
+          </a:fillRef>
+          <a:effectRef idx="2">
+            <a:schemeClr val="accent1"/>
+          </a:effectRef>
+          <a:fontRef idx="minor">
+            <a:schemeClr val="lt1"/>
+          </a:fontRef>
+        </p:style>
+        <p:txBody>
+          <a:bodyPr rtlCol="0" anchor="ctr"/>
+          <a:lstStyle/>
+          <a:p>
+            <a:pPr algn="ctr"/>
+          </a:p>
+        </p:txBody>
+      </p:sp>
+      <p:sp>
+        <p:nvSpPr>
+          <p:cNvPr id="78" name="renderers_dot"/>
+          <p:cNvSpPr/>
+          <p:nvPr/>
+        </p:nvSpPr>
+        <p:spPr>
+          <a:xfrm>
+            <a:off x="9674352" y="2980944"/>
+            <a:ext cx="164592" cy="164592"/>
+          </a:xfrm>
+          <a:prstGeom prst="ellipse">
+            <a:avLst/>
+          </a:prstGeom>
+          <a:solidFill>
+            <a:srgbClr val="CBD5E1"/>
+          </a:solidFill>
+          <a:ln>
+            <a:solidFill>
+              <a:srgbClr val="CBD5E1"/>
+            </a:solidFill>
+          </a:ln>
+        </p:spPr>
+        <p:style>
+          <a:lnRef idx="1">
+            <a:schemeClr val="accent1"/>
+          </a:lnRef>
+          <a:fillRef idx="3">
+            <a:schemeClr val="accent1"/>
+          </a:fillRef>
+          <a:effectRef idx="2">
+            <a:schemeClr val="accent1"/>
+          </a:effectRef>
+          <a:fontRef idx="minor">
+            <a:schemeClr val="lt1"/>
+          </a:fontRef>
+        </p:style>
+        <p:txBody>
+          <a:bodyPr rtlCol="0" anchor="ctr"/>
+          <a:lstStyle/>
+          <a:p>
+            <a:pPr algn="ctr"/>
+          </a:p>
+        </p:txBody>
+      </p:sp>
+      <p:sp>
+        <p:nvSpPr>
+          <p:cNvPr id="79" name="renderers_title"/>
+          <p:cNvSpPr txBox="1"/>
+          <p:nvPr/>
+        </p:nvSpPr>
+        <p:spPr>
+          <a:xfrm>
+            <a:off x="9912096" y="2935224"/>
+            <a:ext cx="987552" cy="201168"/>
+          </a:xfrm>
+          <a:prstGeom prst="rect">
+            <a:avLst/>
+          </a:prstGeom>
+          <a:noFill/>
+        </p:spPr>
+        <p:txBody>
+          <a:bodyPr wrap="square" lIns="0" rIns="0" tIns="0" bIns="0">
+            <a:spAutoFit/>
+          </a:bodyPr>
+          <a:lstStyle/>
+          <a:p>
+            <a:pPr algn="l"/>
+            <a:r>
+              <a:rPr sz="1100" b="1">
+                <a:solidFill>
+                  <a:srgbClr val="111827"/>
+                </a:solidFill>
+              </a:rPr>
+              <a:t>Renderers</a:t>
+            </a:r>
+          </a:p>
+        </p:txBody>
+      </p:sp>
+      <p:sp>
+        <p:nvSpPr>
+          <p:cNvPr id="80" name="renderers_line_0"/>
+          <p:cNvSpPr txBox="1"/>
+          <p:nvPr/>
+        </p:nvSpPr>
+        <p:spPr>
+          <a:xfrm>
+            <a:off x="9729216" y="3218688"/>
+            <a:ext cx="1133856" cy="146304"/>
+          </a:xfrm>
+          <a:prstGeom prst="rect">
+            <a:avLst/>
+          </a:prstGeom>
+          <a:noFill/>
+        </p:spPr>
+        <p:txBody>
+          <a:bodyPr wrap="square" lIns="0" rIns="0" tIns="0" bIns="0">
+            <a:spAutoFit/>
+          </a:bodyPr>
+          <a:lstStyle/>
+          <a:p>
+            <a:pPr algn="l"/>
+            <a:r>
+              <a:rPr sz="800" b="0">
+                <a:solidFill>
+                  <a:srgbClr val="526071"/>
+                </a:solidFill>
+              </a:rPr>
+              <a:t>editable PPTX</a:t>
+            </a:r>
+          </a:p>
+        </p:txBody>
+      </p:sp>
+      <p:sp>
+        <p:nvSpPr>
+          <p:cNvPr id="81" name="renderers_line_1"/>
+          <p:cNvSpPr txBox="1"/>
+          <p:nvPr/>
+        </p:nvSpPr>
+        <p:spPr>
+          <a:xfrm>
+            <a:off x="9729216" y="3383280"/>
+            <a:ext cx="1133856" cy="146304"/>
+          </a:xfrm>
+          <a:prstGeom prst="rect">
+            <a:avLst/>
+          </a:prstGeom>
+          <a:noFill/>
+        </p:spPr>
+        <p:txBody>
+          <a:bodyPr wrap="square" lIns="0" rIns="0" tIns="0" bIns="0">
+            <a:spAutoFit/>
+          </a:bodyPr>
+          <a:lstStyle/>
+          <a:p>
+            <a:pPr algn="l"/>
+            <a:r>
+              <a:rPr sz="800" b="0">
+                <a:solidFill>
+                  <a:srgbClr val="526071"/>
+                </a:solidFill>
+              </a:rPr>
+              <a:t>HTML and PDF</a:t>
+            </a:r>
+          </a:p>
+        </p:txBody>
+      </p:sp>
+      <p:sp>
+        <p:nvSpPr>
+          <p:cNvPr id="82" name="visual_check"/>
+          <p:cNvSpPr/>
+          <p:nvPr/>
+        </p:nvSpPr>
+        <p:spPr>
+          <a:xfrm>
+            <a:off x="9528048" y="3968496"/>
+            <a:ext cx="1517904" cy="384048"/>
+          </a:xfrm>
+          <a:prstGeom prst="roundRect">
+            <a:avLst/>
+          </a:prstGeom>
+          <a:solidFill>
+            <a:srgbClr val="FEF3C7"/>
+          </a:solidFill>
+          <a:ln>
+            <a:solidFill>
+              <a:srgbClr val="F59E0B"/>
+            </a:solidFill>
+          </a:ln>
+        </p:spPr>
+        <p:style>
+          <a:lnRef idx="1">
+            <a:schemeClr val="accent1"/>
+          </a:lnRef>
+          <a:fillRef idx="3">
+            <a:schemeClr val="accent1"/>
+          </a:fillRef>
+          <a:effectRef idx="2">
+            <a:schemeClr val="accent1"/>
+          </a:effectRef>
+          <a:fontRef idx="minor">
+            <a:schemeClr val="lt1"/>
+          </a:fontRef>
+        </p:style>
+        <p:txBody>
+          <a:bodyPr rtlCol="0" anchor="ctr"/>
+          <a:lstStyle/>
+          <a:p>
+            <a:pPr algn="ctr"/>
+          </a:p>
+        </p:txBody>
+      </p:sp>
+      <p:sp>
+        <p:nvSpPr>
+          <p:cNvPr id="83" name="visual_check_title"/>
+          <p:cNvSpPr txBox="1"/>
+          <p:nvPr/>
+        </p:nvSpPr>
+        <p:spPr>
+          <a:xfrm>
+            <a:off x="9710928" y="4105656"/>
+            <a:ext cx="1078992" cy="109728"/>
+          </a:xfrm>
+          <a:prstGeom prst="rect">
+            <a:avLst/>
+          </a:prstGeom>
+          <a:noFill/>
+        </p:spPr>
+        <p:txBody>
+          <a:bodyPr wrap="square" lIns="0" rIns="0" tIns="0" bIns="0">
+            <a:spAutoFit/>
+          </a:bodyPr>
+          <a:lstStyle/>
+          <a:p>
+            <a:pPr algn="l"/>
+            <a:r>
+              <a:rPr sz="800" b="1">
+                <a:solidFill>
+                  <a:srgbClr val="92400E"/>
+                </a:solidFill>
+              </a:rPr>
+              <a:t>visual validation</a:t>
             </a:r>
           </a:p>
         </p:txBody>
       </p:sp>
       <p:cxnSp>
         <p:nvCxnSpPr>
-          <p:cNvPr id="25" name="arrow_markdown_splitter"/>
+          <p:cNvPr id="84" name="main_rules_styled_ir"/>
           <p:cNvCxnSpPr/>
           <p:nvPr/>
         </p:nvCxnSpPr>
         <p:spPr>
           <a:xfrm>
-            <a:off x="2450592" y="2057400"/>
-            <a:ext cx="347472" cy="0"/>
+            <a:off x="8759952" y="1993392"/>
+            <a:ext cx="768096" cy="0"/>
           </a:xfrm>
           <a:prstGeom prst="line">
             <a:avLst/>
           </a:prstGeom>
-          <a:ln w="22860">
+          <a:ln w="53340">
             <a:solidFill>
-              <a:srgbClr val="475569"/>
+              <a:srgbClr val="111827"/>
             </a:solidFill>
           </a:ln>
         </p:spPr>
@@ -3995,284 +6233,22 @@
       </p:cxnSp>
       <p:cxnSp>
         <p:nvCxnSpPr>
-          <p:cNvPr id="26" name="arrow_splitter_ir"/>
+          <p:cNvPr id="85" name="main_styled_renderers"/>
           <p:cNvCxnSpPr/>
           <p:nvPr/>
         </p:nvCxnSpPr>
         <p:spPr>
           <a:xfrm>
-            <a:off x="4700016" y="2057400"/>
-            <a:ext cx="310896" cy="0"/>
+            <a:off x="10287000" y="2505456"/>
+            <a:ext cx="0" cy="310896"/>
           </a:xfrm>
           <a:prstGeom prst="line">
             <a:avLst/>
           </a:prstGeom>
-          <a:ln w="22860">
+          <a:ln w="30480">
             <a:solidFill>
               <a:srgbClr val="475569"/>
             </a:solidFill>
-          </a:ln>
-        </p:spPr>
-        <p:style>
-          <a:lnRef idx="2">
-            <a:schemeClr val="accent1"/>
-          </a:lnRef>
-          <a:fillRef idx="0">
-            <a:schemeClr val="accent1"/>
-          </a:fillRef>
-          <a:effectRef idx="1">
-            <a:schemeClr val="accent1"/>
-          </a:effectRef>
-          <a:fontRef idx="minor">
-            <a:schemeClr val="tx1"/>
-          </a:fontRef>
-        </p:style>
-      </p:cxnSp>
-      <p:sp>
-        <p:nvSpPr>
-          <p:cNvPr id="27" name="llm_card"/>
-          <p:cNvSpPr/>
-          <p:nvPr/>
-        </p:nvSpPr>
-        <p:spPr>
-          <a:xfrm>
-            <a:off x="2615184" y="3127248"/>
-            <a:ext cx="2852928" cy="1051560"/>
-          </a:xfrm>
-          <a:prstGeom prst="roundRect">
-            <a:avLst/>
-          </a:prstGeom>
-          <a:solidFill>
-            <a:srgbClr val="EFF6FF"/>
-          </a:solidFill>
-          <a:ln>
-            <a:solidFill>
-              <a:srgbClr val="93C5FD"/>
-            </a:solidFill>
-          </a:ln>
-        </p:spPr>
-        <p:style>
-          <a:lnRef idx="1">
-            <a:schemeClr val="accent1"/>
-          </a:lnRef>
-          <a:fillRef idx="3">
-            <a:schemeClr val="accent1"/>
-          </a:fillRef>
-          <a:effectRef idx="2">
-            <a:schemeClr val="accent1"/>
-          </a:effectRef>
-          <a:fontRef idx="minor">
-            <a:schemeClr val="lt1"/>
-          </a:fontRef>
-        </p:style>
-        <p:txBody>
-          <a:bodyPr rtlCol="0" anchor="ctr"/>
-          <a:lstStyle/>
-          <a:p>
-            <a:pPr algn="ctr"/>
-          </a:p>
-        </p:txBody>
-      </p:sp>
-      <p:sp>
-        <p:nvSpPr>
-          <p:cNvPr id="28" name="llm_title"/>
-          <p:cNvSpPr txBox="1"/>
-          <p:nvPr/>
-        </p:nvSpPr>
-        <p:spPr>
-          <a:xfrm>
-            <a:off x="2852928" y="3337560"/>
-            <a:ext cx="1572768" cy="219456"/>
-          </a:xfrm>
-          <a:prstGeom prst="rect">
-            <a:avLst/>
-          </a:prstGeom>
-          <a:noFill/>
-        </p:spPr>
-        <p:txBody>
-          <a:bodyPr wrap="square" lIns="0" rIns="0" tIns="0" bIns="0">
-            <a:spAutoFit/>
-          </a:bodyPr>
-          <a:lstStyle/>
-          <a:p>
-            <a:pPr algn="l"/>
-            <a:r>
-              <a:rPr sz="1200" b="1">
-                <a:solidFill>
-                  <a:srgbClr val="111827"/>
-                </a:solidFill>
-              </a:rPr>
-              <a:t>LLM Assistant</a:t>
-            </a:r>
-          </a:p>
-        </p:txBody>
-      </p:sp>
-      <p:sp>
-        <p:nvSpPr>
-          <p:cNvPr id="29" name="llm_body"/>
-          <p:cNvSpPr txBox="1"/>
-          <p:nvPr/>
-        </p:nvSpPr>
-        <p:spPr>
-          <a:xfrm>
-            <a:off x="2852928" y="3621024"/>
-            <a:ext cx="2139696" cy="201168"/>
-          </a:xfrm>
-          <a:prstGeom prst="rect">
-            <a:avLst/>
-          </a:prstGeom>
-          <a:noFill/>
-        </p:spPr>
-        <p:txBody>
-          <a:bodyPr wrap="square" lIns="0" rIns="0" tIns="0" bIns="0">
-            <a:spAutoFit/>
-          </a:bodyPr>
-          <a:lstStyle/>
-          <a:p>
-            <a:pPr algn="l"/>
-            <a:r>
-              <a:rPr sz="800" b="0">
-                <a:solidFill>
-                  <a:srgbClr val="526071"/>
-                </a:solidFill>
-              </a:rPr>
-              <a:t>Intent, grouping, and importance candidates.</a:t>
-            </a:r>
-          </a:p>
-        </p:txBody>
-      </p:sp>
-      <p:sp>
-        <p:nvSpPr>
-          <p:cNvPr id="30" name="llm_badge"/>
-          <p:cNvSpPr/>
-          <p:nvPr/>
-        </p:nvSpPr>
-        <p:spPr>
-          <a:xfrm>
-            <a:off x="4462272" y="3273552"/>
-            <a:ext cx="713232" cy="219456"/>
-          </a:xfrm>
-          <a:prstGeom prst="roundRect">
-            <a:avLst/>
-          </a:prstGeom>
-          <a:solidFill>
-            <a:srgbClr val="2563EB"/>
-          </a:solidFill>
-          <a:ln>
-            <a:solidFill>
-              <a:srgbClr val="2563EB"/>
-            </a:solidFill>
-          </a:ln>
-        </p:spPr>
-        <p:style>
-          <a:lnRef idx="1">
-            <a:schemeClr val="accent1"/>
-          </a:lnRef>
-          <a:fillRef idx="3">
-            <a:schemeClr val="accent1"/>
-          </a:fillRef>
-          <a:effectRef idx="2">
-            <a:schemeClr val="accent1"/>
-          </a:effectRef>
-          <a:fontRef idx="minor">
-            <a:schemeClr val="lt1"/>
-          </a:fontRef>
-        </p:style>
-        <p:txBody>
-          <a:bodyPr rtlCol="0" anchor="ctr"/>
-          <a:lstStyle/>
-          <a:p>
-            <a:pPr algn="ctr"/>
-          </a:p>
-        </p:txBody>
-      </p:sp>
-      <p:sp>
-        <p:nvSpPr>
-          <p:cNvPr id="31" name="llm_badge_text"/>
-          <p:cNvSpPr txBox="1"/>
-          <p:nvPr/>
-        </p:nvSpPr>
-        <p:spPr>
-          <a:xfrm>
-            <a:off x="4608576" y="3328416"/>
-            <a:ext cx="438912" cy="109728"/>
-          </a:xfrm>
-          <a:prstGeom prst="rect">
-            <a:avLst/>
-          </a:prstGeom>
-          <a:noFill/>
-        </p:spPr>
-        <p:txBody>
-          <a:bodyPr wrap="square" lIns="0" rIns="0" tIns="0" bIns="0">
-            <a:spAutoFit/>
-          </a:bodyPr>
-          <a:lstStyle/>
-          <a:p>
-            <a:pPr algn="l"/>
-            <a:r>
-              <a:rPr sz="800" b="1">
-                <a:solidFill>
-                  <a:srgbClr val="FFFFFF"/>
-                </a:solidFill>
-              </a:rPr>
-              <a:t>hints</a:t>
-            </a:r>
-          </a:p>
-        </p:txBody>
-      </p:sp>
-      <p:sp>
-        <p:nvSpPr>
-          <p:cNvPr id="32" name="llm_boundary"/>
-          <p:cNvSpPr txBox="1"/>
-          <p:nvPr/>
-        </p:nvSpPr>
-        <p:spPr>
-          <a:xfrm>
-            <a:off x="2852928" y="3895344"/>
-            <a:ext cx="2286000" cy="164592"/>
-          </a:xfrm>
-          <a:prstGeom prst="rect">
-            <a:avLst/>
-          </a:prstGeom>
-          <a:noFill/>
-        </p:spPr>
-        <p:txBody>
-          <a:bodyPr wrap="square" lIns="0" rIns="0" tIns="0" bIns="0">
-            <a:spAutoFit/>
-          </a:bodyPr>
-          <a:lstStyle/>
-          <a:p>
-            <a:pPr algn="l"/>
-            <a:r>
-              <a:rPr sz="800" b="1">
-                <a:solidFill>
-                  <a:srgbClr val="64748B"/>
-                </a:solidFill>
-              </a:rPr>
-              <a:t>No coordinates, colors, variants, or z-order.</a:t>
-            </a:r>
-          </a:p>
-        </p:txBody>
-      </p:sp>
-      <p:cxnSp>
-        <p:nvCxnSpPr>
-          <p:cNvPr id="33" name="hint_ir_llm"/>
-          <p:cNvCxnSpPr/>
-          <p:nvPr/>
-        </p:nvCxnSpPr>
-        <p:spPr>
-          <a:xfrm flipH="1">
-            <a:off x="5029200" y="2615184"/>
-            <a:ext cx="786384" cy="0"/>
-          </a:xfrm>
-          <a:prstGeom prst="line">
-            <a:avLst/>
-          </a:prstGeom>
-          <a:ln w="22860">
-            <a:solidFill>
-              <a:srgbClr val="2563EB"/>
-            </a:solidFill>
-            <a:prstDash val="dash"/>
           </a:ln>
         </p:spPr>
         <p:style>
@@ -4292,23 +6268,22 @@
       </p:cxnSp>
       <p:cxnSp>
         <p:nvCxnSpPr>
-          <p:cNvPr id="34" name="hint_llm_rules"/>
+          <p:cNvPr id="86" name="validation_loop"/>
           <p:cNvCxnSpPr/>
           <p:nvPr/>
         </p:nvCxnSpPr>
         <p:spPr>
           <a:xfrm>
-            <a:off x="5468112" y="3657600"/>
-            <a:ext cx="585216" cy="0"/>
+            <a:off x="10287000" y="3675887"/>
+            <a:ext cx="0" cy="292609"/>
           </a:xfrm>
           <a:prstGeom prst="line">
             <a:avLst/>
           </a:prstGeom>
-          <a:ln w="22860">
+          <a:ln w="25400">
             <a:solidFill>
-              <a:srgbClr val="2563EB"/>
+              <a:srgbClr val="F59E0B"/>
             </a:solidFill>
-            <a:prstDash val="dash"/>
           </a:ln>
         </p:spPr>
         <p:style>
@@ -4328,1533 +6303,14 @@
       </p:cxnSp>
       <p:sp>
         <p:nvSpPr>
-          <p:cNvPr id="35" name="rule_boundary"/>
+          <p:cNvPr id="87" name="coherence_band"/>
           <p:cNvSpPr/>
           <p:nvPr/>
         </p:nvSpPr>
         <p:spPr>
           <a:xfrm>
-            <a:off x="6309360" y="1481328"/>
-            <a:ext cx="3328416" cy="3054096"/>
-          </a:xfrm>
-          <a:prstGeom prst="roundRect">
-            <a:avLst/>
-          </a:prstGeom>
-          <a:solidFill>
-            <a:srgbClr val="EEF7F1"/>
-          </a:solidFill>
-          <a:ln>
-            <a:solidFill>
-              <a:srgbClr val="86EFAC"/>
-            </a:solidFill>
-          </a:ln>
-        </p:spPr>
-        <p:style>
-          <a:lnRef idx="1">
-            <a:schemeClr val="accent1"/>
-          </a:lnRef>
-          <a:fillRef idx="3">
-            <a:schemeClr val="accent1"/>
-          </a:fillRef>
-          <a:effectRef idx="2">
-            <a:schemeClr val="accent1"/>
-          </a:effectRef>
-          <a:fontRef idx="minor">
-            <a:schemeClr val="lt1"/>
-          </a:fontRef>
-        </p:style>
-        <p:txBody>
-          <a:bodyPr rtlCol="0" anchor="ctr"/>
-          <a:lstStyle/>
-          <a:p>
-            <a:pPr algn="ctr"/>
-          </a:p>
-        </p:txBody>
-      </p:sp>
-      <p:sp>
-        <p:nvSpPr>
-          <p:cNvPr id="36" name="rule_boundary_title"/>
-          <p:cNvSpPr txBox="1"/>
-          <p:nvPr/>
-        </p:nvSpPr>
-        <p:spPr>
-          <a:xfrm>
-            <a:off x="6583680" y="1783080"/>
-            <a:ext cx="2706624" cy="201168"/>
-          </a:xfrm>
-          <a:prstGeom prst="rect">
-            <a:avLst/>
-          </a:prstGeom>
-          <a:noFill/>
-        </p:spPr>
-        <p:txBody>
-          <a:bodyPr wrap="square" lIns="0" rIns="0" tIns="0" bIns="0">
-            <a:spAutoFit/>
-          </a:bodyPr>
-          <a:lstStyle/>
-          <a:p>
-            <a:pPr algn="l"/>
-            <a:r>
-              <a:rPr sz="800" b="1">
-                <a:solidFill>
-                  <a:srgbClr val="15803D"/>
-                </a:solidFill>
-              </a:rPr>
-              <a:t>Final design decisions happen here</a:t>
-            </a:r>
-          </a:p>
-        </p:txBody>
-      </p:sp>
-      <p:sp>
-        <p:nvSpPr>
-          <p:cNvPr id="37" name="features_card"/>
-          <p:cNvSpPr/>
-          <p:nvPr/>
-        </p:nvSpPr>
-        <p:spPr>
-          <a:xfrm>
-            <a:off x="6565392" y="2139696"/>
-            <a:ext cx="1389888" cy="713232"/>
-          </a:xfrm>
-          <a:prstGeom prst="roundRect">
-            <a:avLst/>
-          </a:prstGeom>
-          <a:solidFill>
-            <a:srgbClr val="F8FAFC"/>
-          </a:solidFill>
-          <a:ln>
-            <a:solidFill>
-              <a:srgbClr val="BBF7D0"/>
-            </a:solidFill>
-          </a:ln>
-        </p:spPr>
-        <p:style>
-          <a:lnRef idx="1">
-            <a:schemeClr val="accent1"/>
-          </a:lnRef>
-          <a:fillRef idx="3">
-            <a:schemeClr val="accent1"/>
-          </a:fillRef>
-          <a:effectRef idx="2">
-            <a:schemeClr val="accent1"/>
-          </a:effectRef>
-          <a:fontRef idx="minor">
-            <a:schemeClr val="lt1"/>
-          </a:fontRef>
-        </p:style>
-        <p:txBody>
-          <a:bodyPr rtlCol="0" anchor="ctr"/>
-          <a:lstStyle/>
-          <a:p>
-            <a:pPr algn="ctr"/>
-          </a:p>
-        </p:txBody>
-      </p:sp>
-      <p:sp>
-        <p:nvSpPr>
-          <p:cNvPr id="38" name="features_dot"/>
-          <p:cNvSpPr/>
-          <p:nvPr/>
-        </p:nvSpPr>
-        <p:spPr>
-          <a:xfrm>
-            <a:off x="6711696" y="2304288"/>
-            <a:ext cx="164592" cy="164592"/>
-          </a:xfrm>
-          <a:prstGeom prst="ellipse">
-            <a:avLst/>
-          </a:prstGeom>
-          <a:solidFill>
-            <a:srgbClr val="86EFAC"/>
-          </a:solidFill>
-          <a:ln>
-            <a:solidFill>
-              <a:srgbClr val="86EFAC"/>
-            </a:solidFill>
-          </a:ln>
-        </p:spPr>
-        <p:style>
-          <a:lnRef idx="1">
-            <a:schemeClr val="accent1"/>
-          </a:lnRef>
-          <a:fillRef idx="3">
-            <a:schemeClr val="accent1"/>
-          </a:fillRef>
-          <a:effectRef idx="2">
-            <a:schemeClr val="accent1"/>
-          </a:effectRef>
-          <a:fontRef idx="minor">
-            <a:schemeClr val="lt1"/>
-          </a:fontRef>
-        </p:style>
-        <p:txBody>
-          <a:bodyPr rtlCol="0" anchor="ctr"/>
-          <a:lstStyle/>
-          <a:p>
-            <a:pPr algn="ctr"/>
-          </a:p>
-        </p:txBody>
-      </p:sp>
-      <p:sp>
-        <p:nvSpPr>
-          <p:cNvPr id="39" name="features_title"/>
-          <p:cNvSpPr txBox="1"/>
-          <p:nvPr/>
-        </p:nvSpPr>
-        <p:spPr>
-          <a:xfrm>
-            <a:off x="6949440" y="2258568"/>
-            <a:ext cx="859536" cy="201168"/>
-          </a:xfrm>
-          <a:prstGeom prst="rect">
-            <a:avLst/>
-          </a:prstGeom>
-          <a:noFill/>
-        </p:spPr>
-        <p:txBody>
-          <a:bodyPr wrap="square" lIns="0" rIns="0" tIns="0" bIns="0">
-            <a:spAutoFit/>
-          </a:bodyPr>
-          <a:lstStyle/>
-          <a:p>
-            <a:pPr algn="l"/>
-            <a:r>
-              <a:rPr sz="1100" b="1">
-                <a:solidFill>
-                  <a:srgbClr val="111827"/>
-                </a:solidFill>
-              </a:rPr>
-              <a:t>Features</a:t>
-            </a:r>
-          </a:p>
-        </p:txBody>
-      </p:sp>
-      <p:sp>
-        <p:nvSpPr>
-          <p:cNvPr id="40" name="features_line_0"/>
-          <p:cNvSpPr txBox="1"/>
-          <p:nvPr/>
-        </p:nvSpPr>
-        <p:spPr>
-          <a:xfrm>
-            <a:off x="6766559" y="2542032"/>
-            <a:ext cx="1005840" cy="109728"/>
-          </a:xfrm>
-          <a:prstGeom prst="rect">
-            <a:avLst/>
-          </a:prstGeom>
-          <a:noFill/>
-        </p:spPr>
-        <p:txBody>
-          <a:bodyPr wrap="square" lIns="0" rIns="0" tIns="0" bIns="0">
-            <a:spAutoFit/>
-          </a:bodyPr>
-          <a:lstStyle/>
-          <a:p>
-            <a:pPr algn="l"/>
-            <a:r>
-              <a:rPr sz="800" b="0">
-                <a:solidFill>
-                  <a:srgbClr val="526071"/>
-                </a:solidFill>
-              </a:rPr>
-              <a:t>density and mix</a:t>
-            </a:r>
-          </a:p>
-        </p:txBody>
-      </p:sp>
-      <p:sp>
-        <p:nvSpPr>
-          <p:cNvPr id="41" name="features_line_1"/>
-          <p:cNvSpPr txBox="1"/>
-          <p:nvPr/>
-        </p:nvSpPr>
-        <p:spPr>
-          <a:xfrm>
-            <a:off x="6766559" y="2651760"/>
-            <a:ext cx="1005840" cy="109728"/>
-          </a:xfrm>
-          <a:prstGeom prst="rect">
-            <a:avLst/>
-          </a:prstGeom>
-          <a:noFill/>
-        </p:spPr>
-        <p:txBody>
-          <a:bodyPr wrap="square" lIns="0" rIns="0" tIns="0" bIns="0">
-            <a:spAutoFit/>
-          </a:bodyPr>
-          <a:lstStyle/>
-          <a:p>
-            <a:pPr algn="l"/>
-            <a:r>
-              <a:rPr sz="800" b="0">
-                <a:solidFill>
-                  <a:srgbClr val="526071"/>
-                </a:solidFill>
-              </a:rPr>
-              <a:t>size risk</a:t>
-            </a:r>
-          </a:p>
-        </p:txBody>
-      </p:sp>
-      <p:sp>
-        <p:nvSpPr>
-          <p:cNvPr id="42" name="rules_card"/>
-          <p:cNvSpPr/>
-          <p:nvPr/>
-        </p:nvSpPr>
-        <p:spPr>
-          <a:xfrm>
-            <a:off x="8138160" y="2139696"/>
-            <a:ext cx="1261872" cy="713232"/>
-          </a:xfrm>
-          <a:prstGeom prst="roundRect">
-            <a:avLst/>
-          </a:prstGeom>
-          <a:solidFill>
-            <a:srgbClr val="F8FAFC"/>
-          </a:solidFill>
-          <a:ln>
-            <a:solidFill>
-              <a:srgbClr val="BBF7D0"/>
-            </a:solidFill>
-          </a:ln>
-        </p:spPr>
-        <p:style>
-          <a:lnRef idx="1">
-            <a:schemeClr val="accent1"/>
-          </a:lnRef>
-          <a:fillRef idx="3">
-            <a:schemeClr val="accent1"/>
-          </a:fillRef>
-          <a:effectRef idx="2">
-            <a:schemeClr val="accent1"/>
-          </a:effectRef>
-          <a:fontRef idx="minor">
-            <a:schemeClr val="lt1"/>
-          </a:fontRef>
-        </p:style>
-        <p:txBody>
-          <a:bodyPr rtlCol="0" anchor="ctr"/>
-          <a:lstStyle/>
-          <a:p>
-            <a:pPr algn="ctr"/>
-          </a:p>
-        </p:txBody>
-      </p:sp>
-      <p:sp>
-        <p:nvSpPr>
-          <p:cNvPr id="43" name="rules_dot"/>
-          <p:cNvSpPr/>
-          <p:nvPr/>
-        </p:nvSpPr>
-        <p:spPr>
-          <a:xfrm>
-            <a:off x="8284464" y="2304288"/>
-            <a:ext cx="164592" cy="164592"/>
-          </a:xfrm>
-          <a:prstGeom prst="ellipse">
-            <a:avLst/>
-          </a:prstGeom>
-          <a:solidFill>
-            <a:srgbClr val="86EFAC"/>
-          </a:solidFill>
-          <a:ln>
-            <a:solidFill>
-              <a:srgbClr val="86EFAC"/>
-            </a:solidFill>
-          </a:ln>
-        </p:spPr>
-        <p:style>
-          <a:lnRef idx="1">
-            <a:schemeClr val="accent1"/>
-          </a:lnRef>
-          <a:fillRef idx="3">
-            <a:schemeClr val="accent1"/>
-          </a:fillRef>
-          <a:effectRef idx="2">
-            <a:schemeClr val="accent1"/>
-          </a:effectRef>
-          <a:fontRef idx="minor">
-            <a:schemeClr val="lt1"/>
-          </a:fontRef>
-        </p:style>
-        <p:txBody>
-          <a:bodyPr rtlCol="0" anchor="ctr"/>
-          <a:lstStyle/>
-          <a:p>
-            <a:pPr algn="ctr"/>
-          </a:p>
-        </p:txBody>
-      </p:sp>
-      <p:sp>
-        <p:nvSpPr>
-          <p:cNvPr id="44" name="rules_title"/>
-          <p:cNvSpPr txBox="1"/>
-          <p:nvPr/>
-        </p:nvSpPr>
-        <p:spPr>
-          <a:xfrm>
-            <a:off x="8522208" y="2258568"/>
-            <a:ext cx="731519" cy="201168"/>
-          </a:xfrm>
-          <a:prstGeom prst="rect">
-            <a:avLst/>
-          </a:prstGeom>
-          <a:noFill/>
-        </p:spPr>
-        <p:txBody>
-          <a:bodyPr wrap="square" lIns="0" rIns="0" tIns="0" bIns="0">
-            <a:spAutoFit/>
-          </a:bodyPr>
-          <a:lstStyle/>
-          <a:p>
-            <a:pPr algn="l"/>
-            <a:r>
-              <a:rPr sz="1100" b="1">
-                <a:solidFill>
-                  <a:srgbClr val="111827"/>
-                </a:solidFill>
-              </a:rPr>
-              <a:t>Rules</a:t>
-            </a:r>
-          </a:p>
-        </p:txBody>
-      </p:sp>
-      <p:sp>
-        <p:nvSpPr>
-          <p:cNvPr id="45" name="rules_line_0"/>
-          <p:cNvSpPr txBox="1"/>
-          <p:nvPr/>
-        </p:nvSpPr>
-        <p:spPr>
-          <a:xfrm>
-            <a:off x="8339328" y="2542032"/>
-            <a:ext cx="877824" cy="109728"/>
-          </a:xfrm>
-          <a:prstGeom prst="rect">
-            <a:avLst/>
-          </a:prstGeom>
-          <a:noFill/>
-        </p:spPr>
-        <p:txBody>
-          <a:bodyPr wrap="square" lIns="0" rIns="0" tIns="0" bIns="0">
-            <a:spAutoFit/>
-          </a:bodyPr>
-          <a:lstStyle/>
-          <a:p>
-            <a:pPr algn="l"/>
-            <a:r>
-              <a:rPr sz="800" b="0">
-                <a:solidFill>
-                  <a:srgbClr val="526071"/>
-                </a:solidFill>
-              </a:rPr>
-              <a:t>profile, recipe</a:t>
-            </a:r>
-          </a:p>
-        </p:txBody>
-      </p:sp>
-      <p:sp>
-        <p:nvSpPr>
-          <p:cNvPr id="46" name="rules_line_1"/>
-          <p:cNvSpPr txBox="1"/>
-          <p:nvPr/>
-        </p:nvSpPr>
-        <p:spPr>
-          <a:xfrm>
-            <a:off x="8339328" y="2651760"/>
-            <a:ext cx="877824" cy="109728"/>
-          </a:xfrm>
-          <a:prstGeom prst="rect">
-            <a:avLst/>
-          </a:prstGeom>
-          <a:noFill/>
-        </p:spPr>
-        <p:txBody>
-          <a:bodyPr wrap="square" lIns="0" rIns="0" tIns="0" bIns="0">
-            <a:spAutoFit/>
-          </a:bodyPr>
-          <a:lstStyle/>
-          <a:p>
-            <a:pPr algn="l"/>
-            <a:r>
-              <a:rPr sz="800" b="0">
-                <a:solidFill>
-                  <a:srgbClr val="526071"/>
-                </a:solidFill>
-              </a:rPr>
-              <a:t>variant</a:t>
-            </a:r>
-          </a:p>
-        </p:txBody>
-      </p:sp>
-      <p:sp>
-        <p:nvSpPr>
-          <p:cNvPr id="47" name="compose_card"/>
-          <p:cNvSpPr/>
-          <p:nvPr/>
-        </p:nvSpPr>
-        <p:spPr>
-          <a:xfrm>
-            <a:off x="6565392" y="3291840"/>
-            <a:ext cx="1389888" cy="713232"/>
-          </a:xfrm>
-          <a:prstGeom prst="roundRect">
-            <a:avLst/>
-          </a:prstGeom>
-          <a:solidFill>
-            <a:srgbClr val="F8FAFC"/>
-          </a:solidFill>
-          <a:ln>
-            <a:solidFill>
-              <a:srgbClr val="BBF7D0"/>
-            </a:solidFill>
-          </a:ln>
-        </p:spPr>
-        <p:style>
-          <a:lnRef idx="1">
-            <a:schemeClr val="accent1"/>
-          </a:lnRef>
-          <a:fillRef idx="3">
-            <a:schemeClr val="accent1"/>
-          </a:fillRef>
-          <a:effectRef idx="2">
-            <a:schemeClr val="accent1"/>
-          </a:effectRef>
-          <a:fontRef idx="minor">
-            <a:schemeClr val="lt1"/>
-          </a:fontRef>
-        </p:style>
-        <p:txBody>
-          <a:bodyPr rtlCol="0" anchor="ctr"/>
-          <a:lstStyle/>
-          <a:p>
-            <a:pPr algn="ctr"/>
-          </a:p>
-        </p:txBody>
-      </p:sp>
-      <p:sp>
-        <p:nvSpPr>
-          <p:cNvPr id="48" name="compose_dot"/>
-          <p:cNvSpPr/>
-          <p:nvPr/>
-        </p:nvSpPr>
-        <p:spPr>
-          <a:xfrm>
-            <a:off x="6711696" y="3456432"/>
-            <a:ext cx="164592" cy="164592"/>
-          </a:xfrm>
-          <a:prstGeom prst="ellipse">
-            <a:avLst/>
-          </a:prstGeom>
-          <a:solidFill>
-            <a:srgbClr val="86EFAC"/>
-          </a:solidFill>
-          <a:ln>
-            <a:solidFill>
-              <a:srgbClr val="86EFAC"/>
-            </a:solidFill>
-          </a:ln>
-        </p:spPr>
-        <p:style>
-          <a:lnRef idx="1">
-            <a:schemeClr val="accent1"/>
-          </a:lnRef>
-          <a:fillRef idx="3">
-            <a:schemeClr val="accent1"/>
-          </a:fillRef>
-          <a:effectRef idx="2">
-            <a:schemeClr val="accent1"/>
-          </a:effectRef>
-          <a:fontRef idx="minor">
-            <a:schemeClr val="lt1"/>
-          </a:fontRef>
-        </p:style>
-        <p:txBody>
-          <a:bodyPr rtlCol="0" anchor="ctr"/>
-          <a:lstStyle/>
-          <a:p>
-            <a:pPr algn="ctr"/>
-          </a:p>
-        </p:txBody>
-      </p:sp>
-      <p:sp>
-        <p:nvSpPr>
-          <p:cNvPr id="49" name="compose_title"/>
-          <p:cNvSpPr txBox="1"/>
-          <p:nvPr/>
-        </p:nvSpPr>
-        <p:spPr>
-          <a:xfrm>
-            <a:off x="6949440" y="3410712"/>
-            <a:ext cx="859536" cy="201168"/>
-          </a:xfrm>
-          <a:prstGeom prst="rect">
-            <a:avLst/>
-          </a:prstGeom>
-          <a:noFill/>
-        </p:spPr>
-        <p:txBody>
-          <a:bodyPr wrap="square" lIns="0" rIns="0" tIns="0" bIns="0">
-            <a:spAutoFit/>
-          </a:bodyPr>
-          <a:lstStyle/>
-          <a:p>
-            <a:pPr algn="l"/>
-            <a:r>
-              <a:rPr sz="1100" b="1">
-                <a:solidFill>
-                  <a:srgbClr val="111827"/>
-                </a:solidFill>
-              </a:rPr>
-              <a:t>Compose</a:t>
-            </a:r>
-          </a:p>
-        </p:txBody>
-      </p:sp>
-      <p:sp>
-        <p:nvSpPr>
-          <p:cNvPr id="50" name="compose_line_0"/>
-          <p:cNvSpPr txBox="1"/>
-          <p:nvPr/>
-        </p:nvSpPr>
-        <p:spPr>
-          <a:xfrm>
-            <a:off x="6766559" y="3694176"/>
-            <a:ext cx="1005840" cy="109728"/>
-          </a:xfrm>
-          <a:prstGeom prst="rect">
-            <a:avLst/>
-          </a:prstGeom>
-          <a:noFill/>
-        </p:spPr>
-        <p:txBody>
-          <a:bodyPr wrap="square" lIns="0" rIns="0" tIns="0" bIns="0">
-            <a:spAutoFit/>
-          </a:bodyPr>
-          <a:lstStyle/>
-          <a:p>
-            <a:pPr algn="l"/>
-            <a:r>
-              <a:rPr sz="800" b="0">
-                <a:solidFill>
-                  <a:srgbClr val="526071"/>
-                </a:solidFill>
-              </a:rPr>
-              <a:t>regions, boxes</a:t>
-            </a:r>
-          </a:p>
-        </p:txBody>
-      </p:sp>
-      <p:sp>
-        <p:nvSpPr>
-          <p:cNvPr id="51" name="compose_line_1"/>
-          <p:cNvSpPr txBox="1"/>
-          <p:nvPr/>
-        </p:nvSpPr>
-        <p:spPr>
-          <a:xfrm>
-            <a:off x="6766559" y="3803904"/>
-            <a:ext cx="1005840" cy="109728"/>
-          </a:xfrm>
-          <a:prstGeom prst="rect">
-            <a:avLst/>
-          </a:prstGeom>
-          <a:noFill/>
-        </p:spPr>
-        <p:txBody>
-          <a:bodyPr wrap="square" lIns="0" rIns="0" tIns="0" bIns="0">
-            <a:spAutoFit/>
-          </a:bodyPr>
-          <a:lstStyle/>
-          <a:p>
-            <a:pPr algn="l"/>
-            <a:r>
-              <a:rPr sz="800" b="0">
-                <a:solidFill>
-                  <a:srgbClr val="526071"/>
-                </a:solidFill>
-              </a:rPr>
-              <a:t>fit, overflow</a:t>
-            </a:r>
-          </a:p>
-        </p:txBody>
-      </p:sp>
-      <p:sp>
-        <p:nvSpPr>
-          <p:cNvPr id="52" name="decorate_card"/>
-          <p:cNvSpPr/>
-          <p:nvPr/>
-        </p:nvSpPr>
-        <p:spPr>
-          <a:xfrm>
-            <a:off x="8138160" y="3291840"/>
-            <a:ext cx="1261872" cy="713232"/>
-          </a:xfrm>
-          <a:prstGeom prst="roundRect">
-            <a:avLst/>
-          </a:prstGeom>
-          <a:solidFill>
-            <a:srgbClr val="F8FAFC"/>
-          </a:solidFill>
-          <a:ln>
-            <a:solidFill>
-              <a:srgbClr val="BBF7D0"/>
-            </a:solidFill>
-          </a:ln>
-        </p:spPr>
-        <p:style>
-          <a:lnRef idx="1">
-            <a:schemeClr val="accent1"/>
-          </a:lnRef>
-          <a:fillRef idx="3">
-            <a:schemeClr val="accent1"/>
-          </a:fillRef>
-          <a:effectRef idx="2">
-            <a:schemeClr val="accent1"/>
-          </a:effectRef>
-          <a:fontRef idx="minor">
-            <a:schemeClr val="lt1"/>
-          </a:fontRef>
-        </p:style>
-        <p:txBody>
-          <a:bodyPr rtlCol="0" anchor="ctr"/>
-          <a:lstStyle/>
-          <a:p>
-            <a:pPr algn="ctr"/>
-          </a:p>
-        </p:txBody>
-      </p:sp>
-      <p:sp>
-        <p:nvSpPr>
-          <p:cNvPr id="53" name="decorate_dot"/>
-          <p:cNvSpPr/>
-          <p:nvPr/>
-        </p:nvSpPr>
-        <p:spPr>
-          <a:xfrm>
-            <a:off x="8284464" y="3456432"/>
-            <a:ext cx="164592" cy="164592"/>
-          </a:xfrm>
-          <a:prstGeom prst="ellipse">
-            <a:avLst/>
-          </a:prstGeom>
-          <a:solidFill>
-            <a:srgbClr val="86EFAC"/>
-          </a:solidFill>
-          <a:ln>
-            <a:solidFill>
-              <a:srgbClr val="86EFAC"/>
-            </a:solidFill>
-          </a:ln>
-        </p:spPr>
-        <p:style>
-          <a:lnRef idx="1">
-            <a:schemeClr val="accent1"/>
-          </a:lnRef>
-          <a:fillRef idx="3">
-            <a:schemeClr val="accent1"/>
-          </a:fillRef>
-          <a:effectRef idx="2">
-            <a:schemeClr val="accent1"/>
-          </a:effectRef>
-          <a:fontRef idx="minor">
-            <a:schemeClr val="lt1"/>
-          </a:fontRef>
-        </p:style>
-        <p:txBody>
-          <a:bodyPr rtlCol="0" anchor="ctr"/>
-          <a:lstStyle/>
-          <a:p>
-            <a:pPr algn="ctr"/>
-          </a:p>
-        </p:txBody>
-      </p:sp>
-      <p:sp>
-        <p:nvSpPr>
-          <p:cNvPr id="54" name="decorate_title"/>
-          <p:cNvSpPr txBox="1"/>
-          <p:nvPr/>
-        </p:nvSpPr>
-        <p:spPr>
-          <a:xfrm>
-            <a:off x="8522208" y="3410712"/>
-            <a:ext cx="731519" cy="201168"/>
-          </a:xfrm>
-          <a:prstGeom prst="rect">
-            <a:avLst/>
-          </a:prstGeom>
-          <a:noFill/>
-        </p:spPr>
-        <p:txBody>
-          <a:bodyPr wrap="square" lIns="0" rIns="0" tIns="0" bIns="0">
-            <a:spAutoFit/>
-          </a:bodyPr>
-          <a:lstStyle/>
-          <a:p>
-            <a:pPr algn="l"/>
-            <a:r>
-              <a:rPr sz="1100" b="1">
-                <a:solidFill>
-                  <a:srgbClr val="111827"/>
-                </a:solidFill>
-              </a:rPr>
-              <a:t>Decorate</a:t>
-            </a:r>
-          </a:p>
-        </p:txBody>
-      </p:sp>
-      <p:sp>
-        <p:nvSpPr>
-          <p:cNvPr id="55" name="decorate_line_0"/>
-          <p:cNvSpPr txBox="1"/>
-          <p:nvPr/>
-        </p:nvSpPr>
-        <p:spPr>
-          <a:xfrm>
-            <a:off x="8339328" y="3694176"/>
-            <a:ext cx="877824" cy="109728"/>
-          </a:xfrm>
-          <a:prstGeom prst="rect">
-            <a:avLst/>
-          </a:prstGeom>
-          <a:noFill/>
-        </p:spPr>
-        <p:txBody>
-          <a:bodyPr wrap="square" lIns="0" rIns="0" tIns="0" bIns="0">
-            <a:spAutoFit/>
-          </a:bodyPr>
-          <a:lstStyle/>
-          <a:p>
-            <a:pPr algn="l"/>
-            <a:r>
-              <a:rPr sz="800" b="0">
-                <a:solidFill>
-                  <a:srgbClr val="526071"/>
-                </a:solidFill>
-              </a:rPr>
-              <a:t>type, radius</a:t>
-            </a:r>
-          </a:p>
-        </p:txBody>
-      </p:sp>
-      <p:sp>
-        <p:nvSpPr>
-          <p:cNvPr id="56" name="decorate_line_1"/>
-          <p:cNvSpPr txBox="1"/>
-          <p:nvPr/>
-        </p:nvSpPr>
-        <p:spPr>
-          <a:xfrm>
-            <a:off x="8339328" y="3803904"/>
-            <a:ext cx="877824" cy="109728"/>
-          </a:xfrm>
-          <a:prstGeom prst="rect">
-            <a:avLst/>
-          </a:prstGeom>
-          <a:noFill/>
-        </p:spPr>
-        <p:txBody>
-          <a:bodyPr wrap="square" lIns="0" rIns="0" tIns="0" bIns="0">
-            <a:spAutoFit/>
-          </a:bodyPr>
-          <a:lstStyle/>
-          <a:p>
-            <a:pPr algn="l"/>
-            <a:r>
-              <a:rPr sz="800" b="0">
-                <a:solidFill>
-                  <a:srgbClr val="526071"/>
-                </a:solidFill>
-              </a:rPr>
-              <a:t>shadow, effects</a:t>
-            </a:r>
-          </a:p>
-        </p:txBody>
-      </p:sp>
-      <p:cxnSp>
-        <p:nvCxnSpPr>
-          <p:cNvPr id="57" name="arrow_ir_rule"/>
-          <p:cNvCxnSpPr/>
-          <p:nvPr/>
-        </p:nvCxnSpPr>
-        <p:spPr>
-          <a:xfrm>
-            <a:off x="6894576" y="2057400"/>
-            <a:ext cx="310896" cy="0"/>
-          </a:xfrm>
-          <a:prstGeom prst="line">
-            <a:avLst/>
-          </a:prstGeom>
-          <a:ln w="22860">
-            <a:solidFill>
-              <a:srgbClr val="475569"/>
-            </a:solidFill>
-          </a:ln>
-        </p:spPr>
-        <p:style>
-          <a:lnRef idx="2">
-            <a:schemeClr val="accent1"/>
-          </a:lnRef>
-          <a:fillRef idx="0">
-            <a:schemeClr val="accent1"/>
-          </a:fillRef>
-          <a:effectRef idx="1">
-            <a:schemeClr val="accent1"/>
-          </a:effectRef>
-          <a:fontRef idx="minor">
-            <a:schemeClr val="tx1"/>
-          </a:fontRef>
-        </p:style>
-      </p:cxnSp>
-      <p:cxnSp>
-        <p:nvCxnSpPr>
-          <p:cNvPr id="58" name="rule_arrow_1"/>
-          <p:cNvCxnSpPr/>
-          <p:nvPr/>
-        </p:nvCxnSpPr>
-        <p:spPr>
-          <a:xfrm>
-            <a:off x="7955279" y="2487168"/>
-            <a:ext cx="164592" cy="0"/>
-          </a:xfrm>
-          <a:prstGeom prst="line">
-            <a:avLst/>
-          </a:prstGeom>
-          <a:ln w="22860">
-            <a:solidFill>
-              <a:srgbClr val="16A34A"/>
-            </a:solidFill>
-          </a:ln>
-        </p:spPr>
-        <p:style>
-          <a:lnRef idx="2">
-            <a:schemeClr val="accent1"/>
-          </a:lnRef>
-          <a:fillRef idx="0">
-            <a:schemeClr val="accent1"/>
-          </a:fillRef>
-          <a:effectRef idx="1">
-            <a:schemeClr val="accent1"/>
-          </a:effectRef>
-          <a:fontRef idx="minor">
-            <a:schemeClr val="tx1"/>
-          </a:fontRef>
-        </p:style>
-      </p:cxnSp>
-      <p:cxnSp>
-        <p:nvCxnSpPr>
-          <p:cNvPr id="59" name="rule_arrow_2"/>
-          <p:cNvCxnSpPr/>
-          <p:nvPr/>
-        </p:nvCxnSpPr>
-        <p:spPr>
-          <a:xfrm>
-            <a:off x="8759952" y="2852928"/>
-            <a:ext cx="0" cy="0"/>
-          </a:xfrm>
-          <a:prstGeom prst="line">
-            <a:avLst/>
-          </a:prstGeom>
-          <a:ln w="22860">
-            <a:solidFill>
-              <a:srgbClr val="16A34A"/>
-            </a:solidFill>
-          </a:ln>
-        </p:spPr>
-        <p:style>
-          <a:lnRef idx="2">
-            <a:schemeClr val="accent1"/>
-          </a:lnRef>
-          <a:fillRef idx="0">
-            <a:schemeClr val="accent1"/>
-          </a:fillRef>
-          <a:effectRef idx="1">
-            <a:schemeClr val="accent1"/>
-          </a:effectRef>
-          <a:fontRef idx="minor">
-            <a:schemeClr val="tx1"/>
-          </a:fontRef>
-        </p:style>
-      </p:cxnSp>
-      <p:sp>
-        <p:nvSpPr>
-          <p:cNvPr id="60" name="lint_pill"/>
-          <p:cNvSpPr/>
-          <p:nvPr/>
-        </p:nvSpPr>
-        <p:spPr>
-          <a:xfrm>
-            <a:off x="6748272" y="4187952"/>
-            <a:ext cx="2322576" cy="237744"/>
-          </a:xfrm>
-          <a:prstGeom prst="roundRect">
-            <a:avLst/>
-          </a:prstGeom>
-          <a:solidFill>
-            <a:srgbClr val="DCFCE7"/>
-          </a:solidFill>
-          <a:ln>
-            <a:solidFill>
-              <a:srgbClr val="86EFAC"/>
-            </a:solidFill>
-          </a:ln>
-        </p:spPr>
-        <p:style>
-          <a:lnRef idx="1">
-            <a:schemeClr val="accent1"/>
-          </a:lnRef>
-          <a:fillRef idx="3">
-            <a:schemeClr val="accent1"/>
-          </a:fillRef>
-          <a:effectRef idx="2">
-            <a:schemeClr val="accent1"/>
-          </a:effectRef>
-          <a:fontRef idx="minor">
-            <a:schemeClr val="lt1"/>
-          </a:fontRef>
-        </p:style>
-        <p:txBody>
-          <a:bodyPr rtlCol="0" anchor="ctr"/>
-          <a:lstStyle/>
-          <a:p>
-            <a:pPr algn="ctr"/>
-          </a:p>
-        </p:txBody>
-      </p:sp>
-      <p:sp>
-        <p:nvSpPr>
-          <p:cNvPr id="61" name="lint_text"/>
-          <p:cNvSpPr txBox="1"/>
-          <p:nvPr/>
-        </p:nvSpPr>
-        <p:spPr>
-          <a:xfrm>
-            <a:off x="7077456" y="4261104"/>
-            <a:ext cx="1664208" cy="91440"/>
-          </a:xfrm>
-          <a:prstGeom prst="rect">
-            <a:avLst/>
-          </a:prstGeom>
-          <a:noFill/>
-        </p:spPr>
-        <p:txBody>
-          <a:bodyPr wrap="square" lIns="0" rIns="0" tIns="0" bIns="0">
-            <a:spAutoFit/>
-          </a:bodyPr>
-          <a:lstStyle/>
-          <a:p>
-            <a:pPr algn="l"/>
-            <a:r>
-              <a:rPr sz="800" b="1">
-                <a:solidFill>
-                  <a:srgbClr val="166534"/>
-                </a:solidFill>
-              </a:rPr>
-              <a:t>Coherence lint: one visual language</a:t>
-            </a:r>
-          </a:p>
-        </p:txBody>
-      </p:sp>
-      <p:sp>
-        <p:nvSpPr>
-          <p:cNvPr id="62" name="styled_ir_card"/>
-          <p:cNvSpPr/>
-          <p:nvPr/>
-        </p:nvSpPr>
-        <p:spPr>
-          <a:xfrm>
-            <a:off x="9985248" y="1792224"/>
-            <a:ext cx="1481328" cy="841248"/>
-          </a:xfrm>
-          <a:prstGeom prst="roundRect">
-            <a:avLst/>
-          </a:prstGeom>
-          <a:solidFill>
-            <a:srgbClr val="F8FAFC"/>
-          </a:solidFill>
-          <a:ln>
-            <a:solidFill>
-              <a:srgbClr val="CBD5E1"/>
-            </a:solidFill>
-          </a:ln>
-        </p:spPr>
-        <p:style>
-          <a:lnRef idx="1">
-            <a:schemeClr val="accent1"/>
-          </a:lnRef>
-          <a:fillRef idx="3">
-            <a:schemeClr val="accent1"/>
-          </a:fillRef>
-          <a:effectRef idx="2">
-            <a:schemeClr val="accent1"/>
-          </a:effectRef>
-          <a:fontRef idx="minor">
-            <a:schemeClr val="lt1"/>
-          </a:fontRef>
-        </p:style>
-        <p:txBody>
-          <a:bodyPr rtlCol="0" anchor="ctr"/>
-          <a:lstStyle/>
-          <a:p>
-            <a:pPr algn="ctr"/>
-          </a:p>
-        </p:txBody>
-      </p:sp>
-      <p:sp>
-        <p:nvSpPr>
-          <p:cNvPr id="63" name="styled_ir_dot"/>
-          <p:cNvSpPr/>
-          <p:nvPr/>
-        </p:nvSpPr>
-        <p:spPr>
-          <a:xfrm>
-            <a:off x="10131552" y="1956816"/>
-            <a:ext cx="164592" cy="164592"/>
-          </a:xfrm>
-          <a:prstGeom prst="ellipse">
-            <a:avLst/>
-          </a:prstGeom>
-          <a:solidFill>
-            <a:srgbClr val="CBD5E1"/>
-          </a:solidFill>
-          <a:ln>
-            <a:solidFill>
-              <a:srgbClr val="CBD5E1"/>
-            </a:solidFill>
-          </a:ln>
-        </p:spPr>
-        <p:style>
-          <a:lnRef idx="1">
-            <a:schemeClr val="accent1"/>
-          </a:lnRef>
-          <a:fillRef idx="3">
-            <a:schemeClr val="accent1"/>
-          </a:fillRef>
-          <a:effectRef idx="2">
-            <a:schemeClr val="accent1"/>
-          </a:effectRef>
-          <a:fontRef idx="minor">
-            <a:schemeClr val="lt1"/>
-          </a:fontRef>
-        </p:style>
-        <p:txBody>
-          <a:bodyPr rtlCol="0" anchor="ctr"/>
-          <a:lstStyle/>
-          <a:p>
-            <a:pPr algn="ctr"/>
-          </a:p>
-        </p:txBody>
-      </p:sp>
-      <p:sp>
-        <p:nvSpPr>
-          <p:cNvPr id="64" name="styled_ir_title"/>
-          <p:cNvSpPr txBox="1"/>
-          <p:nvPr/>
-        </p:nvSpPr>
-        <p:spPr>
-          <a:xfrm>
-            <a:off x="10369296" y="1911095"/>
-            <a:ext cx="950976" cy="201168"/>
-          </a:xfrm>
-          <a:prstGeom prst="rect">
-            <a:avLst/>
-          </a:prstGeom>
-          <a:noFill/>
-        </p:spPr>
-        <p:txBody>
-          <a:bodyPr wrap="square" lIns="0" rIns="0" tIns="0" bIns="0">
-            <a:spAutoFit/>
-          </a:bodyPr>
-          <a:lstStyle/>
-          <a:p>
-            <a:pPr algn="l"/>
-            <a:r>
-              <a:rPr sz="1100" b="1">
-                <a:solidFill>
-                  <a:srgbClr val="111827"/>
-                </a:solidFill>
-              </a:rPr>
-              <a:t>Styled Deck IR</a:t>
-            </a:r>
-          </a:p>
-        </p:txBody>
-      </p:sp>
-      <p:sp>
-        <p:nvSpPr>
-          <p:cNvPr id="65" name="styled_ir_line_0"/>
-          <p:cNvSpPr txBox="1"/>
-          <p:nvPr/>
-        </p:nvSpPr>
-        <p:spPr>
-          <a:xfrm>
-            <a:off x="10186416" y="2194560"/>
-            <a:ext cx="1097280" cy="146303"/>
-          </a:xfrm>
-          <a:prstGeom prst="rect">
-            <a:avLst/>
-          </a:prstGeom>
-          <a:noFill/>
-        </p:spPr>
-        <p:txBody>
-          <a:bodyPr wrap="square" lIns="0" rIns="0" tIns="0" bIns="0">
-            <a:spAutoFit/>
-          </a:bodyPr>
-          <a:lstStyle/>
-          <a:p>
-            <a:pPr algn="l"/>
-            <a:r>
-              <a:rPr sz="800" b="0">
-                <a:solidFill>
-                  <a:srgbClr val="526071"/>
-                </a:solidFill>
-              </a:rPr>
-              <a:t>renderer-neutral</a:t>
-            </a:r>
-          </a:p>
-        </p:txBody>
-      </p:sp>
-      <p:sp>
-        <p:nvSpPr>
-          <p:cNvPr id="66" name="styled_ir_line_1"/>
-          <p:cNvSpPr txBox="1"/>
-          <p:nvPr/>
-        </p:nvSpPr>
-        <p:spPr>
-          <a:xfrm>
-            <a:off x="10186416" y="2359152"/>
-            <a:ext cx="1097280" cy="146303"/>
-          </a:xfrm>
-          <a:prstGeom prst="rect">
-            <a:avLst/>
-          </a:prstGeom>
-          <a:noFill/>
-        </p:spPr>
-        <p:txBody>
-          <a:bodyPr wrap="square" lIns="0" rIns="0" tIns="0" bIns="0">
-            <a:spAutoFit/>
-          </a:bodyPr>
-          <a:lstStyle/>
-          <a:p>
-            <a:pPr algn="l"/>
-            <a:r>
-              <a:rPr sz="800" b="0">
-                <a:solidFill>
-                  <a:srgbClr val="526071"/>
-                </a:solidFill>
-              </a:rPr>
-              <a:t>visual contract</a:t>
-            </a:r>
-          </a:p>
-        </p:txBody>
-      </p:sp>
-      <p:sp>
-        <p:nvSpPr>
-          <p:cNvPr id="67" name="renderers_card"/>
-          <p:cNvSpPr/>
-          <p:nvPr/>
-        </p:nvSpPr>
-        <p:spPr>
-          <a:xfrm>
-            <a:off x="9985248" y="3182112"/>
-            <a:ext cx="1481328" cy="1005840"/>
-          </a:xfrm>
-          <a:prstGeom prst="roundRect">
-            <a:avLst/>
-          </a:prstGeom>
-          <a:solidFill>
-            <a:srgbClr val="F8FAFC"/>
-          </a:solidFill>
-          <a:ln>
-            <a:solidFill>
-              <a:srgbClr val="CBD5E1"/>
-            </a:solidFill>
-          </a:ln>
-        </p:spPr>
-        <p:style>
-          <a:lnRef idx="1">
-            <a:schemeClr val="accent1"/>
-          </a:lnRef>
-          <a:fillRef idx="3">
-            <a:schemeClr val="accent1"/>
-          </a:fillRef>
-          <a:effectRef idx="2">
-            <a:schemeClr val="accent1"/>
-          </a:effectRef>
-          <a:fontRef idx="minor">
-            <a:schemeClr val="lt1"/>
-          </a:fontRef>
-        </p:style>
-        <p:txBody>
-          <a:bodyPr rtlCol="0" anchor="ctr"/>
-          <a:lstStyle/>
-          <a:p>
-            <a:pPr algn="ctr"/>
-          </a:p>
-        </p:txBody>
-      </p:sp>
-      <p:sp>
-        <p:nvSpPr>
-          <p:cNvPr id="68" name="renderers_dot"/>
-          <p:cNvSpPr/>
-          <p:nvPr/>
-        </p:nvSpPr>
-        <p:spPr>
-          <a:xfrm>
-            <a:off x="10131552" y="3346704"/>
-            <a:ext cx="164592" cy="164592"/>
-          </a:xfrm>
-          <a:prstGeom prst="ellipse">
-            <a:avLst/>
-          </a:prstGeom>
-          <a:solidFill>
-            <a:srgbClr val="CBD5E1"/>
-          </a:solidFill>
-          <a:ln>
-            <a:solidFill>
-              <a:srgbClr val="CBD5E1"/>
-            </a:solidFill>
-          </a:ln>
-        </p:spPr>
-        <p:style>
-          <a:lnRef idx="1">
-            <a:schemeClr val="accent1"/>
-          </a:lnRef>
-          <a:fillRef idx="3">
-            <a:schemeClr val="accent1"/>
-          </a:fillRef>
-          <a:effectRef idx="2">
-            <a:schemeClr val="accent1"/>
-          </a:effectRef>
-          <a:fontRef idx="minor">
-            <a:schemeClr val="lt1"/>
-          </a:fontRef>
-        </p:style>
-        <p:txBody>
-          <a:bodyPr rtlCol="0" anchor="ctr"/>
-          <a:lstStyle/>
-          <a:p>
-            <a:pPr algn="ctr"/>
-          </a:p>
-        </p:txBody>
-      </p:sp>
-      <p:sp>
-        <p:nvSpPr>
-          <p:cNvPr id="69" name="renderers_title"/>
-          <p:cNvSpPr txBox="1"/>
-          <p:nvPr/>
-        </p:nvSpPr>
-        <p:spPr>
-          <a:xfrm>
-            <a:off x="10369296" y="3300984"/>
-            <a:ext cx="950976" cy="201168"/>
-          </a:xfrm>
-          <a:prstGeom prst="rect">
-            <a:avLst/>
-          </a:prstGeom>
-          <a:noFill/>
-        </p:spPr>
-        <p:txBody>
-          <a:bodyPr wrap="square" lIns="0" rIns="0" tIns="0" bIns="0">
-            <a:spAutoFit/>
-          </a:bodyPr>
-          <a:lstStyle/>
-          <a:p>
-            <a:pPr algn="l"/>
-            <a:r>
-              <a:rPr sz="1100" b="1">
-                <a:solidFill>
-                  <a:srgbClr val="111827"/>
-                </a:solidFill>
-              </a:rPr>
-              <a:t>Renderers</a:t>
-            </a:r>
-          </a:p>
-        </p:txBody>
-      </p:sp>
-      <p:sp>
-        <p:nvSpPr>
-          <p:cNvPr id="70" name="renderers_line_0"/>
-          <p:cNvSpPr txBox="1"/>
-          <p:nvPr/>
-        </p:nvSpPr>
-        <p:spPr>
-          <a:xfrm>
-            <a:off x="10186416" y="3584448"/>
-            <a:ext cx="1097280" cy="146304"/>
-          </a:xfrm>
-          <a:prstGeom prst="rect">
-            <a:avLst/>
-          </a:prstGeom>
-          <a:noFill/>
-        </p:spPr>
-        <p:txBody>
-          <a:bodyPr wrap="square" lIns="0" rIns="0" tIns="0" bIns="0">
-            <a:spAutoFit/>
-          </a:bodyPr>
-          <a:lstStyle/>
-          <a:p>
-            <a:pPr algn="l"/>
-            <a:r>
-              <a:rPr sz="800" b="0">
-                <a:solidFill>
-                  <a:srgbClr val="526071"/>
-                </a:solidFill>
-              </a:rPr>
-              <a:t>editable PPTX</a:t>
-            </a:r>
-          </a:p>
-        </p:txBody>
-      </p:sp>
-      <p:sp>
-        <p:nvSpPr>
-          <p:cNvPr id="71" name="renderers_line_1"/>
-          <p:cNvSpPr txBox="1"/>
-          <p:nvPr/>
-        </p:nvSpPr>
-        <p:spPr>
-          <a:xfrm>
-            <a:off x="10186416" y="3749039"/>
-            <a:ext cx="1097280" cy="146304"/>
-          </a:xfrm>
-          <a:prstGeom prst="rect">
-            <a:avLst/>
-          </a:prstGeom>
-          <a:noFill/>
-        </p:spPr>
-        <p:txBody>
-          <a:bodyPr wrap="square" lIns="0" rIns="0" tIns="0" bIns="0">
-            <a:spAutoFit/>
-          </a:bodyPr>
-          <a:lstStyle/>
-          <a:p>
-            <a:pPr algn="l"/>
-            <a:r>
-              <a:rPr sz="800" b="0">
-                <a:solidFill>
-                  <a:srgbClr val="526071"/>
-                </a:solidFill>
-              </a:rPr>
-              <a:t>HTML and PDF</a:t>
-            </a:r>
-          </a:p>
-        </p:txBody>
-      </p:sp>
-      <p:sp>
-        <p:nvSpPr>
-          <p:cNvPr id="72" name="renderers_line_2"/>
-          <p:cNvSpPr txBox="1"/>
-          <p:nvPr/>
-        </p:nvSpPr>
-        <p:spPr>
-          <a:xfrm>
-            <a:off x="10186416" y="3913632"/>
-            <a:ext cx="1097280" cy="146304"/>
-          </a:xfrm>
-          <a:prstGeom prst="rect">
-            <a:avLst/>
-          </a:prstGeom>
-          <a:noFill/>
-        </p:spPr>
-        <p:txBody>
-          <a:bodyPr wrap="square" lIns="0" rIns="0" tIns="0" bIns="0">
-            <a:spAutoFit/>
-          </a:bodyPr>
-          <a:lstStyle/>
-          <a:p>
-            <a:pPr algn="l"/>
-            <a:r>
-              <a:rPr sz="800" b="0">
-                <a:solidFill>
-                  <a:srgbClr val="526071"/>
-                </a:solidFill>
-              </a:rPr>
-              <a:t>visual validation</a:t>
-            </a:r>
-          </a:p>
-        </p:txBody>
-      </p:sp>
-      <p:cxnSp>
-        <p:nvCxnSpPr>
-          <p:cNvPr id="73" name="arrow_rule_output"/>
-          <p:cNvCxnSpPr/>
-          <p:nvPr/>
-        </p:nvCxnSpPr>
-        <p:spPr>
-          <a:xfrm>
-            <a:off x="9637776" y="2359152"/>
-            <a:ext cx="329183" cy="0"/>
-          </a:xfrm>
-          <a:prstGeom prst="line">
-            <a:avLst/>
-          </a:prstGeom>
-          <a:ln w="22860">
-            <a:solidFill>
-              <a:srgbClr val="475569"/>
-            </a:solidFill>
-          </a:ln>
-        </p:spPr>
-        <p:style>
-          <a:lnRef idx="2">
-            <a:schemeClr val="accent1"/>
-          </a:lnRef>
-          <a:fillRef idx="0">
-            <a:schemeClr val="accent1"/>
-          </a:fillRef>
-          <a:effectRef idx="1">
-            <a:schemeClr val="accent1"/>
-          </a:effectRef>
-          <a:fontRef idx="minor">
-            <a:schemeClr val="tx1"/>
-          </a:fontRef>
-        </p:style>
-      </p:cxnSp>
-      <p:cxnSp>
-        <p:nvCxnSpPr>
-          <p:cNvPr id="74" name="arrow_ir_renderers"/>
-          <p:cNvCxnSpPr/>
-          <p:nvPr/>
-        </p:nvCxnSpPr>
-        <p:spPr>
-          <a:xfrm>
-            <a:off x="10735056" y="2633472"/>
-            <a:ext cx="0" cy="0"/>
-          </a:xfrm>
-          <a:prstGeom prst="line">
-            <a:avLst/>
-          </a:prstGeom>
-          <a:ln w="22860">
-            <a:solidFill>
-              <a:srgbClr val="475569"/>
-            </a:solidFill>
-          </a:ln>
-        </p:spPr>
-        <p:style>
-          <a:lnRef idx="2">
-            <a:schemeClr val="accent1"/>
-          </a:lnRef>
-          <a:fillRef idx="0">
-            <a:schemeClr val="accent1"/>
-          </a:fillRef>
-          <a:effectRef idx="1">
-            <a:schemeClr val="accent1"/>
-          </a:effectRef>
-          <a:fontRef idx="minor">
-            <a:schemeClr val="tx1"/>
-          </a:fontRef>
-        </p:style>
-      </p:cxnSp>
-      <p:sp>
-        <p:nvSpPr>
-          <p:cNvPr id="75" name="responsibility"/>
-          <p:cNvSpPr/>
-          <p:nvPr/>
-        </p:nvSpPr>
-        <p:spPr>
-          <a:xfrm>
-            <a:off x="804672" y="5102352"/>
-            <a:ext cx="10497312" cy="658368"/>
+            <a:off x="804672" y="5084064"/>
+            <a:ext cx="10552176" cy="694944"/>
           </a:xfrm>
           <a:prstGeom prst="roundRect">
             <a:avLst/>
@@ -5892,14 +6348,14 @@
       </p:sp>
       <p:sp>
         <p:nvSpPr>
-          <p:cNvPr id="76" name="responsibility_title"/>
+          <p:cNvPr id="88" name="coherence_title"/>
           <p:cNvSpPr txBox="1"/>
           <p:nvPr/>
         </p:nvSpPr>
         <p:spPr>
           <a:xfrm>
-            <a:off x="1024128" y="5303520"/>
-            <a:ext cx="1426464" cy="164592"/>
+            <a:off x="1042415" y="5285232"/>
+            <a:ext cx="1536192" cy="164592"/>
           </a:xfrm>
           <a:prstGeom prst="rect">
             <a:avLst/>
@@ -5914,25 +6370,25 @@
           <a:p>
             <a:pPr algn="l"/>
             <a:r>
-              <a:rPr sz="1100" b="1">
+              <a:rPr sz="1200" b="1">
                 <a:solidFill>
                   <a:srgbClr val="111827"/>
                 </a:solidFill>
               </a:rPr>
-              <a:t>Responsibility split</a:t>
-            </a:r>
-          </a:p>
-        </p:txBody>
-      </p:sp>
-      <p:sp>
-        <p:nvSpPr>
-          <p:cNvPr id="77" name="responsibility_body"/>
+              <a:t>Coherence checks</a:t>
+            </a:r>
+          </a:p>
+        </p:txBody>
+      </p:sp>
+      <p:sp>
+        <p:nvSpPr>
+          <p:cNvPr id="89" name="coherence_body"/>
           <p:cNvSpPr txBox="1"/>
           <p:nvPr/>
         </p:nvSpPr>
         <p:spPr>
           <a:xfrm>
-            <a:off x="2505456" y="5303520"/>
+            <a:off x="2633472" y="5285232"/>
             <a:ext cx="6309360" cy="201168"/>
           </a:xfrm>
           <a:prstGeom prst="rect">
@@ -5953,21 +6409,21 @@
                   <a:srgbClr val="526071"/>
                 </a:solidFill>
               </a:rPr>
-              <a:t>LLM: semantic hints only. Rules: selection, composition, decoration, coherence, readability. Renderers: editable objects and output verification.</a:t>
-            </a:r>
-          </a:p>
-        </p:txBody>
-      </p:sp>
-      <p:sp>
-        <p:nvSpPr>
-          <p:cNvPr id="78" name="font_badge"/>
+              <a:t>One visual language across mixed objects: hierarchy-scaled type, bounded text, consistent spacing, aligned starts, and readable minimum sizes.</a:t>
+            </a:r>
+          </a:p>
+        </p:txBody>
+      </p:sp>
+      <p:sp>
+        <p:nvSpPr>
+          <p:cNvPr id="90" name="font_badge"/>
           <p:cNvSpPr/>
           <p:nvPr/>
         </p:nvSpPr>
         <p:spPr>
           <a:xfrm>
-            <a:off x="9802368" y="5285232"/>
-            <a:ext cx="1170432" cy="237744"/>
+            <a:off x="9582912" y="5266944"/>
+            <a:ext cx="1298448" cy="256032"/>
           </a:xfrm>
           <a:prstGeom prst="roundRect">
             <a:avLst/>
@@ -6005,14 +6461,14 @@
       </p:sp>
       <p:sp>
         <p:nvSpPr>
-          <p:cNvPr id="79" name="font_badge_text"/>
+          <p:cNvPr id="91" name="font_badge_text"/>
           <p:cNvSpPr txBox="1"/>
           <p:nvPr/>
         </p:nvSpPr>
         <p:spPr>
           <a:xfrm>
-            <a:off x="9966960" y="5358384"/>
-            <a:ext cx="859536" cy="91440"/>
+            <a:off x="9747504" y="5349240"/>
+            <a:ext cx="987552" cy="91440"/>
           </a:xfrm>
           <a:prstGeom prst="rect">
             <a:avLst/>
@@ -6032,7 +6488,7 @@
                   <a:srgbClr val="FFFFFF"/>
                 </a:solidFill>
               </a:rPr>
-              <a:t>font size &gt;= 8pt</a:t>
+              <a:t>font scale by role</a:t>
             </a:r>
           </a:p>
         </p:txBody>

</xml_diff>

<commit_message>
Validate pipeline connector layout
</commit_message>
<xml_diff>
--- a/docs/assets/pipeline-overview.pptx
+++ b/docs/assets/pipeline-overview.pptx
@@ -129,7 +129,7 @@
           <p:cNvPr id="2" name="제목 1">
             <a:extLst>
               <a:ext uri="{FF2B5EF4-FFF2-40B4-BE49-F238E27FC236}">
-                <a16:creationId xmlns:a16="http://schemas.microsoft.com/office/drawing/2014/main" id="{68FFBA55-16AA-7A6E-4B39-B9EF05E5B746}"/>
+                <a16:creationId xmlns:a16="http://schemas.microsoft.com/office/drawing/2014/main" id="{01359E97-4178-2869-1337-8A3246AC1B88}"/>
               </a:ext>
             </a:extLst>
           </p:cNvPr>
@@ -166,7 +166,7 @@
           <p:cNvPr id="3" name="부제목 2">
             <a:extLst>
               <a:ext uri="{FF2B5EF4-FFF2-40B4-BE49-F238E27FC236}">
-                <a16:creationId xmlns:a16="http://schemas.microsoft.com/office/drawing/2014/main" id="{A6290E87-F69F-E4A7-22AE-69CC4AF32B8F}"/>
+                <a16:creationId xmlns:a16="http://schemas.microsoft.com/office/drawing/2014/main" id="{7CA3827E-A20B-D05A-1A92-04EF0C671F4B}"/>
               </a:ext>
             </a:extLst>
           </p:cNvPr>
@@ -236,7 +236,7 @@
           <p:cNvPr id="4" name="날짜 개체 틀 3">
             <a:extLst>
               <a:ext uri="{FF2B5EF4-FFF2-40B4-BE49-F238E27FC236}">
-                <a16:creationId xmlns:a16="http://schemas.microsoft.com/office/drawing/2014/main" id="{D2060FFB-1A8C-9A15-BCA4-0C3D9337B041}"/>
+                <a16:creationId xmlns:a16="http://schemas.microsoft.com/office/drawing/2014/main" id="{F12E059E-BDA8-568A-C2A5-AF7F529D79AD}"/>
               </a:ext>
             </a:extLst>
           </p:cNvPr>
@@ -252,7 +252,7 @@
           <a:bodyPr/>
           <a:lstStyle/>
           <a:p>
-            <a:fld id="{DD780B16-97CC-434D-8C6E-53CCF84409AD}" type="datetimeFigureOut">
+            <a:fld id="{FBD92C38-B0C8-4D61-B511-2B35933A6C49}" type="datetimeFigureOut">
               <a:rPr lang="ko-KR" altLang="en-US" smtClean="0"/>
               <a:t>2026-06-19</a:t>
             </a:fld>
@@ -265,7 +265,7 @@
           <p:cNvPr id="5" name="바닥글 개체 틀 4">
             <a:extLst>
               <a:ext uri="{FF2B5EF4-FFF2-40B4-BE49-F238E27FC236}">
-                <a16:creationId xmlns:a16="http://schemas.microsoft.com/office/drawing/2014/main" id="{20431A69-96E8-F1A7-96B5-5445F35ABABC}"/>
+                <a16:creationId xmlns:a16="http://schemas.microsoft.com/office/drawing/2014/main" id="{9EF1DEDA-B0D3-40A6-C0AE-E2532FEC27E5}"/>
               </a:ext>
             </a:extLst>
           </p:cNvPr>
@@ -290,7 +290,7 @@
           <p:cNvPr id="6" name="슬라이드 번호 개체 틀 5">
             <a:extLst>
               <a:ext uri="{FF2B5EF4-FFF2-40B4-BE49-F238E27FC236}">
-                <a16:creationId xmlns:a16="http://schemas.microsoft.com/office/drawing/2014/main" id="{46241856-4E27-0FE6-15A1-9886DB1BF4EF}"/>
+                <a16:creationId xmlns:a16="http://schemas.microsoft.com/office/drawing/2014/main" id="{94ACC732-7731-7B1D-928B-55176CE6DD5E}"/>
               </a:ext>
             </a:extLst>
           </p:cNvPr>
@@ -306,7 +306,7 @@
           <a:bodyPr/>
           <a:lstStyle/>
           <a:p>
-            <a:fld id="{0BB1D014-6EE4-4A79-AF60-E30C5800C9CC}" type="slidenum">
+            <a:fld id="{A77F83F0-4926-4A81-806C-F53BFF57509D}" type="slidenum">
               <a:rPr lang="ko-KR" altLang="en-US" smtClean="0"/>
               <a:t>‹#›</a:t>
             </a:fld>
@@ -317,7 +317,7 @@
     </p:spTree>
     <p:extLst>
       <p:ext uri="{BB962C8B-B14F-4D97-AF65-F5344CB8AC3E}">
-        <p14:creationId xmlns:p14="http://schemas.microsoft.com/office/powerpoint/2010/main" val="3151922513"/>
+        <p14:creationId xmlns:p14="http://schemas.microsoft.com/office/powerpoint/2010/main" val="2197558230"/>
       </p:ext>
     </p:extLst>
   </p:cSld>
@@ -349,7 +349,7 @@
           <p:cNvPr id="2" name="제목 1">
             <a:extLst>
               <a:ext uri="{FF2B5EF4-FFF2-40B4-BE49-F238E27FC236}">
-                <a16:creationId xmlns:a16="http://schemas.microsoft.com/office/drawing/2014/main" id="{2079E440-9F29-C7A0-B81A-2FC402727B64}"/>
+                <a16:creationId xmlns:a16="http://schemas.microsoft.com/office/drawing/2014/main" id="{E579BB05-BBBC-7095-995B-114B4525D67C}"/>
               </a:ext>
             </a:extLst>
           </p:cNvPr>
@@ -377,7 +377,7 @@
           <p:cNvPr id="3" name="세로 텍스트 개체 틀 2">
             <a:extLst>
               <a:ext uri="{FF2B5EF4-FFF2-40B4-BE49-F238E27FC236}">
-                <a16:creationId xmlns:a16="http://schemas.microsoft.com/office/drawing/2014/main" id="{4AA4C091-EF9E-0FC4-3EB2-82809CDC56BF}"/>
+                <a16:creationId xmlns:a16="http://schemas.microsoft.com/office/drawing/2014/main" id="{915B4677-97CC-9A7D-CDE8-F61C47EE6EAF}"/>
               </a:ext>
             </a:extLst>
           </p:cNvPr>
@@ -434,7 +434,7 @@
           <p:cNvPr id="4" name="날짜 개체 틀 3">
             <a:extLst>
               <a:ext uri="{FF2B5EF4-FFF2-40B4-BE49-F238E27FC236}">
-                <a16:creationId xmlns:a16="http://schemas.microsoft.com/office/drawing/2014/main" id="{D3F8290A-7616-2B52-AB3F-6A7B2B7AA6B5}"/>
+                <a16:creationId xmlns:a16="http://schemas.microsoft.com/office/drawing/2014/main" id="{1807447F-6B0F-83E3-D7A0-785E4497B268}"/>
               </a:ext>
             </a:extLst>
           </p:cNvPr>
@@ -450,7 +450,7 @@
           <a:bodyPr/>
           <a:lstStyle/>
           <a:p>
-            <a:fld id="{DD780B16-97CC-434D-8C6E-53CCF84409AD}" type="datetimeFigureOut">
+            <a:fld id="{FBD92C38-B0C8-4D61-B511-2B35933A6C49}" type="datetimeFigureOut">
               <a:rPr lang="ko-KR" altLang="en-US" smtClean="0"/>
               <a:t>2026-06-19</a:t>
             </a:fld>
@@ -463,7 +463,7 @@
           <p:cNvPr id="5" name="바닥글 개체 틀 4">
             <a:extLst>
               <a:ext uri="{FF2B5EF4-FFF2-40B4-BE49-F238E27FC236}">
-                <a16:creationId xmlns:a16="http://schemas.microsoft.com/office/drawing/2014/main" id="{CC5E1E02-8A21-2AA4-B926-3D1EE2414B7C}"/>
+                <a16:creationId xmlns:a16="http://schemas.microsoft.com/office/drawing/2014/main" id="{4655D705-AE06-A490-81A2-20F2803267A5}"/>
               </a:ext>
             </a:extLst>
           </p:cNvPr>
@@ -488,7 +488,7 @@
           <p:cNvPr id="6" name="슬라이드 번호 개체 틀 5">
             <a:extLst>
               <a:ext uri="{FF2B5EF4-FFF2-40B4-BE49-F238E27FC236}">
-                <a16:creationId xmlns:a16="http://schemas.microsoft.com/office/drawing/2014/main" id="{64D2040F-F29C-22FB-5E0B-125F1DF6A3EE}"/>
+                <a16:creationId xmlns:a16="http://schemas.microsoft.com/office/drawing/2014/main" id="{2DEEA013-7779-3153-7929-DDEE8B98DCCF}"/>
               </a:ext>
             </a:extLst>
           </p:cNvPr>
@@ -504,7 +504,7 @@
           <a:bodyPr/>
           <a:lstStyle/>
           <a:p>
-            <a:fld id="{0BB1D014-6EE4-4A79-AF60-E30C5800C9CC}" type="slidenum">
+            <a:fld id="{A77F83F0-4926-4A81-806C-F53BFF57509D}" type="slidenum">
               <a:rPr lang="ko-KR" altLang="en-US" smtClean="0"/>
               <a:t>‹#›</a:t>
             </a:fld>
@@ -515,7 +515,7 @@
     </p:spTree>
     <p:extLst>
       <p:ext uri="{BB962C8B-B14F-4D97-AF65-F5344CB8AC3E}">
-        <p14:creationId xmlns:p14="http://schemas.microsoft.com/office/powerpoint/2010/main" val="3210431029"/>
+        <p14:creationId xmlns:p14="http://schemas.microsoft.com/office/powerpoint/2010/main" val="2929774933"/>
       </p:ext>
     </p:extLst>
   </p:cSld>
@@ -547,7 +547,7 @@
           <p:cNvPr id="2" name="세로 제목 1">
             <a:extLst>
               <a:ext uri="{FF2B5EF4-FFF2-40B4-BE49-F238E27FC236}">
-                <a16:creationId xmlns:a16="http://schemas.microsoft.com/office/drawing/2014/main" id="{90CB5EAA-D125-BA6F-FEC0-0BCE38BC8AB1}"/>
+                <a16:creationId xmlns:a16="http://schemas.microsoft.com/office/drawing/2014/main" id="{17FEC5C8-BE35-CDF4-793F-28C8C497A355}"/>
               </a:ext>
             </a:extLst>
           </p:cNvPr>
@@ -580,7 +580,7 @@
           <p:cNvPr id="3" name="세로 텍스트 개체 틀 2">
             <a:extLst>
               <a:ext uri="{FF2B5EF4-FFF2-40B4-BE49-F238E27FC236}">
-                <a16:creationId xmlns:a16="http://schemas.microsoft.com/office/drawing/2014/main" id="{CE19C076-113F-CAE8-E627-9FE60E169A58}"/>
+                <a16:creationId xmlns:a16="http://schemas.microsoft.com/office/drawing/2014/main" id="{9487CC96-91F5-76F0-C349-D4980D89DF53}"/>
               </a:ext>
             </a:extLst>
           </p:cNvPr>
@@ -642,7 +642,7 @@
           <p:cNvPr id="4" name="날짜 개체 틀 3">
             <a:extLst>
               <a:ext uri="{FF2B5EF4-FFF2-40B4-BE49-F238E27FC236}">
-                <a16:creationId xmlns:a16="http://schemas.microsoft.com/office/drawing/2014/main" id="{55AC34C1-7554-A5A5-D1B2-5B68B23E49DB}"/>
+                <a16:creationId xmlns:a16="http://schemas.microsoft.com/office/drawing/2014/main" id="{9B102A23-78E5-1851-5B62-91758DEAC4E9}"/>
               </a:ext>
             </a:extLst>
           </p:cNvPr>
@@ -658,7 +658,7 @@
           <a:bodyPr/>
           <a:lstStyle/>
           <a:p>
-            <a:fld id="{DD780B16-97CC-434D-8C6E-53CCF84409AD}" type="datetimeFigureOut">
+            <a:fld id="{FBD92C38-B0C8-4D61-B511-2B35933A6C49}" type="datetimeFigureOut">
               <a:rPr lang="ko-KR" altLang="en-US" smtClean="0"/>
               <a:t>2026-06-19</a:t>
             </a:fld>
@@ -671,7 +671,7 @@
           <p:cNvPr id="5" name="바닥글 개체 틀 4">
             <a:extLst>
               <a:ext uri="{FF2B5EF4-FFF2-40B4-BE49-F238E27FC236}">
-                <a16:creationId xmlns:a16="http://schemas.microsoft.com/office/drawing/2014/main" id="{D608FC99-A111-A9C4-7DEE-0D371E2B1B6D}"/>
+                <a16:creationId xmlns:a16="http://schemas.microsoft.com/office/drawing/2014/main" id="{EC07014D-EA3F-497C-5577-094246555B3C}"/>
               </a:ext>
             </a:extLst>
           </p:cNvPr>
@@ -696,7 +696,7 @@
           <p:cNvPr id="6" name="슬라이드 번호 개체 틀 5">
             <a:extLst>
               <a:ext uri="{FF2B5EF4-FFF2-40B4-BE49-F238E27FC236}">
-                <a16:creationId xmlns:a16="http://schemas.microsoft.com/office/drawing/2014/main" id="{C14C6B6D-8B59-79FB-017D-C8E641C214D3}"/>
+                <a16:creationId xmlns:a16="http://schemas.microsoft.com/office/drawing/2014/main" id="{46F37EAB-9F53-FAAF-586C-2949D7E1C4FE}"/>
               </a:ext>
             </a:extLst>
           </p:cNvPr>
@@ -712,7 +712,7 @@
           <a:bodyPr/>
           <a:lstStyle/>
           <a:p>
-            <a:fld id="{0BB1D014-6EE4-4A79-AF60-E30C5800C9CC}" type="slidenum">
+            <a:fld id="{A77F83F0-4926-4A81-806C-F53BFF57509D}" type="slidenum">
               <a:rPr lang="ko-KR" altLang="en-US" smtClean="0"/>
               <a:t>‹#›</a:t>
             </a:fld>
@@ -723,7 +723,7 @@
     </p:spTree>
     <p:extLst>
       <p:ext uri="{BB962C8B-B14F-4D97-AF65-F5344CB8AC3E}">
-        <p14:creationId xmlns:p14="http://schemas.microsoft.com/office/powerpoint/2010/main" val="284596751"/>
+        <p14:creationId xmlns:p14="http://schemas.microsoft.com/office/powerpoint/2010/main" val="4210593025"/>
       </p:ext>
     </p:extLst>
   </p:cSld>
@@ -755,7 +755,7 @@
           <p:cNvPr id="2" name="제목 1">
             <a:extLst>
               <a:ext uri="{FF2B5EF4-FFF2-40B4-BE49-F238E27FC236}">
-                <a16:creationId xmlns:a16="http://schemas.microsoft.com/office/drawing/2014/main" id="{D3772DF6-4613-0748-505D-DD3F7DF64110}"/>
+                <a16:creationId xmlns:a16="http://schemas.microsoft.com/office/drawing/2014/main" id="{6BCC5FAE-5F66-F01F-0C49-2D7A6D92CF0C}"/>
               </a:ext>
             </a:extLst>
           </p:cNvPr>
@@ -783,7 +783,7 @@
           <p:cNvPr id="3" name="내용 개체 틀 2">
             <a:extLst>
               <a:ext uri="{FF2B5EF4-FFF2-40B4-BE49-F238E27FC236}">
-                <a16:creationId xmlns:a16="http://schemas.microsoft.com/office/drawing/2014/main" id="{1EE5398E-8838-4CCF-4173-31DB1CACDD29}"/>
+                <a16:creationId xmlns:a16="http://schemas.microsoft.com/office/drawing/2014/main" id="{27492B8D-FC86-876A-68B7-E74BFC4A5EE5}"/>
               </a:ext>
             </a:extLst>
           </p:cNvPr>
@@ -840,7 +840,7 @@
           <p:cNvPr id="4" name="날짜 개체 틀 3">
             <a:extLst>
               <a:ext uri="{FF2B5EF4-FFF2-40B4-BE49-F238E27FC236}">
-                <a16:creationId xmlns:a16="http://schemas.microsoft.com/office/drawing/2014/main" id="{58435BCE-5924-A420-6C64-B1A5352F5E26}"/>
+                <a16:creationId xmlns:a16="http://schemas.microsoft.com/office/drawing/2014/main" id="{505622BC-1E35-E2DA-7E01-E0445A3A21AA}"/>
               </a:ext>
             </a:extLst>
           </p:cNvPr>
@@ -856,7 +856,7 @@
           <a:bodyPr/>
           <a:lstStyle/>
           <a:p>
-            <a:fld id="{DD780B16-97CC-434D-8C6E-53CCF84409AD}" type="datetimeFigureOut">
+            <a:fld id="{FBD92C38-B0C8-4D61-B511-2B35933A6C49}" type="datetimeFigureOut">
               <a:rPr lang="ko-KR" altLang="en-US" smtClean="0"/>
               <a:t>2026-06-19</a:t>
             </a:fld>
@@ -869,7 +869,7 @@
           <p:cNvPr id="5" name="바닥글 개체 틀 4">
             <a:extLst>
               <a:ext uri="{FF2B5EF4-FFF2-40B4-BE49-F238E27FC236}">
-                <a16:creationId xmlns:a16="http://schemas.microsoft.com/office/drawing/2014/main" id="{2805DD7C-B5DB-FE3C-A230-6500CC061D5A}"/>
+                <a16:creationId xmlns:a16="http://schemas.microsoft.com/office/drawing/2014/main" id="{D844E76A-C380-2F2D-3150-7F61BBA62E4D}"/>
               </a:ext>
             </a:extLst>
           </p:cNvPr>
@@ -894,7 +894,7 @@
           <p:cNvPr id="6" name="슬라이드 번호 개체 틀 5">
             <a:extLst>
               <a:ext uri="{FF2B5EF4-FFF2-40B4-BE49-F238E27FC236}">
-                <a16:creationId xmlns:a16="http://schemas.microsoft.com/office/drawing/2014/main" id="{71A74622-276E-5B7D-05B4-10C8B2E99AE9}"/>
+                <a16:creationId xmlns:a16="http://schemas.microsoft.com/office/drawing/2014/main" id="{3CA5941B-4340-45FE-A3A0-F440F24EDD3B}"/>
               </a:ext>
             </a:extLst>
           </p:cNvPr>
@@ -910,7 +910,7 @@
           <a:bodyPr/>
           <a:lstStyle/>
           <a:p>
-            <a:fld id="{0BB1D014-6EE4-4A79-AF60-E30C5800C9CC}" type="slidenum">
+            <a:fld id="{A77F83F0-4926-4A81-806C-F53BFF57509D}" type="slidenum">
               <a:rPr lang="ko-KR" altLang="en-US" smtClean="0"/>
               <a:t>‹#›</a:t>
             </a:fld>
@@ -921,7 +921,7 @@
     </p:spTree>
     <p:extLst>
       <p:ext uri="{BB962C8B-B14F-4D97-AF65-F5344CB8AC3E}">
-        <p14:creationId xmlns:p14="http://schemas.microsoft.com/office/powerpoint/2010/main" val="2855792209"/>
+        <p14:creationId xmlns:p14="http://schemas.microsoft.com/office/powerpoint/2010/main" val="1743702733"/>
       </p:ext>
     </p:extLst>
   </p:cSld>
@@ -953,7 +953,7 @@
           <p:cNvPr id="2" name="제목 1">
             <a:extLst>
               <a:ext uri="{FF2B5EF4-FFF2-40B4-BE49-F238E27FC236}">
-                <a16:creationId xmlns:a16="http://schemas.microsoft.com/office/drawing/2014/main" id="{E081DB2E-7E2E-DFFB-6CAF-621551A29C1A}"/>
+                <a16:creationId xmlns:a16="http://schemas.microsoft.com/office/drawing/2014/main" id="{4D1BD8E2-FD41-C356-A6D0-9FAEA2EC66BD}"/>
               </a:ext>
             </a:extLst>
           </p:cNvPr>
@@ -990,7 +990,7 @@
           <p:cNvPr id="3" name="텍스트 개체 틀 2">
             <a:extLst>
               <a:ext uri="{FF2B5EF4-FFF2-40B4-BE49-F238E27FC236}">
-                <a16:creationId xmlns:a16="http://schemas.microsoft.com/office/drawing/2014/main" id="{3E4F9160-0D59-CADB-B608-44C2ED7E4308}"/>
+                <a16:creationId xmlns:a16="http://schemas.microsoft.com/office/drawing/2014/main" id="{A70783F1-A1B6-E8E9-E68B-500D3846DD2E}"/>
               </a:ext>
             </a:extLst>
           </p:cNvPr>
@@ -1115,7 +1115,7 @@
           <p:cNvPr id="4" name="날짜 개체 틀 3">
             <a:extLst>
               <a:ext uri="{FF2B5EF4-FFF2-40B4-BE49-F238E27FC236}">
-                <a16:creationId xmlns:a16="http://schemas.microsoft.com/office/drawing/2014/main" id="{6770B856-2783-0FDB-31CF-20BECD0D0FB2}"/>
+                <a16:creationId xmlns:a16="http://schemas.microsoft.com/office/drawing/2014/main" id="{A21EC263-C078-31E6-1D40-6EE67C3259AE}"/>
               </a:ext>
             </a:extLst>
           </p:cNvPr>
@@ -1131,7 +1131,7 @@
           <a:bodyPr/>
           <a:lstStyle/>
           <a:p>
-            <a:fld id="{DD780B16-97CC-434D-8C6E-53CCF84409AD}" type="datetimeFigureOut">
+            <a:fld id="{FBD92C38-B0C8-4D61-B511-2B35933A6C49}" type="datetimeFigureOut">
               <a:rPr lang="ko-KR" altLang="en-US" smtClean="0"/>
               <a:t>2026-06-19</a:t>
             </a:fld>
@@ -1144,7 +1144,7 @@
           <p:cNvPr id="5" name="바닥글 개체 틀 4">
             <a:extLst>
               <a:ext uri="{FF2B5EF4-FFF2-40B4-BE49-F238E27FC236}">
-                <a16:creationId xmlns:a16="http://schemas.microsoft.com/office/drawing/2014/main" id="{363DFDBE-8946-0A38-4EBB-A966ADC0BFBF}"/>
+                <a16:creationId xmlns:a16="http://schemas.microsoft.com/office/drawing/2014/main" id="{BE049CF7-9912-11FC-C60A-A51A9BDD7224}"/>
               </a:ext>
             </a:extLst>
           </p:cNvPr>
@@ -1169,7 +1169,7 @@
           <p:cNvPr id="6" name="슬라이드 번호 개체 틀 5">
             <a:extLst>
               <a:ext uri="{FF2B5EF4-FFF2-40B4-BE49-F238E27FC236}">
-                <a16:creationId xmlns:a16="http://schemas.microsoft.com/office/drawing/2014/main" id="{89D754D4-3D8A-A4F8-CB60-8A463F283230}"/>
+                <a16:creationId xmlns:a16="http://schemas.microsoft.com/office/drawing/2014/main" id="{DF0BF0F7-63CD-D9DA-55DD-89EEC7E0CF88}"/>
               </a:ext>
             </a:extLst>
           </p:cNvPr>
@@ -1185,7 +1185,7 @@
           <a:bodyPr/>
           <a:lstStyle/>
           <a:p>
-            <a:fld id="{0BB1D014-6EE4-4A79-AF60-E30C5800C9CC}" type="slidenum">
+            <a:fld id="{A77F83F0-4926-4A81-806C-F53BFF57509D}" type="slidenum">
               <a:rPr lang="ko-KR" altLang="en-US" smtClean="0"/>
               <a:t>‹#›</a:t>
             </a:fld>
@@ -1196,7 +1196,7 @@
     </p:spTree>
     <p:extLst>
       <p:ext uri="{BB962C8B-B14F-4D97-AF65-F5344CB8AC3E}">
-        <p14:creationId xmlns:p14="http://schemas.microsoft.com/office/powerpoint/2010/main" val="3716015895"/>
+        <p14:creationId xmlns:p14="http://schemas.microsoft.com/office/powerpoint/2010/main" val="2314713360"/>
       </p:ext>
     </p:extLst>
   </p:cSld>
@@ -1228,7 +1228,7 @@
           <p:cNvPr id="2" name="제목 1">
             <a:extLst>
               <a:ext uri="{FF2B5EF4-FFF2-40B4-BE49-F238E27FC236}">
-                <a16:creationId xmlns:a16="http://schemas.microsoft.com/office/drawing/2014/main" id="{1966610F-BC26-9D0D-2E85-2C22C65DB65F}"/>
+                <a16:creationId xmlns:a16="http://schemas.microsoft.com/office/drawing/2014/main" id="{8083116F-70D5-0440-EB13-B0E392849F50}"/>
               </a:ext>
             </a:extLst>
           </p:cNvPr>
@@ -1256,7 +1256,7 @@
           <p:cNvPr id="3" name="내용 개체 틀 2">
             <a:extLst>
               <a:ext uri="{FF2B5EF4-FFF2-40B4-BE49-F238E27FC236}">
-                <a16:creationId xmlns:a16="http://schemas.microsoft.com/office/drawing/2014/main" id="{1FA8DD36-6B92-CC43-723F-0A4DADF7400E}"/>
+                <a16:creationId xmlns:a16="http://schemas.microsoft.com/office/drawing/2014/main" id="{28D676D2-CC6E-51EB-826F-ECBB43FF68AE}"/>
               </a:ext>
             </a:extLst>
           </p:cNvPr>
@@ -1318,7 +1318,7 @@
           <p:cNvPr id="4" name="내용 개체 틀 3">
             <a:extLst>
               <a:ext uri="{FF2B5EF4-FFF2-40B4-BE49-F238E27FC236}">
-                <a16:creationId xmlns:a16="http://schemas.microsoft.com/office/drawing/2014/main" id="{59A6CED7-00D5-DB74-F3C0-D56DE9217C88}"/>
+                <a16:creationId xmlns:a16="http://schemas.microsoft.com/office/drawing/2014/main" id="{B1BA4F48-1D11-6008-69B3-CBFE3AD1667E}"/>
               </a:ext>
             </a:extLst>
           </p:cNvPr>
@@ -1380,7 +1380,7 @@
           <p:cNvPr id="5" name="날짜 개체 틀 4">
             <a:extLst>
               <a:ext uri="{FF2B5EF4-FFF2-40B4-BE49-F238E27FC236}">
-                <a16:creationId xmlns:a16="http://schemas.microsoft.com/office/drawing/2014/main" id="{01472FF4-6BD3-AE9C-DDA6-18284E6A2399}"/>
+                <a16:creationId xmlns:a16="http://schemas.microsoft.com/office/drawing/2014/main" id="{83138F0E-6B42-4BD7-F803-DCA94D216714}"/>
               </a:ext>
             </a:extLst>
           </p:cNvPr>
@@ -1396,7 +1396,7 @@
           <a:bodyPr/>
           <a:lstStyle/>
           <a:p>
-            <a:fld id="{DD780B16-97CC-434D-8C6E-53CCF84409AD}" type="datetimeFigureOut">
+            <a:fld id="{FBD92C38-B0C8-4D61-B511-2B35933A6C49}" type="datetimeFigureOut">
               <a:rPr lang="ko-KR" altLang="en-US" smtClean="0"/>
               <a:t>2026-06-19</a:t>
             </a:fld>
@@ -1409,7 +1409,7 @@
           <p:cNvPr id="6" name="바닥글 개체 틀 5">
             <a:extLst>
               <a:ext uri="{FF2B5EF4-FFF2-40B4-BE49-F238E27FC236}">
-                <a16:creationId xmlns:a16="http://schemas.microsoft.com/office/drawing/2014/main" id="{1E3469E7-4621-1EA1-BBE3-288FF2CD5746}"/>
+                <a16:creationId xmlns:a16="http://schemas.microsoft.com/office/drawing/2014/main" id="{C97CB2B1-BAB0-48E8-DEC2-FB14D94B8537}"/>
               </a:ext>
             </a:extLst>
           </p:cNvPr>
@@ -1434,7 +1434,7 @@
           <p:cNvPr id="7" name="슬라이드 번호 개체 틀 6">
             <a:extLst>
               <a:ext uri="{FF2B5EF4-FFF2-40B4-BE49-F238E27FC236}">
-                <a16:creationId xmlns:a16="http://schemas.microsoft.com/office/drawing/2014/main" id="{B25DD4CB-1A55-BC4A-9825-604C28245983}"/>
+                <a16:creationId xmlns:a16="http://schemas.microsoft.com/office/drawing/2014/main" id="{93A762BE-5F31-5FE8-E5A1-27BA2465E3C9}"/>
               </a:ext>
             </a:extLst>
           </p:cNvPr>
@@ -1450,7 +1450,7 @@
           <a:bodyPr/>
           <a:lstStyle/>
           <a:p>
-            <a:fld id="{0BB1D014-6EE4-4A79-AF60-E30C5800C9CC}" type="slidenum">
+            <a:fld id="{A77F83F0-4926-4A81-806C-F53BFF57509D}" type="slidenum">
               <a:rPr lang="ko-KR" altLang="en-US" smtClean="0"/>
               <a:t>‹#›</a:t>
             </a:fld>
@@ -1461,7 +1461,7 @@
     </p:spTree>
     <p:extLst>
       <p:ext uri="{BB962C8B-B14F-4D97-AF65-F5344CB8AC3E}">
-        <p14:creationId xmlns:p14="http://schemas.microsoft.com/office/powerpoint/2010/main" val="1881468143"/>
+        <p14:creationId xmlns:p14="http://schemas.microsoft.com/office/powerpoint/2010/main" val="1919991502"/>
       </p:ext>
     </p:extLst>
   </p:cSld>
@@ -1493,7 +1493,7 @@
           <p:cNvPr id="2" name="제목 1">
             <a:extLst>
               <a:ext uri="{FF2B5EF4-FFF2-40B4-BE49-F238E27FC236}">
-                <a16:creationId xmlns:a16="http://schemas.microsoft.com/office/drawing/2014/main" id="{D179AEC3-2E2C-9435-5E36-DBE325DFE5CC}"/>
+                <a16:creationId xmlns:a16="http://schemas.microsoft.com/office/drawing/2014/main" id="{E53DDB7E-6F7D-31ED-E26F-E77CE025E52D}"/>
               </a:ext>
             </a:extLst>
           </p:cNvPr>
@@ -1526,7 +1526,7 @@
           <p:cNvPr id="3" name="텍스트 개체 틀 2">
             <a:extLst>
               <a:ext uri="{FF2B5EF4-FFF2-40B4-BE49-F238E27FC236}">
-                <a16:creationId xmlns:a16="http://schemas.microsoft.com/office/drawing/2014/main" id="{6E0ACCEA-110A-422B-C8AB-DD0C621BCCD4}"/>
+                <a16:creationId xmlns:a16="http://schemas.microsoft.com/office/drawing/2014/main" id="{7ED584A4-8C27-6C4D-7CA3-1B40AE0C2FCD}"/>
               </a:ext>
             </a:extLst>
           </p:cNvPr>
@@ -1597,7 +1597,7 @@
           <p:cNvPr id="4" name="내용 개체 틀 3">
             <a:extLst>
               <a:ext uri="{FF2B5EF4-FFF2-40B4-BE49-F238E27FC236}">
-                <a16:creationId xmlns:a16="http://schemas.microsoft.com/office/drawing/2014/main" id="{08055E0E-CE64-884E-76D5-5E8804952F10}"/>
+                <a16:creationId xmlns:a16="http://schemas.microsoft.com/office/drawing/2014/main" id="{980A1C98-A70B-4535-EB2A-47C5A8F9311E}"/>
               </a:ext>
             </a:extLst>
           </p:cNvPr>
@@ -1659,7 +1659,7 @@
           <p:cNvPr id="5" name="텍스트 개체 틀 4">
             <a:extLst>
               <a:ext uri="{FF2B5EF4-FFF2-40B4-BE49-F238E27FC236}">
-                <a16:creationId xmlns:a16="http://schemas.microsoft.com/office/drawing/2014/main" id="{7E603264-64D6-DA0D-C754-6984A47CEB7B}"/>
+                <a16:creationId xmlns:a16="http://schemas.microsoft.com/office/drawing/2014/main" id="{10720380-8D30-A571-D4DB-4B316D8A1A67}"/>
               </a:ext>
             </a:extLst>
           </p:cNvPr>
@@ -1730,7 +1730,7 @@
           <p:cNvPr id="6" name="내용 개체 틀 5">
             <a:extLst>
               <a:ext uri="{FF2B5EF4-FFF2-40B4-BE49-F238E27FC236}">
-                <a16:creationId xmlns:a16="http://schemas.microsoft.com/office/drawing/2014/main" id="{33D9A40D-C7EA-8498-62DF-DCE911DC96F5}"/>
+                <a16:creationId xmlns:a16="http://schemas.microsoft.com/office/drawing/2014/main" id="{9C21517C-E266-6C5F-6F01-66C3B0E7886C}"/>
               </a:ext>
             </a:extLst>
           </p:cNvPr>
@@ -1792,7 +1792,7 @@
           <p:cNvPr id="7" name="날짜 개체 틀 6">
             <a:extLst>
               <a:ext uri="{FF2B5EF4-FFF2-40B4-BE49-F238E27FC236}">
-                <a16:creationId xmlns:a16="http://schemas.microsoft.com/office/drawing/2014/main" id="{C4E9BC08-9BF6-E2B0-7C4A-06B94D343017}"/>
+                <a16:creationId xmlns:a16="http://schemas.microsoft.com/office/drawing/2014/main" id="{53837287-C999-40CA-3041-837556CA1BCE}"/>
               </a:ext>
             </a:extLst>
           </p:cNvPr>
@@ -1808,7 +1808,7 @@
           <a:bodyPr/>
           <a:lstStyle/>
           <a:p>
-            <a:fld id="{DD780B16-97CC-434D-8C6E-53CCF84409AD}" type="datetimeFigureOut">
+            <a:fld id="{FBD92C38-B0C8-4D61-B511-2B35933A6C49}" type="datetimeFigureOut">
               <a:rPr lang="ko-KR" altLang="en-US" smtClean="0"/>
               <a:t>2026-06-19</a:t>
             </a:fld>
@@ -1821,7 +1821,7 @@
           <p:cNvPr id="8" name="바닥글 개체 틀 7">
             <a:extLst>
               <a:ext uri="{FF2B5EF4-FFF2-40B4-BE49-F238E27FC236}">
-                <a16:creationId xmlns:a16="http://schemas.microsoft.com/office/drawing/2014/main" id="{124E6546-C7A9-44EA-2901-16D7874740B1}"/>
+                <a16:creationId xmlns:a16="http://schemas.microsoft.com/office/drawing/2014/main" id="{C991FB1F-AC3D-66C9-3CA7-4CA759D0A3C6}"/>
               </a:ext>
             </a:extLst>
           </p:cNvPr>
@@ -1846,7 +1846,7 @@
           <p:cNvPr id="9" name="슬라이드 번호 개체 틀 8">
             <a:extLst>
               <a:ext uri="{FF2B5EF4-FFF2-40B4-BE49-F238E27FC236}">
-                <a16:creationId xmlns:a16="http://schemas.microsoft.com/office/drawing/2014/main" id="{75EE0FA6-E6C4-58B4-E4AF-F5CDC76FA3C6}"/>
+                <a16:creationId xmlns:a16="http://schemas.microsoft.com/office/drawing/2014/main" id="{706FB7EA-350F-0259-DF63-1532CC5AFAEE}"/>
               </a:ext>
             </a:extLst>
           </p:cNvPr>
@@ -1862,7 +1862,7 @@
           <a:bodyPr/>
           <a:lstStyle/>
           <a:p>
-            <a:fld id="{0BB1D014-6EE4-4A79-AF60-E30C5800C9CC}" type="slidenum">
+            <a:fld id="{A77F83F0-4926-4A81-806C-F53BFF57509D}" type="slidenum">
               <a:rPr lang="ko-KR" altLang="en-US" smtClean="0"/>
               <a:t>‹#›</a:t>
             </a:fld>
@@ -1873,7 +1873,7 @@
     </p:spTree>
     <p:extLst>
       <p:ext uri="{BB962C8B-B14F-4D97-AF65-F5344CB8AC3E}">
-        <p14:creationId xmlns:p14="http://schemas.microsoft.com/office/powerpoint/2010/main" val="4057832798"/>
+        <p14:creationId xmlns:p14="http://schemas.microsoft.com/office/powerpoint/2010/main" val="687456718"/>
       </p:ext>
     </p:extLst>
   </p:cSld>
@@ -1905,7 +1905,7 @@
           <p:cNvPr id="2" name="제목 1">
             <a:extLst>
               <a:ext uri="{FF2B5EF4-FFF2-40B4-BE49-F238E27FC236}">
-                <a16:creationId xmlns:a16="http://schemas.microsoft.com/office/drawing/2014/main" id="{650D7C15-46D4-1927-29D1-194CC7C07221}"/>
+                <a16:creationId xmlns:a16="http://schemas.microsoft.com/office/drawing/2014/main" id="{87355807-A593-5CAE-14FB-3CC415B120C5}"/>
               </a:ext>
             </a:extLst>
           </p:cNvPr>
@@ -1933,7 +1933,7 @@
           <p:cNvPr id="3" name="날짜 개체 틀 2">
             <a:extLst>
               <a:ext uri="{FF2B5EF4-FFF2-40B4-BE49-F238E27FC236}">
-                <a16:creationId xmlns:a16="http://schemas.microsoft.com/office/drawing/2014/main" id="{3D54B16F-C86B-CEEB-E3A8-C39EBE11F27C}"/>
+                <a16:creationId xmlns:a16="http://schemas.microsoft.com/office/drawing/2014/main" id="{67B6537C-8313-4562-CE18-5E727F16B5BF}"/>
               </a:ext>
             </a:extLst>
           </p:cNvPr>
@@ -1949,7 +1949,7 @@
           <a:bodyPr/>
           <a:lstStyle/>
           <a:p>
-            <a:fld id="{DD780B16-97CC-434D-8C6E-53CCF84409AD}" type="datetimeFigureOut">
+            <a:fld id="{FBD92C38-B0C8-4D61-B511-2B35933A6C49}" type="datetimeFigureOut">
               <a:rPr lang="ko-KR" altLang="en-US" smtClean="0"/>
               <a:t>2026-06-19</a:t>
             </a:fld>
@@ -1962,7 +1962,7 @@
           <p:cNvPr id="4" name="바닥글 개체 틀 3">
             <a:extLst>
               <a:ext uri="{FF2B5EF4-FFF2-40B4-BE49-F238E27FC236}">
-                <a16:creationId xmlns:a16="http://schemas.microsoft.com/office/drawing/2014/main" id="{2240777C-CD87-6AFA-FD98-5D841B6486E7}"/>
+                <a16:creationId xmlns:a16="http://schemas.microsoft.com/office/drawing/2014/main" id="{CB36B3C0-DEBB-4B96-3ADC-6B2F5A814A2C}"/>
               </a:ext>
             </a:extLst>
           </p:cNvPr>
@@ -1987,7 +1987,7 @@
           <p:cNvPr id="5" name="슬라이드 번호 개체 틀 4">
             <a:extLst>
               <a:ext uri="{FF2B5EF4-FFF2-40B4-BE49-F238E27FC236}">
-                <a16:creationId xmlns:a16="http://schemas.microsoft.com/office/drawing/2014/main" id="{3CD7F03C-D487-22B9-7F65-2D3ED54442EA}"/>
+                <a16:creationId xmlns:a16="http://schemas.microsoft.com/office/drawing/2014/main" id="{758EEB0B-7975-CC21-41DD-C4BCF81E17EC}"/>
               </a:ext>
             </a:extLst>
           </p:cNvPr>
@@ -2003,7 +2003,7 @@
           <a:bodyPr/>
           <a:lstStyle/>
           <a:p>
-            <a:fld id="{0BB1D014-6EE4-4A79-AF60-E30C5800C9CC}" type="slidenum">
+            <a:fld id="{A77F83F0-4926-4A81-806C-F53BFF57509D}" type="slidenum">
               <a:rPr lang="ko-KR" altLang="en-US" smtClean="0"/>
               <a:t>‹#›</a:t>
             </a:fld>
@@ -2014,7 +2014,7 @@
     </p:spTree>
     <p:extLst>
       <p:ext uri="{BB962C8B-B14F-4D97-AF65-F5344CB8AC3E}">
-        <p14:creationId xmlns:p14="http://schemas.microsoft.com/office/powerpoint/2010/main" val="3812747188"/>
+        <p14:creationId xmlns:p14="http://schemas.microsoft.com/office/powerpoint/2010/main" val="869215520"/>
       </p:ext>
     </p:extLst>
   </p:cSld>
@@ -2046,7 +2046,7 @@
           <p:cNvPr id="2" name="날짜 개체 틀 1">
             <a:extLst>
               <a:ext uri="{FF2B5EF4-FFF2-40B4-BE49-F238E27FC236}">
-                <a16:creationId xmlns:a16="http://schemas.microsoft.com/office/drawing/2014/main" id="{4418CA73-9D85-1FC4-D376-F8956FE00E5F}"/>
+                <a16:creationId xmlns:a16="http://schemas.microsoft.com/office/drawing/2014/main" id="{FBDA4900-AB43-5C54-A2A9-AE94E49C607C}"/>
               </a:ext>
             </a:extLst>
           </p:cNvPr>
@@ -2062,7 +2062,7 @@
           <a:bodyPr/>
           <a:lstStyle/>
           <a:p>
-            <a:fld id="{DD780B16-97CC-434D-8C6E-53CCF84409AD}" type="datetimeFigureOut">
+            <a:fld id="{FBD92C38-B0C8-4D61-B511-2B35933A6C49}" type="datetimeFigureOut">
               <a:rPr lang="ko-KR" altLang="en-US" smtClean="0"/>
               <a:t>2026-06-19</a:t>
             </a:fld>
@@ -2075,7 +2075,7 @@
           <p:cNvPr id="3" name="바닥글 개체 틀 2">
             <a:extLst>
               <a:ext uri="{FF2B5EF4-FFF2-40B4-BE49-F238E27FC236}">
-                <a16:creationId xmlns:a16="http://schemas.microsoft.com/office/drawing/2014/main" id="{347D3B8B-DEA2-E0E2-3EDB-B17B73DB03E4}"/>
+                <a16:creationId xmlns:a16="http://schemas.microsoft.com/office/drawing/2014/main" id="{F756D1F6-FA89-BD71-2361-CA78DA210E33}"/>
               </a:ext>
             </a:extLst>
           </p:cNvPr>
@@ -2100,7 +2100,7 @@
           <p:cNvPr id="4" name="슬라이드 번호 개체 틀 3">
             <a:extLst>
               <a:ext uri="{FF2B5EF4-FFF2-40B4-BE49-F238E27FC236}">
-                <a16:creationId xmlns:a16="http://schemas.microsoft.com/office/drawing/2014/main" id="{C8008328-498A-F688-C40A-FA77C212A33C}"/>
+                <a16:creationId xmlns:a16="http://schemas.microsoft.com/office/drawing/2014/main" id="{29A3A197-B442-2027-7B97-F54451B351E6}"/>
               </a:ext>
             </a:extLst>
           </p:cNvPr>
@@ -2116,7 +2116,7 @@
           <a:bodyPr/>
           <a:lstStyle/>
           <a:p>
-            <a:fld id="{0BB1D014-6EE4-4A79-AF60-E30C5800C9CC}" type="slidenum">
+            <a:fld id="{A77F83F0-4926-4A81-806C-F53BFF57509D}" type="slidenum">
               <a:rPr lang="ko-KR" altLang="en-US" smtClean="0"/>
               <a:t>‹#›</a:t>
             </a:fld>
@@ -2127,7 +2127,7 @@
     </p:spTree>
     <p:extLst>
       <p:ext uri="{BB962C8B-B14F-4D97-AF65-F5344CB8AC3E}">
-        <p14:creationId xmlns:p14="http://schemas.microsoft.com/office/powerpoint/2010/main" val="3661187816"/>
+        <p14:creationId xmlns:p14="http://schemas.microsoft.com/office/powerpoint/2010/main" val="1888166526"/>
       </p:ext>
     </p:extLst>
   </p:cSld>
@@ -2159,7 +2159,7 @@
           <p:cNvPr id="2" name="제목 1">
             <a:extLst>
               <a:ext uri="{FF2B5EF4-FFF2-40B4-BE49-F238E27FC236}">
-                <a16:creationId xmlns:a16="http://schemas.microsoft.com/office/drawing/2014/main" id="{00ED712C-A110-BBA5-5586-9B8BA2D8689D}"/>
+                <a16:creationId xmlns:a16="http://schemas.microsoft.com/office/drawing/2014/main" id="{9D8AF906-9D68-CA52-477F-BAC21945BB0B}"/>
               </a:ext>
             </a:extLst>
           </p:cNvPr>
@@ -2196,7 +2196,7 @@
           <p:cNvPr id="3" name="내용 개체 틀 2">
             <a:extLst>
               <a:ext uri="{FF2B5EF4-FFF2-40B4-BE49-F238E27FC236}">
-                <a16:creationId xmlns:a16="http://schemas.microsoft.com/office/drawing/2014/main" id="{9F76CA5A-4D39-3678-5AF5-126004864592}"/>
+                <a16:creationId xmlns:a16="http://schemas.microsoft.com/office/drawing/2014/main" id="{81998FA9-35F8-4E80-BDBF-9871F497F26E}"/>
               </a:ext>
             </a:extLst>
           </p:cNvPr>
@@ -2286,7 +2286,7 @@
           <p:cNvPr id="4" name="텍스트 개체 틀 3">
             <a:extLst>
               <a:ext uri="{FF2B5EF4-FFF2-40B4-BE49-F238E27FC236}">
-                <a16:creationId xmlns:a16="http://schemas.microsoft.com/office/drawing/2014/main" id="{0E663D25-61E5-67F8-37FE-4757D119158A}"/>
+                <a16:creationId xmlns:a16="http://schemas.microsoft.com/office/drawing/2014/main" id="{A3F8B1A0-6D0D-872A-BB4B-818AB2B5D1B3}"/>
               </a:ext>
             </a:extLst>
           </p:cNvPr>
@@ -2357,7 +2357,7 @@
           <p:cNvPr id="5" name="날짜 개체 틀 4">
             <a:extLst>
               <a:ext uri="{FF2B5EF4-FFF2-40B4-BE49-F238E27FC236}">
-                <a16:creationId xmlns:a16="http://schemas.microsoft.com/office/drawing/2014/main" id="{F88E7CD2-58B8-3719-963C-93BB48627117}"/>
+                <a16:creationId xmlns:a16="http://schemas.microsoft.com/office/drawing/2014/main" id="{1212B371-9A79-F587-F7B9-B2D4B0A88C0E}"/>
               </a:ext>
             </a:extLst>
           </p:cNvPr>
@@ -2373,7 +2373,7 @@
           <a:bodyPr/>
           <a:lstStyle/>
           <a:p>
-            <a:fld id="{DD780B16-97CC-434D-8C6E-53CCF84409AD}" type="datetimeFigureOut">
+            <a:fld id="{FBD92C38-B0C8-4D61-B511-2B35933A6C49}" type="datetimeFigureOut">
               <a:rPr lang="ko-KR" altLang="en-US" smtClean="0"/>
               <a:t>2026-06-19</a:t>
             </a:fld>
@@ -2386,7 +2386,7 @@
           <p:cNvPr id="6" name="바닥글 개체 틀 5">
             <a:extLst>
               <a:ext uri="{FF2B5EF4-FFF2-40B4-BE49-F238E27FC236}">
-                <a16:creationId xmlns:a16="http://schemas.microsoft.com/office/drawing/2014/main" id="{0E0129AA-2AE6-D388-43B0-93C5C871CA91}"/>
+                <a16:creationId xmlns:a16="http://schemas.microsoft.com/office/drawing/2014/main" id="{489A177C-98EB-6B69-A210-5CE2F69F04A9}"/>
               </a:ext>
             </a:extLst>
           </p:cNvPr>
@@ -2411,7 +2411,7 @@
           <p:cNvPr id="7" name="슬라이드 번호 개체 틀 6">
             <a:extLst>
               <a:ext uri="{FF2B5EF4-FFF2-40B4-BE49-F238E27FC236}">
-                <a16:creationId xmlns:a16="http://schemas.microsoft.com/office/drawing/2014/main" id="{D545DD4C-F085-8DAC-48F1-856DCD6A646C}"/>
+                <a16:creationId xmlns:a16="http://schemas.microsoft.com/office/drawing/2014/main" id="{AD7B1B72-43A3-E69B-A8B3-3A29B7CA6575}"/>
               </a:ext>
             </a:extLst>
           </p:cNvPr>
@@ -2427,7 +2427,7 @@
           <a:bodyPr/>
           <a:lstStyle/>
           <a:p>
-            <a:fld id="{0BB1D014-6EE4-4A79-AF60-E30C5800C9CC}" type="slidenum">
+            <a:fld id="{A77F83F0-4926-4A81-806C-F53BFF57509D}" type="slidenum">
               <a:rPr lang="ko-KR" altLang="en-US" smtClean="0"/>
               <a:t>‹#›</a:t>
             </a:fld>
@@ -2438,7 +2438,7 @@
     </p:spTree>
     <p:extLst>
       <p:ext uri="{BB962C8B-B14F-4D97-AF65-F5344CB8AC3E}">
-        <p14:creationId xmlns:p14="http://schemas.microsoft.com/office/powerpoint/2010/main" val="3799576947"/>
+        <p14:creationId xmlns:p14="http://schemas.microsoft.com/office/powerpoint/2010/main" val="2392031290"/>
       </p:ext>
     </p:extLst>
   </p:cSld>
@@ -2470,7 +2470,7 @@
           <p:cNvPr id="2" name="제목 1">
             <a:extLst>
               <a:ext uri="{FF2B5EF4-FFF2-40B4-BE49-F238E27FC236}">
-                <a16:creationId xmlns:a16="http://schemas.microsoft.com/office/drawing/2014/main" id="{CB08C394-34F5-9000-C7D1-D92CE6B5DD59}"/>
+                <a16:creationId xmlns:a16="http://schemas.microsoft.com/office/drawing/2014/main" id="{A8F38F6C-4B68-3AC5-83FD-CC18DDA77B6C}"/>
               </a:ext>
             </a:extLst>
           </p:cNvPr>
@@ -2507,7 +2507,7 @@
           <p:cNvPr id="3" name="그림 개체 틀 2">
             <a:extLst>
               <a:ext uri="{FF2B5EF4-FFF2-40B4-BE49-F238E27FC236}">
-                <a16:creationId xmlns:a16="http://schemas.microsoft.com/office/drawing/2014/main" id="{5B477BB3-DEF3-3C71-5619-7FCFEDF89382}"/>
+                <a16:creationId xmlns:a16="http://schemas.microsoft.com/office/drawing/2014/main" id="{25E4D112-AA6C-81BF-C867-BFA98FDC648C}"/>
               </a:ext>
             </a:extLst>
           </p:cNvPr>
@@ -2574,7 +2574,7 @@
           <p:cNvPr id="4" name="텍스트 개체 틀 3">
             <a:extLst>
               <a:ext uri="{FF2B5EF4-FFF2-40B4-BE49-F238E27FC236}">
-                <a16:creationId xmlns:a16="http://schemas.microsoft.com/office/drawing/2014/main" id="{A6AFE1B2-1279-9128-DF63-5D651FCC6D64}"/>
+                <a16:creationId xmlns:a16="http://schemas.microsoft.com/office/drawing/2014/main" id="{36AD8CD8-8568-19A3-D3A5-B766A886738F}"/>
               </a:ext>
             </a:extLst>
           </p:cNvPr>
@@ -2645,7 +2645,7 @@
           <p:cNvPr id="5" name="날짜 개체 틀 4">
             <a:extLst>
               <a:ext uri="{FF2B5EF4-FFF2-40B4-BE49-F238E27FC236}">
-                <a16:creationId xmlns:a16="http://schemas.microsoft.com/office/drawing/2014/main" id="{CA9CED80-1E10-1AF6-94E8-AB0AB1BE447B}"/>
+                <a16:creationId xmlns:a16="http://schemas.microsoft.com/office/drawing/2014/main" id="{1E750A3B-7207-F198-6D4E-A9168C41E20A}"/>
               </a:ext>
             </a:extLst>
           </p:cNvPr>
@@ -2661,7 +2661,7 @@
           <a:bodyPr/>
           <a:lstStyle/>
           <a:p>
-            <a:fld id="{DD780B16-97CC-434D-8C6E-53CCF84409AD}" type="datetimeFigureOut">
+            <a:fld id="{FBD92C38-B0C8-4D61-B511-2B35933A6C49}" type="datetimeFigureOut">
               <a:rPr lang="ko-KR" altLang="en-US" smtClean="0"/>
               <a:t>2026-06-19</a:t>
             </a:fld>
@@ -2674,7 +2674,7 @@
           <p:cNvPr id="6" name="바닥글 개체 틀 5">
             <a:extLst>
               <a:ext uri="{FF2B5EF4-FFF2-40B4-BE49-F238E27FC236}">
-                <a16:creationId xmlns:a16="http://schemas.microsoft.com/office/drawing/2014/main" id="{C2B526B9-36DF-5D1A-783F-9E03800E62DE}"/>
+                <a16:creationId xmlns:a16="http://schemas.microsoft.com/office/drawing/2014/main" id="{10E7EDA9-B800-3284-014C-F89AC884ED63}"/>
               </a:ext>
             </a:extLst>
           </p:cNvPr>
@@ -2699,7 +2699,7 @@
           <p:cNvPr id="7" name="슬라이드 번호 개체 틀 6">
             <a:extLst>
               <a:ext uri="{FF2B5EF4-FFF2-40B4-BE49-F238E27FC236}">
-                <a16:creationId xmlns:a16="http://schemas.microsoft.com/office/drawing/2014/main" id="{EBC0E30F-B4DA-C1C7-AFC9-7DF2489DE638}"/>
+                <a16:creationId xmlns:a16="http://schemas.microsoft.com/office/drawing/2014/main" id="{920C32BD-3EC6-0E29-B612-135FD0CF73B4}"/>
               </a:ext>
             </a:extLst>
           </p:cNvPr>
@@ -2715,7 +2715,7 @@
           <a:bodyPr/>
           <a:lstStyle/>
           <a:p>
-            <a:fld id="{0BB1D014-6EE4-4A79-AF60-E30C5800C9CC}" type="slidenum">
+            <a:fld id="{A77F83F0-4926-4A81-806C-F53BFF57509D}" type="slidenum">
               <a:rPr lang="ko-KR" altLang="en-US" smtClean="0"/>
               <a:t>‹#›</a:t>
             </a:fld>
@@ -2726,7 +2726,7 @@
     </p:spTree>
     <p:extLst>
       <p:ext uri="{BB962C8B-B14F-4D97-AF65-F5344CB8AC3E}">
-        <p14:creationId xmlns:p14="http://schemas.microsoft.com/office/powerpoint/2010/main" val="944275136"/>
+        <p14:creationId xmlns:p14="http://schemas.microsoft.com/office/powerpoint/2010/main" val="905053901"/>
       </p:ext>
     </p:extLst>
   </p:cSld>
@@ -2763,7 +2763,7 @@
           <p:cNvPr id="2" name="제목 개체 틀 1">
             <a:extLst>
               <a:ext uri="{FF2B5EF4-FFF2-40B4-BE49-F238E27FC236}">
-                <a16:creationId xmlns:a16="http://schemas.microsoft.com/office/drawing/2014/main" id="{EB6C7263-60C4-E959-D770-E2DDDA37129C}"/>
+                <a16:creationId xmlns:a16="http://schemas.microsoft.com/office/drawing/2014/main" id="{FEE72AF5-2C3C-7239-B657-92E656720926}"/>
               </a:ext>
             </a:extLst>
           </p:cNvPr>
@@ -2801,7 +2801,7 @@
           <p:cNvPr id="3" name="텍스트 개체 틀 2">
             <a:extLst>
               <a:ext uri="{FF2B5EF4-FFF2-40B4-BE49-F238E27FC236}">
-                <a16:creationId xmlns:a16="http://schemas.microsoft.com/office/drawing/2014/main" id="{EA72CCD4-56AA-2133-142A-3E233287D623}"/>
+                <a16:creationId xmlns:a16="http://schemas.microsoft.com/office/drawing/2014/main" id="{BE26B0CB-CDF0-9511-8B62-7F5AD58DE73C}"/>
               </a:ext>
             </a:extLst>
           </p:cNvPr>
@@ -2868,7 +2868,7 @@
           <p:cNvPr id="4" name="날짜 개체 틀 3">
             <a:extLst>
               <a:ext uri="{FF2B5EF4-FFF2-40B4-BE49-F238E27FC236}">
-                <a16:creationId xmlns:a16="http://schemas.microsoft.com/office/drawing/2014/main" id="{7719D90B-0069-EB8E-05BC-31776AB42C91}"/>
+                <a16:creationId xmlns:a16="http://schemas.microsoft.com/office/drawing/2014/main" id="{7BBEC8FC-6564-C068-C34C-E8F828F91FA9}"/>
               </a:ext>
             </a:extLst>
           </p:cNvPr>
@@ -2902,7 +2902,7 @@
             </a:lvl1pPr>
           </a:lstStyle>
           <a:p>
-            <a:fld id="{DD780B16-97CC-434D-8C6E-53CCF84409AD}" type="datetimeFigureOut">
+            <a:fld id="{FBD92C38-B0C8-4D61-B511-2B35933A6C49}" type="datetimeFigureOut">
               <a:rPr lang="ko-KR" altLang="en-US" smtClean="0"/>
               <a:t>2026-06-19</a:t>
             </a:fld>
@@ -2915,7 +2915,7 @@
           <p:cNvPr id="5" name="바닥글 개체 틀 4">
             <a:extLst>
               <a:ext uri="{FF2B5EF4-FFF2-40B4-BE49-F238E27FC236}">
-                <a16:creationId xmlns:a16="http://schemas.microsoft.com/office/drawing/2014/main" id="{CFB79967-8139-7B9D-92F4-802223B3B0F6}"/>
+                <a16:creationId xmlns:a16="http://schemas.microsoft.com/office/drawing/2014/main" id="{8AEA0AD1-457C-45B7-16E7-BF92EABE2273}"/>
               </a:ext>
             </a:extLst>
           </p:cNvPr>
@@ -2958,7 +2958,7 @@
           <p:cNvPr id="6" name="슬라이드 번호 개체 틀 5">
             <a:extLst>
               <a:ext uri="{FF2B5EF4-FFF2-40B4-BE49-F238E27FC236}">
-                <a16:creationId xmlns:a16="http://schemas.microsoft.com/office/drawing/2014/main" id="{CBA7F6A4-76A3-B2FE-A677-647E882A398B}"/>
+                <a16:creationId xmlns:a16="http://schemas.microsoft.com/office/drawing/2014/main" id="{EA8EEB77-7BEA-96CD-16FA-ED30420F5DCE}"/>
               </a:ext>
             </a:extLst>
           </p:cNvPr>
@@ -2992,7 +2992,7 @@
             </a:lvl1pPr>
           </a:lstStyle>
           <a:p>
-            <a:fld id="{0BB1D014-6EE4-4A79-AF60-E30C5800C9CC}" type="slidenum">
+            <a:fld id="{A77F83F0-4926-4A81-806C-F53BFF57509D}" type="slidenum">
               <a:rPr lang="ko-KR" altLang="en-US" smtClean="0"/>
               <a:t>‹#›</a:t>
             </a:fld>
@@ -3003,7 +3003,7 @@
     </p:spTree>
     <p:extLst>
       <p:ext uri="{BB962C8B-B14F-4D97-AF65-F5344CB8AC3E}">
-        <p14:creationId xmlns:p14="http://schemas.microsoft.com/office/powerpoint/2010/main" val="1090671091"/>
+        <p14:creationId xmlns:p14="http://schemas.microsoft.com/office/powerpoint/2010/main" val="839823633"/>
       </p:ext>
     </p:extLst>
   </p:cSld>
@@ -3323,10 +3323,10 @@
       </p:grpSpPr>
       <p:pic>
         <p:nvPicPr>
-          <p:cNvPr id="3" name="그래픽 2">
-            <a:extLst>
-              <a:ext uri="{FF2B5EF4-FFF2-40B4-BE49-F238E27FC236}">
-                <a16:creationId xmlns:a16="http://schemas.microsoft.com/office/drawing/2014/main" id="{2EAA314B-DE08-B7F6-7307-439FDA905390}"/>
+          <p:cNvPr id="3" name="pipeline_overview_svg">
+            <a:extLst>
+              <a:ext uri="{FF2B5EF4-FFF2-40B4-BE49-F238E27FC236}">
+                <a16:creationId xmlns:a16="http://schemas.microsoft.com/office/drawing/2014/main" id="{2A4665A3-0E5D-DC53-39E1-206EA607856F}"/>
               </a:ext>
             </a:extLst>
           </p:cNvPr>
@@ -3355,12 +3355,19 @@
           <a:prstGeom prst="rect">
             <a:avLst/>
           </a:prstGeom>
+          <a:effectLst>
+            <a:outerShdw blurRad="50800" dist="19050" dir="5400000" rotWithShape="0">
+              <a:scrgbClr r="0" g="0" b="0">
+                <a:alpha val="12000"/>
+              </a:scrgbClr>
+            </a:outerShdw>
+          </a:effectLst>
         </p:spPr>
       </p:pic>
     </p:spTree>
     <p:extLst>
       <p:ext uri="{BB962C8B-B14F-4D97-AF65-F5344CB8AC3E}">
-        <p14:creationId xmlns:p14="http://schemas.microsoft.com/office/powerpoint/2010/main" val="3724721694"/>
+        <p14:creationId xmlns:p14="http://schemas.microsoft.com/office/powerpoint/2010/main" val="39618639"/>
       </p:ext>
     </p:extLst>
   </p:cSld>

</xml_diff>

<commit_message>
Generate pipeline image from markdown source
</commit_message>
<xml_diff>
--- a/docs/assets/pipeline-overview.pptx
+++ b/docs/assets/pipeline-overview.pptx
@@ -129,7 +129,7 @@
           <p:cNvPr id="2" name="제목 1">
             <a:extLst>
               <a:ext uri="{FF2B5EF4-FFF2-40B4-BE49-F238E27FC236}">
-                <a16:creationId xmlns:a16="http://schemas.microsoft.com/office/drawing/2014/main" id="{01359E97-4178-2869-1337-8A3246AC1B88}"/>
+                <a16:creationId xmlns:a16="http://schemas.microsoft.com/office/drawing/2014/main" id="{94D7C861-5BE5-8875-FD01-C33CC72D12EA}"/>
               </a:ext>
             </a:extLst>
           </p:cNvPr>
@@ -166,7 +166,7 @@
           <p:cNvPr id="3" name="부제목 2">
             <a:extLst>
               <a:ext uri="{FF2B5EF4-FFF2-40B4-BE49-F238E27FC236}">
-                <a16:creationId xmlns:a16="http://schemas.microsoft.com/office/drawing/2014/main" id="{7CA3827E-A20B-D05A-1A92-04EF0C671F4B}"/>
+                <a16:creationId xmlns:a16="http://schemas.microsoft.com/office/drawing/2014/main" id="{E1E10F19-3C91-4615-CCA5-288143B23121}"/>
               </a:ext>
             </a:extLst>
           </p:cNvPr>
@@ -236,7 +236,7 @@
           <p:cNvPr id="4" name="날짜 개체 틀 3">
             <a:extLst>
               <a:ext uri="{FF2B5EF4-FFF2-40B4-BE49-F238E27FC236}">
-                <a16:creationId xmlns:a16="http://schemas.microsoft.com/office/drawing/2014/main" id="{F12E059E-BDA8-568A-C2A5-AF7F529D79AD}"/>
+                <a16:creationId xmlns:a16="http://schemas.microsoft.com/office/drawing/2014/main" id="{85553287-C6BD-122E-6044-D889D6211D82}"/>
               </a:ext>
             </a:extLst>
           </p:cNvPr>
@@ -252,7 +252,7 @@
           <a:bodyPr/>
           <a:lstStyle/>
           <a:p>
-            <a:fld id="{FBD92C38-B0C8-4D61-B511-2B35933A6C49}" type="datetimeFigureOut">
+            <a:fld id="{AE899331-733F-4720-83EF-03D552583B79}" type="datetimeFigureOut">
               <a:rPr lang="ko-KR" altLang="en-US" smtClean="0"/>
               <a:t>2026-06-19</a:t>
             </a:fld>
@@ -265,7 +265,7 @@
           <p:cNvPr id="5" name="바닥글 개체 틀 4">
             <a:extLst>
               <a:ext uri="{FF2B5EF4-FFF2-40B4-BE49-F238E27FC236}">
-                <a16:creationId xmlns:a16="http://schemas.microsoft.com/office/drawing/2014/main" id="{9EF1DEDA-B0D3-40A6-C0AE-E2532FEC27E5}"/>
+                <a16:creationId xmlns:a16="http://schemas.microsoft.com/office/drawing/2014/main" id="{B3C25F41-A508-D8A1-FC47-DCD602E3CCA3}"/>
               </a:ext>
             </a:extLst>
           </p:cNvPr>
@@ -290,7 +290,7 @@
           <p:cNvPr id="6" name="슬라이드 번호 개체 틀 5">
             <a:extLst>
               <a:ext uri="{FF2B5EF4-FFF2-40B4-BE49-F238E27FC236}">
-                <a16:creationId xmlns:a16="http://schemas.microsoft.com/office/drawing/2014/main" id="{94ACC732-7731-7B1D-928B-55176CE6DD5E}"/>
+                <a16:creationId xmlns:a16="http://schemas.microsoft.com/office/drawing/2014/main" id="{8B14EAFF-78B1-477B-C482-5D574F0FAD5C}"/>
               </a:ext>
             </a:extLst>
           </p:cNvPr>
@@ -306,7 +306,7 @@
           <a:bodyPr/>
           <a:lstStyle/>
           <a:p>
-            <a:fld id="{A77F83F0-4926-4A81-806C-F53BFF57509D}" type="slidenum">
+            <a:fld id="{324CD06F-1683-4109-A93C-652FD2E4AB1B}" type="slidenum">
               <a:rPr lang="ko-KR" altLang="en-US" smtClean="0"/>
               <a:t>‹#›</a:t>
             </a:fld>
@@ -317,7 +317,7 @@
     </p:spTree>
     <p:extLst>
       <p:ext uri="{BB962C8B-B14F-4D97-AF65-F5344CB8AC3E}">
-        <p14:creationId xmlns:p14="http://schemas.microsoft.com/office/powerpoint/2010/main" val="2197558230"/>
+        <p14:creationId xmlns:p14="http://schemas.microsoft.com/office/powerpoint/2010/main" val="657987959"/>
       </p:ext>
     </p:extLst>
   </p:cSld>
@@ -349,7 +349,7 @@
           <p:cNvPr id="2" name="제목 1">
             <a:extLst>
               <a:ext uri="{FF2B5EF4-FFF2-40B4-BE49-F238E27FC236}">
-                <a16:creationId xmlns:a16="http://schemas.microsoft.com/office/drawing/2014/main" id="{E579BB05-BBBC-7095-995B-114B4525D67C}"/>
+                <a16:creationId xmlns:a16="http://schemas.microsoft.com/office/drawing/2014/main" id="{1C7F8601-1687-EC92-F577-75AADA2E0384}"/>
               </a:ext>
             </a:extLst>
           </p:cNvPr>
@@ -377,7 +377,7 @@
           <p:cNvPr id="3" name="세로 텍스트 개체 틀 2">
             <a:extLst>
               <a:ext uri="{FF2B5EF4-FFF2-40B4-BE49-F238E27FC236}">
-                <a16:creationId xmlns:a16="http://schemas.microsoft.com/office/drawing/2014/main" id="{915B4677-97CC-9A7D-CDE8-F61C47EE6EAF}"/>
+                <a16:creationId xmlns:a16="http://schemas.microsoft.com/office/drawing/2014/main" id="{85D1A5E3-EBC6-565A-57CC-8024C2AE00F8}"/>
               </a:ext>
             </a:extLst>
           </p:cNvPr>
@@ -434,7 +434,7 @@
           <p:cNvPr id="4" name="날짜 개체 틀 3">
             <a:extLst>
               <a:ext uri="{FF2B5EF4-FFF2-40B4-BE49-F238E27FC236}">
-                <a16:creationId xmlns:a16="http://schemas.microsoft.com/office/drawing/2014/main" id="{1807447F-6B0F-83E3-D7A0-785E4497B268}"/>
+                <a16:creationId xmlns:a16="http://schemas.microsoft.com/office/drawing/2014/main" id="{5484ACE1-4CCB-E207-BF9A-8C6DD6E3F4C2}"/>
               </a:ext>
             </a:extLst>
           </p:cNvPr>
@@ -450,7 +450,7 @@
           <a:bodyPr/>
           <a:lstStyle/>
           <a:p>
-            <a:fld id="{FBD92C38-B0C8-4D61-B511-2B35933A6C49}" type="datetimeFigureOut">
+            <a:fld id="{AE899331-733F-4720-83EF-03D552583B79}" type="datetimeFigureOut">
               <a:rPr lang="ko-KR" altLang="en-US" smtClean="0"/>
               <a:t>2026-06-19</a:t>
             </a:fld>
@@ -463,7 +463,7 @@
           <p:cNvPr id="5" name="바닥글 개체 틀 4">
             <a:extLst>
               <a:ext uri="{FF2B5EF4-FFF2-40B4-BE49-F238E27FC236}">
-                <a16:creationId xmlns:a16="http://schemas.microsoft.com/office/drawing/2014/main" id="{4655D705-AE06-A490-81A2-20F2803267A5}"/>
+                <a16:creationId xmlns:a16="http://schemas.microsoft.com/office/drawing/2014/main" id="{AEE05642-B1B0-DDF1-BF3D-991C571BA03C}"/>
               </a:ext>
             </a:extLst>
           </p:cNvPr>
@@ -488,7 +488,7 @@
           <p:cNvPr id="6" name="슬라이드 번호 개체 틀 5">
             <a:extLst>
               <a:ext uri="{FF2B5EF4-FFF2-40B4-BE49-F238E27FC236}">
-                <a16:creationId xmlns:a16="http://schemas.microsoft.com/office/drawing/2014/main" id="{2DEEA013-7779-3153-7929-DDEE8B98DCCF}"/>
+                <a16:creationId xmlns:a16="http://schemas.microsoft.com/office/drawing/2014/main" id="{5BB9A8FE-180D-4B48-8B82-796D87BFB99D}"/>
               </a:ext>
             </a:extLst>
           </p:cNvPr>
@@ -504,7 +504,7 @@
           <a:bodyPr/>
           <a:lstStyle/>
           <a:p>
-            <a:fld id="{A77F83F0-4926-4A81-806C-F53BFF57509D}" type="slidenum">
+            <a:fld id="{324CD06F-1683-4109-A93C-652FD2E4AB1B}" type="slidenum">
               <a:rPr lang="ko-KR" altLang="en-US" smtClean="0"/>
               <a:t>‹#›</a:t>
             </a:fld>
@@ -515,7 +515,7 @@
     </p:spTree>
     <p:extLst>
       <p:ext uri="{BB962C8B-B14F-4D97-AF65-F5344CB8AC3E}">
-        <p14:creationId xmlns:p14="http://schemas.microsoft.com/office/powerpoint/2010/main" val="2929774933"/>
+        <p14:creationId xmlns:p14="http://schemas.microsoft.com/office/powerpoint/2010/main" val="1952157581"/>
       </p:ext>
     </p:extLst>
   </p:cSld>
@@ -547,7 +547,7 @@
           <p:cNvPr id="2" name="세로 제목 1">
             <a:extLst>
               <a:ext uri="{FF2B5EF4-FFF2-40B4-BE49-F238E27FC236}">
-                <a16:creationId xmlns:a16="http://schemas.microsoft.com/office/drawing/2014/main" id="{17FEC5C8-BE35-CDF4-793F-28C8C497A355}"/>
+                <a16:creationId xmlns:a16="http://schemas.microsoft.com/office/drawing/2014/main" id="{F6BC9F11-C3CA-9527-99C2-45EB3066E828}"/>
               </a:ext>
             </a:extLst>
           </p:cNvPr>
@@ -580,7 +580,7 @@
           <p:cNvPr id="3" name="세로 텍스트 개체 틀 2">
             <a:extLst>
               <a:ext uri="{FF2B5EF4-FFF2-40B4-BE49-F238E27FC236}">
-                <a16:creationId xmlns:a16="http://schemas.microsoft.com/office/drawing/2014/main" id="{9487CC96-91F5-76F0-C349-D4980D89DF53}"/>
+                <a16:creationId xmlns:a16="http://schemas.microsoft.com/office/drawing/2014/main" id="{05991F69-5709-D2CF-EC00-8BBD45A088FD}"/>
               </a:ext>
             </a:extLst>
           </p:cNvPr>
@@ -642,7 +642,7 @@
           <p:cNvPr id="4" name="날짜 개체 틀 3">
             <a:extLst>
               <a:ext uri="{FF2B5EF4-FFF2-40B4-BE49-F238E27FC236}">
-                <a16:creationId xmlns:a16="http://schemas.microsoft.com/office/drawing/2014/main" id="{9B102A23-78E5-1851-5B62-91758DEAC4E9}"/>
+                <a16:creationId xmlns:a16="http://schemas.microsoft.com/office/drawing/2014/main" id="{F0EC6E46-9C16-3897-69C1-288AE60C6E90}"/>
               </a:ext>
             </a:extLst>
           </p:cNvPr>
@@ -658,7 +658,7 @@
           <a:bodyPr/>
           <a:lstStyle/>
           <a:p>
-            <a:fld id="{FBD92C38-B0C8-4D61-B511-2B35933A6C49}" type="datetimeFigureOut">
+            <a:fld id="{AE899331-733F-4720-83EF-03D552583B79}" type="datetimeFigureOut">
               <a:rPr lang="ko-KR" altLang="en-US" smtClean="0"/>
               <a:t>2026-06-19</a:t>
             </a:fld>
@@ -671,7 +671,7 @@
           <p:cNvPr id="5" name="바닥글 개체 틀 4">
             <a:extLst>
               <a:ext uri="{FF2B5EF4-FFF2-40B4-BE49-F238E27FC236}">
-                <a16:creationId xmlns:a16="http://schemas.microsoft.com/office/drawing/2014/main" id="{EC07014D-EA3F-497C-5577-094246555B3C}"/>
+                <a16:creationId xmlns:a16="http://schemas.microsoft.com/office/drawing/2014/main" id="{38C580E3-E19E-804A-72A8-8D1E1C0BA0E4}"/>
               </a:ext>
             </a:extLst>
           </p:cNvPr>
@@ -696,7 +696,7 @@
           <p:cNvPr id="6" name="슬라이드 번호 개체 틀 5">
             <a:extLst>
               <a:ext uri="{FF2B5EF4-FFF2-40B4-BE49-F238E27FC236}">
-                <a16:creationId xmlns:a16="http://schemas.microsoft.com/office/drawing/2014/main" id="{46F37EAB-9F53-FAAF-586C-2949D7E1C4FE}"/>
+                <a16:creationId xmlns:a16="http://schemas.microsoft.com/office/drawing/2014/main" id="{5658FE8C-D8A0-BA78-DE46-FB62429E5F70}"/>
               </a:ext>
             </a:extLst>
           </p:cNvPr>
@@ -712,7 +712,7 @@
           <a:bodyPr/>
           <a:lstStyle/>
           <a:p>
-            <a:fld id="{A77F83F0-4926-4A81-806C-F53BFF57509D}" type="slidenum">
+            <a:fld id="{324CD06F-1683-4109-A93C-652FD2E4AB1B}" type="slidenum">
               <a:rPr lang="ko-KR" altLang="en-US" smtClean="0"/>
               <a:t>‹#›</a:t>
             </a:fld>
@@ -723,7 +723,7 @@
     </p:spTree>
     <p:extLst>
       <p:ext uri="{BB962C8B-B14F-4D97-AF65-F5344CB8AC3E}">
-        <p14:creationId xmlns:p14="http://schemas.microsoft.com/office/powerpoint/2010/main" val="4210593025"/>
+        <p14:creationId xmlns:p14="http://schemas.microsoft.com/office/powerpoint/2010/main" val="3158140203"/>
       </p:ext>
     </p:extLst>
   </p:cSld>
@@ -755,7 +755,7 @@
           <p:cNvPr id="2" name="제목 1">
             <a:extLst>
               <a:ext uri="{FF2B5EF4-FFF2-40B4-BE49-F238E27FC236}">
-                <a16:creationId xmlns:a16="http://schemas.microsoft.com/office/drawing/2014/main" id="{6BCC5FAE-5F66-F01F-0C49-2D7A6D92CF0C}"/>
+                <a16:creationId xmlns:a16="http://schemas.microsoft.com/office/drawing/2014/main" id="{D67F814E-5DF2-D079-7502-7B3BB43454F2}"/>
               </a:ext>
             </a:extLst>
           </p:cNvPr>
@@ -783,7 +783,7 @@
           <p:cNvPr id="3" name="내용 개체 틀 2">
             <a:extLst>
               <a:ext uri="{FF2B5EF4-FFF2-40B4-BE49-F238E27FC236}">
-                <a16:creationId xmlns:a16="http://schemas.microsoft.com/office/drawing/2014/main" id="{27492B8D-FC86-876A-68B7-E74BFC4A5EE5}"/>
+                <a16:creationId xmlns:a16="http://schemas.microsoft.com/office/drawing/2014/main" id="{D976D1A1-9891-04EA-A42E-5915F0570142}"/>
               </a:ext>
             </a:extLst>
           </p:cNvPr>
@@ -840,7 +840,7 @@
           <p:cNvPr id="4" name="날짜 개체 틀 3">
             <a:extLst>
               <a:ext uri="{FF2B5EF4-FFF2-40B4-BE49-F238E27FC236}">
-                <a16:creationId xmlns:a16="http://schemas.microsoft.com/office/drawing/2014/main" id="{505622BC-1E35-E2DA-7E01-E0445A3A21AA}"/>
+                <a16:creationId xmlns:a16="http://schemas.microsoft.com/office/drawing/2014/main" id="{2A5C772C-C64B-E225-D9D6-B6B80D93741D}"/>
               </a:ext>
             </a:extLst>
           </p:cNvPr>
@@ -856,7 +856,7 @@
           <a:bodyPr/>
           <a:lstStyle/>
           <a:p>
-            <a:fld id="{FBD92C38-B0C8-4D61-B511-2B35933A6C49}" type="datetimeFigureOut">
+            <a:fld id="{AE899331-733F-4720-83EF-03D552583B79}" type="datetimeFigureOut">
               <a:rPr lang="ko-KR" altLang="en-US" smtClean="0"/>
               <a:t>2026-06-19</a:t>
             </a:fld>
@@ -869,7 +869,7 @@
           <p:cNvPr id="5" name="바닥글 개체 틀 4">
             <a:extLst>
               <a:ext uri="{FF2B5EF4-FFF2-40B4-BE49-F238E27FC236}">
-                <a16:creationId xmlns:a16="http://schemas.microsoft.com/office/drawing/2014/main" id="{D844E76A-C380-2F2D-3150-7F61BBA62E4D}"/>
+                <a16:creationId xmlns:a16="http://schemas.microsoft.com/office/drawing/2014/main" id="{6489A7D8-8103-DC34-9507-EA2B5B47487C}"/>
               </a:ext>
             </a:extLst>
           </p:cNvPr>
@@ -894,7 +894,7 @@
           <p:cNvPr id="6" name="슬라이드 번호 개체 틀 5">
             <a:extLst>
               <a:ext uri="{FF2B5EF4-FFF2-40B4-BE49-F238E27FC236}">
-                <a16:creationId xmlns:a16="http://schemas.microsoft.com/office/drawing/2014/main" id="{3CA5941B-4340-45FE-A3A0-F440F24EDD3B}"/>
+                <a16:creationId xmlns:a16="http://schemas.microsoft.com/office/drawing/2014/main" id="{1C9C43C1-5D03-1C72-15ED-87A12568001F}"/>
               </a:ext>
             </a:extLst>
           </p:cNvPr>
@@ -910,7 +910,7 @@
           <a:bodyPr/>
           <a:lstStyle/>
           <a:p>
-            <a:fld id="{A77F83F0-4926-4A81-806C-F53BFF57509D}" type="slidenum">
+            <a:fld id="{324CD06F-1683-4109-A93C-652FD2E4AB1B}" type="slidenum">
               <a:rPr lang="ko-KR" altLang="en-US" smtClean="0"/>
               <a:t>‹#›</a:t>
             </a:fld>
@@ -921,7 +921,7 @@
     </p:spTree>
     <p:extLst>
       <p:ext uri="{BB962C8B-B14F-4D97-AF65-F5344CB8AC3E}">
-        <p14:creationId xmlns:p14="http://schemas.microsoft.com/office/powerpoint/2010/main" val="1743702733"/>
+        <p14:creationId xmlns:p14="http://schemas.microsoft.com/office/powerpoint/2010/main" val="1702649277"/>
       </p:ext>
     </p:extLst>
   </p:cSld>
@@ -953,7 +953,7 @@
           <p:cNvPr id="2" name="제목 1">
             <a:extLst>
               <a:ext uri="{FF2B5EF4-FFF2-40B4-BE49-F238E27FC236}">
-                <a16:creationId xmlns:a16="http://schemas.microsoft.com/office/drawing/2014/main" id="{4D1BD8E2-FD41-C356-A6D0-9FAEA2EC66BD}"/>
+                <a16:creationId xmlns:a16="http://schemas.microsoft.com/office/drawing/2014/main" id="{C8D80257-FCC0-5111-90F0-1371AEEC5800}"/>
               </a:ext>
             </a:extLst>
           </p:cNvPr>
@@ -990,7 +990,7 @@
           <p:cNvPr id="3" name="텍스트 개체 틀 2">
             <a:extLst>
               <a:ext uri="{FF2B5EF4-FFF2-40B4-BE49-F238E27FC236}">
-                <a16:creationId xmlns:a16="http://schemas.microsoft.com/office/drawing/2014/main" id="{A70783F1-A1B6-E8E9-E68B-500D3846DD2E}"/>
+                <a16:creationId xmlns:a16="http://schemas.microsoft.com/office/drawing/2014/main" id="{4EA88015-85C9-2E6D-BB92-19C6C72D8AAE}"/>
               </a:ext>
             </a:extLst>
           </p:cNvPr>
@@ -1115,7 +1115,7 @@
           <p:cNvPr id="4" name="날짜 개체 틀 3">
             <a:extLst>
               <a:ext uri="{FF2B5EF4-FFF2-40B4-BE49-F238E27FC236}">
-                <a16:creationId xmlns:a16="http://schemas.microsoft.com/office/drawing/2014/main" id="{A21EC263-C078-31E6-1D40-6EE67C3259AE}"/>
+                <a16:creationId xmlns:a16="http://schemas.microsoft.com/office/drawing/2014/main" id="{4300F17C-4548-C17A-05A0-1941636D90F2}"/>
               </a:ext>
             </a:extLst>
           </p:cNvPr>
@@ -1131,7 +1131,7 @@
           <a:bodyPr/>
           <a:lstStyle/>
           <a:p>
-            <a:fld id="{FBD92C38-B0C8-4D61-B511-2B35933A6C49}" type="datetimeFigureOut">
+            <a:fld id="{AE899331-733F-4720-83EF-03D552583B79}" type="datetimeFigureOut">
               <a:rPr lang="ko-KR" altLang="en-US" smtClean="0"/>
               <a:t>2026-06-19</a:t>
             </a:fld>
@@ -1144,7 +1144,7 @@
           <p:cNvPr id="5" name="바닥글 개체 틀 4">
             <a:extLst>
               <a:ext uri="{FF2B5EF4-FFF2-40B4-BE49-F238E27FC236}">
-                <a16:creationId xmlns:a16="http://schemas.microsoft.com/office/drawing/2014/main" id="{BE049CF7-9912-11FC-C60A-A51A9BDD7224}"/>
+                <a16:creationId xmlns:a16="http://schemas.microsoft.com/office/drawing/2014/main" id="{331F8EAD-20FC-79C8-4B4E-8915D14C7BB9}"/>
               </a:ext>
             </a:extLst>
           </p:cNvPr>
@@ -1169,7 +1169,7 @@
           <p:cNvPr id="6" name="슬라이드 번호 개체 틀 5">
             <a:extLst>
               <a:ext uri="{FF2B5EF4-FFF2-40B4-BE49-F238E27FC236}">
-                <a16:creationId xmlns:a16="http://schemas.microsoft.com/office/drawing/2014/main" id="{DF0BF0F7-63CD-D9DA-55DD-89EEC7E0CF88}"/>
+                <a16:creationId xmlns:a16="http://schemas.microsoft.com/office/drawing/2014/main" id="{552683B2-A516-0677-D09A-7F09E38FA84F}"/>
               </a:ext>
             </a:extLst>
           </p:cNvPr>
@@ -1185,7 +1185,7 @@
           <a:bodyPr/>
           <a:lstStyle/>
           <a:p>
-            <a:fld id="{A77F83F0-4926-4A81-806C-F53BFF57509D}" type="slidenum">
+            <a:fld id="{324CD06F-1683-4109-A93C-652FD2E4AB1B}" type="slidenum">
               <a:rPr lang="ko-KR" altLang="en-US" smtClean="0"/>
               <a:t>‹#›</a:t>
             </a:fld>
@@ -1196,7 +1196,7 @@
     </p:spTree>
     <p:extLst>
       <p:ext uri="{BB962C8B-B14F-4D97-AF65-F5344CB8AC3E}">
-        <p14:creationId xmlns:p14="http://schemas.microsoft.com/office/powerpoint/2010/main" val="2314713360"/>
+        <p14:creationId xmlns:p14="http://schemas.microsoft.com/office/powerpoint/2010/main" val="323762870"/>
       </p:ext>
     </p:extLst>
   </p:cSld>
@@ -1228,7 +1228,7 @@
           <p:cNvPr id="2" name="제목 1">
             <a:extLst>
               <a:ext uri="{FF2B5EF4-FFF2-40B4-BE49-F238E27FC236}">
-                <a16:creationId xmlns:a16="http://schemas.microsoft.com/office/drawing/2014/main" id="{8083116F-70D5-0440-EB13-B0E392849F50}"/>
+                <a16:creationId xmlns:a16="http://schemas.microsoft.com/office/drawing/2014/main" id="{551FB27F-515D-7E70-35F9-09CE63C97C89}"/>
               </a:ext>
             </a:extLst>
           </p:cNvPr>
@@ -1256,7 +1256,7 @@
           <p:cNvPr id="3" name="내용 개체 틀 2">
             <a:extLst>
               <a:ext uri="{FF2B5EF4-FFF2-40B4-BE49-F238E27FC236}">
-                <a16:creationId xmlns:a16="http://schemas.microsoft.com/office/drawing/2014/main" id="{28D676D2-CC6E-51EB-826F-ECBB43FF68AE}"/>
+                <a16:creationId xmlns:a16="http://schemas.microsoft.com/office/drawing/2014/main" id="{E9C35DAE-9A3D-CC84-C010-1F370701BDB8}"/>
               </a:ext>
             </a:extLst>
           </p:cNvPr>
@@ -1318,7 +1318,7 @@
           <p:cNvPr id="4" name="내용 개체 틀 3">
             <a:extLst>
               <a:ext uri="{FF2B5EF4-FFF2-40B4-BE49-F238E27FC236}">
-                <a16:creationId xmlns:a16="http://schemas.microsoft.com/office/drawing/2014/main" id="{B1BA4F48-1D11-6008-69B3-CBFE3AD1667E}"/>
+                <a16:creationId xmlns:a16="http://schemas.microsoft.com/office/drawing/2014/main" id="{766E1158-3336-8F9E-B720-135A54F0C170}"/>
               </a:ext>
             </a:extLst>
           </p:cNvPr>
@@ -1380,7 +1380,7 @@
           <p:cNvPr id="5" name="날짜 개체 틀 4">
             <a:extLst>
               <a:ext uri="{FF2B5EF4-FFF2-40B4-BE49-F238E27FC236}">
-                <a16:creationId xmlns:a16="http://schemas.microsoft.com/office/drawing/2014/main" id="{83138F0E-6B42-4BD7-F803-DCA94D216714}"/>
+                <a16:creationId xmlns:a16="http://schemas.microsoft.com/office/drawing/2014/main" id="{CF9E4E7B-2D9A-3BD8-D46B-B2E5D4468935}"/>
               </a:ext>
             </a:extLst>
           </p:cNvPr>
@@ -1396,7 +1396,7 @@
           <a:bodyPr/>
           <a:lstStyle/>
           <a:p>
-            <a:fld id="{FBD92C38-B0C8-4D61-B511-2B35933A6C49}" type="datetimeFigureOut">
+            <a:fld id="{AE899331-733F-4720-83EF-03D552583B79}" type="datetimeFigureOut">
               <a:rPr lang="ko-KR" altLang="en-US" smtClean="0"/>
               <a:t>2026-06-19</a:t>
             </a:fld>
@@ -1409,7 +1409,7 @@
           <p:cNvPr id="6" name="바닥글 개체 틀 5">
             <a:extLst>
               <a:ext uri="{FF2B5EF4-FFF2-40B4-BE49-F238E27FC236}">
-                <a16:creationId xmlns:a16="http://schemas.microsoft.com/office/drawing/2014/main" id="{C97CB2B1-BAB0-48E8-DEC2-FB14D94B8537}"/>
+                <a16:creationId xmlns:a16="http://schemas.microsoft.com/office/drawing/2014/main" id="{B74EB3EC-FC92-B07F-CB3D-E33D9011EAAE}"/>
               </a:ext>
             </a:extLst>
           </p:cNvPr>
@@ -1434,7 +1434,7 @@
           <p:cNvPr id="7" name="슬라이드 번호 개체 틀 6">
             <a:extLst>
               <a:ext uri="{FF2B5EF4-FFF2-40B4-BE49-F238E27FC236}">
-                <a16:creationId xmlns:a16="http://schemas.microsoft.com/office/drawing/2014/main" id="{93A762BE-5F31-5FE8-E5A1-27BA2465E3C9}"/>
+                <a16:creationId xmlns:a16="http://schemas.microsoft.com/office/drawing/2014/main" id="{3F205210-7C7E-3E97-CF42-6087A5BE76B8}"/>
               </a:ext>
             </a:extLst>
           </p:cNvPr>
@@ -1450,7 +1450,7 @@
           <a:bodyPr/>
           <a:lstStyle/>
           <a:p>
-            <a:fld id="{A77F83F0-4926-4A81-806C-F53BFF57509D}" type="slidenum">
+            <a:fld id="{324CD06F-1683-4109-A93C-652FD2E4AB1B}" type="slidenum">
               <a:rPr lang="ko-KR" altLang="en-US" smtClean="0"/>
               <a:t>‹#›</a:t>
             </a:fld>
@@ -1461,7 +1461,7 @@
     </p:spTree>
     <p:extLst>
       <p:ext uri="{BB962C8B-B14F-4D97-AF65-F5344CB8AC3E}">
-        <p14:creationId xmlns:p14="http://schemas.microsoft.com/office/powerpoint/2010/main" val="1919991502"/>
+        <p14:creationId xmlns:p14="http://schemas.microsoft.com/office/powerpoint/2010/main" val="1957252489"/>
       </p:ext>
     </p:extLst>
   </p:cSld>
@@ -1493,7 +1493,7 @@
           <p:cNvPr id="2" name="제목 1">
             <a:extLst>
               <a:ext uri="{FF2B5EF4-FFF2-40B4-BE49-F238E27FC236}">
-                <a16:creationId xmlns:a16="http://schemas.microsoft.com/office/drawing/2014/main" id="{E53DDB7E-6F7D-31ED-E26F-E77CE025E52D}"/>
+                <a16:creationId xmlns:a16="http://schemas.microsoft.com/office/drawing/2014/main" id="{1FE921BF-99B1-41E2-722C-4926E524D564}"/>
               </a:ext>
             </a:extLst>
           </p:cNvPr>
@@ -1526,7 +1526,7 @@
           <p:cNvPr id="3" name="텍스트 개체 틀 2">
             <a:extLst>
               <a:ext uri="{FF2B5EF4-FFF2-40B4-BE49-F238E27FC236}">
-                <a16:creationId xmlns:a16="http://schemas.microsoft.com/office/drawing/2014/main" id="{7ED584A4-8C27-6C4D-7CA3-1B40AE0C2FCD}"/>
+                <a16:creationId xmlns:a16="http://schemas.microsoft.com/office/drawing/2014/main" id="{67E0AFE5-BAB4-4A2A-5598-4B5FD0D212A6}"/>
               </a:ext>
             </a:extLst>
           </p:cNvPr>
@@ -1597,7 +1597,7 @@
           <p:cNvPr id="4" name="내용 개체 틀 3">
             <a:extLst>
               <a:ext uri="{FF2B5EF4-FFF2-40B4-BE49-F238E27FC236}">
-                <a16:creationId xmlns:a16="http://schemas.microsoft.com/office/drawing/2014/main" id="{980A1C98-A70B-4535-EB2A-47C5A8F9311E}"/>
+                <a16:creationId xmlns:a16="http://schemas.microsoft.com/office/drawing/2014/main" id="{4923D3CF-D967-D318-CA7B-6114076BE564}"/>
               </a:ext>
             </a:extLst>
           </p:cNvPr>
@@ -1659,7 +1659,7 @@
           <p:cNvPr id="5" name="텍스트 개체 틀 4">
             <a:extLst>
               <a:ext uri="{FF2B5EF4-FFF2-40B4-BE49-F238E27FC236}">
-                <a16:creationId xmlns:a16="http://schemas.microsoft.com/office/drawing/2014/main" id="{10720380-8D30-A571-D4DB-4B316D8A1A67}"/>
+                <a16:creationId xmlns:a16="http://schemas.microsoft.com/office/drawing/2014/main" id="{22889564-9F29-DD86-6656-52FAD7F70170}"/>
               </a:ext>
             </a:extLst>
           </p:cNvPr>
@@ -1730,7 +1730,7 @@
           <p:cNvPr id="6" name="내용 개체 틀 5">
             <a:extLst>
               <a:ext uri="{FF2B5EF4-FFF2-40B4-BE49-F238E27FC236}">
-                <a16:creationId xmlns:a16="http://schemas.microsoft.com/office/drawing/2014/main" id="{9C21517C-E266-6C5F-6F01-66C3B0E7886C}"/>
+                <a16:creationId xmlns:a16="http://schemas.microsoft.com/office/drawing/2014/main" id="{2743AB72-1B46-FF86-29A7-48BB649C87F2}"/>
               </a:ext>
             </a:extLst>
           </p:cNvPr>
@@ -1792,7 +1792,7 @@
           <p:cNvPr id="7" name="날짜 개체 틀 6">
             <a:extLst>
               <a:ext uri="{FF2B5EF4-FFF2-40B4-BE49-F238E27FC236}">
-                <a16:creationId xmlns:a16="http://schemas.microsoft.com/office/drawing/2014/main" id="{53837287-C999-40CA-3041-837556CA1BCE}"/>
+                <a16:creationId xmlns:a16="http://schemas.microsoft.com/office/drawing/2014/main" id="{5E3BA9D9-48F6-DDF9-C9F4-B16EA125100B}"/>
               </a:ext>
             </a:extLst>
           </p:cNvPr>
@@ -1808,7 +1808,7 @@
           <a:bodyPr/>
           <a:lstStyle/>
           <a:p>
-            <a:fld id="{FBD92C38-B0C8-4D61-B511-2B35933A6C49}" type="datetimeFigureOut">
+            <a:fld id="{AE899331-733F-4720-83EF-03D552583B79}" type="datetimeFigureOut">
               <a:rPr lang="ko-KR" altLang="en-US" smtClean="0"/>
               <a:t>2026-06-19</a:t>
             </a:fld>
@@ -1821,7 +1821,7 @@
           <p:cNvPr id="8" name="바닥글 개체 틀 7">
             <a:extLst>
               <a:ext uri="{FF2B5EF4-FFF2-40B4-BE49-F238E27FC236}">
-                <a16:creationId xmlns:a16="http://schemas.microsoft.com/office/drawing/2014/main" id="{C991FB1F-AC3D-66C9-3CA7-4CA759D0A3C6}"/>
+                <a16:creationId xmlns:a16="http://schemas.microsoft.com/office/drawing/2014/main" id="{AB624BD7-187A-660B-276F-439CEB859CA0}"/>
               </a:ext>
             </a:extLst>
           </p:cNvPr>
@@ -1846,7 +1846,7 @@
           <p:cNvPr id="9" name="슬라이드 번호 개체 틀 8">
             <a:extLst>
               <a:ext uri="{FF2B5EF4-FFF2-40B4-BE49-F238E27FC236}">
-                <a16:creationId xmlns:a16="http://schemas.microsoft.com/office/drawing/2014/main" id="{706FB7EA-350F-0259-DF63-1532CC5AFAEE}"/>
+                <a16:creationId xmlns:a16="http://schemas.microsoft.com/office/drawing/2014/main" id="{3B482BF7-D4E5-2877-5325-DF7AEE269527}"/>
               </a:ext>
             </a:extLst>
           </p:cNvPr>
@@ -1862,7 +1862,7 @@
           <a:bodyPr/>
           <a:lstStyle/>
           <a:p>
-            <a:fld id="{A77F83F0-4926-4A81-806C-F53BFF57509D}" type="slidenum">
+            <a:fld id="{324CD06F-1683-4109-A93C-652FD2E4AB1B}" type="slidenum">
               <a:rPr lang="ko-KR" altLang="en-US" smtClean="0"/>
               <a:t>‹#›</a:t>
             </a:fld>
@@ -1873,7 +1873,7 @@
     </p:spTree>
     <p:extLst>
       <p:ext uri="{BB962C8B-B14F-4D97-AF65-F5344CB8AC3E}">
-        <p14:creationId xmlns:p14="http://schemas.microsoft.com/office/powerpoint/2010/main" val="687456718"/>
+        <p14:creationId xmlns:p14="http://schemas.microsoft.com/office/powerpoint/2010/main" val="3233019883"/>
       </p:ext>
     </p:extLst>
   </p:cSld>
@@ -1905,7 +1905,7 @@
           <p:cNvPr id="2" name="제목 1">
             <a:extLst>
               <a:ext uri="{FF2B5EF4-FFF2-40B4-BE49-F238E27FC236}">
-                <a16:creationId xmlns:a16="http://schemas.microsoft.com/office/drawing/2014/main" id="{87355807-A593-5CAE-14FB-3CC415B120C5}"/>
+                <a16:creationId xmlns:a16="http://schemas.microsoft.com/office/drawing/2014/main" id="{C2D54FAD-8D09-3A7D-4380-A2A0C5BFDB0C}"/>
               </a:ext>
             </a:extLst>
           </p:cNvPr>
@@ -1933,7 +1933,7 @@
           <p:cNvPr id="3" name="날짜 개체 틀 2">
             <a:extLst>
               <a:ext uri="{FF2B5EF4-FFF2-40B4-BE49-F238E27FC236}">
-                <a16:creationId xmlns:a16="http://schemas.microsoft.com/office/drawing/2014/main" id="{67B6537C-8313-4562-CE18-5E727F16B5BF}"/>
+                <a16:creationId xmlns:a16="http://schemas.microsoft.com/office/drawing/2014/main" id="{AA0717EB-7173-6567-C422-8403022E345B}"/>
               </a:ext>
             </a:extLst>
           </p:cNvPr>
@@ -1949,7 +1949,7 @@
           <a:bodyPr/>
           <a:lstStyle/>
           <a:p>
-            <a:fld id="{FBD92C38-B0C8-4D61-B511-2B35933A6C49}" type="datetimeFigureOut">
+            <a:fld id="{AE899331-733F-4720-83EF-03D552583B79}" type="datetimeFigureOut">
               <a:rPr lang="ko-KR" altLang="en-US" smtClean="0"/>
               <a:t>2026-06-19</a:t>
             </a:fld>
@@ -1962,7 +1962,7 @@
           <p:cNvPr id="4" name="바닥글 개체 틀 3">
             <a:extLst>
               <a:ext uri="{FF2B5EF4-FFF2-40B4-BE49-F238E27FC236}">
-                <a16:creationId xmlns:a16="http://schemas.microsoft.com/office/drawing/2014/main" id="{CB36B3C0-DEBB-4B96-3ADC-6B2F5A814A2C}"/>
+                <a16:creationId xmlns:a16="http://schemas.microsoft.com/office/drawing/2014/main" id="{AADD5942-004E-3A5C-A661-FCB8FE82CAE2}"/>
               </a:ext>
             </a:extLst>
           </p:cNvPr>
@@ -1987,7 +1987,7 @@
           <p:cNvPr id="5" name="슬라이드 번호 개체 틀 4">
             <a:extLst>
               <a:ext uri="{FF2B5EF4-FFF2-40B4-BE49-F238E27FC236}">
-                <a16:creationId xmlns:a16="http://schemas.microsoft.com/office/drawing/2014/main" id="{758EEB0B-7975-CC21-41DD-C4BCF81E17EC}"/>
+                <a16:creationId xmlns:a16="http://schemas.microsoft.com/office/drawing/2014/main" id="{9C2DFE50-B55F-2E5A-D241-87E012C79F36}"/>
               </a:ext>
             </a:extLst>
           </p:cNvPr>
@@ -2003,7 +2003,7 @@
           <a:bodyPr/>
           <a:lstStyle/>
           <a:p>
-            <a:fld id="{A77F83F0-4926-4A81-806C-F53BFF57509D}" type="slidenum">
+            <a:fld id="{324CD06F-1683-4109-A93C-652FD2E4AB1B}" type="slidenum">
               <a:rPr lang="ko-KR" altLang="en-US" smtClean="0"/>
               <a:t>‹#›</a:t>
             </a:fld>
@@ -2014,7 +2014,7 @@
     </p:spTree>
     <p:extLst>
       <p:ext uri="{BB962C8B-B14F-4D97-AF65-F5344CB8AC3E}">
-        <p14:creationId xmlns:p14="http://schemas.microsoft.com/office/powerpoint/2010/main" val="869215520"/>
+        <p14:creationId xmlns:p14="http://schemas.microsoft.com/office/powerpoint/2010/main" val="2630176028"/>
       </p:ext>
     </p:extLst>
   </p:cSld>
@@ -2046,7 +2046,7 @@
           <p:cNvPr id="2" name="날짜 개체 틀 1">
             <a:extLst>
               <a:ext uri="{FF2B5EF4-FFF2-40B4-BE49-F238E27FC236}">
-                <a16:creationId xmlns:a16="http://schemas.microsoft.com/office/drawing/2014/main" id="{FBDA4900-AB43-5C54-A2A9-AE94E49C607C}"/>
+                <a16:creationId xmlns:a16="http://schemas.microsoft.com/office/drawing/2014/main" id="{FA1BA1FD-7DF8-A8A2-A8DA-25072132AA92}"/>
               </a:ext>
             </a:extLst>
           </p:cNvPr>
@@ -2062,7 +2062,7 @@
           <a:bodyPr/>
           <a:lstStyle/>
           <a:p>
-            <a:fld id="{FBD92C38-B0C8-4D61-B511-2B35933A6C49}" type="datetimeFigureOut">
+            <a:fld id="{AE899331-733F-4720-83EF-03D552583B79}" type="datetimeFigureOut">
               <a:rPr lang="ko-KR" altLang="en-US" smtClean="0"/>
               <a:t>2026-06-19</a:t>
             </a:fld>
@@ -2075,7 +2075,7 @@
           <p:cNvPr id="3" name="바닥글 개체 틀 2">
             <a:extLst>
               <a:ext uri="{FF2B5EF4-FFF2-40B4-BE49-F238E27FC236}">
-                <a16:creationId xmlns:a16="http://schemas.microsoft.com/office/drawing/2014/main" id="{F756D1F6-FA89-BD71-2361-CA78DA210E33}"/>
+                <a16:creationId xmlns:a16="http://schemas.microsoft.com/office/drawing/2014/main" id="{7B357A76-DFC0-B51D-19E8-0BE20B6D8410}"/>
               </a:ext>
             </a:extLst>
           </p:cNvPr>
@@ -2100,7 +2100,7 @@
           <p:cNvPr id="4" name="슬라이드 번호 개체 틀 3">
             <a:extLst>
               <a:ext uri="{FF2B5EF4-FFF2-40B4-BE49-F238E27FC236}">
-                <a16:creationId xmlns:a16="http://schemas.microsoft.com/office/drawing/2014/main" id="{29A3A197-B442-2027-7B97-F54451B351E6}"/>
+                <a16:creationId xmlns:a16="http://schemas.microsoft.com/office/drawing/2014/main" id="{334495BE-2ADA-F904-9AE6-2F282667ADC2}"/>
               </a:ext>
             </a:extLst>
           </p:cNvPr>
@@ -2116,7 +2116,7 @@
           <a:bodyPr/>
           <a:lstStyle/>
           <a:p>
-            <a:fld id="{A77F83F0-4926-4A81-806C-F53BFF57509D}" type="slidenum">
+            <a:fld id="{324CD06F-1683-4109-A93C-652FD2E4AB1B}" type="slidenum">
               <a:rPr lang="ko-KR" altLang="en-US" smtClean="0"/>
               <a:t>‹#›</a:t>
             </a:fld>
@@ -2127,7 +2127,7 @@
     </p:spTree>
     <p:extLst>
       <p:ext uri="{BB962C8B-B14F-4D97-AF65-F5344CB8AC3E}">
-        <p14:creationId xmlns:p14="http://schemas.microsoft.com/office/powerpoint/2010/main" val="1888166526"/>
+        <p14:creationId xmlns:p14="http://schemas.microsoft.com/office/powerpoint/2010/main" val="519552188"/>
       </p:ext>
     </p:extLst>
   </p:cSld>
@@ -2159,7 +2159,7 @@
           <p:cNvPr id="2" name="제목 1">
             <a:extLst>
               <a:ext uri="{FF2B5EF4-FFF2-40B4-BE49-F238E27FC236}">
-                <a16:creationId xmlns:a16="http://schemas.microsoft.com/office/drawing/2014/main" id="{9D8AF906-9D68-CA52-477F-BAC21945BB0B}"/>
+                <a16:creationId xmlns:a16="http://schemas.microsoft.com/office/drawing/2014/main" id="{717C8BD2-8FA3-7585-96DD-569FC27A3302}"/>
               </a:ext>
             </a:extLst>
           </p:cNvPr>
@@ -2196,7 +2196,7 @@
           <p:cNvPr id="3" name="내용 개체 틀 2">
             <a:extLst>
               <a:ext uri="{FF2B5EF4-FFF2-40B4-BE49-F238E27FC236}">
-                <a16:creationId xmlns:a16="http://schemas.microsoft.com/office/drawing/2014/main" id="{81998FA9-35F8-4E80-BDBF-9871F497F26E}"/>
+                <a16:creationId xmlns:a16="http://schemas.microsoft.com/office/drawing/2014/main" id="{1712B2CA-F535-8EAE-DD34-8CE671B26018}"/>
               </a:ext>
             </a:extLst>
           </p:cNvPr>
@@ -2286,7 +2286,7 @@
           <p:cNvPr id="4" name="텍스트 개체 틀 3">
             <a:extLst>
               <a:ext uri="{FF2B5EF4-FFF2-40B4-BE49-F238E27FC236}">
-                <a16:creationId xmlns:a16="http://schemas.microsoft.com/office/drawing/2014/main" id="{A3F8B1A0-6D0D-872A-BB4B-818AB2B5D1B3}"/>
+                <a16:creationId xmlns:a16="http://schemas.microsoft.com/office/drawing/2014/main" id="{3531CD9E-8FA2-5927-2A40-027BFAE2CF58}"/>
               </a:ext>
             </a:extLst>
           </p:cNvPr>
@@ -2357,7 +2357,7 @@
           <p:cNvPr id="5" name="날짜 개체 틀 4">
             <a:extLst>
               <a:ext uri="{FF2B5EF4-FFF2-40B4-BE49-F238E27FC236}">
-                <a16:creationId xmlns:a16="http://schemas.microsoft.com/office/drawing/2014/main" id="{1212B371-9A79-F587-F7B9-B2D4B0A88C0E}"/>
+                <a16:creationId xmlns:a16="http://schemas.microsoft.com/office/drawing/2014/main" id="{0DFD9E66-5048-B489-579F-9FCA29F97408}"/>
               </a:ext>
             </a:extLst>
           </p:cNvPr>
@@ -2373,7 +2373,7 @@
           <a:bodyPr/>
           <a:lstStyle/>
           <a:p>
-            <a:fld id="{FBD92C38-B0C8-4D61-B511-2B35933A6C49}" type="datetimeFigureOut">
+            <a:fld id="{AE899331-733F-4720-83EF-03D552583B79}" type="datetimeFigureOut">
               <a:rPr lang="ko-KR" altLang="en-US" smtClean="0"/>
               <a:t>2026-06-19</a:t>
             </a:fld>
@@ -2386,7 +2386,7 @@
           <p:cNvPr id="6" name="바닥글 개체 틀 5">
             <a:extLst>
               <a:ext uri="{FF2B5EF4-FFF2-40B4-BE49-F238E27FC236}">
-                <a16:creationId xmlns:a16="http://schemas.microsoft.com/office/drawing/2014/main" id="{489A177C-98EB-6B69-A210-5CE2F69F04A9}"/>
+                <a16:creationId xmlns:a16="http://schemas.microsoft.com/office/drawing/2014/main" id="{F915BF74-6AA2-2703-0079-9836758C65BE}"/>
               </a:ext>
             </a:extLst>
           </p:cNvPr>
@@ -2411,7 +2411,7 @@
           <p:cNvPr id="7" name="슬라이드 번호 개체 틀 6">
             <a:extLst>
               <a:ext uri="{FF2B5EF4-FFF2-40B4-BE49-F238E27FC236}">
-                <a16:creationId xmlns:a16="http://schemas.microsoft.com/office/drawing/2014/main" id="{AD7B1B72-43A3-E69B-A8B3-3A29B7CA6575}"/>
+                <a16:creationId xmlns:a16="http://schemas.microsoft.com/office/drawing/2014/main" id="{E58662C9-264A-BC69-9778-C05DCAEBBE43}"/>
               </a:ext>
             </a:extLst>
           </p:cNvPr>
@@ -2427,7 +2427,7 @@
           <a:bodyPr/>
           <a:lstStyle/>
           <a:p>
-            <a:fld id="{A77F83F0-4926-4A81-806C-F53BFF57509D}" type="slidenum">
+            <a:fld id="{324CD06F-1683-4109-A93C-652FD2E4AB1B}" type="slidenum">
               <a:rPr lang="ko-KR" altLang="en-US" smtClean="0"/>
               <a:t>‹#›</a:t>
             </a:fld>
@@ -2438,7 +2438,7 @@
     </p:spTree>
     <p:extLst>
       <p:ext uri="{BB962C8B-B14F-4D97-AF65-F5344CB8AC3E}">
-        <p14:creationId xmlns:p14="http://schemas.microsoft.com/office/powerpoint/2010/main" val="2392031290"/>
+        <p14:creationId xmlns:p14="http://schemas.microsoft.com/office/powerpoint/2010/main" val="52148405"/>
       </p:ext>
     </p:extLst>
   </p:cSld>
@@ -2470,7 +2470,7 @@
           <p:cNvPr id="2" name="제목 1">
             <a:extLst>
               <a:ext uri="{FF2B5EF4-FFF2-40B4-BE49-F238E27FC236}">
-                <a16:creationId xmlns:a16="http://schemas.microsoft.com/office/drawing/2014/main" id="{A8F38F6C-4B68-3AC5-83FD-CC18DDA77B6C}"/>
+                <a16:creationId xmlns:a16="http://schemas.microsoft.com/office/drawing/2014/main" id="{822A5F1F-F8DA-9B1F-6688-1CA543C22BA6}"/>
               </a:ext>
             </a:extLst>
           </p:cNvPr>
@@ -2507,7 +2507,7 @@
           <p:cNvPr id="3" name="그림 개체 틀 2">
             <a:extLst>
               <a:ext uri="{FF2B5EF4-FFF2-40B4-BE49-F238E27FC236}">
-                <a16:creationId xmlns:a16="http://schemas.microsoft.com/office/drawing/2014/main" id="{25E4D112-AA6C-81BF-C867-BFA98FDC648C}"/>
+                <a16:creationId xmlns:a16="http://schemas.microsoft.com/office/drawing/2014/main" id="{CF3D078C-C16C-4114-E8A0-3E13FC41EA15}"/>
               </a:ext>
             </a:extLst>
           </p:cNvPr>
@@ -2574,7 +2574,7 @@
           <p:cNvPr id="4" name="텍스트 개체 틀 3">
             <a:extLst>
               <a:ext uri="{FF2B5EF4-FFF2-40B4-BE49-F238E27FC236}">
-                <a16:creationId xmlns:a16="http://schemas.microsoft.com/office/drawing/2014/main" id="{36AD8CD8-8568-19A3-D3A5-B766A886738F}"/>
+                <a16:creationId xmlns:a16="http://schemas.microsoft.com/office/drawing/2014/main" id="{B8234DB4-FC8A-B964-8DF4-69F8CA420338}"/>
               </a:ext>
             </a:extLst>
           </p:cNvPr>
@@ -2645,7 +2645,7 @@
           <p:cNvPr id="5" name="날짜 개체 틀 4">
             <a:extLst>
               <a:ext uri="{FF2B5EF4-FFF2-40B4-BE49-F238E27FC236}">
-                <a16:creationId xmlns:a16="http://schemas.microsoft.com/office/drawing/2014/main" id="{1E750A3B-7207-F198-6D4E-A9168C41E20A}"/>
+                <a16:creationId xmlns:a16="http://schemas.microsoft.com/office/drawing/2014/main" id="{93F7A6E3-59B3-E1D7-256D-2CA0A7B63E9C}"/>
               </a:ext>
             </a:extLst>
           </p:cNvPr>
@@ -2661,7 +2661,7 @@
           <a:bodyPr/>
           <a:lstStyle/>
           <a:p>
-            <a:fld id="{FBD92C38-B0C8-4D61-B511-2B35933A6C49}" type="datetimeFigureOut">
+            <a:fld id="{AE899331-733F-4720-83EF-03D552583B79}" type="datetimeFigureOut">
               <a:rPr lang="ko-KR" altLang="en-US" smtClean="0"/>
               <a:t>2026-06-19</a:t>
             </a:fld>
@@ -2674,7 +2674,7 @@
           <p:cNvPr id="6" name="바닥글 개체 틀 5">
             <a:extLst>
               <a:ext uri="{FF2B5EF4-FFF2-40B4-BE49-F238E27FC236}">
-                <a16:creationId xmlns:a16="http://schemas.microsoft.com/office/drawing/2014/main" id="{10E7EDA9-B800-3284-014C-F89AC884ED63}"/>
+                <a16:creationId xmlns:a16="http://schemas.microsoft.com/office/drawing/2014/main" id="{837D42D8-D8D5-E230-4873-D9A4FC73AC51}"/>
               </a:ext>
             </a:extLst>
           </p:cNvPr>
@@ -2699,7 +2699,7 @@
           <p:cNvPr id="7" name="슬라이드 번호 개체 틀 6">
             <a:extLst>
               <a:ext uri="{FF2B5EF4-FFF2-40B4-BE49-F238E27FC236}">
-                <a16:creationId xmlns:a16="http://schemas.microsoft.com/office/drawing/2014/main" id="{920C32BD-3EC6-0E29-B612-135FD0CF73B4}"/>
+                <a16:creationId xmlns:a16="http://schemas.microsoft.com/office/drawing/2014/main" id="{3A40273D-BD1F-1310-6E8B-0E328978876E}"/>
               </a:ext>
             </a:extLst>
           </p:cNvPr>
@@ -2715,7 +2715,7 @@
           <a:bodyPr/>
           <a:lstStyle/>
           <a:p>
-            <a:fld id="{A77F83F0-4926-4A81-806C-F53BFF57509D}" type="slidenum">
+            <a:fld id="{324CD06F-1683-4109-A93C-652FD2E4AB1B}" type="slidenum">
               <a:rPr lang="ko-KR" altLang="en-US" smtClean="0"/>
               <a:t>‹#›</a:t>
             </a:fld>
@@ -2726,7 +2726,7 @@
     </p:spTree>
     <p:extLst>
       <p:ext uri="{BB962C8B-B14F-4D97-AF65-F5344CB8AC3E}">
-        <p14:creationId xmlns:p14="http://schemas.microsoft.com/office/powerpoint/2010/main" val="905053901"/>
+        <p14:creationId xmlns:p14="http://schemas.microsoft.com/office/powerpoint/2010/main" val="2553808010"/>
       </p:ext>
     </p:extLst>
   </p:cSld>
@@ -2763,7 +2763,7 @@
           <p:cNvPr id="2" name="제목 개체 틀 1">
             <a:extLst>
               <a:ext uri="{FF2B5EF4-FFF2-40B4-BE49-F238E27FC236}">
-                <a16:creationId xmlns:a16="http://schemas.microsoft.com/office/drawing/2014/main" id="{FEE72AF5-2C3C-7239-B657-92E656720926}"/>
+                <a16:creationId xmlns:a16="http://schemas.microsoft.com/office/drawing/2014/main" id="{56A6EB8E-0645-3C9A-FCF3-95D234814D42}"/>
               </a:ext>
             </a:extLst>
           </p:cNvPr>
@@ -2801,7 +2801,7 @@
           <p:cNvPr id="3" name="텍스트 개체 틀 2">
             <a:extLst>
               <a:ext uri="{FF2B5EF4-FFF2-40B4-BE49-F238E27FC236}">
-                <a16:creationId xmlns:a16="http://schemas.microsoft.com/office/drawing/2014/main" id="{BE26B0CB-CDF0-9511-8B62-7F5AD58DE73C}"/>
+                <a16:creationId xmlns:a16="http://schemas.microsoft.com/office/drawing/2014/main" id="{81E84DE3-AB3F-3D48-7FFE-7AFB2A030C76}"/>
               </a:ext>
             </a:extLst>
           </p:cNvPr>
@@ -2868,7 +2868,7 @@
           <p:cNvPr id="4" name="날짜 개체 틀 3">
             <a:extLst>
               <a:ext uri="{FF2B5EF4-FFF2-40B4-BE49-F238E27FC236}">
-                <a16:creationId xmlns:a16="http://schemas.microsoft.com/office/drawing/2014/main" id="{7BBEC8FC-6564-C068-C34C-E8F828F91FA9}"/>
+                <a16:creationId xmlns:a16="http://schemas.microsoft.com/office/drawing/2014/main" id="{116A4DB5-C1A0-378E-655D-E481798E72E4}"/>
               </a:ext>
             </a:extLst>
           </p:cNvPr>
@@ -2902,7 +2902,7 @@
             </a:lvl1pPr>
           </a:lstStyle>
           <a:p>
-            <a:fld id="{FBD92C38-B0C8-4D61-B511-2B35933A6C49}" type="datetimeFigureOut">
+            <a:fld id="{AE899331-733F-4720-83EF-03D552583B79}" type="datetimeFigureOut">
               <a:rPr lang="ko-KR" altLang="en-US" smtClean="0"/>
               <a:t>2026-06-19</a:t>
             </a:fld>
@@ -2915,7 +2915,7 @@
           <p:cNvPr id="5" name="바닥글 개체 틀 4">
             <a:extLst>
               <a:ext uri="{FF2B5EF4-FFF2-40B4-BE49-F238E27FC236}">
-                <a16:creationId xmlns:a16="http://schemas.microsoft.com/office/drawing/2014/main" id="{8AEA0AD1-457C-45B7-16E7-BF92EABE2273}"/>
+                <a16:creationId xmlns:a16="http://schemas.microsoft.com/office/drawing/2014/main" id="{B716B58A-23BE-CA9F-F05F-993A3281A0BB}"/>
               </a:ext>
             </a:extLst>
           </p:cNvPr>
@@ -2958,7 +2958,7 @@
           <p:cNvPr id="6" name="슬라이드 번호 개체 틀 5">
             <a:extLst>
               <a:ext uri="{FF2B5EF4-FFF2-40B4-BE49-F238E27FC236}">
-                <a16:creationId xmlns:a16="http://schemas.microsoft.com/office/drawing/2014/main" id="{EA8EEB77-7BEA-96CD-16FA-ED30420F5DCE}"/>
+                <a16:creationId xmlns:a16="http://schemas.microsoft.com/office/drawing/2014/main" id="{22D2EAF7-EA93-F172-BD52-1CA5F0C9106E}"/>
               </a:ext>
             </a:extLst>
           </p:cNvPr>
@@ -2992,7 +2992,7 @@
             </a:lvl1pPr>
           </a:lstStyle>
           <a:p>
-            <a:fld id="{A77F83F0-4926-4A81-806C-F53BFF57509D}" type="slidenum">
+            <a:fld id="{324CD06F-1683-4109-A93C-652FD2E4AB1B}" type="slidenum">
               <a:rPr lang="ko-KR" altLang="en-US" smtClean="0"/>
               <a:t>‹#›</a:t>
             </a:fld>
@@ -3003,7 +3003,7 @@
     </p:spTree>
     <p:extLst>
       <p:ext uri="{BB962C8B-B14F-4D97-AF65-F5344CB8AC3E}">
-        <p14:creationId xmlns:p14="http://schemas.microsoft.com/office/powerpoint/2010/main" val="839823633"/>
+        <p14:creationId xmlns:p14="http://schemas.microsoft.com/office/powerpoint/2010/main" val="75149600"/>
       </p:ext>
     </p:extLst>
   </p:cSld>
@@ -3326,7 +3326,7 @@
           <p:cNvPr id="3" name="pipeline_overview_svg">
             <a:extLst>
               <a:ext uri="{FF2B5EF4-FFF2-40B4-BE49-F238E27FC236}">
-                <a16:creationId xmlns:a16="http://schemas.microsoft.com/office/drawing/2014/main" id="{2A4665A3-0E5D-DC53-39E1-206EA607856F}"/>
+                <a16:creationId xmlns:a16="http://schemas.microsoft.com/office/drawing/2014/main" id="{A59667C2-9A6E-046E-6B16-F4FA265CA058}"/>
               </a:ext>
             </a:extLst>
           </p:cNvPr>
@@ -3367,7 +3367,7 @@
     </p:spTree>
     <p:extLst>
       <p:ext uri="{BB962C8B-B14F-4D97-AF65-F5344CB8AC3E}">
-        <p14:creationId xmlns:p14="http://schemas.microsoft.com/office/powerpoint/2010/main" val="39618639"/>
+        <p14:creationId xmlns:p14="http://schemas.microsoft.com/office/powerpoint/2010/main" val="993714057"/>
       </p:ext>
     </p:extLst>
   </p:cSld>

</xml_diff>

<commit_message>
Align pipeline layout with PowerPoint rules
</commit_message>
<xml_diff>
--- a/docs/assets/pipeline-overview.pptx
+++ b/docs/assets/pipeline-overview.pptx
@@ -129,7 +129,7 @@
           <p:cNvPr id="2" name="제목 1">
             <a:extLst>
               <a:ext uri="{FF2B5EF4-FFF2-40B4-BE49-F238E27FC236}">
-                <a16:creationId xmlns:a16="http://schemas.microsoft.com/office/drawing/2014/main" id="{94D7C861-5BE5-8875-FD01-C33CC72D12EA}"/>
+                <a16:creationId xmlns:a16="http://schemas.microsoft.com/office/drawing/2014/main" id="{9171FBC1-8257-F8EE-6627-FCF507D96855}"/>
               </a:ext>
             </a:extLst>
           </p:cNvPr>
@@ -166,7 +166,7 @@
           <p:cNvPr id="3" name="부제목 2">
             <a:extLst>
               <a:ext uri="{FF2B5EF4-FFF2-40B4-BE49-F238E27FC236}">
-                <a16:creationId xmlns:a16="http://schemas.microsoft.com/office/drawing/2014/main" id="{E1E10F19-3C91-4615-CCA5-288143B23121}"/>
+                <a16:creationId xmlns:a16="http://schemas.microsoft.com/office/drawing/2014/main" id="{711C2455-512B-A1E6-1D4A-190AF5EA7BD8}"/>
               </a:ext>
             </a:extLst>
           </p:cNvPr>
@@ -236,7 +236,7 @@
           <p:cNvPr id="4" name="날짜 개체 틀 3">
             <a:extLst>
               <a:ext uri="{FF2B5EF4-FFF2-40B4-BE49-F238E27FC236}">
-                <a16:creationId xmlns:a16="http://schemas.microsoft.com/office/drawing/2014/main" id="{85553287-C6BD-122E-6044-D889D6211D82}"/>
+                <a16:creationId xmlns:a16="http://schemas.microsoft.com/office/drawing/2014/main" id="{1C1400A6-1CF0-8E2F-685A-1F791EAD5DA3}"/>
               </a:ext>
             </a:extLst>
           </p:cNvPr>
@@ -252,7 +252,7 @@
           <a:bodyPr/>
           <a:lstStyle/>
           <a:p>
-            <a:fld id="{AE899331-733F-4720-83EF-03D552583B79}" type="datetimeFigureOut">
+            <a:fld id="{9742B1B7-23B9-44F4-B08E-E585703C19EC}" type="datetimeFigureOut">
               <a:rPr lang="ko-KR" altLang="en-US" smtClean="0"/>
               <a:t>2026-06-19</a:t>
             </a:fld>
@@ -265,7 +265,7 @@
           <p:cNvPr id="5" name="바닥글 개체 틀 4">
             <a:extLst>
               <a:ext uri="{FF2B5EF4-FFF2-40B4-BE49-F238E27FC236}">
-                <a16:creationId xmlns:a16="http://schemas.microsoft.com/office/drawing/2014/main" id="{B3C25F41-A508-D8A1-FC47-DCD602E3CCA3}"/>
+                <a16:creationId xmlns:a16="http://schemas.microsoft.com/office/drawing/2014/main" id="{E9B50CD2-D7AC-9DEB-F70B-17A5C49B8E72}"/>
               </a:ext>
             </a:extLst>
           </p:cNvPr>
@@ -290,7 +290,7 @@
           <p:cNvPr id="6" name="슬라이드 번호 개체 틀 5">
             <a:extLst>
               <a:ext uri="{FF2B5EF4-FFF2-40B4-BE49-F238E27FC236}">
-                <a16:creationId xmlns:a16="http://schemas.microsoft.com/office/drawing/2014/main" id="{8B14EAFF-78B1-477B-C482-5D574F0FAD5C}"/>
+                <a16:creationId xmlns:a16="http://schemas.microsoft.com/office/drawing/2014/main" id="{5B07612A-6C59-A760-F154-65B752D96C7C}"/>
               </a:ext>
             </a:extLst>
           </p:cNvPr>
@@ -306,7 +306,7 @@
           <a:bodyPr/>
           <a:lstStyle/>
           <a:p>
-            <a:fld id="{324CD06F-1683-4109-A93C-652FD2E4AB1B}" type="slidenum">
+            <a:fld id="{F8562357-FFAC-4DD4-994D-CC30F1B809D6}" type="slidenum">
               <a:rPr lang="ko-KR" altLang="en-US" smtClean="0"/>
               <a:t>‹#›</a:t>
             </a:fld>
@@ -317,7 +317,7 @@
     </p:spTree>
     <p:extLst>
       <p:ext uri="{BB962C8B-B14F-4D97-AF65-F5344CB8AC3E}">
-        <p14:creationId xmlns:p14="http://schemas.microsoft.com/office/powerpoint/2010/main" val="657987959"/>
+        <p14:creationId xmlns:p14="http://schemas.microsoft.com/office/powerpoint/2010/main" val="897659318"/>
       </p:ext>
     </p:extLst>
   </p:cSld>
@@ -349,7 +349,7 @@
           <p:cNvPr id="2" name="제목 1">
             <a:extLst>
               <a:ext uri="{FF2B5EF4-FFF2-40B4-BE49-F238E27FC236}">
-                <a16:creationId xmlns:a16="http://schemas.microsoft.com/office/drawing/2014/main" id="{1C7F8601-1687-EC92-F577-75AADA2E0384}"/>
+                <a16:creationId xmlns:a16="http://schemas.microsoft.com/office/drawing/2014/main" id="{85B22CA5-D057-04D7-875F-5696DEA0ABDF}"/>
               </a:ext>
             </a:extLst>
           </p:cNvPr>
@@ -377,7 +377,7 @@
           <p:cNvPr id="3" name="세로 텍스트 개체 틀 2">
             <a:extLst>
               <a:ext uri="{FF2B5EF4-FFF2-40B4-BE49-F238E27FC236}">
-                <a16:creationId xmlns:a16="http://schemas.microsoft.com/office/drawing/2014/main" id="{85D1A5E3-EBC6-565A-57CC-8024C2AE00F8}"/>
+                <a16:creationId xmlns:a16="http://schemas.microsoft.com/office/drawing/2014/main" id="{146FD2AB-5735-06C5-4A3A-CDBEF9218DB3}"/>
               </a:ext>
             </a:extLst>
           </p:cNvPr>
@@ -434,7 +434,7 @@
           <p:cNvPr id="4" name="날짜 개체 틀 3">
             <a:extLst>
               <a:ext uri="{FF2B5EF4-FFF2-40B4-BE49-F238E27FC236}">
-                <a16:creationId xmlns:a16="http://schemas.microsoft.com/office/drawing/2014/main" id="{5484ACE1-4CCB-E207-BF9A-8C6DD6E3F4C2}"/>
+                <a16:creationId xmlns:a16="http://schemas.microsoft.com/office/drawing/2014/main" id="{CBE03DFC-38FC-CDFA-9B02-C9FBF9C90B8F}"/>
               </a:ext>
             </a:extLst>
           </p:cNvPr>
@@ -450,7 +450,7 @@
           <a:bodyPr/>
           <a:lstStyle/>
           <a:p>
-            <a:fld id="{AE899331-733F-4720-83EF-03D552583B79}" type="datetimeFigureOut">
+            <a:fld id="{9742B1B7-23B9-44F4-B08E-E585703C19EC}" type="datetimeFigureOut">
               <a:rPr lang="ko-KR" altLang="en-US" smtClean="0"/>
               <a:t>2026-06-19</a:t>
             </a:fld>
@@ -463,7 +463,7 @@
           <p:cNvPr id="5" name="바닥글 개체 틀 4">
             <a:extLst>
               <a:ext uri="{FF2B5EF4-FFF2-40B4-BE49-F238E27FC236}">
-                <a16:creationId xmlns:a16="http://schemas.microsoft.com/office/drawing/2014/main" id="{AEE05642-B1B0-DDF1-BF3D-991C571BA03C}"/>
+                <a16:creationId xmlns:a16="http://schemas.microsoft.com/office/drawing/2014/main" id="{828E767B-6A41-FC82-3D42-C3655964C8F7}"/>
               </a:ext>
             </a:extLst>
           </p:cNvPr>
@@ -488,7 +488,7 @@
           <p:cNvPr id="6" name="슬라이드 번호 개체 틀 5">
             <a:extLst>
               <a:ext uri="{FF2B5EF4-FFF2-40B4-BE49-F238E27FC236}">
-                <a16:creationId xmlns:a16="http://schemas.microsoft.com/office/drawing/2014/main" id="{5BB9A8FE-180D-4B48-8B82-796D87BFB99D}"/>
+                <a16:creationId xmlns:a16="http://schemas.microsoft.com/office/drawing/2014/main" id="{280581F7-4640-E411-FAB8-45F039ECC56D}"/>
               </a:ext>
             </a:extLst>
           </p:cNvPr>
@@ -504,7 +504,7 @@
           <a:bodyPr/>
           <a:lstStyle/>
           <a:p>
-            <a:fld id="{324CD06F-1683-4109-A93C-652FD2E4AB1B}" type="slidenum">
+            <a:fld id="{F8562357-FFAC-4DD4-994D-CC30F1B809D6}" type="slidenum">
               <a:rPr lang="ko-KR" altLang="en-US" smtClean="0"/>
               <a:t>‹#›</a:t>
             </a:fld>
@@ -515,7 +515,7 @@
     </p:spTree>
     <p:extLst>
       <p:ext uri="{BB962C8B-B14F-4D97-AF65-F5344CB8AC3E}">
-        <p14:creationId xmlns:p14="http://schemas.microsoft.com/office/powerpoint/2010/main" val="1952157581"/>
+        <p14:creationId xmlns:p14="http://schemas.microsoft.com/office/powerpoint/2010/main" val="1090552103"/>
       </p:ext>
     </p:extLst>
   </p:cSld>
@@ -547,7 +547,7 @@
           <p:cNvPr id="2" name="세로 제목 1">
             <a:extLst>
               <a:ext uri="{FF2B5EF4-FFF2-40B4-BE49-F238E27FC236}">
-                <a16:creationId xmlns:a16="http://schemas.microsoft.com/office/drawing/2014/main" id="{F6BC9F11-C3CA-9527-99C2-45EB3066E828}"/>
+                <a16:creationId xmlns:a16="http://schemas.microsoft.com/office/drawing/2014/main" id="{EE79527F-5FD2-69EC-ED78-EFE73583C398}"/>
               </a:ext>
             </a:extLst>
           </p:cNvPr>
@@ -580,7 +580,7 @@
           <p:cNvPr id="3" name="세로 텍스트 개체 틀 2">
             <a:extLst>
               <a:ext uri="{FF2B5EF4-FFF2-40B4-BE49-F238E27FC236}">
-                <a16:creationId xmlns:a16="http://schemas.microsoft.com/office/drawing/2014/main" id="{05991F69-5709-D2CF-EC00-8BBD45A088FD}"/>
+                <a16:creationId xmlns:a16="http://schemas.microsoft.com/office/drawing/2014/main" id="{D578FF85-8F42-CA32-6644-8D3BB171375B}"/>
               </a:ext>
             </a:extLst>
           </p:cNvPr>
@@ -642,7 +642,7 @@
           <p:cNvPr id="4" name="날짜 개체 틀 3">
             <a:extLst>
               <a:ext uri="{FF2B5EF4-FFF2-40B4-BE49-F238E27FC236}">
-                <a16:creationId xmlns:a16="http://schemas.microsoft.com/office/drawing/2014/main" id="{F0EC6E46-9C16-3897-69C1-288AE60C6E90}"/>
+                <a16:creationId xmlns:a16="http://schemas.microsoft.com/office/drawing/2014/main" id="{B2BD405B-C81D-6F0A-24E2-896A058E60F5}"/>
               </a:ext>
             </a:extLst>
           </p:cNvPr>
@@ -658,7 +658,7 @@
           <a:bodyPr/>
           <a:lstStyle/>
           <a:p>
-            <a:fld id="{AE899331-733F-4720-83EF-03D552583B79}" type="datetimeFigureOut">
+            <a:fld id="{9742B1B7-23B9-44F4-B08E-E585703C19EC}" type="datetimeFigureOut">
               <a:rPr lang="ko-KR" altLang="en-US" smtClean="0"/>
               <a:t>2026-06-19</a:t>
             </a:fld>
@@ -671,7 +671,7 @@
           <p:cNvPr id="5" name="바닥글 개체 틀 4">
             <a:extLst>
               <a:ext uri="{FF2B5EF4-FFF2-40B4-BE49-F238E27FC236}">
-                <a16:creationId xmlns:a16="http://schemas.microsoft.com/office/drawing/2014/main" id="{38C580E3-E19E-804A-72A8-8D1E1C0BA0E4}"/>
+                <a16:creationId xmlns:a16="http://schemas.microsoft.com/office/drawing/2014/main" id="{0F45C956-BA93-3FAC-1AC4-F0532F1A4F4B}"/>
               </a:ext>
             </a:extLst>
           </p:cNvPr>
@@ -696,7 +696,7 @@
           <p:cNvPr id="6" name="슬라이드 번호 개체 틀 5">
             <a:extLst>
               <a:ext uri="{FF2B5EF4-FFF2-40B4-BE49-F238E27FC236}">
-                <a16:creationId xmlns:a16="http://schemas.microsoft.com/office/drawing/2014/main" id="{5658FE8C-D8A0-BA78-DE46-FB62429E5F70}"/>
+                <a16:creationId xmlns:a16="http://schemas.microsoft.com/office/drawing/2014/main" id="{624B173F-0E31-4B9C-11C9-CBCAFD674AF9}"/>
               </a:ext>
             </a:extLst>
           </p:cNvPr>
@@ -712,7 +712,7 @@
           <a:bodyPr/>
           <a:lstStyle/>
           <a:p>
-            <a:fld id="{324CD06F-1683-4109-A93C-652FD2E4AB1B}" type="slidenum">
+            <a:fld id="{F8562357-FFAC-4DD4-994D-CC30F1B809D6}" type="slidenum">
               <a:rPr lang="ko-KR" altLang="en-US" smtClean="0"/>
               <a:t>‹#›</a:t>
             </a:fld>
@@ -723,7 +723,7 @@
     </p:spTree>
     <p:extLst>
       <p:ext uri="{BB962C8B-B14F-4D97-AF65-F5344CB8AC3E}">
-        <p14:creationId xmlns:p14="http://schemas.microsoft.com/office/powerpoint/2010/main" val="3158140203"/>
+        <p14:creationId xmlns:p14="http://schemas.microsoft.com/office/powerpoint/2010/main" val="777971622"/>
       </p:ext>
     </p:extLst>
   </p:cSld>
@@ -755,7 +755,7 @@
           <p:cNvPr id="2" name="제목 1">
             <a:extLst>
               <a:ext uri="{FF2B5EF4-FFF2-40B4-BE49-F238E27FC236}">
-                <a16:creationId xmlns:a16="http://schemas.microsoft.com/office/drawing/2014/main" id="{D67F814E-5DF2-D079-7502-7B3BB43454F2}"/>
+                <a16:creationId xmlns:a16="http://schemas.microsoft.com/office/drawing/2014/main" id="{E7A5E432-E74B-0C96-778C-28CFA27235BE}"/>
               </a:ext>
             </a:extLst>
           </p:cNvPr>
@@ -783,7 +783,7 @@
           <p:cNvPr id="3" name="내용 개체 틀 2">
             <a:extLst>
               <a:ext uri="{FF2B5EF4-FFF2-40B4-BE49-F238E27FC236}">
-                <a16:creationId xmlns:a16="http://schemas.microsoft.com/office/drawing/2014/main" id="{D976D1A1-9891-04EA-A42E-5915F0570142}"/>
+                <a16:creationId xmlns:a16="http://schemas.microsoft.com/office/drawing/2014/main" id="{78769D69-F0D8-42A2-3B43-E66DDEE0E82B}"/>
               </a:ext>
             </a:extLst>
           </p:cNvPr>
@@ -840,7 +840,7 @@
           <p:cNvPr id="4" name="날짜 개체 틀 3">
             <a:extLst>
               <a:ext uri="{FF2B5EF4-FFF2-40B4-BE49-F238E27FC236}">
-                <a16:creationId xmlns:a16="http://schemas.microsoft.com/office/drawing/2014/main" id="{2A5C772C-C64B-E225-D9D6-B6B80D93741D}"/>
+                <a16:creationId xmlns:a16="http://schemas.microsoft.com/office/drawing/2014/main" id="{0F85E5AE-66AC-7083-1BCE-B8B532E8C91D}"/>
               </a:ext>
             </a:extLst>
           </p:cNvPr>
@@ -856,7 +856,7 @@
           <a:bodyPr/>
           <a:lstStyle/>
           <a:p>
-            <a:fld id="{AE899331-733F-4720-83EF-03D552583B79}" type="datetimeFigureOut">
+            <a:fld id="{9742B1B7-23B9-44F4-B08E-E585703C19EC}" type="datetimeFigureOut">
               <a:rPr lang="ko-KR" altLang="en-US" smtClean="0"/>
               <a:t>2026-06-19</a:t>
             </a:fld>
@@ -869,7 +869,7 @@
           <p:cNvPr id="5" name="바닥글 개체 틀 4">
             <a:extLst>
               <a:ext uri="{FF2B5EF4-FFF2-40B4-BE49-F238E27FC236}">
-                <a16:creationId xmlns:a16="http://schemas.microsoft.com/office/drawing/2014/main" id="{6489A7D8-8103-DC34-9507-EA2B5B47487C}"/>
+                <a16:creationId xmlns:a16="http://schemas.microsoft.com/office/drawing/2014/main" id="{98C314FF-9589-F8EE-B927-4762E12128AF}"/>
               </a:ext>
             </a:extLst>
           </p:cNvPr>
@@ -894,7 +894,7 @@
           <p:cNvPr id="6" name="슬라이드 번호 개체 틀 5">
             <a:extLst>
               <a:ext uri="{FF2B5EF4-FFF2-40B4-BE49-F238E27FC236}">
-                <a16:creationId xmlns:a16="http://schemas.microsoft.com/office/drawing/2014/main" id="{1C9C43C1-5D03-1C72-15ED-87A12568001F}"/>
+                <a16:creationId xmlns:a16="http://schemas.microsoft.com/office/drawing/2014/main" id="{12684494-2FC0-AA45-82BF-D7711A3FC49E}"/>
               </a:ext>
             </a:extLst>
           </p:cNvPr>
@@ -910,7 +910,7 @@
           <a:bodyPr/>
           <a:lstStyle/>
           <a:p>
-            <a:fld id="{324CD06F-1683-4109-A93C-652FD2E4AB1B}" type="slidenum">
+            <a:fld id="{F8562357-FFAC-4DD4-994D-CC30F1B809D6}" type="slidenum">
               <a:rPr lang="ko-KR" altLang="en-US" smtClean="0"/>
               <a:t>‹#›</a:t>
             </a:fld>
@@ -921,7 +921,7 @@
     </p:spTree>
     <p:extLst>
       <p:ext uri="{BB962C8B-B14F-4D97-AF65-F5344CB8AC3E}">
-        <p14:creationId xmlns:p14="http://schemas.microsoft.com/office/powerpoint/2010/main" val="1702649277"/>
+        <p14:creationId xmlns:p14="http://schemas.microsoft.com/office/powerpoint/2010/main" val="3758428053"/>
       </p:ext>
     </p:extLst>
   </p:cSld>
@@ -953,7 +953,7 @@
           <p:cNvPr id="2" name="제목 1">
             <a:extLst>
               <a:ext uri="{FF2B5EF4-FFF2-40B4-BE49-F238E27FC236}">
-                <a16:creationId xmlns:a16="http://schemas.microsoft.com/office/drawing/2014/main" id="{C8D80257-FCC0-5111-90F0-1371AEEC5800}"/>
+                <a16:creationId xmlns:a16="http://schemas.microsoft.com/office/drawing/2014/main" id="{4C151E88-D741-A76C-04D4-859699A5B691}"/>
               </a:ext>
             </a:extLst>
           </p:cNvPr>
@@ -990,7 +990,7 @@
           <p:cNvPr id="3" name="텍스트 개체 틀 2">
             <a:extLst>
               <a:ext uri="{FF2B5EF4-FFF2-40B4-BE49-F238E27FC236}">
-                <a16:creationId xmlns:a16="http://schemas.microsoft.com/office/drawing/2014/main" id="{4EA88015-85C9-2E6D-BB92-19C6C72D8AAE}"/>
+                <a16:creationId xmlns:a16="http://schemas.microsoft.com/office/drawing/2014/main" id="{B724D6F2-28DE-1FF1-5ED1-FD2E97521600}"/>
               </a:ext>
             </a:extLst>
           </p:cNvPr>
@@ -1115,7 +1115,7 @@
           <p:cNvPr id="4" name="날짜 개체 틀 3">
             <a:extLst>
               <a:ext uri="{FF2B5EF4-FFF2-40B4-BE49-F238E27FC236}">
-                <a16:creationId xmlns:a16="http://schemas.microsoft.com/office/drawing/2014/main" id="{4300F17C-4548-C17A-05A0-1941636D90F2}"/>
+                <a16:creationId xmlns:a16="http://schemas.microsoft.com/office/drawing/2014/main" id="{CCCFDA43-F709-5FF8-0B77-93444CACC528}"/>
               </a:ext>
             </a:extLst>
           </p:cNvPr>
@@ -1131,7 +1131,7 @@
           <a:bodyPr/>
           <a:lstStyle/>
           <a:p>
-            <a:fld id="{AE899331-733F-4720-83EF-03D552583B79}" type="datetimeFigureOut">
+            <a:fld id="{9742B1B7-23B9-44F4-B08E-E585703C19EC}" type="datetimeFigureOut">
               <a:rPr lang="ko-KR" altLang="en-US" smtClean="0"/>
               <a:t>2026-06-19</a:t>
             </a:fld>
@@ -1144,7 +1144,7 @@
           <p:cNvPr id="5" name="바닥글 개체 틀 4">
             <a:extLst>
               <a:ext uri="{FF2B5EF4-FFF2-40B4-BE49-F238E27FC236}">
-                <a16:creationId xmlns:a16="http://schemas.microsoft.com/office/drawing/2014/main" id="{331F8EAD-20FC-79C8-4B4E-8915D14C7BB9}"/>
+                <a16:creationId xmlns:a16="http://schemas.microsoft.com/office/drawing/2014/main" id="{D477244E-DEFB-43B2-DA46-EC3ADCBF96F5}"/>
               </a:ext>
             </a:extLst>
           </p:cNvPr>
@@ -1169,7 +1169,7 @@
           <p:cNvPr id="6" name="슬라이드 번호 개체 틀 5">
             <a:extLst>
               <a:ext uri="{FF2B5EF4-FFF2-40B4-BE49-F238E27FC236}">
-                <a16:creationId xmlns:a16="http://schemas.microsoft.com/office/drawing/2014/main" id="{552683B2-A516-0677-D09A-7F09E38FA84F}"/>
+                <a16:creationId xmlns:a16="http://schemas.microsoft.com/office/drawing/2014/main" id="{1EBE132F-0A18-C94D-314C-4F71C6E3F6FC}"/>
               </a:ext>
             </a:extLst>
           </p:cNvPr>
@@ -1185,7 +1185,7 @@
           <a:bodyPr/>
           <a:lstStyle/>
           <a:p>
-            <a:fld id="{324CD06F-1683-4109-A93C-652FD2E4AB1B}" type="slidenum">
+            <a:fld id="{F8562357-FFAC-4DD4-994D-CC30F1B809D6}" type="slidenum">
               <a:rPr lang="ko-KR" altLang="en-US" smtClean="0"/>
               <a:t>‹#›</a:t>
             </a:fld>
@@ -1196,7 +1196,7 @@
     </p:spTree>
     <p:extLst>
       <p:ext uri="{BB962C8B-B14F-4D97-AF65-F5344CB8AC3E}">
-        <p14:creationId xmlns:p14="http://schemas.microsoft.com/office/powerpoint/2010/main" val="323762870"/>
+        <p14:creationId xmlns:p14="http://schemas.microsoft.com/office/powerpoint/2010/main" val="1024824775"/>
       </p:ext>
     </p:extLst>
   </p:cSld>
@@ -1228,7 +1228,7 @@
           <p:cNvPr id="2" name="제목 1">
             <a:extLst>
               <a:ext uri="{FF2B5EF4-FFF2-40B4-BE49-F238E27FC236}">
-                <a16:creationId xmlns:a16="http://schemas.microsoft.com/office/drawing/2014/main" id="{551FB27F-515D-7E70-35F9-09CE63C97C89}"/>
+                <a16:creationId xmlns:a16="http://schemas.microsoft.com/office/drawing/2014/main" id="{CB49C830-D1C4-0AB2-1EEA-BEF364A8C54D}"/>
               </a:ext>
             </a:extLst>
           </p:cNvPr>
@@ -1256,7 +1256,7 @@
           <p:cNvPr id="3" name="내용 개체 틀 2">
             <a:extLst>
               <a:ext uri="{FF2B5EF4-FFF2-40B4-BE49-F238E27FC236}">
-                <a16:creationId xmlns:a16="http://schemas.microsoft.com/office/drawing/2014/main" id="{E9C35DAE-9A3D-CC84-C010-1F370701BDB8}"/>
+                <a16:creationId xmlns:a16="http://schemas.microsoft.com/office/drawing/2014/main" id="{EF7D38B1-2714-72D1-D2C8-F0B1398BB16C}"/>
               </a:ext>
             </a:extLst>
           </p:cNvPr>
@@ -1318,7 +1318,7 @@
           <p:cNvPr id="4" name="내용 개체 틀 3">
             <a:extLst>
               <a:ext uri="{FF2B5EF4-FFF2-40B4-BE49-F238E27FC236}">
-                <a16:creationId xmlns:a16="http://schemas.microsoft.com/office/drawing/2014/main" id="{766E1158-3336-8F9E-B720-135A54F0C170}"/>
+                <a16:creationId xmlns:a16="http://schemas.microsoft.com/office/drawing/2014/main" id="{345B48F3-9D7A-4EF1-54F8-F0497468CF58}"/>
               </a:ext>
             </a:extLst>
           </p:cNvPr>
@@ -1380,7 +1380,7 @@
           <p:cNvPr id="5" name="날짜 개체 틀 4">
             <a:extLst>
               <a:ext uri="{FF2B5EF4-FFF2-40B4-BE49-F238E27FC236}">
-                <a16:creationId xmlns:a16="http://schemas.microsoft.com/office/drawing/2014/main" id="{CF9E4E7B-2D9A-3BD8-D46B-B2E5D4468935}"/>
+                <a16:creationId xmlns:a16="http://schemas.microsoft.com/office/drawing/2014/main" id="{9866C2AD-4F91-E695-14FE-E504124856D9}"/>
               </a:ext>
             </a:extLst>
           </p:cNvPr>
@@ -1396,7 +1396,7 @@
           <a:bodyPr/>
           <a:lstStyle/>
           <a:p>
-            <a:fld id="{AE899331-733F-4720-83EF-03D552583B79}" type="datetimeFigureOut">
+            <a:fld id="{9742B1B7-23B9-44F4-B08E-E585703C19EC}" type="datetimeFigureOut">
               <a:rPr lang="ko-KR" altLang="en-US" smtClean="0"/>
               <a:t>2026-06-19</a:t>
             </a:fld>
@@ -1409,7 +1409,7 @@
           <p:cNvPr id="6" name="바닥글 개체 틀 5">
             <a:extLst>
               <a:ext uri="{FF2B5EF4-FFF2-40B4-BE49-F238E27FC236}">
-                <a16:creationId xmlns:a16="http://schemas.microsoft.com/office/drawing/2014/main" id="{B74EB3EC-FC92-B07F-CB3D-E33D9011EAAE}"/>
+                <a16:creationId xmlns:a16="http://schemas.microsoft.com/office/drawing/2014/main" id="{C2D4C5AD-F5C2-ABA2-F8B2-5347351C554D}"/>
               </a:ext>
             </a:extLst>
           </p:cNvPr>
@@ -1434,7 +1434,7 @@
           <p:cNvPr id="7" name="슬라이드 번호 개체 틀 6">
             <a:extLst>
               <a:ext uri="{FF2B5EF4-FFF2-40B4-BE49-F238E27FC236}">
-                <a16:creationId xmlns:a16="http://schemas.microsoft.com/office/drawing/2014/main" id="{3F205210-7C7E-3E97-CF42-6087A5BE76B8}"/>
+                <a16:creationId xmlns:a16="http://schemas.microsoft.com/office/drawing/2014/main" id="{2B38C58A-D221-45E6-EB67-1D55B4DBE0AD}"/>
               </a:ext>
             </a:extLst>
           </p:cNvPr>
@@ -1450,7 +1450,7 @@
           <a:bodyPr/>
           <a:lstStyle/>
           <a:p>
-            <a:fld id="{324CD06F-1683-4109-A93C-652FD2E4AB1B}" type="slidenum">
+            <a:fld id="{F8562357-FFAC-4DD4-994D-CC30F1B809D6}" type="slidenum">
               <a:rPr lang="ko-KR" altLang="en-US" smtClean="0"/>
               <a:t>‹#›</a:t>
             </a:fld>
@@ -1461,7 +1461,7 @@
     </p:spTree>
     <p:extLst>
       <p:ext uri="{BB962C8B-B14F-4D97-AF65-F5344CB8AC3E}">
-        <p14:creationId xmlns:p14="http://schemas.microsoft.com/office/powerpoint/2010/main" val="1957252489"/>
+        <p14:creationId xmlns:p14="http://schemas.microsoft.com/office/powerpoint/2010/main" val="630499528"/>
       </p:ext>
     </p:extLst>
   </p:cSld>
@@ -1493,7 +1493,7 @@
           <p:cNvPr id="2" name="제목 1">
             <a:extLst>
               <a:ext uri="{FF2B5EF4-FFF2-40B4-BE49-F238E27FC236}">
-                <a16:creationId xmlns:a16="http://schemas.microsoft.com/office/drawing/2014/main" id="{1FE921BF-99B1-41E2-722C-4926E524D564}"/>
+                <a16:creationId xmlns:a16="http://schemas.microsoft.com/office/drawing/2014/main" id="{E5A214BD-7ACC-C297-F6DF-55FB4637F074}"/>
               </a:ext>
             </a:extLst>
           </p:cNvPr>
@@ -1526,7 +1526,7 @@
           <p:cNvPr id="3" name="텍스트 개체 틀 2">
             <a:extLst>
               <a:ext uri="{FF2B5EF4-FFF2-40B4-BE49-F238E27FC236}">
-                <a16:creationId xmlns:a16="http://schemas.microsoft.com/office/drawing/2014/main" id="{67E0AFE5-BAB4-4A2A-5598-4B5FD0D212A6}"/>
+                <a16:creationId xmlns:a16="http://schemas.microsoft.com/office/drawing/2014/main" id="{CF55C0F8-7A73-0E6E-19CE-04D41C5D38CD}"/>
               </a:ext>
             </a:extLst>
           </p:cNvPr>
@@ -1597,7 +1597,7 @@
           <p:cNvPr id="4" name="내용 개체 틀 3">
             <a:extLst>
               <a:ext uri="{FF2B5EF4-FFF2-40B4-BE49-F238E27FC236}">
-                <a16:creationId xmlns:a16="http://schemas.microsoft.com/office/drawing/2014/main" id="{4923D3CF-D967-D318-CA7B-6114076BE564}"/>
+                <a16:creationId xmlns:a16="http://schemas.microsoft.com/office/drawing/2014/main" id="{7FFAA6DD-AC30-11F4-17FD-13DC5FBE1108}"/>
               </a:ext>
             </a:extLst>
           </p:cNvPr>
@@ -1659,7 +1659,7 @@
           <p:cNvPr id="5" name="텍스트 개체 틀 4">
             <a:extLst>
               <a:ext uri="{FF2B5EF4-FFF2-40B4-BE49-F238E27FC236}">
-                <a16:creationId xmlns:a16="http://schemas.microsoft.com/office/drawing/2014/main" id="{22889564-9F29-DD86-6656-52FAD7F70170}"/>
+                <a16:creationId xmlns:a16="http://schemas.microsoft.com/office/drawing/2014/main" id="{CD7DA009-2D41-55AC-FB9A-4EC752CD5995}"/>
               </a:ext>
             </a:extLst>
           </p:cNvPr>
@@ -1730,7 +1730,7 @@
           <p:cNvPr id="6" name="내용 개체 틀 5">
             <a:extLst>
               <a:ext uri="{FF2B5EF4-FFF2-40B4-BE49-F238E27FC236}">
-                <a16:creationId xmlns:a16="http://schemas.microsoft.com/office/drawing/2014/main" id="{2743AB72-1B46-FF86-29A7-48BB649C87F2}"/>
+                <a16:creationId xmlns:a16="http://schemas.microsoft.com/office/drawing/2014/main" id="{599CBEA8-3F26-84BF-0C2B-E2B4100C7687}"/>
               </a:ext>
             </a:extLst>
           </p:cNvPr>
@@ -1792,7 +1792,7 @@
           <p:cNvPr id="7" name="날짜 개체 틀 6">
             <a:extLst>
               <a:ext uri="{FF2B5EF4-FFF2-40B4-BE49-F238E27FC236}">
-                <a16:creationId xmlns:a16="http://schemas.microsoft.com/office/drawing/2014/main" id="{5E3BA9D9-48F6-DDF9-C9F4-B16EA125100B}"/>
+                <a16:creationId xmlns:a16="http://schemas.microsoft.com/office/drawing/2014/main" id="{8D5800D1-7D95-FA73-7B75-4DB7B1C274A3}"/>
               </a:ext>
             </a:extLst>
           </p:cNvPr>
@@ -1808,7 +1808,7 @@
           <a:bodyPr/>
           <a:lstStyle/>
           <a:p>
-            <a:fld id="{AE899331-733F-4720-83EF-03D552583B79}" type="datetimeFigureOut">
+            <a:fld id="{9742B1B7-23B9-44F4-B08E-E585703C19EC}" type="datetimeFigureOut">
               <a:rPr lang="ko-KR" altLang="en-US" smtClean="0"/>
               <a:t>2026-06-19</a:t>
             </a:fld>
@@ -1821,7 +1821,7 @@
           <p:cNvPr id="8" name="바닥글 개체 틀 7">
             <a:extLst>
               <a:ext uri="{FF2B5EF4-FFF2-40B4-BE49-F238E27FC236}">
-                <a16:creationId xmlns:a16="http://schemas.microsoft.com/office/drawing/2014/main" id="{AB624BD7-187A-660B-276F-439CEB859CA0}"/>
+                <a16:creationId xmlns:a16="http://schemas.microsoft.com/office/drawing/2014/main" id="{D85A0AF6-0799-D5C4-B70F-74502F4A2EB8}"/>
               </a:ext>
             </a:extLst>
           </p:cNvPr>
@@ -1846,7 +1846,7 @@
           <p:cNvPr id="9" name="슬라이드 번호 개체 틀 8">
             <a:extLst>
               <a:ext uri="{FF2B5EF4-FFF2-40B4-BE49-F238E27FC236}">
-                <a16:creationId xmlns:a16="http://schemas.microsoft.com/office/drawing/2014/main" id="{3B482BF7-D4E5-2877-5325-DF7AEE269527}"/>
+                <a16:creationId xmlns:a16="http://schemas.microsoft.com/office/drawing/2014/main" id="{0C8AC03B-394D-3253-0E80-DBE3269CC4C2}"/>
               </a:ext>
             </a:extLst>
           </p:cNvPr>
@@ -1862,7 +1862,7 @@
           <a:bodyPr/>
           <a:lstStyle/>
           <a:p>
-            <a:fld id="{324CD06F-1683-4109-A93C-652FD2E4AB1B}" type="slidenum">
+            <a:fld id="{F8562357-FFAC-4DD4-994D-CC30F1B809D6}" type="slidenum">
               <a:rPr lang="ko-KR" altLang="en-US" smtClean="0"/>
               <a:t>‹#›</a:t>
             </a:fld>
@@ -1873,7 +1873,7 @@
     </p:spTree>
     <p:extLst>
       <p:ext uri="{BB962C8B-B14F-4D97-AF65-F5344CB8AC3E}">
-        <p14:creationId xmlns:p14="http://schemas.microsoft.com/office/powerpoint/2010/main" val="3233019883"/>
+        <p14:creationId xmlns:p14="http://schemas.microsoft.com/office/powerpoint/2010/main" val="1287031164"/>
       </p:ext>
     </p:extLst>
   </p:cSld>
@@ -1905,7 +1905,7 @@
           <p:cNvPr id="2" name="제목 1">
             <a:extLst>
               <a:ext uri="{FF2B5EF4-FFF2-40B4-BE49-F238E27FC236}">
-                <a16:creationId xmlns:a16="http://schemas.microsoft.com/office/drawing/2014/main" id="{C2D54FAD-8D09-3A7D-4380-A2A0C5BFDB0C}"/>
+                <a16:creationId xmlns:a16="http://schemas.microsoft.com/office/drawing/2014/main" id="{590ADCFA-E665-0CC1-500B-EE38C73A3080}"/>
               </a:ext>
             </a:extLst>
           </p:cNvPr>
@@ -1933,7 +1933,7 @@
           <p:cNvPr id="3" name="날짜 개체 틀 2">
             <a:extLst>
               <a:ext uri="{FF2B5EF4-FFF2-40B4-BE49-F238E27FC236}">
-                <a16:creationId xmlns:a16="http://schemas.microsoft.com/office/drawing/2014/main" id="{AA0717EB-7173-6567-C422-8403022E345B}"/>
+                <a16:creationId xmlns:a16="http://schemas.microsoft.com/office/drawing/2014/main" id="{DF63594C-88F6-AB67-CEC1-7730621B4419}"/>
               </a:ext>
             </a:extLst>
           </p:cNvPr>
@@ -1949,7 +1949,7 @@
           <a:bodyPr/>
           <a:lstStyle/>
           <a:p>
-            <a:fld id="{AE899331-733F-4720-83EF-03D552583B79}" type="datetimeFigureOut">
+            <a:fld id="{9742B1B7-23B9-44F4-B08E-E585703C19EC}" type="datetimeFigureOut">
               <a:rPr lang="ko-KR" altLang="en-US" smtClean="0"/>
               <a:t>2026-06-19</a:t>
             </a:fld>
@@ -1962,7 +1962,7 @@
           <p:cNvPr id="4" name="바닥글 개체 틀 3">
             <a:extLst>
               <a:ext uri="{FF2B5EF4-FFF2-40B4-BE49-F238E27FC236}">
-                <a16:creationId xmlns:a16="http://schemas.microsoft.com/office/drawing/2014/main" id="{AADD5942-004E-3A5C-A661-FCB8FE82CAE2}"/>
+                <a16:creationId xmlns:a16="http://schemas.microsoft.com/office/drawing/2014/main" id="{93A2F1E7-780F-C6A4-059D-F0CFFDE76AEF}"/>
               </a:ext>
             </a:extLst>
           </p:cNvPr>
@@ -1987,7 +1987,7 @@
           <p:cNvPr id="5" name="슬라이드 번호 개체 틀 4">
             <a:extLst>
               <a:ext uri="{FF2B5EF4-FFF2-40B4-BE49-F238E27FC236}">
-                <a16:creationId xmlns:a16="http://schemas.microsoft.com/office/drawing/2014/main" id="{9C2DFE50-B55F-2E5A-D241-87E012C79F36}"/>
+                <a16:creationId xmlns:a16="http://schemas.microsoft.com/office/drawing/2014/main" id="{A63A23AF-3690-562B-7D20-2FCD6A11A32B}"/>
               </a:ext>
             </a:extLst>
           </p:cNvPr>
@@ -2003,7 +2003,7 @@
           <a:bodyPr/>
           <a:lstStyle/>
           <a:p>
-            <a:fld id="{324CD06F-1683-4109-A93C-652FD2E4AB1B}" type="slidenum">
+            <a:fld id="{F8562357-FFAC-4DD4-994D-CC30F1B809D6}" type="slidenum">
               <a:rPr lang="ko-KR" altLang="en-US" smtClean="0"/>
               <a:t>‹#›</a:t>
             </a:fld>
@@ -2014,7 +2014,7 @@
     </p:spTree>
     <p:extLst>
       <p:ext uri="{BB962C8B-B14F-4D97-AF65-F5344CB8AC3E}">
-        <p14:creationId xmlns:p14="http://schemas.microsoft.com/office/powerpoint/2010/main" val="2630176028"/>
+        <p14:creationId xmlns:p14="http://schemas.microsoft.com/office/powerpoint/2010/main" val="2901779742"/>
       </p:ext>
     </p:extLst>
   </p:cSld>
@@ -2046,7 +2046,7 @@
           <p:cNvPr id="2" name="날짜 개체 틀 1">
             <a:extLst>
               <a:ext uri="{FF2B5EF4-FFF2-40B4-BE49-F238E27FC236}">
-                <a16:creationId xmlns:a16="http://schemas.microsoft.com/office/drawing/2014/main" id="{FA1BA1FD-7DF8-A8A2-A8DA-25072132AA92}"/>
+                <a16:creationId xmlns:a16="http://schemas.microsoft.com/office/drawing/2014/main" id="{28C19200-BCF6-E873-156C-4F0A56FED23E}"/>
               </a:ext>
             </a:extLst>
           </p:cNvPr>
@@ -2062,7 +2062,7 @@
           <a:bodyPr/>
           <a:lstStyle/>
           <a:p>
-            <a:fld id="{AE899331-733F-4720-83EF-03D552583B79}" type="datetimeFigureOut">
+            <a:fld id="{9742B1B7-23B9-44F4-B08E-E585703C19EC}" type="datetimeFigureOut">
               <a:rPr lang="ko-KR" altLang="en-US" smtClean="0"/>
               <a:t>2026-06-19</a:t>
             </a:fld>
@@ -2075,7 +2075,7 @@
           <p:cNvPr id="3" name="바닥글 개체 틀 2">
             <a:extLst>
               <a:ext uri="{FF2B5EF4-FFF2-40B4-BE49-F238E27FC236}">
-                <a16:creationId xmlns:a16="http://schemas.microsoft.com/office/drawing/2014/main" id="{7B357A76-DFC0-B51D-19E8-0BE20B6D8410}"/>
+                <a16:creationId xmlns:a16="http://schemas.microsoft.com/office/drawing/2014/main" id="{FD74C4A3-7638-5FF2-3094-79EFF169921D}"/>
               </a:ext>
             </a:extLst>
           </p:cNvPr>
@@ -2100,7 +2100,7 @@
           <p:cNvPr id="4" name="슬라이드 번호 개체 틀 3">
             <a:extLst>
               <a:ext uri="{FF2B5EF4-FFF2-40B4-BE49-F238E27FC236}">
-                <a16:creationId xmlns:a16="http://schemas.microsoft.com/office/drawing/2014/main" id="{334495BE-2ADA-F904-9AE6-2F282667ADC2}"/>
+                <a16:creationId xmlns:a16="http://schemas.microsoft.com/office/drawing/2014/main" id="{9612F57F-1198-1BF4-9E7F-1699E90B748E}"/>
               </a:ext>
             </a:extLst>
           </p:cNvPr>
@@ -2116,7 +2116,7 @@
           <a:bodyPr/>
           <a:lstStyle/>
           <a:p>
-            <a:fld id="{324CD06F-1683-4109-A93C-652FD2E4AB1B}" type="slidenum">
+            <a:fld id="{F8562357-FFAC-4DD4-994D-CC30F1B809D6}" type="slidenum">
               <a:rPr lang="ko-KR" altLang="en-US" smtClean="0"/>
               <a:t>‹#›</a:t>
             </a:fld>
@@ -2127,7 +2127,7 @@
     </p:spTree>
     <p:extLst>
       <p:ext uri="{BB962C8B-B14F-4D97-AF65-F5344CB8AC3E}">
-        <p14:creationId xmlns:p14="http://schemas.microsoft.com/office/powerpoint/2010/main" val="519552188"/>
+        <p14:creationId xmlns:p14="http://schemas.microsoft.com/office/powerpoint/2010/main" val="772918046"/>
       </p:ext>
     </p:extLst>
   </p:cSld>
@@ -2159,7 +2159,7 @@
           <p:cNvPr id="2" name="제목 1">
             <a:extLst>
               <a:ext uri="{FF2B5EF4-FFF2-40B4-BE49-F238E27FC236}">
-                <a16:creationId xmlns:a16="http://schemas.microsoft.com/office/drawing/2014/main" id="{717C8BD2-8FA3-7585-96DD-569FC27A3302}"/>
+                <a16:creationId xmlns:a16="http://schemas.microsoft.com/office/drawing/2014/main" id="{33DEDD95-0706-DA22-8CE6-12C590E57B65}"/>
               </a:ext>
             </a:extLst>
           </p:cNvPr>
@@ -2196,7 +2196,7 @@
           <p:cNvPr id="3" name="내용 개체 틀 2">
             <a:extLst>
               <a:ext uri="{FF2B5EF4-FFF2-40B4-BE49-F238E27FC236}">
-                <a16:creationId xmlns:a16="http://schemas.microsoft.com/office/drawing/2014/main" id="{1712B2CA-F535-8EAE-DD34-8CE671B26018}"/>
+                <a16:creationId xmlns:a16="http://schemas.microsoft.com/office/drawing/2014/main" id="{A9E9CD25-BB88-2FA5-8759-579111D00C93}"/>
               </a:ext>
             </a:extLst>
           </p:cNvPr>
@@ -2286,7 +2286,7 @@
           <p:cNvPr id="4" name="텍스트 개체 틀 3">
             <a:extLst>
               <a:ext uri="{FF2B5EF4-FFF2-40B4-BE49-F238E27FC236}">
-                <a16:creationId xmlns:a16="http://schemas.microsoft.com/office/drawing/2014/main" id="{3531CD9E-8FA2-5927-2A40-027BFAE2CF58}"/>
+                <a16:creationId xmlns:a16="http://schemas.microsoft.com/office/drawing/2014/main" id="{FAC1D064-4954-414C-BB3B-F4C6108DCEB4}"/>
               </a:ext>
             </a:extLst>
           </p:cNvPr>
@@ -2357,7 +2357,7 @@
           <p:cNvPr id="5" name="날짜 개체 틀 4">
             <a:extLst>
               <a:ext uri="{FF2B5EF4-FFF2-40B4-BE49-F238E27FC236}">
-                <a16:creationId xmlns:a16="http://schemas.microsoft.com/office/drawing/2014/main" id="{0DFD9E66-5048-B489-579F-9FCA29F97408}"/>
+                <a16:creationId xmlns:a16="http://schemas.microsoft.com/office/drawing/2014/main" id="{5001E746-1EA4-C54D-E058-984549DF72AC}"/>
               </a:ext>
             </a:extLst>
           </p:cNvPr>
@@ -2373,7 +2373,7 @@
           <a:bodyPr/>
           <a:lstStyle/>
           <a:p>
-            <a:fld id="{AE899331-733F-4720-83EF-03D552583B79}" type="datetimeFigureOut">
+            <a:fld id="{9742B1B7-23B9-44F4-B08E-E585703C19EC}" type="datetimeFigureOut">
               <a:rPr lang="ko-KR" altLang="en-US" smtClean="0"/>
               <a:t>2026-06-19</a:t>
             </a:fld>
@@ -2386,7 +2386,7 @@
           <p:cNvPr id="6" name="바닥글 개체 틀 5">
             <a:extLst>
               <a:ext uri="{FF2B5EF4-FFF2-40B4-BE49-F238E27FC236}">
-                <a16:creationId xmlns:a16="http://schemas.microsoft.com/office/drawing/2014/main" id="{F915BF74-6AA2-2703-0079-9836758C65BE}"/>
+                <a16:creationId xmlns:a16="http://schemas.microsoft.com/office/drawing/2014/main" id="{EA5B53D9-6127-FC21-57AE-899DC9B981C8}"/>
               </a:ext>
             </a:extLst>
           </p:cNvPr>
@@ -2411,7 +2411,7 @@
           <p:cNvPr id="7" name="슬라이드 번호 개체 틀 6">
             <a:extLst>
               <a:ext uri="{FF2B5EF4-FFF2-40B4-BE49-F238E27FC236}">
-                <a16:creationId xmlns:a16="http://schemas.microsoft.com/office/drawing/2014/main" id="{E58662C9-264A-BC69-9778-C05DCAEBBE43}"/>
+                <a16:creationId xmlns:a16="http://schemas.microsoft.com/office/drawing/2014/main" id="{54EF234A-D827-4E68-24D7-9E3FC0FBDA18}"/>
               </a:ext>
             </a:extLst>
           </p:cNvPr>
@@ -2427,7 +2427,7 @@
           <a:bodyPr/>
           <a:lstStyle/>
           <a:p>
-            <a:fld id="{324CD06F-1683-4109-A93C-652FD2E4AB1B}" type="slidenum">
+            <a:fld id="{F8562357-FFAC-4DD4-994D-CC30F1B809D6}" type="slidenum">
               <a:rPr lang="ko-KR" altLang="en-US" smtClean="0"/>
               <a:t>‹#›</a:t>
             </a:fld>
@@ -2438,7 +2438,7 @@
     </p:spTree>
     <p:extLst>
       <p:ext uri="{BB962C8B-B14F-4D97-AF65-F5344CB8AC3E}">
-        <p14:creationId xmlns:p14="http://schemas.microsoft.com/office/powerpoint/2010/main" val="52148405"/>
+        <p14:creationId xmlns:p14="http://schemas.microsoft.com/office/powerpoint/2010/main" val="3902401637"/>
       </p:ext>
     </p:extLst>
   </p:cSld>
@@ -2470,7 +2470,7 @@
           <p:cNvPr id="2" name="제목 1">
             <a:extLst>
               <a:ext uri="{FF2B5EF4-FFF2-40B4-BE49-F238E27FC236}">
-                <a16:creationId xmlns:a16="http://schemas.microsoft.com/office/drawing/2014/main" id="{822A5F1F-F8DA-9B1F-6688-1CA543C22BA6}"/>
+                <a16:creationId xmlns:a16="http://schemas.microsoft.com/office/drawing/2014/main" id="{5E26744A-AFB3-4382-FAD4-6E2FAA00F145}"/>
               </a:ext>
             </a:extLst>
           </p:cNvPr>
@@ -2507,7 +2507,7 @@
           <p:cNvPr id="3" name="그림 개체 틀 2">
             <a:extLst>
               <a:ext uri="{FF2B5EF4-FFF2-40B4-BE49-F238E27FC236}">
-                <a16:creationId xmlns:a16="http://schemas.microsoft.com/office/drawing/2014/main" id="{CF3D078C-C16C-4114-E8A0-3E13FC41EA15}"/>
+                <a16:creationId xmlns:a16="http://schemas.microsoft.com/office/drawing/2014/main" id="{95A93FD3-D4E4-2C51-4994-53AE32FE0947}"/>
               </a:ext>
             </a:extLst>
           </p:cNvPr>
@@ -2574,7 +2574,7 @@
           <p:cNvPr id="4" name="텍스트 개체 틀 3">
             <a:extLst>
               <a:ext uri="{FF2B5EF4-FFF2-40B4-BE49-F238E27FC236}">
-                <a16:creationId xmlns:a16="http://schemas.microsoft.com/office/drawing/2014/main" id="{B8234DB4-FC8A-B964-8DF4-69F8CA420338}"/>
+                <a16:creationId xmlns:a16="http://schemas.microsoft.com/office/drawing/2014/main" id="{BA6DF269-8145-9CC7-CFDB-77802117EA98}"/>
               </a:ext>
             </a:extLst>
           </p:cNvPr>
@@ -2645,7 +2645,7 @@
           <p:cNvPr id="5" name="날짜 개체 틀 4">
             <a:extLst>
               <a:ext uri="{FF2B5EF4-FFF2-40B4-BE49-F238E27FC236}">
-                <a16:creationId xmlns:a16="http://schemas.microsoft.com/office/drawing/2014/main" id="{93F7A6E3-59B3-E1D7-256D-2CA0A7B63E9C}"/>
+                <a16:creationId xmlns:a16="http://schemas.microsoft.com/office/drawing/2014/main" id="{62E19826-D6B0-AD0D-2F42-1AC720ACF85B}"/>
               </a:ext>
             </a:extLst>
           </p:cNvPr>
@@ -2661,7 +2661,7 @@
           <a:bodyPr/>
           <a:lstStyle/>
           <a:p>
-            <a:fld id="{AE899331-733F-4720-83EF-03D552583B79}" type="datetimeFigureOut">
+            <a:fld id="{9742B1B7-23B9-44F4-B08E-E585703C19EC}" type="datetimeFigureOut">
               <a:rPr lang="ko-KR" altLang="en-US" smtClean="0"/>
               <a:t>2026-06-19</a:t>
             </a:fld>
@@ -2674,7 +2674,7 @@
           <p:cNvPr id="6" name="바닥글 개체 틀 5">
             <a:extLst>
               <a:ext uri="{FF2B5EF4-FFF2-40B4-BE49-F238E27FC236}">
-                <a16:creationId xmlns:a16="http://schemas.microsoft.com/office/drawing/2014/main" id="{837D42D8-D8D5-E230-4873-D9A4FC73AC51}"/>
+                <a16:creationId xmlns:a16="http://schemas.microsoft.com/office/drawing/2014/main" id="{91AA7AFD-7712-D7BD-3620-D224C551E3A1}"/>
               </a:ext>
             </a:extLst>
           </p:cNvPr>
@@ -2699,7 +2699,7 @@
           <p:cNvPr id="7" name="슬라이드 번호 개체 틀 6">
             <a:extLst>
               <a:ext uri="{FF2B5EF4-FFF2-40B4-BE49-F238E27FC236}">
-                <a16:creationId xmlns:a16="http://schemas.microsoft.com/office/drawing/2014/main" id="{3A40273D-BD1F-1310-6E8B-0E328978876E}"/>
+                <a16:creationId xmlns:a16="http://schemas.microsoft.com/office/drawing/2014/main" id="{5FADA503-B5CD-3545-2135-27F80DB59BAC}"/>
               </a:ext>
             </a:extLst>
           </p:cNvPr>
@@ -2715,7 +2715,7 @@
           <a:bodyPr/>
           <a:lstStyle/>
           <a:p>
-            <a:fld id="{324CD06F-1683-4109-A93C-652FD2E4AB1B}" type="slidenum">
+            <a:fld id="{F8562357-FFAC-4DD4-994D-CC30F1B809D6}" type="slidenum">
               <a:rPr lang="ko-KR" altLang="en-US" smtClean="0"/>
               <a:t>‹#›</a:t>
             </a:fld>
@@ -2726,7 +2726,7 @@
     </p:spTree>
     <p:extLst>
       <p:ext uri="{BB962C8B-B14F-4D97-AF65-F5344CB8AC3E}">
-        <p14:creationId xmlns:p14="http://schemas.microsoft.com/office/powerpoint/2010/main" val="2553808010"/>
+        <p14:creationId xmlns:p14="http://schemas.microsoft.com/office/powerpoint/2010/main" val="3238473450"/>
       </p:ext>
     </p:extLst>
   </p:cSld>
@@ -2763,7 +2763,7 @@
           <p:cNvPr id="2" name="제목 개체 틀 1">
             <a:extLst>
               <a:ext uri="{FF2B5EF4-FFF2-40B4-BE49-F238E27FC236}">
-                <a16:creationId xmlns:a16="http://schemas.microsoft.com/office/drawing/2014/main" id="{56A6EB8E-0645-3C9A-FCF3-95D234814D42}"/>
+                <a16:creationId xmlns:a16="http://schemas.microsoft.com/office/drawing/2014/main" id="{8F0C6027-A167-F2A0-3ED9-3137EB593E0D}"/>
               </a:ext>
             </a:extLst>
           </p:cNvPr>
@@ -2801,7 +2801,7 @@
           <p:cNvPr id="3" name="텍스트 개체 틀 2">
             <a:extLst>
               <a:ext uri="{FF2B5EF4-FFF2-40B4-BE49-F238E27FC236}">
-                <a16:creationId xmlns:a16="http://schemas.microsoft.com/office/drawing/2014/main" id="{81E84DE3-AB3F-3D48-7FFE-7AFB2A030C76}"/>
+                <a16:creationId xmlns:a16="http://schemas.microsoft.com/office/drawing/2014/main" id="{EFF4C8A0-C1BA-94E5-0F28-58A5E9CF9612}"/>
               </a:ext>
             </a:extLst>
           </p:cNvPr>
@@ -2868,7 +2868,7 @@
           <p:cNvPr id="4" name="날짜 개체 틀 3">
             <a:extLst>
               <a:ext uri="{FF2B5EF4-FFF2-40B4-BE49-F238E27FC236}">
-                <a16:creationId xmlns:a16="http://schemas.microsoft.com/office/drawing/2014/main" id="{116A4DB5-C1A0-378E-655D-E481798E72E4}"/>
+                <a16:creationId xmlns:a16="http://schemas.microsoft.com/office/drawing/2014/main" id="{29BD0D54-8E14-DB6D-F5BA-54DA01DE19EC}"/>
               </a:ext>
             </a:extLst>
           </p:cNvPr>
@@ -2902,7 +2902,7 @@
             </a:lvl1pPr>
           </a:lstStyle>
           <a:p>
-            <a:fld id="{AE899331-733F-4720-83EF-03D552583B79}" type="datetimeFigureOut">
+            <a:fld id="{9742B1B7-23B9-44F4-B08E-E585703C19EC}" type="datetimeFigureOut">
               <a:rPr lang="ko-KR" altLang="en-US" smtClean="0"/>
               <a:t>2026-06-19</a:t>
             </a:fld>
@@ -2915,7 +2915,7 @@
           <p:cNvPr id="5" name="바닥글 개체 틀 4">
             <a:extLst>
               <a:ext uri="{FF2B5EF4-FFF2-40B4-BE49-F238E27FC236}">
-                <a16:creationId xmlns:a16="http://schemas.microsoft.com/office/drawing/2014/main" id="{B716B58A-23BE-CA9F-F05F-993A3281A0BB}"/>
+                <a16:creationId xmlns:a16="http://schemas.microsoft.com/office/drawing/2014/main" id="{7E0DA922-CAD3-7C3B-A23A-069A475B5557}"/>
               </a:ext>
             </a:extLst>
           </p:cNvPr>
@@ -2958,7 +2958,7 @@
           <p:cNvPr id="6" name="슬라이드 번호 개체 틀 5">
             <a:extLst>
               <a:ext uri="{FF2B5EF4-FFF2-40B4-BE49-F238E27FC236}">
-                <a16:creationId xmlns:a16="http://schemas.microsoft.com/office/drawing/2014/main" id="{22D2EAF7-EA93-F172-BD52-1CA5F0C9106E}"/>
+                <a16:creationId xmlns:a16="http://schemas.microsoft.com/office/drawing/2014/main" id="{174328F5-6D2F-8ACC-A635-8970A57EA3BF}"/>
               </a:ext>
             </a:extLst>
           </p:cNvPr>
@@ -2992,7 +2992,7 @@
             </a:lvl1pPr>
           </a:lstStyle>
           <a:p>
-            <a:fld id="{324CD06F-1683-4109-A93C-652FD2E4AB1B}" type="slidenum">
+            <a:fld id="{F8562357-FFAC-4DD4-994D-CC30F1B809D6}" type="slidenum">
               <a:rPr lang="ko-KR" altLang="en-US" smtClean="0"/>
               <a:t>‹#›</a:t>
             </a:fld>
@@ -3003,7 +3003,7 @@
     </p:spTree>
     <p:extLst>
       <p:ext uri="{BB962C8B-B14F-4D97-AF65-F5344CB8AC3E}">
-        <p14:creationId xmlns:p14="http://schemas.microsoft.com/office/powerpoint/2010/main" val="75149600"/>
+        <p14:creationId xmlns:p14="http://schemas.microsoft.com/office/powerpoint/2010/main" val="1013868154"/>
       </p:ext>
     </p:extLst>
   </p:cSld>
@@ -3326,7 +3326,7 @@
           <p:cNvPr id="3" name="pipeline_overview_svg">
             <a:extLst>
               <a:ext uri="{FF2B5EF4-FFF2-40B4-BE49-F238E27FC236}">
-                <a16:creationId xmlns:a16="http://schemas.microsoft.com/office/drawing/2014/main" id="{A59667C2-9A6E-046E-6B16-F4FA265CA058}"/>
+                <a16:creationId xmlns:a16="http://schemas.microsoft.com/office/drawing/2014/main" id="{E2CC43E6-31DD-B9DA-360B-035D0612CF8A}"/>
               </a:ext>
             </a:extLst>
           </p:cNvPr>
@@ -3367,7 +3367,7 @@
     </p:spTree>
     <p:extLst>
       <p:ext uri="{BB962C8B-B14F-4D97-AF65-F5344CB8AC3E}">
-        <p14:creationId xmlns:p14="http://schemas.microsoft.com/office/powerpoint/2010/main" val="993714057"/>
+        <p14:creationId xmlns:p14="http://schemas.microsoft.com/office/powerpoint/2010/main" val="3386420991"/>
       </p:ext>
     </p:extLst>
   </p:cSld>

</xml_diff>

<commit_message>
Enforce coherent pipeline arrow styles
</commit_message>
<xml_diff>
--- a/docs/assets/pipeline-overview.pptx
+++ b/docs/assets/pipeline-overview.pptx
@@ -129,7 +129,7 @@
           <p:cNvPr id="2" name="제목 1">
             <a:extLst>
               <a:ext uri="{FF2B5EF4-FFF2-40B4-BE49-F238E27FC236}">
-                <a16:creationId xmlns:a16="http://schemas.microsoft.com/office/drawing/2014/main" id="{9171FBC1-8257-F8EE-6627-FCF507D96855}"/>
+                <a16:creationId xmlns:a16="http://schemas.microsoft.com/office/drawing/2014/main" id="{DCC1611C-15F7-5F67-DF3B-86B3439FC93B}"/>
               </a:ext>
             </a:extLst>
           </p:cNvPr>
@@ -166,7 +166,7 @@
           <p:cNvPr id="3" name="부제목 2">
             <a:extLst>
               <a:ext uri="{FF2B5EF4-FFF2-40B4-BE49-F238E27FC236}">
-                <a16:creationId xmlns:a16="http://schemas.microsoft.com/office/drawing/2014/main" id="{711C2455-512B-A1E6-1D4A-190AF5EA7BD8}"/>
+                <a16:creationId xmlns:a16="http://schemas.microsoft.com/office/drawing/2014/main" id="{1C8AF413-2A0D-BACF-F7C6-A1EE7900D0C8}"/>
               </a:ext>
             </a:extLst>
           </p:cNvPr>
@@ -236,7 +236,7 @@
           <p:cNvPr id="4" name="날짜 개체 틀 3">
             <a:extLst>
               <a:ext uri="{FF2B5EF4-FFF2-40B4-BE49-F238E27FC236}">
-                <a16:creationId xmlns:a16="http://schemas.microsoft.com/office/drawing/2014/main" id="{1C1400A6-1CF0-8E2F-685A-1F791EAD5DA3}"/>
+                <a16:creationId xmlns:a16="http://schemas.microsoft.com/office/drawing/2014/main" id="{B43BD26B-E762-FC9D-1F8E-9D05BF36452F}"/>
               </a:ext>
             </a:extLst>
           </p:cNvPr>
@@ -252,7 +252,7 @@
           <a:bodyPr/>
           <a:lstStyle/>
           <a:p>
-            <a:fld id="{9742B1B7-23B9-44F4-B08E-E585703C19EC}" type="datetimeFigureOut">
+            <a:fld id="{32E9D3ED-3924-43EC-83E7-C21FD4BF3549}" type="datetimeFigureOut">
               <a:rPr lang="ko-KR" altLang="en-US" smtClean="0"/>
               <a:t>2026-06-19</a:t>
             </a:fld>
@@ -265,7 +265,7 @@
           <p:cNvPr id="5" name="바닥글 개체 틀 4">
             <a:extLst>
               <a:ext uri="{FF2B5EF4-FFF2-40B4-BE49-F238E27FC236}">
-                <a16:creationId xmlns:a16="http://schemas.microsoft.com/office/drawing/2014/main" id="{E9B50CD2-D7AC-9DEB-F70B-17A5C49B8E72}"/>
+                <a16:creationId xmlns:a16="http://schemas.microsoft.com/office/drawing/2014/main" id="{83591421-6C87-C67F-ACA8-FC0EC9C9A8D6}"/>
               </a:ext>
             </a:extLst>
           </p:cNvPr>
@@ -290,7 +290,7 @@
           <p:cNvPr id="6" name="슬라이드 번호 개체 틀 5">
             <a:extLst>
               <a:ext uri="{FF2B5EF4-FFF2-40B4-BE49-F238E27FC236}">
-                <a16:creationId xmlns:a16="http://schemas.microsoft.com/office/drawing/2014/main" id="{5B07612A-6C59-A760-F154-65B752D96C7C}"/>
+                <a16:creationId xmlns:a16="http://schemas.microsoft.com/office/drawing/2014/main" id="{CCC9ACC8-27BA-4C86-A020-D441F460B1CC}"/>
               </a:ext>
             </a:extLst>
           </p:cNvPr>
@@ -306,7 +306,7 @@
           <a:bodyPr/>
           <a:lstStyle/>
           <a:p>
-            <a:fld id="{F8562357-FFAC-4DD4-994D-CC30F1B809D6}" type="slidenum">
+            <a:fld id="{B2A52879-9975-4A1A-B0EB-44F71CED55F9}" type="slidenum">
               <a:rPr lang="ko-KR" altLang="en-US" smtClean="0"/>
               <a:t>‹#›</a:t>
             </a:fld>
@@ -317,7 +317,7 @@
     </p:spTree>
     <p:extLst>
       <p:ext uri="{BB962C8B-B14F-4D97-AF65-F5344CB8AC3E}">
-        <p14:creationId xmlns:p14="http://schemas.microsoft.com/office/powerpoint/2010/main" val="897659318"/>
+        <p14:creationId xmlns:p14="http://schemas.microsoft.com/office/powerpoint/2010/main" val="3168411531"/>
       </p:ext>
     </p:extLst>
   </p:cSld>
@@ -349,7 +349,7 @@
           <p:cNvPr id="2" name="제목 1">
             <a:extLst>
               <a:ext uri="{FF2B5EF4-FFF2-40B4-BE49-F238E27FC236}">
-                <a16:creationId xmlns:a16="http://schemas.microsoft.com/office/drawing/2014/main" id="{85B22CA5-D057-04D7-875F-5696DEA0ABDF}"/>
+                <a16:creationId xmlns:a16="http://schemas.microsoft.com/office/drawing/2014/main" id="{25067D16-905F-FDC1-652A-EE097BFE1D3A}"/>
               </a:ext>
             </a:extLst>
           </p:cNvPr>
@@ -377,7 +377,7 @@
           <p:cNvPr id="3" name="세로 텍스트 개체 틀 2">
             <a:extLst>
               <a:ext uri="{FF2B5EF4-FFF2-40B4-BE49-F238E27FC236}">
-                <a16:creationId xmlns:a16="http://schemas.microsoft.com/office/drawing/2014/main" id="{146FD2AB-5735-06C5-4A3A-CDBEF9218DB3}"/>
+                <a16:creationId xmlns:a16="http://schemas.microsoft.com/office/drawing/2014/main" id="{3B3059AA-0394-95AE-9517-BA58706D46FF}"/>
               </a:ext>
             </a:extLst>
           </p:cNvPr>
@@ -434,7 +434,7 @@
           <p:cNvPr id="4" name="날짜 개체 틀 3">
             <a:extLst>
               <a:ext uri="{FF2B5EF4-FFF2-40B4-BE49-F238E27FC236}">
-                <a16:creationId xmlns:a16="http://schemas.microsoft.com/office/drawing/2014/main" id="{CBE03DFC-38FC-CDFA-9B02-C9FBF9C90B8F}"/>
+                <a16:creationId xmlns:a16="http://schemas.microsoft.com/office/drawing/2014/main" id="{2240A1A1-957A-EF9C-B3B0-97E3FDB0E05F}"/>
               </a:ext>
             </a:extLst>
           </p:cNvPr>
@@ -450,7 +450,7 @@
           <a:bodyPr/>
           <a:lstStyle/>
           <a:p>
-            <a:fld id="{9742B1B7-23B9-44F4-B08E-E585703C19EC}" type="datetimeFigureOut">
+            <a:fld id="{32E9D3ED-3924-43EC-83E7-C21FD4BF3549}" type="datetimeFigureOut">
               <a:rPr lang="ko-KR" altLang="en-US" smtClean="0"/>
               <a:t>2026-06-19</a:t>
             </a:fld>
@@ -463,7 +463,7 @@
           <p:cNvPr id="5" name="바닥글 개체 틀 4">
             <a:extLst>
               <a:ext uri="{FF2B5EF4-FFF2-40B4-BE49-F238E27FC236}">
-                <a16:creationId xmlns:a16="http://schemas.microsoft.com/office/drawing/2014/main" id="{828E767B-6A41-FC82-3D42-C3655964C8F7}"/>
+                <a16:creationId xmlns:a16="http://schemas.microsoft.com/office/drawing/2014/main" id="{F31107C1-6E63-9F8F-A6F9-0CB77ECBB1AF}"/>
               </a:ext>
             </a:extLst>
           </p:cNvPr>
@@ -488,7 +488,7 @@
           <p:cNvPr id="6" name="슬라이드 번호 개체 틀 5">
             <a:extLst>
               <a:ext uri="{FF2B5EF4-FFF2-40B4-BE49-F238E27FC236}">
-                <a16:creationId xmlns:a16="http://schemas.microsoft.com/office/drawing/2014/main" id="{280581F7-4640-E411-FAB8-45F039ECC56D}"/>
+                <a16:creationId xmlns:a16="http://schemas.microsoft.com/office/drawing/2014/main" id="{DCCBBC14-D4FB-A715-ACC2-5B2EBB20D7C7}"/>
               </a:ext>
             </a:extLst>
           </p:cNvPr>
@@ -504,7 +504,7 @@
           <a:bodyPr/>
           <a:lstStyle/>
           <a:p>
-            <a:fld id="{F8562357-FFAC-4DD4-994D-CC30F1B809D6}" type="slidenum">
+            <a:fld id="{B2A52879-9975-4A1A-B0EB-44F71CED55F9}" type="slidenum">
               <a:rPr lang="ko-KR" altLang="en-US" smtClean="0"/>
               <a:t>‹#›</a:t>
             </a:fld>
@@ -515,7 +515,7 @@
     </p:spTree>
     <p:extLst>
       <p:ext uri="{BB962C8B-B14F-4D97-AF65-F5344CB8AC3E}">
-        <p14:creationId xmlns:p14="http://schemas.microsoft.com/office/powerpoint/2010/main" val="1090552103"/>
+        <p14:creationId xmlns:p14="http://schemas.microsoft.com/office/powerpoint/2010/main" val="1167010410"/>
       </p:ext>
     </p:extLst>
   </p:cSld>
@@ -547,7 +547,7 @@
           <p:cNvPr id="2" name="세로 제목 1">
             <a:extLst>
               <a:ext uri="{FF2B5EF4-FFF2-40B4-BE49-F238E27FC236}">
-                <a16:creationId xmlns:a16="http://schemas.microsoft.com/office/drawing/2014/main" id="{EE79527F-5FD2-69EC-ED78-EFE73583C398}"/>
+                <a16:creationId xmlns:a16="http://schemas.microsoft.com/office/drawing/2014/main" id="{451CD770-97B0-B91C-3FF6-B81853E48974}"/>
               </a:ext>
             </a:extLst>
           </p:cNvPr>
@@ -580,7 +580,7 @@
           <p:cNvPr id="3" name="세로 텍스트 개체 틀 2">
             <a:extLst>
               <a:ext uri="{FF2B5EF4-FFF2-40B4-BE49-F238E27FC236}">
-                <a16:creationId xmlns:a16="http://schemas.microsoft.com/office/drawing/2014/main" id="{D578FF85-8F42-CA32-6644-8D3BB171375B}"/>
+                <a16:creationId xmlns:a16="http://schemas.microsoft.com/office/drawing/2014/main" id="{AF93FD98-4B33-C1DA-25A2-719763F7FC2F}"/>
               </a:ext>
             </a:extLst>
           </p:cNvPr>
@@ -642,7 +642,7 @@
           <p:cNvPr id="4" name="날짜 개체 틀 3">
             <a:extLst>
               <a:ext uri="{FF2B5EF4-FFF2-40B4-BE49-F238E27FC236}">
-                <a16:creationId xmlns:a16="http://schemas.microsoft.com/office/drawing/2014/main" id="{B2BD405B-C81D-6F0A-24E2-896A058E60F5}"/>
+                <a16:creationId xmlns:a16="http://schemas.microsoft.com/office/drawing/2014/main" id="{D1386076-E026-7A40-CDAC-094FA055FF64}"/>
               </a:ext>
             </a:extLst>
           </p:cNvPr>
@@ -658,7 +658,7 @@
           <a:bodyPr/>
           <a:lstStyle/>
           <a:p>
-            <a:fld id="{9742B1B7-23B9-44F4-B08E-E585703C19EC}" type="datetimeFigureOut">
+            <a:fld id="{32E9D3ED-3924-43EC-83E7-C21FD4BF3549}" type="datetimeFigureOut">
               <a:rPr lang="ko-KR" altLang="en-US" smtClean="0"/>
               <a:t>2026-06-19</a:t>
             </a:fld>
@@ -671,7 +671,7 @@
           <p:cNvPr id="5" name="바닥글 개체 틀 4">
             <a:extLst>
               <a:ext uri="{FF2B5EF4-FFF2-40B4-BE49-F238E27FC236}">
-                <a16:creationId xmlns:a16="http://schemas.microsoft.com/office/drawing/2014/main" id="{0F45C956-BA93-3FAC-1AC4-F0532F1A4F4B}"/>
+                <a16:creationId xmlns:a16="http://schemas.microsoft.com/office/drawing/2014/main" id="{1480979F-6283-12E8-3D5F-9DE7DC7DCE6A}"/>
               </a:ext>
             </a:extLst>
           </p:cNvPr>
@@ -696,7 +696,7 @@
           <p:cNvPr id="6" name="슬라이드 번호 개체 틀 5">
             <a:extLst>
               <a:ext uri="{FF2B5EF4-FFF2-40B4-BE49-F238E27FC236}">
-                <a16:creationId xmlns:a16="http://schemas.microsoft.com/office/drawing/2014/main" id="{624B173F-0E31-4B9C-11C9-CBCAFD674AF9}"/>
+                <a16:creationId xmlns:a16="http://schemas.microsoft.com/office/drawing/2014/main" id="{04896C0C-FDE1-8E14-CABA-5A64479F1690}"/>
               </a:ext>
             </a:extLst>
           </p:cNvPr>
@@ -712,7 +712,7 @@
           <a:bodyPr/>
           <a:lstStyle/>
           <a:p>
-            <a:fld id="{F8562357-FFAC-4DD4-994D-CC30F1B809D6}" type="slidenum">
+            <a:fld id="{B2A52879-9975-4A1A-B0EB-44F71CED55F9}" type="slidenum">
               <a:rPr lang="ko-KR" altLang="en-US" smtClean="0"/>
               <a:t>‹#›</a:t>
             </a:fld>
@@ -723,7 +723,7 @@
     </p:spTree>
     <p:extLst>
       <p:ext uri="{BB962C8B-B14F-4D97-AF65-F5344CB8AC3E}">
-        <p14:creationId xmlns:p14="http://schemas.microsoft.com/office/powerpoint/2010/main" val="777971622"/>
+        <p14:creationId xmlns:p14="http://schemas.microsoft.com/office/powerpoint/2010/main" val="233391226"/>
       </p:ext>
     </p:extLst>
   </p:cSld>
@@ -755,7 +755,7 @@
           <p:cNvPr id="2" name="제목 1">
             <a:extLst>
               <a:ext uri="{FF2B5EF4-FFF2-40B4-BE49-F238E27FC236}">
-                <a16:creationId xmlns:a16="http://schemas.microsoft.com/office/drawing/2014/main" id="{E7A5E432-E74B-0C96-778C-28CFA27235BE}"/>
+                <a16:creationId xmlns:a16="http://schemas.microsoft.com/office/drawing/2014/main" id="{589D6503-C788-10D3-0C40-3A82CDDF03CB}"/>
               </a:ext>
             </a:extLst>
           </p:cNvPr>
@@ -783,7 +783,7 @@
           <p:cNvPr id="3" name="내용 개체 틀 2">
             <a:extLst>
               <a:ext uri="{FF2B5EF4-FFF2-40B4-BE49-F238E27FC236}">
-                <a16:creationId xmlns:a16="http://schemas.microsoft.com/office/drawing/2014/main" id="{78769D69-F0D8-42A2-3B43-E66DDEE0E82B}"/>
+                <a16:creationId xmlns:a16="http://schemas.microsoft.com/office/drawing/2014/main" id="{605B7B7E-30C6-55A4-43F9-389DBD97F145}"/>
               </a:ext>
             </a:extLst>
           </p:cNvPr>
@@ -840,7 +840,7 @@
           <p:cNvPr id="4" name="날짜 개체 틀 3">
             <a:extLst>
               <a:ext uri="{FF2B5EF4-FFF2-40B4-BE49-F238E27FC236}">
-                <a16:creationId xmlns:a16="http://schemas.microsoft.com/office/drawing/2014/main" id="{0F85E5AE-66AC-7083-1BCE-B8B532E8C91D}"/>
+                <a16:creationId xmlns:a16="http://schemas.microsoft.com/office/drawing/2014/main" id="{E4192613-03CC-D140-AB09-19877877EB17}"/>
               </a:ext>
             </a:extLst>
           </p:cNvPr>
@@ -856,7 +856,7 @@
           <a:bodyPr/>
           <a:lstStyle/>
           <a:p>
-            <a:fld id="{9742B1B7-23B9-44F4-B08E-E585703C19EC}" type="datetimeFigureOut">
+            <a:fld id="{32E9D3ED-3924-43EC-83E7-C21FD4BF3549}" type="datetimeFigureOut">
               <a:rPr lang="ko-KR" altLang="en-US" smtClean="0"/>
               <a:t>2026-06-19</a:t>
             </a:fld>
@@ -869,7 +869,7 @@
           <p:cNvPr id="5" name="바닥글 개체 틀 4">
             <a:extLst>
               <a:ext uri="{FF2B5EF4-FFF2-40B4-BE49-F238E27FC236}">
-                <a16:creationId xmlns:a16="http://schemas.microsoft.com/office/drawing/2014/main" id="{98C314FF-9589-F8EE-B927-4762E12128AF}"/>
+                <a16:creationId xmlns:a16="http://schemas.microsoft.com/office/drawing/2014/main" id="{1B68FFB6-DAE5-0E82-4FF5-5222053C4B13}"/>
               </a:ext>
             </a:extLst>
           </p:cNvPr>
@@ -894,7 +894,7 @@
           <p:cNvPr id="6" name="슬라이드 번호 개체 틀 5">
             <a:extLst>
               <a:ext uri="{FF2B5EF4-FFF2-40B4-BE49-F238E27FC236}">
-                <a16:creationId xmlns:a16="http://schemas.microsoft.com/office/drawing/2014/main" id="{12684494-2FC0-AA45-82BF-D7711A3FC49E}"/>
+                <a16:creationId xmlns:a16="http://schemas.microsoft.com/office/drawing/2014/main" id="{9F4ABEFC-56FD-78F4-CC5B-902EF6C69AD0}"/>
               </a:ext>
             </a:extLst>
           </p:cNvPr>
@@ -910,7 +910,7 @@
           <a:bodyPr/>
           <a:lstStyle/>
           <a:p>
-            <a:fld id="{F8562357-FFAC-4DD4-994D-CC30F1B809D6}" type="slidenum">
+            <a:fld id="{B2A52879-9975-4A1A-B0EB-44F71CED55F9}" type="slidenum">
               <a:rPr lang="ko-KR" altLang="en-US" smtClean="0"/>
               <a:t>‹#›</a:t>
             </a:fld>
@@ -921,7 +921,7 @@
     </p:spTree>
     <p:extLst>
       <p:ext uri="{BB962C8B-B14F-4D97-AF65-F5344CB8AC3E}">
-        <p14:creationId xmlns:p14="http://schemas.microsoft.com/office/powerpoint/2010/main" val="3758428053"/>
+        <p14:creationId xmlns:p14="http://schemas.microsoft.com/office/powerpoint/2010/main" val="3773079764"/>
       </p:ext>
     </p:extLst>
   </p:cSld>
@@ -953,7 +953,7 @@
           <p:cNvPr id="2" name="제목 1">
             <a:extLst>
               <a:ext uri="{FF2B5EF4-FFF2-40B4-BE49-F238E27FC236}">
-                <a16:creationId xmlns:a16="http://schemas.microsoft.com/office/drawing/2014/main" id="{4C151E88-D741-A76C-04D4-859699A5B691}"/>
+                <a16:creationId xmlns:a16="http://schemas.microsoft.com/office/drawing/2014/main" id="{54D464A3-43E8-F8EF-EBDA-666BB456C2A8}"/>
               </a:ext>
             </a:extLst>
           </p:cNvPr>
@@ -990,7 +990,7 @@
           <p:cNvPr id="3" name="텍스트 개체 틀 2">
             <a:extLst>
               <a:ext uri="{FF2B5EF4-FFF2-40B4-BE49-F238E27FC236}">
-                <a16:creationId xmlns:a16="http://schemas.microsoft.com/office/drawing/2014/main" id="{B724D6F2-28DE-1FF1-5ED1-FD2E97521600}"/>
+                <a16:creationId xmlns:a16="http://schemas.microsoft.com/office/drawing/2014/main" id="{C2525960-D407-9947-8E10-42D29CD9086F}"/>
               </a:ext>
             </a:extLst>
           </p:cNvPr>
@@ -1115,7 +1115,7 @@
           <p:cNvPr id="4" name="날짜 개체 틀 3">
             <a:extLst>
               <a:ext uri="{FF2B5EF4-FFF2-40B4-BE49-F238E27FC236}">
-                <a16:creationId xmlns:a16="http://schemas.microsoft.com/office/drawing/2014/main" id="{CCCFDA43-F709-5FF8-0B77-93444CACC528}"/>
+                <a16:creationId xmlns:a16="http://schemas.microsoft.com/office/drawing/2014/main" id="{F5987A1A-0BBD-2650-3925-DF3816E0012F}"/>
               </a:ext>
             </a:extLst>
           </p:cNvPr>
@@ -1131,7 +1131,7 @@
           <a:bodyPr/>
           <a:lstStyle/>
           <a:p>
-            <a:fld id="{9742B1B7-23B9-44F4-B08E-E585703C19EC}" type="datetimeFigureOut">
+            <a:fld id="{32E9D3ED-3924-43EC-83E7-C21FD4BF3549}" type="datetimeFigureOut">
               <a:rPr lang="ko-KR" altLang="en-US" smtClean="0"/>
               <a:t>2026-06-19</a:t>
             </a:fld>
@@ -1144,7 +1144,7 @@
           <p:cNvPr id="5" name="바닥글 개체 틀 4">
             <a:extLst>
               <a:ext uri="{FF2B5EF4-FFF2-40B4-BE49-F238E27FC236}">
-                <a16:creationId xmlns:a16="http://schemas.microsoft.com/office/drawing/2014/main" id="{D477244E-DEFB-43B2-DA46-EC3ADCBF96F5}"/>
+                <a16:creationId xmlns:a16="http://schemas.microsoft.com/office/drawing/2014/main" id="{BA69636F-09D1-D1BB-C1E3-F47593721B0F}"/>
               </a:ext>
             </a:extLst>
           </p:cNvPr>
@@ -1169,7 +1169,7 @@
           <p:cNvPr id="6" name="슬라이드 번호 개체 틀 5">
             <a:extLst>
               <a:ext uri="{FF2B5EF4-FFF2-40B4-BE49-F238E27FC236}">
-                <a16:creationId xmlns:a16="http://schemas.microsoft.com/office/drawing/2014/main" id="{1EBE132F-0A18-C94D-314C-4F71C6E3F6FC}"/>
+                <a16:creationId xmlns:a16="http://schemas.microsoft.com/office/drawing/2014/main" id="{F61211D7-E980-2712-3B49-D938BA51A200}"/>
               </a:ext>
             </a:extLst>
           </p:cNvPr>
@@ -1185,7 +1185,7 @@
           <a:bodyPr/>
           <a:lstStyle/>
           <a:p>
-            <a:fld id="{F8562357-FFAC-4DD4-994D-CC30F1B809D6}" type="slidenum">
+            <a:fld id="{B2A52879-9975-4A1A-B0EB-44F71CED55F9}" type="slidenum">
               <a:rPr lang="ko-KR" altLang="en-US" smtClean="0"/>
               <a:t>‹#›</a:t>
             </a:fld>
@@ -1196,7 +1196,7 @@
     </p:spTree>
     <p:extLst>
       <p:ext uri="{BB962C8B-B14F-4D97-AF65-F5344CB8AC3E}">
-        <p14:creationId xmlns:p14="http://schemas.microsoft.com/office/powerpoint/2010/main" val="1024824775"/>
+        <p14:creationId xmlns:p14="http://schemas.microsoft.com/office/powerpoint/2010/main" val="3572135615"/>
       </p:ext>
     </p:extLst>
   </p:cSld>
@@ -1228,7 +1228,7 @@
           <p:cNvPr id="2" name="제목 1">
             <a:extLst>
               <a:ext uri="{FF2B5EF4-FFF2-40B4-BE49-F238E27FC236}">
-                <a16:creationId xmlns:a16="http://schemas.microsoft.com/office/drawing/2014/main" id="{CB49C830-D1C4-0AB2-1EEA-BEF364A8C54D}"/>
+                <a16:creationId xmlns:a16="http://schemas.microsoft.com/office/drawing/2014/main" id="{89FCCAB2-B841-C654-4733-F08B7C1A4C04}"/>
               </a:ext>
             </a:extLst>
           </p:cNvPr>
@@ -1256,7 +1256,7 @@
           <p:cNvPr id="3" name="내용 개체 틀 2">
             <a:extLst>
               <a:ext uri="{FF2B5EF4-FFF2-40B4-BE49-F238E27FC236}">
-                <a16:creationId xmlns:a16="http://schemas.microsoft.com/office/drawing/2014/main" id="{EF7D38B1-2714-72D1-D2C8-F0B1398BB16C}"/>
+                <a16:creationId xmlns:a16="http://schemas.microsoft.com/office/drawing/2014/main" id="{AC79019F-D677-A46A-9C3D-897B7E7D120F}"/>
               </a:ext>
             </a:extLst>
           </p:cNvPr>
@@ -1318,7 +1318,7 @@
           <p:cNvPr id="4" name="내용 개체 틀 3">
             <a:extLst>
               <a:ext uri="{FF2B5EF4-FFF2-40B4-BE49-F238E27FC236}">
-                <a16:creationId xmlns:a16="http://schemas.microsoft.com/office/drawing/2014/main" id="{345B48F3-9D7A-4EF1-54F8-F0497468CF58}"/>
+                <a16:creationId xmlns:a16="http://schemas.microsoft.com/office/drawing/2014/main" id="{81811814-BE88-325F-A146-02A6EF38FC2E}"/>
               </a:ext>
             </a:extLst>
           </p:cNvPr>
@@ -1380,7 +1380,7 @@
           <p:cNvPr id="5" name="날짜 개체 틀 4">
             <a:extLst>
               <a:ext uri="{FF2B5EF4-FFF2-40B4-BE49-F238E27FC236}">
-                <a16:creationId xmlns:a16="http://schemas.microsoft.com/office/drawing/2014/main" id="{9866C2AD-4F91-E695-14FE-E504124856D9}"/>
+                <a16:creationId xmlns:a16="http://schemas.microsoft.com/office/drawing/2014/main" id="{BAC48594-9F08-4281-17B0-CD28C9CB6708}"/>
               </a:ext>
             </a:extLst>
           </p:cNvPr>
@@ -1396,7 +1396,7 @@
           <a:bodyPr/>
           <a:lstStyle/>
           <a:p>
-            <a:fld id="{9742B1B7-23B9-44F4-B08E-E585703C19EC}" type="datetimeFigureOut">
+            <a:fld id="{32E9D3ED-3924-43EC-83E7-C21FD4BF3549}" type="datetimeFigureOut">
               <a:rPr lang="ko-KR" altLang="en-US" smtClean="0"/>
               <a:t>2026-06-19</a:t>
             </a:fld>
@@ -1409,7 +1409,7 @@
           <p:cNvPr id="6" name="바닥글 개체 틀 5">
             <a:extLst>
               <a:ext uri="{FF2B5EF4-FFF2-40B4-BE49-F238E27FC236}">
-                <a16:creationId xmlns:a16="http://schemas.microsoft.com/office/drawing/2014/main" id="{C2D4C5AD-F5C2-ABA2-F8B2-5347351C554D}"/>
+                <a16:creationId xmlns:a16="http://schemas.microsoft.com/office/drawing/2014/main" id="{50DF7391-31E1-7B26-8FDF-362B5C36CBD4}"/>
               </a:ext>
             </a:extLst>
           </p:cNvPr>
@@ -1434,7 +1434,7 @@
           <p:cNvPr id="7" name="슬라이드 번호 개체 틀 6">
             <a:extLst>
               <a:ext uri="{FF2B5EF4-FFF2-40B4-BE49-F238E27FC236}">
-                <a16:creationId xmlns:a16="http://schemas.microsoft.com/office/drawing/2014/main" id="{2B38C58A-D221-45E6-EB67-1D55B4DBE0AD}"/>
+                <a16:creationId xmlns:a16="http://schemas.microsoft.com/office/drawing/2014/main" id="{D0726E63-BCA0-E822-850E-8E9E76051284}"/>
               </a:ext>
             </a:extLst>
           </p:cNvPr>
@@ -1450,7 +1450,7 @@
           <a:bodyPr/>
           <a:lstStyle/>
           <a:p>
-            <a:fld id="{F8562357-FFAC-4DD4-994D-CC30F1B809D6}" type="slidenum">
+            <a:fld id="{B2A52879-9975-4A1A-B0EB-44F71CED55F9}" type="slidenum">
               <a:rPr lang="ko-KR" altLang="en-US" smtClean="0"/>
               <a:t>‹#›</a:t>
             </a:fld>
@@ -1461,7 +1461,7 @@
     </p:spTree>
     <p:extLst>
       <p:ext uri="{BB962C8B-B14F-4D97-AF65-F5344CB8AC3E}">
-        <p14:creationId xmlns:p14="http://schemas.microsoft.com/office/powerpoint/2010/main" val="630499528"/>
+        <p14:creationId xmlns:p14="http://schemas.microsoft.com/office/powerpoint/2010/main" val="2690139098"/>
       </p:ext>
     </p:extLst>
   </p:cSld>
@@ -1493,7 +1493,7 @@
           <p:cNvPr id="2" name="제목 1">
             <a:extLst>
               <a:ext uri="{FF2B5EF4-FFF2-40B4-BE49-F238E27FC236}">
-                <a16:creationId xmlns:a16="http://schemas.microsoft.com/office/drawing/2014/main" id="{E5A214BD-7ACC-C297-F6DF-55FB4637F074}"/>
+                <a16:creationId xmlns:a16="http://schemas.microsoft.com/office/drawing/2014/main" id="{F6EA6644-78AE-764B-81D1-80F83B150C7E}"/>
               </a:ext>
             </a:extLst>
           </p:cNvPr>
@@ -1526,7 +1526,7 @@
           <p:cNvPr id="3" name="텍스트 개체 틀 2">
             <a:extLst>
               <a:ext uri="{FF2B5EF4-FFF2-40B4-BE49-F238E27FC236}">
-                <a16:creationId xmlns:a16="http://schemas.microsoft.com/office/drawing/2014/main" id="{CF55C0F8-7A73-0E6E-19CE-04D41C5D38CD}"/>
+                <a16:creationId xmlns:a16="http://schemas.microsoft.com/office/drawing/2014/main" id="{112BA49E-0210-66B0-68BE-940F1490B958}"/>
               </a:ext>
             </a:extLst>
           </p:cNvPr>
@@ -1597,7 +1597,7 @@
           <p:cNvPr id="4" name="내용 개체 틀 3">
             <a:extLst>
               <a:ext uri="{FF2B5EF4-FFF2-40B4-BE49-F238E27FC236}">
-                <a16:creationId xmlns:a16="http://schemas.microsoft.com/office/drawing/2014/main" id="{7FFAA6DD-AC30-11F4-17FD-13DC5FBE1108}"/>
+                <a16:creationId xmlns:a16="http://schemas.microsoft.com/office/drawing/2014/main" id="{8A05A4F4-6011-E313-4936-9AF6D8258DB4}"/>
               </a:ext>
             </a:extLst>
           </p:cNvPr>
@@ -1659,7 +1659,7 @@
           <p:cNvPr id="5" name="텍스트 개체 틀 4">
             <a:extLst>
               <a:ext uri="{FF2B5EF4-FFF2-40B4-BE49-F238E27FC236}">
-                <a16:creationId xmlns:a16="http://schemas.microsoft.com/office/drawing/2014/main" id="{CD7DA009-2D41-55AC-FB9A-4EC752CD5995}"/>
+                <a16:creationId xmlns:a16="http://schemas.microsoft.com/office/drawing/2014/main" id="{767DCDEE-2F1D-8518-C203-FCE0D6B96FC1}"/>
               </a:ext>
             </a:extLst>
           </p:cNvPr>
@@ -1730,7 +1730,7 @@
           <p:cNvPr id="6" name="내용 개체 틀 5">
             <a:extLst>
               <a:ext uri="{FF2B5EF4-FFF2-40B4-BE49-F238E27FC236}">
-                <a16:creationId xmlns:a16="http://schemas.microsoft.com/office/drawing/2014/main" id="{599CBEA8-3F26-84BF-0C2B-E2B4100C7687}"/>
+                <a16:creationId xmlns:a16="http://schemas.microsoft.com/office/drawing/2014/main" id="{3E527D70-79B1-026C-E493-949081143217}"/>
               </a:ext>
             </a:extLst>
           </p:cNvPr>
@@ -1792,7 +1792,7 @@
           <p:cNvPr id="7" name="날짜 개체 틀 6">
             <a:extLst>
               <a:ext uri="{FF2B5EF4-FFF2-40B4-BE49-F238E27FC236}">
-                <a16:creationId xmlns:a16="http://schemas.microsoft.com/office/drawing/2014/main" id="{8D5800D1-7D95-FA73-7B75-4DB7B1C274A3}"/>
+                <a16:creationId xmlns:a16="http://schemas.microsoft.com/office/drawing/2014/main" id="{0F97775F-FD1D-9C2C-5503-3D591A0A724A}"/>
               </a:ext>
             </a:extLst>
           </p:cNvPr>
@@ -1808,7 +1808,7 @@
           <a:bodyPr/>
           <a:lstStyle/>
           <a:p>
-            <a:fld id="{9742B1B7-23B9-44F4-B08E-E585703C19EC}" type="datetimeFigureOut">
+            <a:fld id="{32E9D3ED-3924-43EC-83E7-C21FD4BF3549}" type="datetimeFigureOut">
               <a:rPr lang="ko-KR" altLang="en-US" smtClean="0"/>
               <a:t>2026-06-19</a:t>
             </a:fld>
@@ -1821,7 +1821,7 @@
           <p:cNvPr id="8" name="바닥글 개체 틀 7">
             <a:extLst>
               <a:ext uri="{FF2B5EF4-FFF2-40B4-BE49-F238E27FC236}">
-                <a16:creationId xmlns:a16="http://schemas.microsoft.com/office/drawing/2014/main" id="{D85A0AF6-0799-D5C4-B70F-74502F4A2EB8}"/>
+                <a16:creationId xmlns:a16="http://schemas.microsoft.com/office/drawing/2014/main" id="{D61119DA-4109-17D1-5383-DF948BC42DBA}"/>
               </a:ext>
             </a:extLst>
           </p:cNvPr>
@@ -1846,7 +1846,7 @@
           <p:cNvPr id="9" name="슬라이드 번호 개체 틀 8">
             <a:extLst>
               <a:ext uri="{FF2B5EF4-FFF2-40B4-BE49-F238E27FC236}">
-                <a16:creationId xmlns:a16="http://schemas.microsoft.com/office/drawing/2014/main" id="{0C8AC03B-394D-3253-0E80-DBE3269CC4C2}"/>
+                <a16:creationId xmlns:a16="http://schemas.microsoft.com/office/drawing/2014/main" id="{2E209097-0721-AB27-2287-E01688F40F15}"/>
               </a:ext>
             </a:extLst>
           </p:cNvPr>
@@ -1862,7 +1862,7 @@
           <a:bodyPr/>
           <a:lstStyle/>
           <a:p>
-            <a:fld id="{F8562357-FFAC-4DD4-994D-CC30F1B809D6}" type="slidenum">
+            <a:fld id="{B2A52879-9975-4A1A-B0EB-44F71CED55F9}" type="slidenum">
               <a:rPr lang="ko-KR" altLang="en-US" smtClean="0"/>
               <a:t>‹#›</a:t>
             </a:fld>
@@ -1873,7 +1873,7 @@
     </p:spTree>
     <p:extLst>
       <p:ext uri="{BB962C8B-B14F-4D97-AF65-F5344CB8AC3E}">
-        <p14:creationId xmlns:p14="http://schemas.microsoft.com/office/powerpoint/2010/main" val="1287031164"/>
+        <p14:creationId xmlns:p14="http://schemas.microsoft.com/office/powerpoint/2010/main" val="3749077625"/>
       </p:ext>
     </p:extLst>
   </p:cSld>
@@ -1905,7 +1905,7 @@
           <p:cNvPr id="2" name="제목 1">
             <a:extLst>
               <a:ext uri="{FF2B5EF4-FFF2-40B4-BE49-F238E27FC236}">
-                <a16:creationId xmlns:a16="http://schemas.microsoft.com/office/drawing/2014/main" id="{590ADCFA-E665-0CC1-500B-EE38C73A3080}"/>
+                <a16:creationId xmlns:a16="http://schemas.microsoft.com/office/drawing/2014/main" id="{45C42F6A-4465-360F-599E-E3C69DE39E38}"/>
               </a:ext>
             </a:extLst>
           </p:cNvPr>
@@ -1933,7 +1933,7 @@
           <p:cNvPr id="3" name="날짜 개체 틀 2">
             <a:extLst>
               <a:ext uri="{FF2B5EF4-FFF2-40B4-BE49-F238E27FC236}">
-                <a16:creationId xmlns:a16="http://schemas.microsoft.com/office/drawing/2014/main" id="{DF63594C-88F6-AB67-CEC1-7730621B4419}"/>
+                <a16:creationId xmlns:a16="http://schemas.microsoft.com/office/drawing/2014/main" id="{84A0740B-4C7E-C0FB-EA10-66AFD07BD917}"/>
               </a:ext>
             </a:extLst>
           </p:cNvPr>
@@ -1949,7 +1949,7 @@
           <a:bodyPr/>
           <a:lstStyle/>
           <a:p>
-            <a:fld id="{9742B1B7-23B9-44F4-B08E-E585703C19EC}" type="datetimeFigureOut">
+            <a:fld id="{32E9D3ED-3924-43EC-83E7-C21FD4BF3549}" type="datetimeFigureOut">
               <a:rPr lang="ko-KR" altLang="en-US" smtClean="0"/>
               <a:t>2026-06-19</a:t>
             </a:fld>
@@ -1962,7 +1962,7 @@
           <p:cNvPr id="4" name="바닥글 개체 틀 3">
             <a:extLst>
               <a:ext uri="{FF2B5EF4-FFF2-40B4-BE49-F238E27FC236}">
-                <a16:creationId xmlns:a16="http://schemas.microsoft.com/office/drawing/2014/main" id="{93A2F1E7-780F-C6A4-059D-F0CFFDE76AEF}"/>
+                <a16:creationId xmlns:a16="http://schemas.microsoft.com/office/drawing/2014/main" id="{CEE3802B-FCF2-7D37-FAE0-7ED942144703}"/>
               </a:ext>
             </a:extLst>
           </p:cNvPr>
@@ -1987,7 +1987,7 @@
           <p:cNvPr id="5" name="슬라이드 번호 개체 틀 4">
             <a:extLst>
               <a:ext uri="{FF2B5EF4-FFF2-40B4-BE49-F238E27FC236}">
-                <a16:creationId xmlns:a16="http://schemas.microsoft.com/office/drawing/2014/main" id="{A63A23AF-3690-562B-7D20-2FCD6A11A32B}"/>
+                <a16:creationId xmlns:a16="http://schemas.microsoft.com/office/drawing/2014/main" id="{8D35EB3C-4B02-72D1-ABDC-8740A336F33B}"/>
               </a:ext>
             </a:extLst>
           </p:cNvPr>
@@ -2003,7 +2003,7 @@
           <a:bodyPr/>
           <a:lstStyle/>
           <a:p>
-            <a:fld id="{F8562357-FFAC-4DD4-994D-CC30F1B809D6}" type="slidenum">
+            <a:fld id="{B2A52879-9975-4A1A-B0EB-44F71CED55F9}" type="slidenum">
               <a:rPr lang="ko-KR" altLang="en-US" smtClean="0"/>
               <a:t>‹#›</a:t>
             </a:fld>
@@ -2014,7 +2014,7 @@
     </p:spTree>
     <p:extLst>
       <p:ext uri="{BB962C8B-B14F-4D97-AF65-F5344CB8AC3E}">
-        <p14:creationId xmlns:p14="http://schemas.microsoft.com/office/powerpoint/2010/main" val="2901779742"/>
+        <p14:creationId xmlns:p14="http://schemas.microsoft.com/office/powerpoint/2010/main" val="1415121809"/>
       </p:ext>
     </p:extLst>
   </p:cSld>
@@ -2046,7 +2046,7 @@
           <p:cNvPr id="2" name="날짜 개체 틀 1">
             <a:extLst>
               <a:ext uri="{FF2B5EF4-FFF2-40B4-BE49-F238E27FC236}">
-                <a16:creationId xmlns:a16="http://schemas.microsoft.com/office/drawing/2014/main" id="{28C19200-BCF6-E873-156C-4F0A56FED23E}"/>
+                <a16:creationId xmlns:a16="http://schemas.microsoft.com/office/drawing/2014/main" id="{C2008B1D-59F0-D39D-0FC7-138DAB3DCB3F}"/>
               </a:ext>
             </a:extLst>
           </p:cNvPr>
@@ -2062,7 +2062,7 @@
           <a:bodyPr/>
           <a:lstStyle/>
           <a:p>
-            <a:fld id="{9742B1B7-23B9-44F4-B08E-E585703C19EC}" type="datetimeFigureOut">
+            <a:fld id="{32E9D3ED-3924-43EC-83E7-C21FD4BF3549}" type="datetimeFigureOut">
               <a:rPr lang="ko-KR" altLang="en-US" smtClean="0"/>
               <a:t>2026-06-19</a:t>
             </a:fld>
@@ -2075,7 +2075,7 @@
           <p:cNvPr id="3" name="바닥글 개체 틀 2">
             <a:extLst>
               <a:ext uri="{FF2B5EF4-FFF2-40B4-BE49-F238E27FC236}">
-                <a16:creationId xmlns:a16="http://schemas.microsoft.com/office/drawing/2014/main" id="{FD74C4A3-7638-5FF2-3094-79EFF169921D}"/>
+                <a16:creationId xmlns:a16="http://schemas.microsoft.com/office/drawing/2014/main" id="{9AE4D93F-E3C5-4460-3B75-D3C2C36D1BB7}"/>
               </a:ext>
             </a:extLst>
           </p:cNvPr>
@@ -2100,7 +2100,7 @@
           <p:cNvPr id="4" name="슬라이드 번호 개체 틀 3">
             <a:extLst>
               <a:ext uri="{FF2B5EF4-FFF2-40B4-BE49-F238E27FC236}">
-                <a16:creationId xmlns:a16="http://schemas.microsoft.com/office/drawing/2014/main" id="{9612F57F-1198-1BF4-9E7F-1699E90B748E}"/>
+                <a16:creationId xmlns:a16="http://schemas.microsoft.com/office/drawing/2014/main" id="{B963EAEF-8698-CD1D-96F6-04A3E16F8D67}"/>
               </a:ext>
             </a:extLst>
           </p:cNvPr>
@@ -2116,7 +2116,7 @@
           <a:bodyPr/>
           <a:lstStyle/>
           <a:p>
-            <a:fld id="{F8562357-FFAC-4DD4-994D-CC30F1B809D6}" type="slidenum">
+            <a:fld id="{B2A52879-9975-4A1A-B0EB-44F71CED55F9}" type="slidenum">
               <a:rPr lang="ko-KR" altLang="en-US" smtClean="0"/>
               <a:t>‹#›</a:t>
             </a:fld>
@@ -2127,7 +2127,7 @@
     </p:spTree>
     <p:extLst>
       <p:ext uri="{BB962C8B-B14F-4D97-AF65-F5344CB8AC3E}">
-        <p14:creationId xmlns:p14="http://schemas.microsoft.com/office/powerpoint/2010/main" val="772918046"/>
+        <p14:creationId xmlns:p14="http://schemas.microsoft.com/office/powerpoint/2010/main" val="1066348018"/>
       </p:ext>
     </p:extLst>
   </p:cSld>
@@ -2159,7 +2159,7 @@
           <p:cNvPr id="2" name="제목 1">
             <a:extLst>
               <a:ext uri="{FF2B5EF4-FFF2-40B4-BE49-F238E27FC236}">
-                <a16:creationId xmlns:a16="http://schemas.microsoft.com/office/drawing/2014/main" id="{33DEDD95-0706-DA22-8CE6-12C590E57B65}"/>
+                <a16:creationId xmlns:a16="http://schemas.microsoft.com/office/drawing/2014/main" id="{5242F898-3A85-6FED-DDDA-13BDA086C8E1}"/>
               </a:ext>
             </a:extLst>
           </p:cNvPr>
@@ -2196,7 +2196,7 @@
           <p:cNvPr id="3" name="내용 개체 틀 2">
             <a:extLst>
               <a:ext uri="{FF2B5EF4-FFF2-40B4-BE49-F238E27FC236}">
-                <a16:creationId xmlns:a16="http://schemas.microsoft.com/office/drawing/2014/main" id="{A9E9CD25-BB88-2FA5-8759-579111D00C93}"/>
+                <a16:creationId xmlns:a16="http://schemas.microsoft.com/office/drawing/2014/main" id="{E9BC631C-DDBB-AE59-0AED-74A4A2873713}"/>
               </a:ext>
             </a:extLst>
           </p:cNvPr>
@@ -2286,7 +2286,7 @@
           <p:cNvPr id="4" name="텍스트 개체 틀 3">
             <a:extLst>
               <a:ext uri="{FF2B5EF4-FFF2-40B4-BE49-F238E27FC236}">
-                <a16:creationId xmlns:a16="http://schemas.microsoft.com/office/drawing/2014/main" id="{FAC1D064-4954-414C-BB3B-F4C6108DCEB4}"/>
+                <a16:creationId xmlns:a16="http://schemas.microsoft.com/office/drawing/2014/main" id="{1A037752-BA9A-B991-FE75-23B756270285}"/>
               </a:ext>
             </a:extLst>
           </p:cNvPr>
@@ -2357,7 +2357,7 @@
           <p:cNvPr id="5" name="날짜 개체 틀 4">
             <a:extLst>
               <a:ext uri="{FF2B5EF4-FFF2-40B4-BE49-F238E27FC236}">
-                <a16:creationId xmlns:a16="http://schemas.microsoft.com/office/drawing/2014/main" id="{5001E746-1EA4-C54D-E058-984549DF72AC}"/>
+                <a16:creationId xmlns:a16="http://schemas.microsoft.com/office/drawing/2014/main" id="{6CF3DB0A-C234-65FC-81C3-D18C005EEFF1}"/>
               </a:ext>
             </a:extLst>
           </p:cNvPr>
@@ -2373,7 +2373,7 @@
           <a:bodyPr/>
           <a:lstStyle/>
           <a:p>
-            <a:fld id="{9742B1B7-23B9-44F4-B08E-E585703C19EC}" type="datetimeFigureOut">
+            <a:fld id="{32E9D3ED-3924-43EC-83E7-C21FD4BF3549}" type="datetimeFigureOut">
               <a:rPr lang="ko-KR" altLang="en-US" smtClean="0"/>
               <a:t>2026-06-19</a:t>
             </a:fld>
@@ -2386,7 +2386,7 @@
           <p:cNvPr id="6" name="바닥글 개체 틀 5">
             <a:extLst>
               <a:ext uri="{FF2B5EF4-FFF2-40B4-BE49-F238E27FC236}">
-                <a16:creationId xmlns:a16="http://schemas.microsoft.com/office/drawing/2014/main" id="{EA5B53D9-6127-FC21-57AE-899DC9B981C8}"/>
+                <a16:creationId xmlns:a16="http://schemas.microsoft.com/office/drawing/2014/main" id="{CF895922-57D8-9A19-F7A2-308A1CFDB881}"/>
               </a:ext>
             </a:extLst>
           </p:cNvPr>
@@ -2411,7 +2411,7 @@
           <p:cNvPr id="7" name="슬라이드 번호 개체 틀 6">
             <a:extLst>
               <a:ext uri="{FF2B5EF4-FFF2-40B4-BE49-F238E27FC236}">
-                <a16:creationId xmlns:a16="http://schemas.microsoft.com/office/drawing/2014/main" id="{54EF234A-D827-4E68-24D7-9E3FC0FBDA18}"/>
+                <a16:creationId xmlns:a16="http://schemas.microsoft.com/office/drawing/2014/main" id="{C9412AD3-5B85-A8BD-52C8-1AF559A47D18}"/>
               </a:ext>
             </a:extLst>
           </p:cNvPr>
@@ -2427,7 +2427,7 @@
           <a:bodyPr/>
           <a:lstStyle/>
           <a:p>
-            <a:fld id="{F8562357-FFAC-4DD4-994D-CC30F1B809D6}" type="slidenum">
+            <a:fld id="{B2A52879-9975-4A1A-B0EB-44F71CED55F9}" type="slidenum">
               <a:rPr lang="ko-KR" altLang="en-US" smtClean="0"/>
               <a:t>‹#›</a:t>
             </a:fld>
@@ -2438,7 +2438,7 @@
     </p:spTree>
     <p:extLst>
       <p:ext uri="{BB962C8B-B14F-4D97-AF65-F5344CB8AC3E}">
-        <p14:creationId xmlns:p14="http://schemas.microsoft.com/office/powerpoint/2010/main" val="3902401637"/>
+        <p14:creationId xmlns:p14="http://schemas.microsoft.com/office/powerpoint/2010/main" val="75225519"/>
       </p:ext>
     </p:extLst>
   </p:cSld>
@@ -2470,7 +2470,7 @@
           <p:cNvPr id="2" name="제목 1">
             <a:extLst>
               <a:ext uri="{FF2B5EF4-FFF2-40B4-BE49-F238E27FC236}">
-                <a16:creationId xmlns:a16="http://schemas.microsoft.com/office/drawing/2014/main" id="{5E26744A-AFB3-4382-FAD4-6E2FAA00F145}"/>
+                <a16:creationId xmlns:a16="http://schemas.microsoft.com/office/drawing/2014/main" id="{247C24E8-9623-BF5C-6BCC-1AFE0485A500}"/>
               </a:ext>
             </a:extLst>
           </p:cNvPr>
@@ -2507,7 +2507,7 @@
           <p:cNvPr id="3" name="그림 개체 틀 2">
             <a:extLst>
               <a:ext uri="{FF2B5EF4-FFF2-40B4-BE49-F238E27FC236}">
-                <a16:creationId xmlns:a16="http://schemas.microsoft.com/office/drawing/2014/main" id="{95A93FD3-D4E4-2C51-4994-53AE32FE0947}"/>
+                <a16:creationId xmlns:a16="http://schemas.microsoft.com/office/drawing/2014/main" id="{6184DF0E-B6B3-B23B-A012-EDB467D8BC93}"/>
               </a:ext>
             </a:extLst>
           </p:cNvPr>
@@ -2574,7 +2574,7 @@
           <p:cNvPr id="4" name="텍스트 개체 틀 3">
             <a:extLst>
               <a:ext uri="{FF2B5EF4-FFF2-40B4-BE49-F238E27FC236}">
-                <a16:creationId xmlns:a16="http://schemas.microsoft.com/office/drawing/2014/main" id="{BA6DF269-8145-9CC7-CFDB-77802117EA98}"/>
+                <a16:creationId xmlns:a16="http://schemas.microsoft.com/office/drawing/2014/main" id="{779D4DFF-10AA-7170-ACA1-2ACA9B4CE440}"/>
               </a:ext>
             </a:extLst>
           </p:cNvPr>
@@ -2645,7 +2645,7 @@
           <p:cNvPr id="5" name="날짜 개체 틀 4">
             <a:extLst>
               <a:ext uri="{FF2B5EF4-FFF2-40B4-BE49-F238E27FC236}">
-                <a16:creationId xmlns:a16="http://schemas.microsoft.com/office/drawing/2014/main" id="{62E19826-D6B0-AD0D-2F42-1AC720ACF85B}"/>
+                <a16:creationId xmlns:a16="http://schemas.microsoft.com/office/drawing/2014/main" id="{FFCDDFB9-4000-5E0B-C4FB-4D336CAF688F}"/>
               </a:ext>
             </a:extLst>
           </p:cNvPr>
@@ -2661,7 +2661,7 @@
           <a:bodyPr/>
           <a:lstStyle/>
           <a:p>
-            <a:fld id="{9742B1B7-23B9-44F4-B08E-E585703C19EC}" type="datetimeFigureOut">
+            <a:fld id="{32E9D3ED-3924-43EC-83E7-C21FD4BF3549}" type="datetimeFigureOut">
               <a:rPr lang="ko-KR" altLang="en-US" smtClean="0"/>
               <a:t>2026-06-19</a:t>
             </a:fld>
@@ -2674,7 +2674,7 @@
           <p:cNvPr id="6" name="바닥글 개체 틀 5">
             <a:extLst>
               <a:ext uri="{FF2B5EF4-FFF2-40B4-BE49-F238E27FC236}">
-                <a16:creationId xmlns:a16="http://schemas.microsoft.com/office/drawing/2014/main" id="{91AA7AFD-7712-D7BD-3620-D224C551E3A1}"/>
+                <a16:creationId xmlns:a16="http://schemas.microsoft.com/office/drawing/2014/main" id="{C6AD0C96-5097-0EE6-4691-5181B68ADEC2}"/>
               </a:ext>
             </a:extLst>
           </p:cNvPr>
@@ -2699,7 +2699,7 @@
           <p:cNvPr id="7" name="슬라이드 번호 개체 틀 6">
             <a:extLst>
               <a:ext uri="{FF2B5EF4-FFF2-40B4-BE49-F238E27FC236}">
-                <a16:creationId xmlns:a16="http://schemas.microsoft.com/office/drawing/2014/main" id="{5FADA503-B5CD-3545-2135-27F80DB59BAC}"/>
+                <a16:creationId xmlns:a16="http://schemas.microsoft.com/office/drawing/2014/main" id="{FBB33566-5DE5-0E14-839B-661F393F13BA}"/>
               </a:ext>
             </a:extLst>
           </p:cNvPr>
@@ -2715,7 +2715,7 @@
           <a:bodyPr/>
           <a:lstStyle/>
           <a:p>
-            <a:fld id="{F8562357-FFAC-4DD4-994D-CC30F1B809D6}" type="slidenum">
+            <a:fld id="{B2A52879-9975-4A1A-B0EB-44F71CED55F9}" type="slidenum">
               <a:rPr lang="ko-KR" altLang="en-US" smtClean="0"/>
               <a:t>‹#›</a:t>
             </a:fld>
@@ -2726,7 +2726,7 @@
     </p:spTree>
     <p:extLst>
       <p:ext uri="{BB962C8B-B14F-4D97-AF65-F5344CB8AC3E}">
-        <p14:creationId xmlns:p14="http://schemas.microsoft.com/office/powerpoint/2010/main" val="3238473450"/>
+        <p14:creationId xmlns:p14="http://schemas.microsoft.com/office/powerpoint/2010/main" val="1612417871"/>
       </p:ext>
     </p:extLst>
   </p:cSld>
@@ -2763,7 +2763,7 @@
           <p:cNvPr id="2" name="제목 개체 틀 1">
             <a:extLst>
               <a:ext uri="{FF2B5EF4-FFF2-40B4-BE49-F238E27FC236}">
-                <a16:creationId xmlns:a16="http://schemas.microsoft.com/office/drawing/2014/main" id="{8F0C6027-A167-F2A0-3ED9-3137EB593E0D}"/>
+                <a16:creationId xmlns:a16="http://schemas.microsoft.com/office/drawing/2014/main" id="{C26B3F69-A10B-A7D6-469E-11C65C567EF3}"/>
               </a:ext>
             </a:extLst>
           </p:cNvPr>
@@ -2801,7 +2801,7 @@
           <p:cNvPr id="3" name="텍스트 개체 틀 2">
             <a:extLst>
               <a:ext uri="{FF2B5EF4-FFF2-40B4-BE49-F238E27FC236}">
-                <a16:creationId xmlns:a16="http://schemas.microsoft.com/office/drawing/2014/main" id="{EFF4C8A0-C1BA-94E5-0F28-58A5E9CF9612}"/>
+                <a16:creationId xmlns:a16="http://schemas.microsoft.com/office/drawing/2014/main" id="{B5DB3DA8-A609-DA19-B83C-485B5C118209}"/>
               </a:ext>
             </a:extLst>
           </p:cNvPr>
@@ -2868,7 +2868,7 @@
           <p:cNvPr id="4" name="날짜 개체 틀 3">
             <a:extLst>
               <a:ext uri="{FF2B5EF4-FFF2-40B4-BE49-F238E27FC236}">
-                <a16:creationId xmlns:a16="http://schemas.microsoft.com/office/drawing/2014/main" id="{29BD0D54-8E14-DB6D-F5BA-54DA01DE19EC}"/>
+                <a16:creationId xmlns:a16="http://schemas.microsoft.com/office/drawing/2014/main" id="{91403004-9D5C-BEEA-F521-615AD6050867}"/>
               </a:ext>
             </a:extLst>
           </p:cNvPr>
@@ -2902,7 +2902,7 @@
             </a:lvl1pPr>
           </a:lstStyle>
           <a:p>
-            <a:fld id="{9742B1B7-23B9-44F4-B08E-E585703C19EC}" type="datetimeFigureOut">
+            <a:fld id="{32E9D3ED-3924-43EC-83E7-C21FD4BF3549}" type="datetimeFigureOut">
               <a:rPr lang="ko-KR" altLang="en-US" smtClean="0"/>
               <a:t>2026-06-19</a:t>
             </a:fld>
@@ -2915,7 +2915,7 @@
           <p:cNvPr id="5" name="바닥글 개체 틀 4">
             <a:extLst>
               <a:ext uri="{FF2B5EF4-FFF2-40B4-BE49-F238E27FC236}">
-                <a16:creationId xmlns:a16="http://schemas.microsoft.com/office/drawing/2014/main" id="{7E0DA922-CAD3-7C3B-A23A-069A475B5557}"/>
+                <a16:creationId xmlns:a16="http://schemas.microsoft.com/office/drawing/2014/main" id="{9D4C85E8-9111-DA6D-1C17-627439A1CCF7}"/>
               </a:ext>
             </a:extLst>
           </p:cNvPr>
@@ -2958,7 +2958,7 @@
           <p:cNvPr id="6" name="슬라이드 번호 개체 틀 5">
             <a:extLst>
               <a:ext uri="{FF2B5EF4-FFF2-40B4-BE49-F238E27FC236}">
-                <a16:creationId xmlns:a16="http://schemas.microsoft.com/office/drawing/2014/main" id="{174328F5-6D2F-8ACC-A635-8970A57EA3BF}"/>
+                <a16:creationId xmlns:a16="http://schemas.microsoft.com/office/drawing/2014/main" id="{D6417FE9-0F42-399A-D818-6529B73AC443}"/>
               </a:ext>
             </a:extLst>
           </p:cNvPr>
@@ -2992,7 +2992,7 @@
             </a:lvl1pPr>
           </a:lstStyle>
           <a:p>
-            <a:fld id="{F8562357-FFAC-4DD4-994D-CC30F1B809D6}" type="slidenum">
+            <a:fld id="{B2A52879-9975-4A1A-B0EB-44F71CED55F9}" type="slidenum">
               <a:rPr lang="ko-KR" altLang="en-US" smtClean="0"/>
               <a:t>‹#›</a:t>
             </a:fld>
@@ -3003,7 +3003,7 @@
     </p:spTree>
     <p:extLst>
       <p:ext uri="{BB962C8B-B14F-4D97-AF65-F5344CB8AC3E}">
-        <p14:creationId xmlns:p14="http://schemas.microsoft.com/office/powerpoint/2010/main" val="1013868154"/>
+        <p14:creationId xmlns:p14="http://schemas.microsoft.com/office/powerpoint/2010/main" val="2952433198"/>
       </p:ext>
     </p:extLst>
   </p:cSld>
@@ -3326,7 +3326,7 @@
           <p:cNvPr id="3" name="pipeline_overview_svg">
             <a:extLst>
               <a:ext uri="{FF2B5EF4-FFF2-40B4-BE49-F238E27FC236}">
-                <a16:creationId xmlns:a16="http://schemas.microsoft.com/office/drawing/2014/main" id="{E2CC43E6-31DD-B9DA-360B-035D0612CF8A}"/>
+                <a16:creationId xmlns:a16="http://schemas.microsoft.com/office/drawing/2014/main" id="{A5455E88-1C35-C545-2545-76C446D9382F}"/>
               </a:ext>
             </a:extLst>
           </p:cNvPr>
@@ -3367,7 +3367,7 @@
     </p:spTree>
     <p:extLst>
       <p:ext uri="{BB962C8B-B14F-4D97-AF65-F5344CB8AC3E}">
-        <p14:creationId xmlns:p14="http://schemas.microsoft.com/office/powerpoint/2010/main" val="3386420991"/>
+        <p14:creationId xmlns:p14="http://schemas.microsoft.com/office/powerpoint/2010/main" val="3972086654"/>
       </p:ext>
     </p:extLst>
   </p:cSld>

</xml_diff>

<commit_message>
Add infographic visual diversification seeds
</commit_message>
<xml_diff>
--- a/docs/assets/pipeline-overview.pptx
+++ b/docs/assets/pipeline-overview.pptx
@@ -129,7 +129,7 @@
           <p:cNvPr id="2" name="제목 1">
             <a:extLst>
               <a:ext uri="{FF2B5EF4-FFF2-40B4-BE49-F238E27FC236}">
-                <a16:creationId xmlns:a16="http://schemas.microsoft.com/office/drawing/2014/main" id="{DCC1611C-15F7-5F67-DF3B-86B3439FC93B}"/>
+                <a16:creationId xmlns:a16="http://schemas.microsoft.com/office/drawing/2014/main" id="{C5D7D315-AEDB-BEFD-F569-79F40F6ED46C}"/>
               </a:ext>
             </a:extLst>
           </p:cNvPr>
@@ -166,7 +166,7 @@
           <p:cNvPr id="3" name="부제목 2">
             <a:extLst>
               <a:ext uri="{FF2B5EF4-FFF2-40B4-BE49-F238E27FC236}">
-                <a16:creationId xmlns:a16="http://schemas.microsoft.com/office/drawing/2014/main" id="{1C8AF413-2A0D-BACF-F7C6-A1EE7900D0C8}"/>
+                <a16:creationId xmlns:a16="http://schemas.microsoft.com/office/drawing/2014/main" id="{374209C7-6833-CE12-A6FB-E3CB5A24E10E}"/>
               </a:ext>
             </a:extLst>
           </p:cNvPr>
@@ -236,7 +236,7 @@
           <p:cNvPr id="4" name="날짜 개체 틀 3">
             <a:extLst>
               <a:ext uri="{FF2B5EF4-FFF2-40B4-BE49-F238E27FC236}">
-                <a16:creationId xmlns:a16="http://schemas.microsoft.com/office/drawing/2014/main" id="{B43BD26B-E762-FC9D-1F8E-9D05BF36452F}"/>
+                <a16:creationId xmlns:a16="http://schemas.microsoft.com/office/drawing/2014/main" id="{74880A08-A2EF-B35B-B8D4-65577DABDF8A}"/>
               </a:ext>
             </a:extLst>
           </p:cNvPr>
@@ -252,7 +252,7 @@
           <a:bodyPr/>
           <a:lstStyle/>
           <a:p>
-            <a:fld id="{32E9D3ED-3924-43EC-83E7-C21FD4BF3549}" type="datetimeFigureOut">
+            <a:fld id="{7EE25133-7C67-4B9C-964D-BE920F85976E}" type="datetimeFigureOut">
               <a:rPr lang="ko-KR" altLang="en-US" smtClean="0"/>
               <a:t>2026-06-19</a:t>
             </a:fld>
@@ -265,7 +265,7 @@
           <p:cNvPr id="5" name="바닥글 개체 틀 4">
             <a:extLst>
               <a:ext uri="{FF2B5EF4-FFF2-40B4-BE49-F238E27FC236}">
-                <a16:creationId xmlns:a16="http://schemas.microsoft.com/office/drawing/2014/main" id="{83591421-6C87-C67F-ACA8-FC0EC9C9A8D6}"/>
+                <a16:creationId xmlns:a16="http://schemas.microsoft.com/office/drawing/2014/main" id="{955F1BC3-68AB-B0F9-9ADC-264390A0A3DB}"/>
               </a:ext>
             </a:extLst>
           </p:cNvPr>
@@ -290,7 +290,7 @@
           <p:cNvPr id="6" name="슬라이드 번호 개체 틀 5">
             <a:extLst>
               <a:ext uri="{FF2B5EF4-FFF2-40B4-BE49-F238E27FC236}">
-                <a16:creationId xmlns:a16="http://schemas.microsoft.com/office/drawing/2014/main" id="{CCC9ACC8-27BA-4C86-A020-D441F460B1CC}"/>
+                <a16:creationId xmlns:a16="http://schemas.microsoft.com/office/drawing/2014/main" id="{3281E0FF-F048-38FC-315B-25EEA900D179}"/>
               </a:ext>
             </a:extLst>
           </p:cNvPr>
@@ -306,7 +306,7 @@
           <a:bodyPr/>
           <a:lstStyle/>
           <a:p>
-            <a:fld id="{B2A52879-9975-4A1A-B0EB-44F71CED55F9}" type="slidenum">
+            <a:fld id="{E32915CC-3A59-4995-B4C4-64BB3C7A621C}" type="slidenum">
               <a:rPr lang="ko-KR" altLang="en-US" smtClean="0"/>
               <a:t>‹#›</a:t>
             </a:fld>
@@ -317,7 +317,7 @@
     </p:spTree>
     <p:extLst>
       <p:ext uri="{BB962C8B-B14F-4D97-AF65-F5344CB8AC3E}">
-        <p14:creationId xmlns:p14="http://schemas.microsoft.com/office/powerpoint/2010/main" val="3168411531"/>
+        <p14:creationId xmlns:p14="http://schemas.microsoft.com/office/powerpoint/2010/main" val="3317475513"/>
       </p:ext>
     </p:extLst>
   </p:cSld>
@@ -349,7 +349,7 @@
           <p:cNvPr id="2" name="제목 1">
             <a:extLst>
               <a:ext uri="{FF2B5EF4-FFF2-40B4-BE49-F238E27FC236}">
-                <a16:creationId xmlns:a16="http://schemas.microsoft.com/office/drawing/2014/main" id="{25067D16-905F-FDC1-652A-EE097BFE1D3A}"/>
+                <a16:creationId xmlns:a16="http://schemas.microsoft.com/office/drawing/2014/main" id="{6E4BF79A-5806-5D6D-2B5D-708B50158E46}"/>
               </a:ext>
             </a:extLst>
           </p:cNvPr>
@@ -377,7 +377,7 @@
           <p:cNvPr id="3" name="세로 텍스트 개체 틀 2">
             <a:extLst>
               <a:ext uri="{FF2B5EF4-FFF2-40B4-BE49-F238E27FC236}">
-                <a16:creationId xmlns:a16="http://schemas.microsoft.com/office/drawing/2014/main" id="{3B3059AA-0394-95AE-9517-BA58706D46FF}"/>
+                <a16:creationId xmlns:a16="http://schemas.microsoft.com/office/drawing/2014/main" id="{6BFF3E02-491A-B8A6-99EC-97D50B815693}"/>
               </a:ext>
             </a:extLst>
           </p:cNvPr>
@@ -434,7 +434,7 @@
           <p:cNvPr id="4" name="날짜 개체 틀 3">
             <a:extLst>
               <a:ext uri="{FF2B5EF4-FFF2-40B4-BE49-F238E27FC236}">
-                <a16:creationId xmlns:a16="http://schemas.microsoft.com/office/drawing/2014/main" id="{2240A1A1-957A-EF9C-B3B0-97E3FDB0E05F}"/>
+                <a16:creationId xmlns:a16="http://schemas.microsoft.com/office/drawing/2014/main" id="{DA8D75FE-D345-1C3D-9917-47B1361B5F5D}"/>
               </a:ext>
             </a:extLst>
           </p:cNvPr>
@@ -450,7 +450,7 @@
           <a:bodyPr/>
           <a:lstStyle/>
           <a:p>
-            <a:fld id="{32E9D3ED-3924-43EC-83E7-C21FD4BF3549}" type="datetimeFigureOut">
+            <a:fld id="{7EE25133-7C67-4B9C-964D-BE920F85976E}" type="datetimeFigureOut">
               <a:rPr lang="ko-KR" altLang="en-US" smtClean="0"/>
               <a:t>2026-06-19</a:t>
             </a:fld>
@@ -463,7 +463,7 @@
           <p:cNvPr id="5" name="바닥글 개체 틀 4">
             <a:extLst>
               <a:ext uri="{FF2B5EF4-FFF2-40B4-BE49-F238E27FC236}">
-                <a16:creationId xmlns:a16="http://schemas.microsoft.com/office/drawing/2014/main" id="{F31107C1-6E63-9F8F-A6F9-0CB77ECBB1AF}"/>
+                <a16:creationId xmlns:a16="http://schemas.microsoft.com/office/drawing/2014/main" id="{57905F91-5112-8222-F929-82488638464F}"/>
               </a:ext>
             </a:extLst>
           </p:cNvPr>
@@ -488,7 +488,7 @@
           <p:cNvPr id="6" name="슬라이드 번호 개체 틀 5">
             <a:extLst>
               <a:ext uri="{FF2B5EF4-FFF2-40B4-BE49-F238E27FC236}">
-                <a16:creationId xmlns:a16="http://schemas.microsoft.com/office/drawing/2014/main" id="{DCCBBC14-D4FB-A715-ACC2-5B2EBB20D7C7}"/>
+                <a16:creationId xmlns:a16="http://schemas.microsoft.com/office/drawing/2014/main" id="{A83CBBBA-852E-4761-42CC-9C73A6495222}"/>
               </a:ext>
             </a:extLst>
           </p:cNvPr>
@@ -504,7 +504,7 @@
           <a:bodyPr/>
           <a:lstStyle/>
           <a:p>
-            <a:fld id="{B2A52879-9975-4A1A-B0EB-44F71CED55F9}" type="slidenum">
+            <a:fld id="{E32915CC-3A59-4995-B4C4-64BB3C7A621C}" type="slidenum">
               <a:rPr lang="ko-KR" altLang="en-US" smtClean="0"/>
               <a:t>‹#›</a:t>
             </a:fld>
@@ -515,7 +515,7 @@
     </p:spTree>
     <p:extLst>
       <p:ext uri="{BB962C8B-B14F-4D97-AF65-F5344CB8AC3E}">
-        <p14:creationId xmlns:p14="http://schemas.microsoft.com/office/powerpoint/2010/main" val="1167010410"/>
+        <p14:creationId xmlns:p14="http://schemas.microsoft.com/office/powerpoint/2010/main" val="3138824147"/>
       </p:ext>
     </p:extLst>
   </p:cSld>
@@ -547,7 +547,7 @@
           <p:cNvPr id="2" name="세로 제목 1">
             <a:extLst>
               <a:ext uri="{FF2B5EF4-FFF2-40B4-BE49-F238E27FC236}">
-                <a16:creationId xmlns:a16="http://schemas.microsoft.com/office/drawing/2014/main" id="{451CD770-97B0-B91C-3FF6-B81853E48974}"/>
+                <a16:creationId xmlns:a16="http://schemas.microsoft.com/office/drawing/2014/main" id="{556B1F9C-BFC2-60E7-B70C-0DAC18D83B6B}"/>
               </a:ext>
             </a:extLst>
           </p:cNvPr>
@@ -580,7 +580,7 @@
           <p:cNvPr id="3" name="세로 텍스트 개체 틀 2">
             <a:extLst>
               <a:ext uri="{FF2B5EF4-FFF2-40B4-BE49-F238E27FC236}">
-                <a16:creationId xmlns:a16="http://schemas.microsoft.com/office/drawing/2014/main" id="{AF93FD98-4B33-C1DA-25A2-719763F7FC2F}"/>
+                <a16:creationId xmlns:a16="http://schemas.microsoft.com/office/drawing/2014/main" id="{90AB6B18-A8A4-79F2-ACAD-8F0A67F083B5}"/>
               </a:ext>
             </a:extLst>
           </p:cNvPr>
@@ -642,7 +642,7 @@
           <p:cNvPr id="4" name="날짜 개체 틀 3">
             <a:extLst>
               <a:ext uri="{FF2B5EF4-FFF2-40B4-BE49-F238E27FC236}">
-                <a16:creationId xmlns:a16="http://schemas.microsoft.com/office/drawing/2014/main" id="{D1386076-E026-7A40-CDAC-094FA055FF64}"/>
+                <a16:creationId xmlns:a16="http://schemas.microsoft.com/office/drawing/2014/main" id="{B83274B9-5A7E-994E-4704-F7D5E2FBBF6B}"/>
               </a:ext>
             </a:extLst>
           </p:cNvPr>
@@ -658,7 +658,7 @@
           <a:bodyPr/>
           <a:lstStyle/>
           <a:p>
-            <a:fld id="{32E9D3ED-3924-43EC-83E7-C21FD4BF3549}" type="datetimeFigureOut">
+            <a:fld id="{7EE25133-7C67-4B9C-964D-BE920F85976E}" type="datetimeFigureOut">
               <a:rPr lang="ko-KR" altLang="en-US" smtClean="0"/>
               <a:t>2026-06-19</a:t>
             </a:fld>
@@ -671,7 +671,7 @@
           <p:cNvPr id="5" name="바닥글 개체 틀 4">
             <a:extLst>
               <a:ext uri="{FF2B5EF4-FFF2-40B4-BE49-F238E27FC236}">
-                <a16:creationId xmlns:a16="http://schemas.microsoft.com/office/drawing/2014/main" id="{1480979F-6283-12E8-3D5F-9DE7DC7DCE6A}"/>
+                <a16:creationId xmlns:a16="http://schemas.microsoft.com/office/drawing/2014/main" id="{C41AE08D-7D44-8C64-6A8E-DD42C43145D1}"/>
               </a:ext>
             </a:extLst>
           </p:cNvPr>
@@ -696,7 +696,7 @@
           <p:cNvPr id="6" name="슬라이드 번호 개체 틀 5">
             <a:extLst>
               <a:ext uri="{FF2B5EF4-FFF2-40B4-BE49-F238E27FC236}">
-                <a16:creationId xmlns:a16="http://schemas.microsoft.com/office/drawing/2014/main" id="{04896C0C-FDE1-8E14-CABA-5A64479F1690}"/>
+                <a16:creationId xmlns:a16="http://schemas.microsoft.com/office/drawing/2014/main" id="{680C224E-F8D0-CC67-0602-C6CEA33AD3F1}"/>
               </a:ext>
             </a:extLst>
           </p:cNvPr>
@@ -712,7 +712,7 @@
           <a:bodyPr/>
           <a:lstStyle/>
           <a:p>
-            <a:fld id="{B2A52879-9975-4A1A-B0EB-44F71CED55F9}" type="slidenum">
+            <a:fld id="{E32915CC-3A59-4995-B4C4-64BB3C7A621C}" type="slidenum">
               <a:rPr lang="ko-KR" altLang="en-US" smtClean="0"/>
               <a:t>‹#›</a:t>
             </a:fld>
@@ -723,7 +723,7 @@
     </p:spTree>
     <p:extLst>
       <p:ext uri="{BB962C8B-B14F-4D97-AF65-F5344CB8AC3E}">
-        <p14:creationId xmlns:p14="http://schemas.microsoft.com/office/powerpoint/2010/main" val="233391226"/>
+        <p14:creationId xmlns:p14="http://schemas.microsoft.com/office/powerpoint/2010/main" val="570157091"/>
       </p:ext>
     </p:extLst>
   </p:cSld>
@@ -755,7 +755,7 @@
           <p:cNvPr id="2" name="제목 1">
             <a:extLst>
               <a:ext uri="{FF2B5EF4-FFF2-40B4-BE49-F238E27FC236}">
-                <a16:creationId xmlns:a16="http://schemas.microsoft.com/office/drawing/2014/main" id="{589D6503-C788-10D3-0C40-3A82CDDF03CB}"/>
+                <a16:creationId xmlns:a16="http://schemas.microsoft.com/office/drawing/2014/main" id="{6C35BECA-2FED-6AE8-B06B-9E5215D1AC65}"/>
               </a:ext>
             </a:extLst>
           </p:cNvPr>
@@ -783,7 +783,7 @@
           <p:cNvPr id="3" name="내용 개체 틀 2">
             <a:extLst>
               <a:ext uri="{FF2B5EF4-FFF2-40B4-BE49-F238E27FC236}">
-                <a16:creationId xmlns:a16="http://schemas.microsoft.com/office/drawing/2014/main" id="{605B7B7E-30C6-55A4-43F9-389DBD97F145}"/>
+                <a16:creationId xmlns:a16="http://schemas.microsoft.com/office/drawing/2014/main" id="{6D9AABEE-F2D7-3796-84B2-F670151DBCF5}"/>
               </a:ext>
             </a:extLst>
           </p:cNvPr>
@@ -840,7 +840,7 @@
           <p:cNvPr id="4" name="날짜 개체 틀 3">
             <a:extLst>
               <a:ext uri="{FF2B5EF4-FFF2-40B4-BE49-F238E27FC236}">
-                <a16:creationId xmlns:a16="http://schemas.microsoft.com/office/drawing/2014/main" id="{E4192613-03CC-D140-AB09-19877877EB17}"/>
+                <a16:creationId xmlns:a16="http://schemas.microsoft.com/office/drawing/2014/main" id="{973D81D6-C00C-4D28-5BB7-4235B8A37505}"/>
               </a:ext>
             </a:extLst>
           </p:cNvPr>
@@ -856,7 +856,7 @@
           <a:bodyPr/>
           <a:lstStyle/>
           <a:p>
-            <a:fld id="{32E9D3ED-3924-43EC-83E7-C21FD4BF3549}" type="datetimeFigureOut">
+            <a:fld id="{7EE25133-7C67-4B9C-964D-BE920F85976E}" type="datetimeFigureOut">
               <a:rPr lang="ko-KR" altLang="en-US" smtClean="0"/>
               <a:t>2026-06-19</a:t>
             </a:fld>
@@ -869,7 +869,7 @@
           <p:cNvPr id="5" name="바닥글 개체 틀 4">
             <a:extLst>
               <a:ext uri="{FF2B5EF4-FFF2-40B4-BE49-F238E27FC236}">
-                <a16:creationId xmlns:a16="http://schemas.microsoft.com/office/drawing/2014/main" id="{1B68FFB6-DAE5-0E82-4FF5-5222053C4B13}"/>
+                <a16:creationId xmlns:a16="http://schemas.microsoft.com/office/drawing/2014/main" id="{7FD28872-E25E-A45B-B9CA-67AB3CD95007}"/>
               </a:ext>
             </a:extLst>
           </p:cNvPr>
@@ -894,7 +894,7 @@
           <p:cNvPr id="6" name="슬라이드 번호 개체 틀 5">
             <a:extLst>
               <a:ext uri="{FF2B5EF4-FFF2-40B4-BE49-F238E27FC236}">
-                <a16:creationId xmlns:a16="http://schemas.microsoft.com/office/drawing/2014/main" id="{9F4ABEFC-56FD-78F4-CC5B-902EF6C69AD0}"/>
+                <a16:creationId xmlns:a16="http://schemas.microsoft.com/office/drawing/2014/main" id="{F154F78B-B73E-0461-23BA-347D0B41EF0C}"/>
               </a:ext>
             </a:extLst>
           </p:cNvPr>
@@ -910,7 +910,7 @@
           <a:bodyPr/>
           <a:lstStyle/>
           <a:p>
-            <a:fld id="{B2A52879-9975-4A1A-B0EB-44F71CED55F9}" type="slidenum">
+            <a:fld id="{E32915CC-3A59-4995-B4C4-64BB3C7A621C}" type="slidenum">
               <a:rPr lang="ko-KR" altLang="en-US" smtClean="0"/>
               <a:t>‹#›</a:t>
             </a:fld>
@@ -921,7 +921,7 @@
     </p:spTree>
     <p:extLst>
       <p:ext uri="{BB962C8B-B14F-4D97-AF65-F5344CB8AC3E}">
-        <p14:creationId xmlns:p14="http://schemas.microsoft.com/office/powerpoint/2010/main" val="3773079764"/>
+        <p14:creationId xmlns:p14="http://schemas.microsoft.com/office/powerpoint/2010/main" val="475470636"/>
       </p:ext>
     </p:extLst>
   </p:cSld>
@@ -953,7 +953,7 @@
           <p:cNvPr id="2" name="제목 1">
             <a:extLst>
               <a:ext uri="{FF2B5EF4-FFF2-40B4-BE49-F238E27FC236}">
-                <a16:creationId xmlns:a16="http://schemas.microsoft.com/office/drawing/2014/main" id="{54D464A3-43E8-F8EF-EBDA-666BB456C2A8}"/>
+                <a16:creationId xmlns:a16="http://schemas.microsoft.com/office/drawing/2014/main" id="{1234A649-36A5-0879-A7D8-229C8EC3F1AC}"/>
               </a:ext>
             </a:extLst>
           </p:cNvPr>
@@ -990,7 +990,7 @@
           <p:cNvPr id="3" name="텍스트 개체 틀 2">
             <a:extLst>
               <a:ext uri="{FF2B5EF4-FFF2-40B4-BE49-F238E27FC236}">
-                <a16:creationId xmlns:a16="http://schemas.microsoft.com/office/drawing/2014/main" id="{C2525960-D407-9947-8E10-42D29CD9086F}"/>
+                <a16:creationId xmlns:a16="http://schemas.microsoft.com/office/drawing/2014/main" id="{ED859CF7-4CE8-3C60-35E4-E1884B4F8615}"/>
               </a:ext>
             </a:extLst>
           </p:cNvPr>
@@ -1115,7 +1115,7 @@
           <p:cNvPr id="4" name="날짜 개체 틀 3">
             <a:extLst>
               <a:ext uri="{FF2B5EF4-FFF2-40B4-BE49-F238E27FC236}">
-                <a16:creationId xmlns:a16="http://schemas.microsoft.com/office/drawing/2014/main" id="{F5987A1A-0BBD-2650-3925-DF3816E0012F}"/>
+                <a16:creationId xmlns:a16="http://schemas.microsoft.com/office/drawing/2014/main" id="{81C4C790-BCD5-2438-0D63-1F6F339C1528}"/>
               </a:ext>
             </a:extLst>
           </p:cNvPr>
@@ -1131,7 +1131,7 @@
           <a:bodyPr/>
           <a:lstStyle/>
           <a:p>
-            <a:fld id="{32E9D3ED-3924-43EC-83E7-C21FD4BF3549}" type="datetimeFigureOut">
+            <a:fld id="{7EE25133-7C67-4B9C-964D-BE920F85976E}" type="datetimeFigureOut">
               <a:rPr lang="ko-KR" altLang="en-US" smtClean="0"/>
               <a:t>2026-06-19</a:t>
             </a:fld>
@@ -1144,7 +1144,7 @@
           <p:cNvPr id="5" name="바닥글 개체 틀 4">
             <a:extLst>
               <a:ext uri="{FF2B5EF4-FFF2-40B4-BE49-F238E27FC236}">
-                <a16:creationId xmlns:a16="http://schemas.microsoft.com/office/drawing/2014/main" id="{BA69636F-09D1-D1BB-C1E3-F47593721B0F}"/>
+                <a16:creationId xmlns:a16="http://schemas.microsoft.com/office/drawing/2014/main" id="{0E0E5211-2FE0-CD99-2E21-F546DDF413BA}"/>
               </a:ext>
             </a:extLst>
           </p:cNvPr>
@@ -1169,7 +1169,7 @@
           <p:cNvPr id="6" name="슬라이드 번호 개체 틀 5">
             <a:extLst>
               <a:ext uri="{FF2B5EF4-FFF2-40B4-BE49-F238E27FC236}">
-                <a16:creationId xmlns:a16="http://schemas.microsoft.com/office/drawing/2014/main" id="{F61211D7-E980-2712-3B49-D938BA51A200}"/>
+                <a16:creationId xmlns:a16="http://schemas.microsoft.com/office/drawing/2014/main" id="{0E85BA3D-2681-1933-F53E-2EEF1CFD480D}"/>
               </a:ext>
             </a:extLst>
           </p:cNvPr>
@@ -1185,7 +1185,7 @@
           <a:bodyPr/>
           <a:lstStyle/>
           <a:p>
-            <a:fld id="{B2A52879-9975-4A1A-B0EB-44F71CED55F9}" type="slidenum">
+            <a:fld id="{E32915CC-3A59-4995-B4C4-64BB3C7A621C}" type="slidenum">
               <a:rPr lang="ko-KR" altLang="en-US" smtClean="0"/>
               <a:t>‹#›</a:t>
             </a:fld>
@@ -1196,7 +1196,7 @@
     </p:spTree>
     <p:extLst>
       <p:ext uri="{BB962C8B-B14F-4D97-AF65-F5344CB8AC3E}">
-        <p14:creationId xmlns:p14="http://schemas.microsoft.com/office/powerpoint/2010/main" val="3572135615"/>
+        <p14:creationId xmlns:p14="http://schemas.microsoft.com/office/powerpoint/2010/main" val="3209500888"/>
       </p:ext>
     </p:extLst>
   </p:cSld>
@@ -1228,7 +1228,7 @@
           <p:cNvPr id="2" name="제목 1">
             <a:extLst>
               <a:ext uri="{FF2B5EF4-FFF2-40B4-BE49-F238E27FC236}">
-                <a16:creationId xmlns:a16="http://schemas.microsoft.com/office/drawing/2014/main" id="{89FCCAB2-B841-C654-4733-F08B7C1A4C04}"/>
+                <a16:creationId xmlns:a16="http://schemas.microsoft.com/office/drawing/2014/main" id="{2BA2E317-76AD-D7D9-835E-70FF97499B26}"/>
               </a:ext>
             </a:extLst>
           </p:cNvPr>
@@ -1256,7 +1256,7 @@
           <p:cNvPr id="3" name="내용 개체 틀 2">
             <a:extLst>
               <a:ext uri="{FF2B5EF4-FFF2-40B4-BE49-F238E27FC236}">
-                <a16:creationId xmlns:a16="http://schemas.microsoft.com/office/drawing/2014/main" id="{AC79019F-D677-A46A-9C3D-897B7E7D120F}"/>
+                <a16:creationId xmlns:a16="http://schemas.microsoft.com/office/drawing/2014/main" id="{90DC6957-5AD0-A41E-DBD0-D70C61CAB86C}"/>
               </a:ext>
             </a:extLst>
           </p:cNvPr>
@@ -1318,7 +1318,7 @@
           <p:cNvPr id="4" name="내용 개체 틀 3">
             <a:extLst>
               <a:ext uri="{FF2B5EF4-FFF2-40B4-BE49-F238E27FC236}">
-                <a16:creationId xmlns:a16="http://schemas.microsoft.com/office/drawing/2014/main" id="{81811814-BE88-325F-A146-02A6EF38FC2E}"/>
+                <a16:creationId xmlns:a16="http://schemas.microsoft.com/office/drawing/2014/main" id="{ACECBC05-DEE5-3B68-F476-F7AFFCCC5A13}"/>
               </a:ext>
             </a:extLst>
           </p:cNvPr>
@@ -1380,7 +1380,7 @@
           <p:cNvPr id="5" name="날짜 개체 틀 4">
             <a:extLst>
               <a:ext uri="{FF2B5EF4-FFF2-40B4-BE49-F238E27FC236}">
-                <a16:creationId xmlns:a16="http://schemas.microsoft.com/office/drawing/2014/main" id="{BAC48594-9F08-4281-17B0-CD28C9CB6708}"/>
+                <a16:creationId xmlns:a16="http://schemas.microsoft.com/office/drawing/2014/main" id="{32DF9B79-826B-2B1C-E60B-D43C8FC64C42}"/>
               </a:ext>
             </a:extLst>
           </p:cNvPr>
@@ -1396,7 +1396,7 @@
           <a:bodyPr/>
           <a:lstStyle/>
           <a:p>
-            <a:fld id="{32E9D3ED-3924-43EC-83E7-C21FD4BF3549}" type="datetimeFigureOut">
+            <a:fld id="{7EE25133-7C67-4B9C-964D-BE920F85976E}" type="datetimeFigureOut">
               <a:rPr lang="ko-KR" altLang="en-US" smtClean="0"/>
               <a:t>2026-06-19</a:t>
             </a:fld>
@@ -1409,7 +1409,7 @@
           <p:cNvPr id="6" name="바닥글 개체 틀 5">
             <a:extLst>
               <a:ext uri="{FF2B5EF4-FFF2-40B4-BE49-F238E27FC236}">
-                <a16:creationId xmlns:a16="http://schemas.microsoft.com/office/drawing/2014/main" id="{50DF7391-31E1-7B26-8FDF-362B5C36CBD4}"/>
+                <a16:creationId xmlns:a16="http://schemas.microsoft.com/office/drawing/2014/main" id="{26C8A4FF-672D-2658-C8C4-6F152DE38788}"/>
               </a:ext>
             </a:extLst>
           </p:cNvPr>
@@ -1434,7 +1434,7 @@
           <p:cNvPr id="7" name="슬라이드 번호 개체 틀 6">
             <a:extLst>
               <a:ext uri="{FF2B5EF4-FFF2-40B4-BE49-F238E27FC236}">
-                <a16:creationId xmlns:a16="http://schemas.microsoft.com/office/drawing/2014/main" id="{D0726E63-BCA0-E822-850E-8E9E76051284}"/>
+                <a16:creationId xmlns:a16="http://schemas.microsoft.com/office/drawing/2014/main" id="{15AB099B-6836-D3EC-7441-F74EC9831F30}"/>
               </a:ext>
             </a:extLst>
           </p:cNvPr>
@@ -1450,7 +1450,7 @@
           <a:bodyPr/>
           <a:lstStyle/>
           <a:p>
-            <a:fld id="{B2A52879-9975-4A1A-B0EB-44F71CED55F9}" type="slidenum">
+            <a:fld id="{E32915CC-3A59-4995-B4C4-64BB3C7A621C}" type="slidenum">
               <a:rPr lang="ko-KR" altLang="en-US" smtClean="0"/>
               <a:t>‹#›</a:t>
             </a:fld>
@@ -1461,7 +1461,7 @@
     </p:spTree>
     <p:extLst>
       <p:ext uri="{BB962C8B-B14F-4D97-AF65-F5344CB8AC3E}">
-        <p14:creationId xmlns:p14="http://schemas.microsoft.com/office/powerpoint/2010/main" val="2690139098"/>
+        <p14:creationId xmlns:p14="http://schemas.microsoft.com/office/powerpoint/2010/main" val="3213069937"/>
       </p:ext>
     </p:extLst>
   </p:cSld>
@@ -1493,7 +1493,7 @@
           <p:cNvPr id="2" name="제목 1">
             <a:extLst>
               <a:ext uri="{FF2B5EF4-FFF2-40B4-BE49-F238E27FC236}">
-                <a16:creationId xmlns:a16="http://schemas.microsoft.com/office/drawing/2014/main" id="{F6EA6644-78AE-764B-81D1-80F83B150C7E}"/>
+                <a16:creationId xmlns:a16="http://schemas.microsoft.com/office/drawing/2014/main" id="{C92D3886-FE6D-936A-E5BC-35F75FBE2EB1}"/>
               </a:ext>
             </a:extLst>
           </p:cNvPr>
@@ -1526,7 +1526,7 @@
           <p:cNvPr id="3" name="텍스트 개체 틀 2">
             <a:extLst>
               <a:ext uri="{FF2B5EF4-FFF2-40B4-BE49-F238E27FC236}">
-                <a16:creationId xmlns:a16="http://schemas.microsoft.com/office/drawing/2014/main" id="{112BA49E-0210-66B0-68BE-940F1490B958}"/>
+                <a16:creationId xmlns:a16="http://schemas.microsoft.com/office/drawing/2014/main" id="{BF06EDE2-0CBD-2A97-DD2C-5A92413CBA86}"/>
               </a:ext>
             </a:extLst>
           </p:cNvPr>
@@ -1597,7 +1597,7 @@
           <p:cNvPr id="4" name="내용 개체 틀 3">
             <a:extLst>
               <a:ext uri="{FF2B5EF4-FFF2-40B4-BE49-F238E27FC236}">
-                <a16:creationId xmlns:a16="http://schemas.microsoft.com/office/drawing/2014/main" id="{8A05A4F4-6011-E313-4936-9AF6D8258DB4}"/>
+                <a16:creationId xmlns:a16="http://schemas.microsoft.com/office/drawing/2014/main" id="{483C695A-B020-9995-7D94-FD6F5AF09689}"/>
               </a:ext>
             </a:extLst>
           </p:cNvPr>
@@ -1659,7 +1659,7 @@
           <p:cNvPr id="5" name="텍스트 개체 틀 4">
             <a:extLst>
               <a:ext uri="{FF2B5EF4-FFF2-40B4-BE49-F238E27FC236}">
-                <a16:creationId xmlns:a16="http://schemas.microsoft.com/office/drawing/2014/main" id="{767DCDEE-2F1D-8518-C203-FCE0D6B96FC1}"/>
+                <a16:creationId xmlns:a16="http://schemas.microsoft.com/office/drawing/2014/main" id="{E5F86B00-25A7-6F0D-1060-5604BCE0B9C1}"/>
               </a:ext>
             </a:extLst>
           </p:cNvPr>
@@ -1730,7 +1730,7 @@
           <p:cNvPr id="6" name="내용 개체 틀 5">
             <a:extLst>
               <a:ext uri="{FF2B5EF4-FFF2-40B4-BE49-F238E27FC236}">
-                <a16:creationId xmlns:a16="http://schemas.microsoft.com/office/drawing/2014/main" id="{3E527D70-79B1-026C-E493-949081143217}"/>
+                <a16:creationId xmlns:a16="http://schemas.microsoft.com/office/drawing/2014/main" id="{45A9833D-5885-D23F-7EAC-13B506533932}"/>
               </a:ext>
             </a:extLst>
           </p:cNvPr>
@@ -1792,7 +1792,7 @@
           <p:cNvPr id="7" name="날짜 개체 틀 6">
             <a:extLst>
               <a:ext uri="{FF2B5EF4-FFF2-40B4-BE49-F238E27FC236}">
-                <a16:creationId xmlns:a16="http://schemas.microsoft.com/office/drawing/2014/main" id="{0F97775F-FD1D-9C2C-5503-3D591A0A724A}"/>
+                <a16:creationId xmlns:a16="http://schemas.microsoft.com/office/drawing/2014/main" id="{579A0705-6744-DCA0-BCBF-04F197D84C49}"/>
               </a:ext>
             </a:extLst>
           </p:cNvPr>
@@ -1808,7 +1808,7 @@
           <a:bodyPr/>
           <a:lstStyle/>
           <a:p>
-            <a:fld id="{32E9D3ED-3924-43EC-83E7-C21FD4BF3549}" type="datetimeFigureOut">
+            <a:fld id="{7EE25133-7C67-4B9C-964D-BE920F85976E}" type="datetimeFigureOut">
               <a:rPr lang="ko-KR" altLang="en-US" smtClean="0"/>
               <a:t>2026-06-19</a:t>
             </a:fld>
@@ -1821,7 +1821,7 @@
           <p:cNvPr id="8" name="바닥글 개체 틀 7">
             <a:extLst>
               <a:ext uri="{FF2B5EF4-FFF2-40B4-BE49-F238E27FC236}">
-                <a16:creationId xmlns:a16="http://schemas.microsoft.com/office/drawing/2014/main" id="{D61119DA-4109-17D1-5383-DF948BC42DBA}"/>
+                <a16:creationId xmlns:a16="http://schemas.microsoft.com/office/drawing/2014/main" id="{400154ED-A3A8-3E2C-3CEC-E1CB2444CA77}"/>
               </a:ext>
             </a:extLst>
           </p:cNvPr>
@@ -1846,7 +1846,7 @@
           <p:cNvPr id="9" name="슬라이드 번호 개체 틀 8">
             <a:extLst>
               <a:ext uri="{FF2B5EF4-FFF2-40B4-BE49-F238E27FC236}">
-                <a16:creationId xmlns:a16="http://schemas.microsoft.com/office/drawing/2014/main" id="{2E209097-0721-AB27-2287-E01688F40F15}"/>
+                <a16:creationId xmlns:a16="http://schemas.microsoft.com/office/drawing/2014/main" id="{EBCE2CB8-4C44-1DD2-371D-055DB29D603C}"/>
               </a:ext>
             </a:extLst>
           </p:cNvPr>
@@ -1862,7 +1862,7 @@
           <a:bodyPr/>
           <a:lstStyle/>
           <a:p>
-            <a:fld id="{B2A52879-9975-4A1A-B0EB-44F71CED55F9}" type="slidenum">
+            <a:fld id="{E32915CC-3A59-4995-B4C4-64BB3C7A621C}" type="slidenum">
               <a:rPr lang="ko-KR" altLang="en-US" smtClean="0"/>
               <a:t>‹#›</a:t>
             </a:fld>
@@ -1873,7 +1873,7 @@
     </p:spTree>
     <p:extLst>
       <p:ext uri="{BB962C8B-B14F-4D97-AF65-F5344CB8AC3E}">
-        <p14:creationId xmlns:p14="http://schemas.microsoft.com/office/powerpoint/2010/main" val="3749077625"/>
+        <p14:creationId xmlns:p14="http://schemas.microsoft.com/office/powerpoint/2010/main" val="2111898779"/>
       </p:ext>
     </p:extLst>
   </p:cSld>
@@ -1905,7 +1905,7 @@
           <p:cNvPr id="2" name="제목 1">
             <a:extLst>
               <a:ext uri="{FF2B5EF4-FFF2-40B4-BE49-F238E27FC236}">
-                <a16:creationId xmlns:a16="http://schemas.microsoft.com/office/drawing/2014/main" id="{45C42F6A-4465-360F-599E-E3C69DE39E38}"/>
+                <a16:creationId xmlns:a16="http://schemas.microsoft.com/office/drawing/2014/main" id="{C55F5279-1CE2-D0A4-32E2-03EEA28587A6}"/>
               </a:ext>
             </a:extLst>
           </p:cNvPr>
@@ -1933,7 +1933,7 @@
           <p:cNvPr id="3" name="날짜 개체 틀 2">
             <a:extLst>
               <a:ext uri="{FF2B5EF4-FFF2-40B4-BE49-F238E27FC236}">
-                <a16:creationId xmlns:a16="http://schemas.microsoft.com/office/drawing/2014/main" id="{84A0740B-4C7E-C0FB-EA10-66AFD07BD917}"/>
+                <a16:creationId xmlns:a16="http://schemas.microsoft.com/office/drawing/2014/main" id="{B4B47737-A6BA-E821-1F4B-2E4E74E4E2D4}"/>
               </a:ext>
             </a:extLst>
           </p:cNvPr>
@@ -1949,7 +1949,7 @@
           <a:bodyPr/>
           <a:lstStyle/>
           <a:p>
-            <a:fld id="{32E9D3ED-3924-43EC-83E7-C21FD4BF3549}" type="datetimeFigureOut">
+            <a:fld id="{7EE25133-7C67-4B9C-964D-BE920F85976E}" type="datetimeFigureOut">
               <a:rPr lang="ko-KR" altLang="en-US" smtClean="0"/>
               <a:t>2026-06-19</a:t>
             </a:fld>
@@ -1962,7 +1962,7 @@
           <p:cNvPr id="4" name="바닥글 개체 틀 3">
             <a:extLst>
               <a:ext uri="{FF2B5EF4-FFF2-40B4-BE49-F238E27FC236}">
-                <a16:creationId xmlns:a16="http://schemas.microsoft.com/office/drawing/2014/main" id="{CEE3802B-FCF2-7D37-FAE0-7ED942144703}"/>
+                <a16:creationId xmlns:a16="http://schemas.microsoft.com/office/drawing/2014/main" id="{ED51A51D-1BB3-D7CC-4830-2F93247D7A63}"/>
               </a:ext>
             </a:extLst>
           </p:cNvPr>
@@ -1987,7 +1987,7 @@
           <p:cNvPr id="5" name="슬라이드 번호 개체 틀 4">
             <a:extLst>
               <a:ext uri="{FF2B5EF4-FFF2-40B4-BE49-F238E27FC236}">
-                <a16:creationId xmlns:a16="http://schemas.microsoft.com/office/drawing/2014/main" id="{8D35EB3C-4B02-72D1-ABDC-8740A336F33B}"/>
+                <a16:creationId xmlns:a16="http://schemas.microsoft.com/office/drawing/2014/main" id="{8A641A5F-EF30-8DCE-F163-2BC046631685}"/>
               </a:ext>
             </a:extLst>
           </p:cNvPr>
@@ -2003,7 +2003,7 @@
           <a:bodyPr/>
           <a:lstStyle/>
           <a:p>
-            <a:fld id="{B2A52879-9975-4A1A-B0EB-44F71CED55F9}" type="slidenum">
+            <a:fld id="{E32915CC-3A59-4995-B4C4-64BB3C7A621C}" type="slidenum">
               <a:rPr lang="ko-KR" altLang="en-US" smtClean="0"/>
               <a:t>‹#›</a:t>
             </a:fld>
@@ -2014,7 +2014,7 @@
     </p:spTree>
     <p:extLst>
       <p:ext uri="{BB962C8B-B14F-4D97-AF65-F5344CB8AC3E}">
-        <p14:creationId xmlns:p14="http://schemas.microsoft.com/office/powerpoint/2010/main" val="1415121809"/>
+        <p14:creationId xmlns:p14="http://schemas.microsoft.com/office/powerpoint/2010/main" val="2164459870"/>
       </p:ext>
     </p:extLst>
   </p:cSld>
@@ -2046,7 +2046,7 @@
           <p:cNvPr id="2" name="날짜 개체 틀 1">
             <a:extLst>
               <a:ext uri="{FF2B5EF4-FFF2-40B4-BE49-F238E27FC236}">
-                <a16:creationId xmlns:a16="http://schemas.microsoft.com/office/drawing/2014/main" id="{C2008B1D-59F0-D39D-0FC7-138DAB3DCB3F}"/>
+                <a16:creationId xmlns:a16="http://schemas.microsoft.com/office/drawing/2014/main" id="{426CC934-AA4A-F5DC-B313-4B95510FEA33}"/>
               </a:ext>
             </a:extLst>
           </p:cNvPr>
@@ -2062,7 +2062,7 @@
           <a:bodyPr/>
           <a:lstStyle/>
           <a:p>
-            <a:fld id="{32E9D3ED-3924-43EC-83E7-C21FD4BF3549}" type="datetimeFigureOut">
+            <a:fld id="{7EE25133-7C67-4B9C-964D-BE920F85976E}" type="datetimeFigureOut">
               <a:rPr lang="ko-KR" altLang="en-US" smtClean="0"/>
               <a:t>2026-06-19</a:t>
             </a:fld>
@@ -2075,7 +2075,7 @@
           <p:cNvPr id="3" name="바닥글 개체 틀 2">
             <a:extLst>
               <a:ext uri="{FF2B5EF4-FFF2-40B4-BE49-F238E27FC236}">
-                <a16:creationId xmlns:a16="http://schemas.microsoft.com/office/drawing/2014/main" id="{9AE4D93F-E3C5-4460-3B75-D3C2C36D1BB7}"/>
+                <a16:creationId xmlns:a16="http://schemas.microsoft.com/office/drawing/2014/main" id="{0167C87B-5FCD-7FAF-AA28-AC4FAC02ECA9}"/>
               </a:ext>
             </a:extLst>
           </p:cNvPr>
@@ -2100,7 +2100,7 @@
           <p:cNvPr id="4" name="슬라이드 번호 개체 틀 3">
             <a:extLst>
               <a:ext uri="{FF2B5EF4-FFF2-40B4-BE49-F238E27FC236}">
-                <a16:creationId xmlns:a16="http://schemas.microsoft.com/office/drawing/2014/main" id="{B963EAEF-8698-CD1D-96F6-04A3E16F8D67}"/>
+                <a16:creationId xmlns:a16="http://schemas.microsoft.com/office/drawing/2014/main" id="{654377B9-1F1F-A746-E50C-852865DB737D}"/>
               </a:ext>
             </a:extLst>
           </p:cNvPr>
@@ -2116,7 +2116,7 @@
           <a:bodyPr/>
           <a:lstStyle/>
           <a:p>
-            <a:fld id="{B2A52879-9975-4A1A-B0EB-44F71CED55F9}" type="slidenum">
+            <a:fld id="{E32915CC-3A59-4995-B4C4-64BB3C7A621C}" type="slidenum">
               <a:rPr lang="ko-KR" altLang="en-US" smtClean="0"/>
               <a:t>‹#›</a:t>
             </a:fld>
@@ -2127,7 +2127,7 @@
     </p:spTree>
     <p:extLst>
       <p:ext uri="{BB962C8B-B14F-4D97-AF65-F5344CB8AC3E}">
-        <p14:creationId xmlns:p14="http://schemas.microsoft.com/office/powerpoint/2010/main" val="1066348018"/>
+        <p14:creationId xmlns:p14="http://schemas.microsoft.com/office/powerpoint/2010/main" val="1369021746"/>
       </p:ext>
     </p:extLst>
   </p:cSld>
@@ -2159,7 +2159,7 @@
           <p:cNvPr id="2" name="제목 1">
             <a:extLst>
               <a:ext uri="{FF2B5EF4-FFF2-40B4-BE49-F238E27FC236}">
-                <a16:creationId xmlns:a16="http://schemas.microsoft.com/office/drawing/2014/main" id="{5242F898-3A85-6FED-DDDA-13BDA086C8E1}"/>
+                <a16:creationId xmlns:a16="http://schemas.microsoft.com/office/drawing/2014/main" id="{712E029D-80A6-23DE-3748-625DE067FF04}"/>
               </a:ext>
             </a:extLst>
           </p:cNvPr>
@@ -2196,7 +2196,7 @@
           <p:cNvPr id="3" name="내용 개체 틀 2">
             <a:extLst>
               <a:ext uri="{FF2B5EF4-FFF2-40B4-BE49-F238E27FC236}">
-                <a16:creationId xmlns:a16="http://schemas.microsoft.com/office/drawing/2014/main" id="{E9BC631C-DDBB-AE59-0AED-74A4A2873713}"/>
+                <a16:creationId xmlns:a16="http://schemas.microsoft.com/office/drawing/2014/main" id="{98EE3ADB-2164-21F7-BB8C-89FC345BCD38}"/>
               </a:ext>
             </a:extLst>
           </p:cNvPr>
@@ -2286,7 +2286,7 @@
           <p:cNvPr id="4" name="텍스트 개체 틀 3">
             <a:extLst>
               <a:ext uri="{FF2B5EF4-FFF2-40B4-BE49-F238E27FC236}">
-                <a16:creationId xmlns:a16="http://schemas.microsoft.com/office/drawing/2014/main" id="{1A037752-BA9A-B991-FE75-23B756270285}"/>
+                <a16:creationId xmlns:a16="http://schemas.microsoft.com/office/drawing/2014/main" id="{F3C9ABD8-A8DA-8915-C05D-33B125EA7EA1}"/>
               </a:ext>
             </a:extLst>
           </p:cNvPr>
@@ -2357,7 +2357,7 @@
           <p:cNvPr id="5" name="날짜 개체 틀 4">
             <a:extLst>
               <a:ext uri="{FF2B5EF4-FFF2-40B4-BE49-F238E27FC236}">
-                <a16:creationId xmlns:a16="http://schemas.microsoft.com/office/drawing/2014/main" id="{6CF3DB0A-C234-65FC-81C3-D18C005EEFF1}"/>
+                <a16:creationId xmlns:a16="http://schemas.microsoft.com/office/drawing/2014/main" id="{4B82A752-E4B6-3EB6-5EB5-E186F951BE6B}"/>
               </a:ext>
             </a:extLst>
           </p:cNvPr>
@@ -2373,7 +2373,7 @@
           <a:bodyPr/>
           <a:lstStyle/>
           <a:p>
-            <a:fld id="{32E9D3ED-3924-43EC-83E7-C21FD4BF3549}" type="datetimeFigureOut">
+            <a:fld id="{7EE25133-7C67-4B9C-964D-BE920F85976E}" type="datetimeFigureOut">
               <a:rPr lang="ko-KR" altLang="en-US" smtClean="0"/>
               <a:t>2026-06-19</a:t>
             </a:fld>
@@ -2386,7 +2386,7 @@
           <p:cNvPr id="6" name="바닥글 개체 틀 5">
             <a:extLst>
               <a:ext uri="{FF2B5EF4-FFF2-40B4-BE49-F238E27FC236}">
-                <a16:creationId xmlns:a16="http://schemas.microsoft.com/office/drawing/2014/main" id="{CF895922-57D8-9A19-F7A2-308A1CFDB881}"/>
+                <a16:creationId xmlns:a16="http://schemas.microsoft.com/office/drawing/2014/main" id="{CD80DE11-297A-AA35-E1F3-DF55F33832E2}"/>
               </a:ext>
             </a:extLst>
           </p:cNvPr>
@@ -2411,7 +2411,7 @@
           <p:cNvPr id="7" name="슬라이드 번호 개체 틀 6">
             <a:extLst>
               <a:ext uri="{FF2B5EF4-FFF2-40B4-BE49-F238E27FC236}">
-                <a16:creationId xmlns:a16="http://schemas.microsoft.com/office/drawing/2014/main" id="{C9412AD3-5B85-A8BD-52C8-1AF559A47D18}"/>
+                <a16:creationId xmlns:a16="http://schemas.microsoft.com/office/drawing/2014/main" id="{6A6D3DFF-B84B-06D2-C3CB-8A62090B2262}"/>
               </a:ext>
             </a:extLst>
           </p:cNvPr>
@@ -2427,7 +2427,7 @@
           <a:bodyPr/>
           <a:lstStyle/>
           <a:p>
-            <a:fld id="{B2A52879-9975-4A1A-B0EB-44F71CED55F9}" type="slidenum">
+            <a:fld id="{E32915CC-3A59-4995-B4C4-64BB3C7A621C}" type="slidenum">
               <a:rPr lang="ko-KR" altLang="en-US" smtClean="0"/>
               <a:t>‹#›</a:t>
             </a:fld>
@@ -2438,7 +2438,7 @@
     </p:spTree>
     <p:extLst>
       <p:ext uri="{BB962C8B-B14F-4D97-AF65-F5344CB8AC3E}">
-        <p14:creationId xmlns:p14="http://schemas.microsoft.com/office/powerpoint/2010/main" val="75225519"/>
+        <p14:creationId xmlns:p14="http://schemas.microsoft.com/office/powerpoint/2010/main" val="79493632"/>
       </p:ext>
     </p:extLst>
   </p:cSld>
@@ -2470,7 +2470,7 @@
           <p:cNvPr id="2" name="제목 1">
             <a:extLst>
               <a:ext uri="{FF2B5EF4-FFF2-40B4-BE49-F238E27FC236}">
-                <a16:creationId xmlns:a16="http://schemas.microsoft.com/office/drawing/2014/main" id="{247C24E8-9623-BF5C-6BCC-1AFE0485A500}"/>
+                <a16:creationId xmlns:a16="http://schemas.microsoft.com/office/drawing/2014/main" id="{66B1DF66-A8F4-0F38-3F77-CB0C38188D0D}"/>
               </a:ext>
             </a:extLst>
           </p:cNvPr>
@@ -2507,7 +2507,7 @@
           <p:cNvPr id="3" name="그림 개체 틀 2">
             <a:extLst>
               <a:ext uri="{FF2B5EF4-FFF2-40B4-BE49-F238E27FC236}">
-                <a16:creationId xmlns:a16="http://schemas.microsoft.com/office/drawing/2014/main" id="{6184DF0E-B6B3-B23B-A012-EDB467D8BC93}"/>
+                <a16:creationId xmlns:a16="http://schemas.microsoft.com/office/drawing/2014/main" id="{77A4514A-A6DD-6EA6-220C-4B5B4E2DB33C}"/>
               </a:ext>
             </a:extLst>
           </p:cNvPr>
@@ -2574,7 +2574,7 @@
           <p:cNvPr id="4" name="텍스트 개체 틀 3">
             <a:extLst>
               <a:ext uri="{FF2B5EF4-FFF2-40B4-BE49-F238E27FC236}">
-                <a16:creationId xmlns:a16="http://schemas.microsoft.com/office/drawing/2014/main" id="{779D4DFF-10AA-7170-ACA1-2ACA9B4CE440}"/>
+                <a16:creationId xmlns:a16="http://schemas.microsoft.com/office/drawing/2014/main" id="{391B2250-5695-8735-7A31-25B286C4B5DD}"/>
               </a:ext>
             </a:extLst>
           </p:cNvPr>
@@ -2645,7 +2645,7 @@
           <p:cNvPr id="5" name="날짜 개체 틀 4">
             <a:extLst>
               <a:ext uri="{FF2B5EF4-FFF2-40B4-BE49-F238E27FC236}">
-                <a16:creationId xmlns:a16="http://schemas.microsoft.com/office/drawing/2014/main" id="{FFCDDFB9-4000-5E0B-C4FB-4D336CAF688F}"/>
+                <a16:creationId xmlns:a16="http://schemas.microsoft.com/office/drawing/2014/main" id="{06EF8FBD-F216-2E7C-7EC9-934FF3BC9D31}"/>
               </a:ext>
             </a:extLst>
           </p:cNvPr>
@@ -2661,7 +2661,7 @@
           <a:bodyPr/>
           <a:lstStyle/>
           <a:p>
-            <a:fld id="{32E9D3ED-3924-43EC-83E7-C21FD4BF3549}" type="datetimeFigureOut">
+            <a:fld id="{7EE25133-7C67-4B9C-964D-BE920F85976E}" type="datetimeFigureOut">
               <a:rPr lang="ko-KR" altLang="en-US" smtClean="0"/>
               <a:t>2026-06-19</a:t>
             </a:fld>
@@ -2674,7 +2674,7 @@
           <p:cNvPr id="6" name="바닥글 개체 틀 5">
             <a:extLst>
               <a:ext uri="{FF2B5EF4-FFF2-40B4-BE49-F238E27FC236}">
-                <a16:creationId xmlns:a16="http://schemas.microsoft.com/office/drawing/2014/main" id="{C6AD0C96-5097-0EE6-4691-5181B68ADEC2}"/>
+                <a16:creationId xmlns:a16="http://schemas.microsoft.com/office/drawing/2014/main" id="{5BBB2050-31F2-A8EF-BB3B-F61D07AF8A2C}"/>
               </a:ext>
             </a:extLst>
           </p:cNvPr>
@@ -2699,7 +2699,7 @@
           <p:cNvPr id="7" name="슬라이드 번호 개체 틀 6">
             <a:extLst>
               <a:ext uri="{FF2B5EF4-FFF2-40B4-BE49-F238E27FC236}">
-                <a16:creationId xmlns:a16="http://schemas.microsoft.com/office/drawing/2014/main" id="{FBB33566-5DE5-0E14-839B-661F393F13BA}"/>
+                <a16:creationId xmlns:a16="http://schemas.microsoft.com/office/drawing/2014/main" id="{D419CA00-6A1B-9F78-7E93-63458D22EE5A}"/>
               </a:ext>
             </a:extLst>
           </p:cNvPr>
@@ -2715,7 +2715,7 @@
           <a:bodyPr/>
           <a:lstStyle/>
           <a:p>
-            <a:fld id="{B2A52879-9975-4A1A-B0EB-44F71CED55F9}" type="slidenum">
+            <a:fld id="{E32915CC-3A59-4995-B4C4-64BB3C7A621C}" type="slidenum">
               <a:rPr lang="ko-KR" altLang="en-US" smtClean="0"/>
               <a:t>‹#›</a:t>
             </a:fld>
@@ -2726,7 +2726,7 @@
     </p:spTree>
     <p:extLst>
       <p:ext uri="{BB962C8B-B14F-4D97-AF65-F5344CB8AC3E}">
-        <p14:creationId xmlns:p14="http://schemas.microsoft.com/office/powerpoint/2010/main" val="1612417871"/>
+        <p14:creationId xmlns:p14="http://schemas.microsoft.com/office/powerpoint/2010/main" val="1119381078"/>
       </p:ext>
     </p:extLst>
   </p:cSld>
@@ -2763,7 +2763,7 @@
           <p:cNvPr id="2" name="제목 개체 틀 1">
             <a:extLst>
               <a:ext uri="{FF2B5EF4-FFF2-40B4-BE49-F238E27FC236}">
-                <a16:creationId xmlns:a16="http://schemas.microsoft.com/office/drawing/2014/main" id="{C26B3F69-A10B-A7D6-469E-11C65C567EF3}"/>
+                <a16:creationId xmlns:a16="http://schemas.microsoft.com/office/drawing/2014/main" id="{F9D8940C-E1FD-5EB0-22E7-65D5AA2E0BBA}"/>
               </a:ext>
             </a:extLst>
           </p:cNvPr>
@@ -2801,7 +2801,7 @@
           <p:cNvPr id="3" name="텍스트 개체 틀 2">
             <a:extLst>
               <a:ext uri="{FF2B5EF4-FFF2-40B4-BE49-F238E27FC236}">
-                <a16:creationId xmlns:a16="http://schemas.microsoft.com/office/drawing/2014/main" id="{B5DB3DA8-A609-DA19-B83C-485B5C118209}"/>
+                <a16:creationId xmlns:a16="http://schemas.microsoft.com/office/drawing/2014/main" id="{E10AFA42-3657-AF47-8711-8612A0E21112}"/>
               </a:ext>
             </a:extLst>
           </p:cNvPr>
@@ -2868,7 +2868,7 @@
           <p:cNvPr id="4" name="날짜 개체 틀 3">
             <a:extLst>
               <a:ext uri="{FF2B5EF4-FFF2-40B4-BE49-F238E27FC236}">
-                <a16:creationId xmlns:a16="http://schemas.microsoft.com/office/drawing/2014/main" id="{91403004-9D5C-BEEA-F521-615AD6050867}"/>
+                <a16:creationId xmlns:a16="http://schemas.microsoft.com/office/drawing/2014/main" id="{F3850C16-DF2A-85EB-A814-4CC72C4C8A4C}"/>
               </a:ext>
             </a:extLst>
           </p:cNvPr>
@@ -2902,7 +2902,7 @@
             </a:lvl1pPr>
           </a:lstStyle>
           <a:p>
-            <a:fld id="{32E9D3ED-3924-43EC-83E7-C21FD4BF3549}" type="datetimeFigureOut">
+            <a:fld id="{7EE25133-7C67-4B9C-964D-BE920F85976E}" type="datetimeFigureOut">
               <a:rPr lang="ko-KR" altLang="en-US" smtClean="0"/>
               <a:t>2026-06-19</a:t>
             </a:fld>
@@ -2915,7 +2915,7 @@
           <p:cNvPr id="5" name="바닥글 개체 틀 4">
             <a:extLst>
               <a:ext uri="{FF2B5EF4-FFF2-40B4-BE49-F238E27FC236}">
-                <a16:creationId xmlns:a16="http://schemas.microsoft.com/office/drawing/2014/main" id="{9D4C85E8-9111-DA6D-1C17-627439A1CCF7}"/>
+                <a16:creationId xmlns:a16="http://schemas.microsoft.com/office/drawing/2014/main" id="{6CB35ED9-FA55-5676-587B-AD6591E4FB0C}"/>
               </a:ext>
             </a:extLst>
           </p:cNvPr>
@@ -2958,7 +2958,7 @@
           <p:cNvPr id="6" name="슬라이드 번호 개체 틀 5">
             <a:extLst>
               <a:ext uri="{FF2B5EF4-FFF2-40B4-BE49-F238E27FC236}">
-                <a16:creationId xmlns:a16="http://schemas.microsoft.com/office/drawing/2014/main" id="{D6417FE9-0F42-399A-D818-6529B73AC443}"/>
+                <a16:creationId xmlns:a16="http://schemas.microsoft.com/office/drawing/2014/main" id="{E639EFD2-94D1-939A-6609-8C48FF2E3CE4}"/>
               </a:ext>
             </a:extLst>
           </p:cNvPr>
@@ -2992,7 +2992,7 @@
             </a:lvl1pPr>
           </a:lstStyle>
           <a:p>
-            <a:fld id="{B2A52879-9975-4A1A-B0EB-44F71CED55F9}" type="slidenum">
+            <a:fld id="{E32915CC-3A59-4995-B4C4-64BB3C7A621C}" type="slidenum">
               <a:rPr lang="ko-KR" altLang="en-US" smtClean="0"/>
               <a:t>‹#›</a:t>
             </a:fld>
@@ -3003,7 +3003,7 @@
     </p:spTree>
     <p:extLst>
       <p:ext uri="{BB962C8B-B14F-4D97-AF65-F5344CB8AC3E}">
-        <p14:creationId xmlns:p14="http://schemas.microsoft.com/office/powerpoint/2010/main" val="2952433198"/>
+        <p14:creationId xmlns:p14="http://schemas.microsoft.com/office/powerpoint/2010/main" val="3305464509"/>
       </p:ext>
     </p:extLst>
   </p:cSld>
@@ -3326,7 +3326,7 @@
           <p:cNvPr id="3" name="pipeline_overview_svg">
             <a:extLst>
               <a:ext uri="{FF2B5EF4-FFF2-40B4-BE49-F238E27FC236}">
-                <a16:creationId xmlns:a16="http://schemas.microsoft.com/office/drawing/2014/main" id="{A5455E88-1C35-C545-2545-76C446D9382F}"/>
+                <a16:creationId xmlns:a16="http://schemas.microsoft.com/office/drawing/2014/main" id="{06616A3E-9B8B-E2B3-BF21-7625A04BACD6}"/>
               </a:ext>
             </a:extLst>
           </p:cNvPr>
@@ -3367,7 +3367,7 @@
     </p:spTree>
     <p:extLst>
       <p:ext uri="{BB962C8B-B14F-4D97-AF65-F5344CB8AC3E}">
-        <p14:creationId xmlns:p14="http://schemas.microsoft.com/office/powerpoint/2010/main" val="3972086654"/>
+        <p14:creationId xmlns:p14="http://schemas.microsoft.com/office/powerpoint/2010/main" val="2613319376"/>
       </p:ext>
     </p:extLst>
   </p:cSld>

</xml_diff>

<commit_message>
Refresh MDPR pipeline overview asset
</commit_message>
<xml_diff>
--- a/docs/assets/pipeline-overview.pptx
+++ b/docs/assets/pipeline-overview.pptx
@@ -129,7 +129,7 @@
           <p:cNvPr id="2" name="제목 1">
             <a:extLst>
               <a:ext uri="{FF2B5EF4-FFF2-40B4-BE49-F238E27FC236}">
-                <a16:creationId xmlns:a16="http://schemas.microsoft.com/office/drawing/2014/main" id="{2FBA2AFE-3941-81EC-158F-06E887711673}"/>
+                <a16:creationId xmlns:a16="http://schemas.microsoft.com/office/drawing/2014/main" id="{8088D0CE-628C-97FF-9378-93A47BBB64BA}"/>
               </a:ext>
             </a:extLst>
           </p:cNvPr>
@@ -166,7 +166,7 @@
           <p:cNvPr id="3" name="부제목 2">
             <a:extLst>
               <a:ext uri="{FF2B5EF4-FFF2-40B4-BE49-F238E27FC236}">
-                <a16:creationId xmlns:a16="http://schemas.microsoft.com/office/drawing/2014/main" id="{44B6CA54-E401-BFB8-211E-EDB9EF132171}"/>
+                <a16:creationId xmlns:a16="http://schemas.microsoft.com/office/drawing/2014/main" id="{68445BB9-3E60-330B-9477-18457D8E2516}"/>
               </a:ext>
             </a:extLst>
           </p:cNvPr>
@@ -236,7 +236,7 @@
           <p:cNvPr id="4" name="날짜 개체 틀 3">
             <a:extLst>
               <a:ext uri="{FF2B5EF4-FFF2-40B4-BE49-F238E27FC236}">
-                <a16:creationId xmlns:a16="http://schemas.microsoft.com/office/drawing/2014/main" id="{6B5C7A79-9C06-3CCE-2186-F38D9B61E110}"/>
+                <a16:creationId xmlns:a16="http://schemas.microsoft.com/office/drawing/2014/main" id="{12F6F056-6CB4-7CDB-7501-19A7C69BE9FB}"/>
               </a:ext>
             </a:extLst>
           </p:cNvPr>
@@ -252,9 +252,9 @@
           <a:bodyPr/>
           <a:lstStyle/>
           <a:p>
-            <a:fld id="{0345C9D7-F6C7-4C02-9146-8B76B3D130D1}" type="datetimeFigureOut">
+            <a:fld id="{EA81C09F-EDF6-4DBB-A73F-92F9C5F671FF}" type="datetimeFigureOut">
               <a:rPr lang="ko-KR" altLang="en-US" smtClean="0"/>
-              <a:t>2026-06-19</a:t>
+              <a:t>2026-06-20</a:t>
             </a:fld>
             <a:endParaRPr lang="ko-KR" altLang="en-US"/>
           </a:p>
@@ -265,7 +265,7 @@
           <p:cNvPr id="5" name="바닥글 개체 틀 4">
             <a:extLst>
               <a:ext uri="{FF2B5EF4-FFF2-40B4-BE49-F238E27FC236}">
-                <a16:creationId xmlns:a16="http://schemas.microsoft.com/office/drawing/2014/main" id="{FD58D382-9693-FB47-4764-488C54DDF732}"/>
+                <a16:creationId xmlns:a16="http://schemas.microsoft.com/office/drawing/2014/main" id="{636C5BD6-066D-1933-7117-51DA9C76A725}"/>
               </a:ext>
             </a:extLst>
           </p:cNvPr>
@@ -290,7 +290,7 @@
           <p:cNvPr id="6" name="슬라이드 번호 개체 틀 5">
             <a:extLst>
               <a:ext uri="{FF2B5EF4-FFF2-40B4-BE49-F238E27FC236}">
-                <a16:creationId xmlns:a16="http://schemas.microsoft.com/office/drawing/2014/main" id="{8EF2EF55-D411-7F66-1AB2-853B24C44337}"/>
+                <a16:creationId xmlns:a16="http://schemas.microsoft.com/office/drawing/2014/main" id="{1A6B9F51-AF03-DDB8-4840-A72100AAB9FC}"/>
               </a:ext>
             </a:extLst>
           </p:cNvPr>
@@ -306,7 +306,7 @@
           <a:bodyPr/>
           <a:lstStyle/>
           <a:p>
-            <a:fld id="{A1E2397E-EA6D-4E64-8CFF-2304B77E2C8B}" type="slidenum">
+            <a:fld id="{B4193615-8533-47CD-8C7D-DF261FCA69FC}" type="slidenum">
               <a:rPr lang="ko-KR" altLang="en-US" smtClean="0"/>
               <a:t>‹#›</a:t>
             </a:fld>
@@ -317,7 +317,7 @@
     </p:spTree>
     <p:extLst>
       <p:ext uri="{BB962C8B-B14F-4D97-AF65-F5344CB8AC3E}">
-        <p14:creationId xmlns:p14="http://schemas.microsoft.com/office/powerpoint/2010/main" val="3529398161"/>
+        <p14:creationId xmlns:p14="http://schemas.microsoft.com/office/powerpoint/2010/main" val="1317684259"/>
       </p:ext>
     </p:extLst>
   </p:cSld>
@@ -349,7 +349,7 @@
           <p:cNvPr id="2" name="제목 1">
             <a:extLst>
               <a:ext uri="{FF2B5EF4-FFF2-40B4-BE49-F238E27FC236}">
-                <a16:creationId xmlns:a16="http://schemas.microsoft.com/office/drawing/2014/main" id="{AD78F011-2E78-EB9A-2EC3-578EB7C852B1}"/>
+                <a16:creationId xmlns:a16="http://schemas.microsoft.com/office/drawing/2014/main" id="{62608C1C-5A8E-4567-4660-EF293D181B17}"/>
               </a:ext>
             </a:extLst>
           </p:cNvPr>
@@ -377,7 +377,7 @@
           <p:cNvPr id="3" name="세로 텍스트 개체 틀 2">
             <a:extLst>
               <a:ext uri="{FF2B5EF4-FFF2-40B4-BE49-F238E27FC236}">
-                <a16:creationId xmlns:a16="http://schemas.microsoft.com/office/drawing/2014/main" id="{A4374D09-BB79-964B-E829-5B78C12C9033}"/>
+                <a16:creationId xmlns:a16="http://schemas.microsoft.com/office/drawing/2014/main" id="{911ED10A-98C2-F31D-9DC3-F85207884957}"/>
               </a:ext>
             </a:extLst>
           </p:cNvPr>
@@ -434,7 +434,7 @@
           <p:cNvPr id="4" name="날짜 개체 틀 3">
             <a:extLst>
               <a:ext uri="{FF2B5EF4-FFF2-40B4-BE49-F238E27FC236}">
-                <a16:creationId xmlns:a16="http://schemas.microsoft.com/office/drawing/2014/main" id="{A6234DAD-18DC-3C6C-6024-E8464695F042}"/>
+                <a16:creationId xmlns:a16="http://schemas.microsoft.com/office/drawing/2014/main" id="{946FCAD2-6338-8925-CAEC-CFD405924F66}"/>
               </a:ext>
             </a:extLst>
           </p:cNvPr>
@@ -450,9 +450,9 @@
           <a:bodyPr/>
           <a:lstStyle/>
           <a:p>
-            <a:fld id="{0345C9D7-F6C7-4C02-9146-8B76B3D130D1}" type="datetimeFigureOut">
+            <a:fld id="{EA81C09F-EDF6-4DBB-A73F-92F9C5F671FF}" type="datetimeFigureOut">
               <a:rPr lang="ko-KR" altLang="en-US" smtClean="0"/>
-              <a:t>2026-06-19</a:t>
+              <a:t>2026-06-20</a:t>
             </a:fld>
             <a:endParaRPr lang="ko-KR" altLang="en-US"/>
           </a:p>
@@ -463,7 +463,7 @@
           <p:cNvPr id="5" name="바닥글 개체 틀 4">
             <a:extLst>
               <a:ext uri="{FF2B5EF4-FFF2-40B4-BE49-F238E27FC236}">
-                <a16:creationId xmlns:a16="http://schemas.microsoft.com/office/drawing/2014/main" id="{694F392D-7E00-86D3-3438-6A4D5FA23BE2}"/>
+                <a16:creationId xmlns:a16="http://schemas.microsoft.com/office/drawing/2014/main" id="{8C1F6D4A-CC0A-1458-BAFE-EFFC1819A3E6}"/>
               </a:ext>
             </a:extLst>
           </p:cNvPr>
@@ -488,7 +488,7 @@
           <p:cNvPr id="6" name="슬라이드 번호 개체 틀 5">
             <a:extLst>
               <a:ext uri="{FF2B5EF4-FFF2-40B4-BE49-F238E27FC236}">
-                <a16:creationId xmlns:a16="http://schemas.microsoft.com/office/drawing/2014/main" id="{5FA1A1DF-663B-CD67-E729-94A85955E32C}"/>
+                <a16:creationId xmlns:a16="http://schemas.microsoft.com/office/drawing/2014/main" id="{878F61AE-FE10-A116-48AB-870531371448}"/>
               </a:ext>
             </a:extLst>
           </p:cNvPr>
@@ -504,7 +504,7 @@
           <a:bodyPr/>
           <a:lstStyle/>
           <a:p>
-            <a:fld id="{A1E2397E-EA6D-4E64-8CFF-2304B77E2C8B}" type="slidenum">
+            <a:fld id="{B4193615-8533-47CD-8C7D-DF261FCA69FC}" type="slidenum">
               <a:rPr lang="ko-KR" altLang="en-US" smtClean="0"/>
               <a:t>‹#›</a:t>
             </a:fld>
@@ -515,7 +515,7 @@
     </p:spTree>
     <p:extLst>
       <p:ext uri="{BB962C8B-B14F-4D97-AF65-F5344CB8AC3E}">
-        <p14:creationId xmlns:p14="http://schemas.microsoft.com/office/powerpoint/2010/main" val="830753336"/>
+        <p14:creationId xmlns:p14="http://schemas.microsoft.com/office/powerpoint/2010/main" val="3052387748"/>
       </p:ext>
     </p:extLst>
   </p:cSld>
@@ -547,7 +547,7 @@
           <p:cNvPr id="2" name="세로 제목 1">
             <a:extLst>
               <a:ext uri="{FF2B5EF4-FFF2-40B4-BE49-F238E27FC236}">
-                <a16:creationId xmlns:a16="http://schemas.microsoft.com/office/drawing/2014/main" id="{290222F9-2FFD-A33C-721E-4AFB54A89600}"/>
+                <a16:creationId xmlns:a16="http://schemas.microsoft.com/office/drawing/2014/main" id="{1CB78D35-0528-ED2B-374F-2BC475711F9E}"/>
               </a:ext>
             </a:extLst>
           </p:cNvPr>
@@ -580,7 +580,7 @@
           <p:cNvPr id="3" name="세로 텍스트 개체 틀 2">
             <a:extLst>
               <a:ext uri="{FF2B5EF4-FFF2-40B4-BE49-F238E27FC236}">
-                <a16:creationId xmlns:a16="http://schemas.microsoft.com/office/drawing/2014/main" id="{540E7115-FBC9-9951-BB7A-CB0A75ADA3D0}"/>
+                <a16:creationId xmlns:a16="http://schemas.microsoft.com/office/drawing/2014/main" id="{A1F988CF-F49B-9BC9-D759-78E2B79CA7DA}"/>
               </a:ext>
             </a:extLst>
           </p:cNvPr>
@@ -642,7 +642,7 @@
           <p:cNvPr id="4" name="날짜 개체 틀 3">
             <a:extLst>
               <a:ext uri="{FF2B5EF4-FFF2-40B4-BE49-F238E27FC236}">
-                <a16:creationId xmlns:a16="http://schemas.microsoft.com/office/drawing/2014/main" id="{9FE973CD-835A-0723-FBA8-C8546DFFE1AE}"/>
+                <a16:creationId xmlns:a16="http://schemas.microsoft.com/office/drawing/2014/main" id="{948BB609-9296-7771-434C-031D5AEE76A8}"/>
               </a:ext>
             </a:extLst>
           </p:cNvPr>
@@ -658,9 +658,9 @@
           <a:bodyPr/>
           <a:lstStyle/>
           <a:p>
-            <a:fld id="{0345C9D7-F6C7-4C02-9146-8B76B3D130D1}" type="datetimeFigureOut">
+            <a:fld id="{EA81C09F-EDF6-4DBB-A73F-92F9C5F671FF}" type="datetimeFigureOut">
               <a:rPr lang="ko-KR" altLang="en-US" smtClean="0"/>
-              <a:t>2026-06-19</a:t>
+              <a:t>2026-06-20</a:t>
             </a:fld>
             <a:endParaRPr lang="ko-KR" altLang="en-US"/>
           </a:p>
@@ -671,7 +671,7 @@
           <p:cNvPr id="5" name="바닥글 개체 틀 4">
             <a:extLst>
               <a:ext uri="{FF2B5EF4-FFF2-40B4-BE49-F238E27FC236}">
-                <a16:creationId xmlns:a16="http://schemas.microsoft.com/office/drawing/2014/main" id="{7F028A7F-51E2-97A7-7552-4040DC2E36AE}"/>
+                <a16:creationId xmlns:a16="http://schemas.microsoft.com/office/drawing/2014/main" id="{FCB2063C-C406-BE19-C469-FFAAC94DBDAE}"/>
               </a:ext>
             </a:extLst>
           </p:cNvPr>
@@ -696,7 +696,7 @@
           <p:cNvPr id="6" name="슬라이드 번호 개체 틀 5">
             <a:extLst>
               <a:ext uri="{FF2B5EF4-FFF2-40B4-BE49-F238E27FC236}">
-                <a16:creationId xmlns:a16="http://schemas.microsoft.com/office/drawing/2014/main" id="{0744B7C6-1639-92BC-911C-9B0D2AB29DC7}"/>
+                <a16:creationId xmlns:a16="http://schemas.microsoft.com/office/drawing/2014/main" id="{04AB00F5-C3D9-D4A9-8126-97994BD46AD8}"/>
               </a:ext>
             </a:extLst>
           </p:cNvPr>
@@ -712,7 +712,7 @@
           <a:bodyPr/>
           <a:lstStyle/>
           <a:p>
-            <a:fld id="{A1E2397E-EA6D-4E64-8CFF-2304B77E2C8B}" type="slidenum">
+            <a:fld id="{B4193615-8533-47CD-8C7D-DF261FCA69FC}" type="slidenum">
               <a:rPr lang="ko-KR" altLang="en-US" smtClean="0"/>
               <a:t>‹#›</a:t>
             </a:fld>
@@ -723,7 +723,7 @@
     </p:spTree>
     <p:extLst>
       <p:ext uri="{BB962C8B-B14F-4D97-AF65-F5344CB8AC3E}">
-        <p14:creationId xmlns:p14="http://schemas.microsoft.com/office/powerpoint/2010/main" val="2421538055"/>
+        <p14:creationId xmlns:p14="http://schemas.microsoft.com/office/powerpoint/2010/main" val="2909763206"/>
       </p:ext>
     </p:extLst>
   </p:cSld>
@@ -755,7 +755,7 @@
           <p:cNvPr id="2" name="제목 1">
             <a:extLst>
               <a:ext uri="{FF2B5EF4-FFF2-40B4-BE49-F238E27FC236}">
-                <a16:creationId xmlns:a16="http://schemas.microsoft.com/office/drawing/2014/main" id="{33C094B5-6978-12D7-F9F9-F4EA202FA222}"/>
+                <a16:creationId xmlns:a16="http://schemas.microsoft.com/office/drawing/2014/main" id="{3F6E509E-731F-AAA9-3A1D-81A3BB7AF27F}"/>
               </a:ext>
             </a:extLst>
           </p:cNvPr>
@@ -783,7 +783,7 @@
           <p:cNvPr id="3" name="내용 개체 틀 2">
             <a:extLst>
               <a:ext uri="{FF2B5EF4-FFF2-40B4-BE49-F238E27FC236}">
-                <a16:creationId xmlns:a16="http://schemas.microsoft.com/office/drawing/2014/main" id="{697859E6-1F56-57D0-53F2-4C0C60383630}"/>
+                <a16:creationId xmlns:a16="http://schemas.microsoft.com/office/drawing/2014/main" id="{95C6A175-22CF-C6FE-EC5D-9D5EE215299C}"/>
               </a:ext>
             </a:extLst>
           </p:cNvPr>
@@ -840,7 +840,7 @@
           <p:cNvPr id="4" name="날짜 개체 틀 3">
             <a:extLst>
               <a:ext uri="{FF2B5EF4-FFF2-40B4-BE49-F238E27FC236}">
-                <a16:creationId xmlns:a16="http://schemas.microsoft.com/office/drawing/2014/main" id="{BD4E2AE4-8A94-E740-10A1-6D5B7632FE25}"/>
+                <a16:creationId xmlns:a16="http://schemas.microsoft.com/office/drawing/2014/main" id="{82816839-0152-5E47-4C99-0F6347993EA9}"/>
               </a:ext>
             </a:extLst>
           </p:cNvPr>
@@ -856,9 +856,9 @@
           <a:bodyPr/>
           <a:lstStyle/>
           <a:p>
-            <a:fld id="{0345C9D7-F6C7-4C02-9146-8B76B3D130D1}" type="datetimeFigureOut">
+            <a:fld id="{EA81C09F-EDF6-4DBB-A73F-92F9C5F671FF}" type="datetimeFigureOut">
               <a:rPr lang="ko-KR" altLang="en-US" smtClean="0"/>
-              <a:t>2026-06-19</a:t>
+              <a:t>2026-06-20</a:t>
             </a:fld>
             <a:endParaRPr lang="ko-KR" altLang="en-US"/>
           </a:p>
@@ -869,7 +869,7 @@
           <p:cNvPr id="5" name="바닥글 개체 틀 4">
             <a:extLst>
               <a:ext uri="{FF2B5EF4-FFF2-40B4-BE49-F238E27FC236}">
-                <a16:creationId xmlns:a16="http://schemas.microsoft.com/office/drawing/2014/main" id="{D973487F-6609-2907-DCDC-36737205631D}"/>
+                <a16:creationId xmlns:a16="http://schemas.microsoft.com/office/drawing/2014/main" id="{EF683680-BAAA-5E52-DACE-0F0C961EBD26}"/>
               </a:ext>
             </a:extLst>
           </p:cNvPr>
@@ -894,7 +894,7 @@
           <p:cNvPr id="6" name="슬라이드 번호 개체 틀 5">
             <a:extLst>
               <a:ext uri="{FF2B5EF4-FFF2-40B4-BE49-F238E27FC236}">
-                <a16:creationId xmlns:a16="http://schemas.microsoft.com/office/drawing/2014/main" id="{702DEC0A-AF63-0385-9ED9-8AC2F5F56EE1}"/>
+                <a16:creationId xmlns:a16="http://schemas.microsoft.com/office/drawing/2014/main" id="{CEC5F623-38C1-1E34-4EF9-344E38A4AD78}"/>
               </a:ext>
             </a:extLst>
           </p:cNvPr>
@@ -910,7 +910,7 @@
           <a:bodyPr/>
           <a:lstStyle/>
           <a:p>
-            <a:fld id="{A1E2397E-EA6D-4E64-8CFF-2304B77E2C8B}" type="slidenum">
+            <a:fld id="{B4193615-8533-47CD-8C7D-DF261FCA69FC}" type="slidenum">
               <a:rPr lang="ko-KR" altLang="en-US" smtClean="0"/>
               <a:t>‹#›</a:t>
             </a:fld>
@@ -921,7 +921,7 @@
     </p:spTree>
     <p:extLst>
       <p:ext uri="{BB962C8B-B14F-4D97-AF65-F5344CB8AC3E}">
-        <p14:creationId xmlns:p14="http://schemas.microsoft.com/office/powerpoint/2010/main" val="475070656"/>
+        <p14:creationId xmlns:p14="http://schemas.microsoft.com/office/powerpoint/2010/main" val="895526711"/>
       </p:ext>
     </p:extLst>
   </p:cSld>
@@ -953,7 +953,7 @@
           <p:cNvPr id="2" name="제목 1">
             <a:extLst>
               <a:ext uri="{FF2B5EF4-FFF2-40B4-BE49-F238E27FC236}">
-                <a16:creationId xmlns:a16="http://schemas.microsoft.com/office/drawing/2014/main" id="{308C2F76-E36B-BD94-57DF-E30F88EE4D20}"/>
+                <a16:creationId xmlns:a16="http://schemas.microsoft.com/office/drawing/2014/main" id="{0C535F45-0DA9-7F48-43F3-1803B7CCBF47}"/>
               </a:ext>
             </a:extLst>
           </p:cNvPr>
@@ -990,7 +990,7 @@
           <p:cNvPr id="3" name="텍스트 개체 틀 2">
             <a:extLst>
               <a:ext uri="{FF2B5EF4-FFF2-40B4-BE49-F238E27FC236}">
-                <a16:creationId xmlns:a16="http://schemas.microsoft.com/office/drawing/2014/main" id="{378DDB1B-F4D6-DD91-12AA-215C21AA744B}"/>
+                <a16:creationId xmlns:a16="http://schemas.microsoft.com/office/drawing/2014/main" id="{AFE40358-8A42-9FC6-2917-B18736A4C3F1}"/>
               </a:ext>
             </a:extLst>
           </p:cNvPr>
@@ -1115,7 +1115,7 @@
           <p:cNvPr id="4" name="날짜 개체 틀 3">
             <a:extLst>
               <a:ext uri="{FF2B5EF4-FFF2-40B4-BE49-F238E27FC236}">
-                <a16:creationId xmlns:a16="http://schemas.microsoft.com/office/drawing/2014/main" id="{4F86CBCE-1353-2EC3-12E4-BFE5D26312A2}"/>
+                <a16:creationId xmlns:a16="http://schemas.microsoft.com/office/drawing/2014/main" id="{C0F394CB-CECA-6EEB-B31A-390E093573F3}"/>
               </a:ext>
             </a:extLst>
           </p:cNvPr>
@@ -1131,9 +1131,9 @@
           <a:bodyPr/>
           <a:lstStyle/>
           <a:p>
-            <a:fld id="{0345C9D7-F6C7-4C02-9146-8B76B3D130D1}" type="datetimeFigureOut">
+            <a:fld id="{EA81C09F-EDF6-4DBB-A73F-92F9C5F671FF}" type="datetimeFigureOut">
               <a:rPr lang="ko-KR" altLang="en-US" smtClean="0"/>
-              <a:t>2026-06-19</a:t>
+              <a:t>2026-06-20</a:t>
             </a:fld>
             <a:endParaRPr lang="ko-KR" altLang="en-US"/>
           </a:p>
@@ -1144,7 +1144,7 @@
           <p:cNvPr id="5" name="바닥글 개체 틀 4">
             <a:extLst>
               <a:ext uri="{FF2B5EF4-FFF2-40B4-BE49-F238E27FC236}">
-                <a16:creationId xmlns:a16="http://schemas.microsoft.com/office/drawing/2014/main" id="{DED580CE-FBBE-A006-4BE9-650C3215797B}"/>
+                <a16:creationId xmlns:a16="http://schemas.microsoft.com/office/drawing/2014/main" id="{51ADCA71-0BFE-CB7D-EA96-5A5036E19F19}"/>
               </a:ext>
             </a:extLst>
           </p:cNvPr>
@@ -1169,7 +1169,7 @@
           <p:cNvPr id="6" name="슬라이드 번호 개체 틀 5">
             <a:extLst>
               <a:ext uri="{FF2B5EF4-FFF2-40B4-BE49-F238E27FC236}">
-                <a16:creationId xmlns:a16="http://schemas.microsoft.com/office/drawing/2014/main" id="{E7167E45-7362-47A8-15D8-91D07EC6CF05}"/>
+                <a16:creationId xmlns:a16="http://schemas.microsoft.com/office/drawing/2014/main" id="{A8AA0E8E-2557-7A11-47AD-2537E783964B}"/>
               </a:ext>
             </a:extLst>
           </p:cNvPr>
@@ -1185,7 +1185,7 @@
           <a:bodyPr/>
           <a:lstStyle/>
           <a:p>
-            <a:fld id="{A1E2397E-EA6D-4E64-8CFF-2304B77E2C8B}" type="slidenum">
+            <a:fld id="{B4193615-8533-47CD-8C7D-DF261FCA69FC}" type="slidenum">
               <a:rPr lang="ko-KR" altLang="en-US" smtClean="0"/>
               <a:t>‹#›</a:t>
             </a:fld>
@@ -1196,7 +1196,7 @@
     </p:spTree>
     <p:extLst>
       <p:ext uri="{BB962C8B-B14F-4D97-AF65-F5344CB8AC3E}">
-        <p14:creationId xmlns:p14="http://schemas.microsoft.com/office/powerpoint/2010/main" val="370802377"/>
+        <p14:creationId xmlns:p14="http://schemas.microsoft.com/office/powerpoint/2010/main" val="701053141"/>
       </p:ext>
     </p:extLst>
   </p:cSld>
@@ -1228,7 +1228,7 @@
           <p:cNvPr id="2" name="제목 1">
             <a:extLst>
               <a:ext uri="{FF2B5EF4-FFF2-40B4-BE49-F238E27FC236}">
-                <a16:creationId xmlns:a16="http://schemas.microsoft.com/office/drawing/2014/main" id="{DFDEAA67-A918-4B49-694C-3443B03BD781}"/>
+                <a16:creationId xmlns:a16="http://schemas.microsoft.com/office/drawing/2014/main" id="{9863DFB5-D423-3967-1ECD-092881E77B3C}"/>
               </a:ext>
             </a:extLst>
           </p:cNvPr>
@@ -1256,7 +1256,7 @@
           <p:cNvPr id="3" name="내용 개체 틀 2">
             <a:extLst>
               <a:ext uri="{FF2B5EF4-FFF2-40B4-BE49-F238E27FC236}">
-                <a16:creationId xmlns:a16="http://schemas.microsoft.com/office/drawing/2014/main" id="{A8681926-D7BD-57F0-252E-61D50F2D3D76}"/>
+                <a16:creationId xmlns:a16="http://schemas.microsoft.com/office/drawing/2014/main" id="{8286057D-A692-69C3-F19B-239E3B968FB8}"/>
               </a:ext>
             </a:extLst>
           </p:cNvPr>
@@ -1318,7 +1318,7 @@
           <p:cNvPr id="4" name="내용 개체 틀 3">
             <a:extLst>
               <a:ext uri="{FF2B5EF4-FFF2-40B4-BE49-F238E27FC236}">
-                <a16:creationId xmlns:a16="http://schemas.microsoft.com/office/drawing/2014/main" id="{26E6536C-A562-7C1C-C5FB-0899EF6837C8}"/>
+                <a16:creationId xmlns:a16="http://schemas.microsoft.com/office/drawing/2014/main" id="{13FFC00E-8C65-D363-F6B3-374DA9526730}"/>
               </a:ext>
             </a:extLst>
           </p:cNvPr>
@@ -1380,7 +1380,7 @@
           <p:cNvPr id="5" name="날짜 개체 틀 4">
             <a:extLst>
               <a:ext uri="{FF2B5EF4-FFF2-40B4-BE49-F238E27FC236}">
-                <a16:creationId xmlns:a16="http://schemas.microsoft.com/office/drawing/2014/main" id="{842C8CC1-AA10-C700-53F2-8B8A59C457D7}"/>
+                <a16:creationId xmlns:a16="http://schemas.microsoft.com/office/drawing/2014/main" id="{723F1470-0822-EC5B-F661-5F459B595742}"/>
               </a:ext>
             </a:extLst>
           </p:cNvPr>
@@ -1396,9 +1396,9 @@
           <a:bodyPr/>
           <a:lstStyle/>
           <a:p>
-            <a:fld id="{0345C9D7-F6C7-4C02-9146-8B76B3D130D1}" type="datetimeFigureOut">
+            <a:fld id="{EA81C09F-EDF6-4DBB-A73F-92F9C5F671FF}" type="datetimeFigureOut">
               <a:rPr lang="ko-KR" altLang="en-US" smtClean="0"/>
-              <a:t>2026-06-19</a:t>
+              <a:t>2026-06-20</a:t>
             </a:fld>
             <a:endParaRPr lang="ko-KR" altLang="en-US"/>
           </a:p>
@@ -1409,7 +1409,7 @@
           <p:cNvPr id="6" name="바닥글 개체 틀 5">
             <a:extLst>
               <a:ext uri="{FF2B5EF4-FFF2-40B4-BE49-F238E27FC236}">
-                <a16:creationId xmlns:a16="http://schemas.microsoft.com/office/drawing/2014/main" id="{91E5F71E-C077-88C5-37D9-3E602901D0DF}"/>
+                <a16:creationId xmlns:a16="http://schemas.microsoft.com/office/drawing/2014/main" id="{6C5CBBB0-8F5E-41BF-1CE6-13EC90ABE7BD}"/>
               </a:ext>
             </a:extLst>
           </p:cNvPr>
@@ -1434,7 +1434,7 @@
           <p:cNvPr id="7" name="슬라이드 번호 개체 틀 6">
             <a:extLst>
               <a:ext uri="{FF2B5EF4-FFF2-40B4-BE49-F238E27FC236}">
-                <a16:creationId xmlns:a16="http://schemas.microsoft.com/office/drawing/2014/main" id="{4386DB92-5919-4EB5-F8CF-187EE5D9C0F3}"/>
+                <a16:creationId xmlns:a16="http://schemas.microsoft.com/office/drawing/2014/main" id="{E513C0A7-A081-3A5A-E746-EFDB7AB8CC07}"/>
               </a:ext>
             </a:extLst>
           </p:cNvPr>
@@ -1450,7 +1450,7 @@
           <a:bodyPr/>
           <a:lstStyle/>
           <a:p>
-            <a:fld id="{A1E2397E-EA6D-4E64-8CFF-2304B77E2C8B}" type="slidenum">
+            <a:fld id="{B4193615-8533-47CD-8C7D-DF261FCA69FC}" type="slidenum">
               <a:rPr lang="ko-KR" altLang="en-US" smtClean="0"/>
               <a:t>‹#›</a:t>
             </a:fld>
@@ -1461,7 +1461,7 @@
     </p:spTree>
     <p:extLst>
       <p:ext uri="{BB962C8B-B14F-4D97-AF65-F5344CB8AC3E}">
-        <p14:creationId xmlns:p14="http://schemas.microsoft.com/office/powerpoint/2010/main" val="2172679131"/>
+        <p14:creationId xmlns:p14="http://schemas.microsoft.com/office/powerpoint/2010/main" val="1865948152"/>
       </p:ext>
     </p:extLst>
   </p:cSld>
@@ -1493,7 +1493,7 @@
           <p:cNvPr id="2" name="제목 1">
             <a:extLst>
               <a:ext uri="{FF2B5EF4-FFF2-40B4-BE49-F238E27FC236}">
-                <a16:creationId xmlns:a16="http://schemas.microsoft.com/office/drawing/2014/main" id="{F0871F4F-2780-DF4A-73F2-C902B867ED13}"/>
+                <a16:creationId xmlns:a16="http://schemas.microsoft.com/office/drawing/2014/main" id="{F3220BF3-514B-E1CE-98DE-96CA91905FE4}"/>
               </a:ext>
             </a:extLst>
           </p:cNvPr>
@@ -1526,7 +1526,7 @@
           <p:cNvPr id="3" name="텍스트 개체 틀 2">
             <a:extLst>
               <a:ext uri="{FF2B5EF4-FFF2-40B4-BE49-F238E27FC236}">
-                <a16:creationId xmlns:a16="http://schemas.microsoft.com/office/drawing/2014/main" id="{C8FCAB3B-0407-3F7D-0633-91697F71F863}"/>
+                <a16:creationId xmlns:a16="http://schemas.microsoft.com/office/drawing/2014/main" id="{68D2DF47-6694-74E4-E959-A482CECD918B}"/>
               </a:ext>
             </a:extLst>
           </p:cNvPr>
@@ -1597,7 +1597,7 @@
           <p:cNvPr id="4" name="내용 개체 틀 3">
             <a:extLst>
               <a:ext uri="{FF2B5EF4-FFF2-40B4-BE49-F238E27FC236}">
-                <a16:creationId xmlns:a16="http://schemas.microsoft.com/office/drawing/2014/main" id="{62E435B9-D30A-A02B-8043-6C72F47DC951}"/>
+                <a16:creationId xmlns:a16="http://schemas.microsoft.com/office/drawing/2014/main" id="{5FA2EB6A-3062-1A02-81EA-9458B394BB11}"/>
               </a:ext>
             </a:extLst>
           </p:cNvPr>
@@ -1659,7 +1659,7 @@
           <p:cNvPr id="5" name="텍스트 개체 틀 4">
             <a:extLst>
               <a:ext uri="{FF2B5EF4-FFF2-40B4-BE49-F238E27FC236}">
-                <a16:creationId xmlns:a16="http://schemas.microsoft.com/office/drawing/2014/main" id="{7D2ED550-A8CE-DFD9-2DEA-0880F58EAD23}"/>
+                <a16:creationId xmlns:a16="http://schemas.microsoft.com/office/drawing/2014/main" id="{1D45156E-442F-0663-D74D-0A0E1CFC7D7D}"/>
               </a:ext>
             </a:extLst>
           </p:cNvPr>
@@ -1730,7 +1730,7 @@
           <p:cNvPr id="6" name="내용 개체 틀 5">
             <a:extLst>
               <a:ext uri="{FF2B5EF4-FFF2-40B4-BE49-F238E27FC236}">
-                <a16:creationId xmlns:a16="http://schemas.microsoft.com/office/drawing/2014/main" id="{A3222074-6EC1-DE78-8406-615B8CE0B800}"/>
+                <a16:creationId xmlns:a16="http://schemas.microsoft.com/office/drawing/2014/main" id="{1BD0259D-E711-69B8-D201-39CD5A2CB6B4}"/>
               </a:ext>
             </a:extLst>
           </p:cNvPr>
@@ -1792,7 +1792,7 @@
           <p:cNvPr id="7" name="날짜 개체 틀 6">
             <a:extLst>
               <a:ext uri="{FF2B5EF4-FFF2-40B4-BE49-F238E27FC236}">
-                <a16:creationId xmlns:a16="http://schemas.microsoft.com/office/drawing/2014/main" id="{D0209C1F-84BA-AB82-1F38-D620642BBB37}"/>
+                <a16:creationId xmlns:a16="http://schemas.microsoft.com/office/drawing/2014/main" id="{28472E78-3353-FDC3-0DA1-4ED6A72A3440}"/>
               </a:ext>
             </a:extLst>
           </p:cNvPr>
@@ -1808,9 +1808,9 @@
           <a:bodyPr/>
           <a:lstStyle/>
           <a:p>
-            <a:fld id="{0345C9D7-F6C7-4C02-9146-8B76B3D130D1}" type="datetimeFigureOut">
+            <a:fld id="{EA81C09F-EDF6-4DBB-A73F-92F9C5F671FF}" type="datetimeFigureOut">
               <a:rPr lang="ko-KR" altLang="en-US" smtClean="0"/>
-              <a:t>2026-06-19</a:t>
+              <a:t>2026-06-20</a:t>
             </a:fld>
             <a:endParaRPr lang="ko-KR" altLang="en-US"/>
           </a:p>
@@ -1821,7 +1821,7 @@
           <p:cNvPr id="8" name="바닥글 개체 틀 7">
             <a:extLst>
               <a:ext uri="{FF2B5EF4-FFF2-40B4-BE49-F238E27FC236}">
-                <a16:creationId xmlns:a16="http://schemas.microsoft.com/office/drawing/2014/main" id="{FCC5154B-E4DE-AD10-C352-E2F58516A8C1}"/>
+                <a16:creationId xmlns:a16="http://schemas.microsoft.com/office/drawing/2014/main" id="{4FA96DC9-299F-D73F-9684-21B575DCFAE2}"/>
               </a:ext>
             </a:extLst>
           </p:cNvPr>
@@ -1846,7 +1846,7 @@
           <p:cNvPr id="9" name="슬라이드 번호 개체 틀 8">
             <a:extLst>
               <a:ext uri="{FF2B5EF4-FFF2-40B4-BE49-F238E27FC236}">
-                <a16:creationId xmlns:a16="http://schemas.microsoft.com/office/drawing/2014/main" id="{08B14E57-DF9D-FDBD-4813-E853A93E7D3F}"/>
+                <a16:creationId xmlns:a16="http://schemas.microsoft.com/office/drawing/2014/main" id="{9878EB29-0FEF-751B-36E1-C78AE7563E7B}"/>
               </a:ext>
             </a:extLst>
           </p:cNvPr>
@@ -1862,7 +1862,7 @@
           <a:bodyPr/>
           <a:lstStyle/>
           <a:p>
-            <a:fld id="{A1E2397E-EA6D-4E64-8CFF-2304B77E2C8B}" type="slidenum">
+            <a:fld id="{B4193615-8533-47CD-8C7D-DF261FCA69FC}" type="slidenum">
               <a:rPr lang="ko-KR" altLang="en-US" smtClean="0"/>
               <a:t>‹#›</a:t>
             </a:fld>
@@ -1873,7 +1873,7 @@
     </p:spTree>
     <p:extLst>
       <p:ext uri="{BB962C8B-B14F-4D97-AF65-F5344CB8AC3E}">
-        <p14:creationId xmlns:p14="http://schemas.microsoft.com/office/powerpoint/2010/main" val="3467703870"/>
+        <p14:creationId xmlns:p14="http://schemas.microsoft.com/office/powerpoint/2010/main" val="1535623118"/>
       </p:ext>
     </p:extLst>
   </p:cSld>
@@ -1905,7 +1905,7 @@
           <p:cNvPr id="2" name="제목 1">
             <a:extLst>
               <a:ext uri="{FF2B5EF4-FFF2-40B4-BE49-F238E27FC236}">
-                <a16:creationId xmlns:a16="http://schemas.microsoft.com/office/drawing/2014/main" id="{463C6994-C1F6-7E96-8F7C-8B02739409BC}"/>
+                <a16:creationId xmlns:a16="http://schemas.microsoft.com/office/drawing/2014/main" id="{DE73F5BA-78B6-570B-DF42-FE22F0FBB881}"/>
               </a:ext>
             </a:extLst>
           </p:cNvPr>
@@ -1933,7 +1933,7 @@
           <p:cNvPr id="3" name="날짜 개체 틀 2">
             <a:extLst>
               <a:ext uri="{FF2B5EF4-FFF2-40B4-BE49-F238E27FC236}">
-                <a16:creationId xmlns:a16="http://schemas.microsoft.com/office/drawing/2014/main" id="{69ED8D78-796C-3819-46C4-30563791D81A}"/>
+                <a16:creationId xmlns:a16="http://schemas.microsoft.com/office/drawing/2014/main" id="{887656B1-855F-B05D-BA74-81365E14D78E}"/>
               </a:ext>
             </a:extLst>
           </p:cNvPr>
@@ -1949,9 +1949,9 @@
           <a:bodyPr/>
           <a:lstStyle/>
           <a:p>
-            <a:fld id="{0345C9D7-F6C7-4C02-9146-8B76B3D130D1}" type="datetimeFigureOut">
+            <a:fld id="{EA81C09F-EDF6-4DBB-A73F-92F9C5F671FF}" type="datetimeFigureOut">
               <a:rPr lang="ko-KR" altLang="en-US" smtClean="0"/>
-              <a:t>2026-06-19</a:t>
+              <a:t>2026-06-20</a:t>
             </a:fld>
             <a:endParaRPr lang="ko-KR" altLang="en-US"/>
           </a:p>
@@ -1962,7 +1962,7 @@
           <p:cNvPr id="4" name="바닥글 개체 틀 3">
             <a:extLst>
               <a:ext uri="{FF2B5EF4-FFF2-40B4-BE49-F238E27FC236}">
-                <a16:creationId xmlns:a16="http://schemas.microsoft.com/office/drawing/2014/main" id="{ACDDB6A2-A408-6591-5411-DE900A255C77}"/>
+                <a16:creationId xmlns:a16="http://schemas.microsoft.com/office/drawing/2014/main" id="{243A5DC2-739D-8CAD-F3DD-4F7464AF9DA8}"/>
               </a:ext>
             </a:extLst>
           </p:cNvPr>
@@ -1987,7 +1987,7 @@
           <p:cNvPr id="5" name="슬라이드 번호 개체 틀 4">
             <a:extLst>
               <a:ext uri="{FF2B5EF4-FFF2-40B4-BE49-F238E27FC236}">
-                <a16:creationId xmlns:a16="http://schemas.microsoft.com/office/drawing/2014/main" id="{F896EBCA-478A-E2A2-DF4F-DCC76406D70C}"/>
+                <a16:creationId xmlns:a16="http://schemas.microsoft.com/office/drawing/2014/main" id="{0E465B24-96F8-8AFC-ABE0-BB193F7AFC91}"/>
               </a:ext>
             </a:extLst>
           </p:cNvPr>
@@ -2003,7 +2003,7 @@
           <a:bodyPr/>
           <a:lstStyle/>
           <a:p>
-            <a:fld id="{A1E2397E-EA6D-4E64-8CFF-2304B77E2C8B}" type="slidenum">
+            <a:fld id="{B4193615-8533-47CD-8C7D-DF261FCA69FC}" type="slidenum">
               <a:rPr lang="ko-KR" altLang="en-US" smtClean="0"/>
               <a:t>‹#›</a:t>
             </a:fld>
@@ -2014,7 +2014,7 @@
     </p:spTree>
     <p:extLst>
       <p:ext uri="{BB962C8B-B14F-4D97-AF65-F5344CB8AC3E}">
-        <p14:creationId xmlns:p14="http://schemas.microsoft.com/office/powerpoint/2010/main" val="2325635566"/>
+        <p14:creationId xmlns:p14="http://schemas.microsoft.com/office/powerpoint/2010/main" val="721461465"/>
       </p:ext>
     </p:extLst>
   </p:cSld>
@@ -2046,7 +2046,7 @@
           <p:cNvPr id="2" name="날짜 개체 틀 1">
             <a:extLst>
               <a:ext uri="{FF2B5EF4-FFF2-40B4-BE49-F238E27FC236}">
-                <a16:creationId xmlns:a16="http://schemas.microsoft.com/office/drawing/2014/main" id="{CF136C61-7986-6DA7-000A-649C384CF63A}"/>
+                <a16:creationId xmlns:a16="http://schemas.microsoft.com/office/drawing/2014/main" id="{6190D2E2-674E-57EF-4A68-51FCEC124BE6}"/>
               </a:ext>
             </a:extLst>
           </p:cNvPr>
@@ -2062,9 +2062,9 @@
           <a:bodyPr/>
           <a:lstStyle/>
           <a:p>
-            <a:fld id="{0345C9D7-F6C7-4C02-9146-8B76B3D130D1}" type="datetimeFigureOut">
+            <a:fld id="{EA81C09F-EDF6-4DBB-A73F-92F9C5F671FF}" type="datetimeFigureOut">
               <a:rPr lang="ko-KR" altLang="en-US" smtClean="0"/>
-              <a:t>2026-06-19</a:t>
+              <a:t>2026-06-20</a:t>
             </a:fld>
             <a:endParaRPr lang="ko-KR" altLang="en-US"/>
           </a:p>
@@ -2075,7 +2075,7 @@
           <p:cNvPr id="3" name="바닥글 개체 틀 2">
             <a:extLst>
               <a:ext uri="{FF2B5EF4-FFF2-40B4-BE49-F238E27FC236}">
-                <a16:creationId xmlns:a16="http://schemas.microsoft.com/office/drawing/2014/main" id="{0F3EA11C-8BF9-78EB-47F6-A1FF2659A5A1}"/>
+                <a16:creationId xmlns:a16="http://schemas.microsoft.com/office/drawing/2014/main" id="{A2E30F7D-D658-CCD7-547D-26E90344D459}"/>
               </a:ext>
             </a:extLst>
           </p:cNvPr>
@@ -2100,7 +2100,7 @@
           <p:cNvPr id="4" name="슬라이드 번호 개체 틀 3">
             <a:extLst>
               <a:ext uri="{FF2B5EF4-FFF2-40B4-BE49-F238E27FC236}">
-                <a16:creationId xmlns:a16="http://schemas.microsoft.com/office/drawing/2014/main" id="{705DA143-16A7-F226-8B1E-1F9EC3FED0DC}"/>
+                <a16:creationId xmlns:a16="http://schemas.microsoft.com/office/drawing/2014/main" id="{14958636-E2AB-9D79-AF9B-269FAB80AADE}"/>
               </a:ext>
             </a:extLst>
           </p:cNvPr>
@@ -2116,7 +2116,7 @@
           <a:bodyPr/>
           <a:lstStyle/>
           <a:p>
-            <a:fld id="{A1E2397E-EA6D-4E64-8CFF-2304B77E2C8B}" type="slidenum">
+            <a:fld id="{B4193615-8533-47CD-8C7D-DF261FCA69FC}" type="slidenum">
               <a:rPr lang="ko-KR" altLang="en-US" smtClean="0"/>
               <a:t>‹#›</a:t>
             </a:fld>
@@ -2127,7 +2127,7 @@
     </p:spTree>
     <p:extLst>
       <p:ext uri="{BB962C8B-B14F-4D97-AF65-F5344CB8AC3E}">
-        <p14:creationId xmlns:p14="http://schemas.microsoft.com/office/powerpoint/2010/main" val="4009857169"/>
+        <p14:creationId xmlns:p14="http://schemas.microsoft.com/office/powerpoint/2010/main" val="895208578"/>
       </p:ext>
     </p:extLst>
   </p:cSld>
@@ -2159,7 +2159,7 @@
           <p:cNvPr id="2" name="제목 1">
             <a:extLst>
               <a:ext uri="{FF2B5EF4-FFF2-40B4-BE49-F238E27FC236}">
-                <a16:creationId xmlns:a16="http://schemas.microsoft.com/office/drawing/2014/main" id="{A6AAF9F3-2AB0-0C08-1EEF-1E75172E32B2}"/>
+                <a16:creationId xmlns:a16="http://schemas.microsoft.com/office/drawing/2014/main" id="{9D59D824-4DE3-DB5C-CCD6-C5EFF5AD4F50}"/>
               </a:ext>
             </a:extLst>
           </p:cNvPr>
@@ -2196,7 +2196,7 @@
           <p:cNvPr id="3" name="내용 개체 틀 2">
             <a:extLst>
               <a:ext uri="{FF2B5EF4-FFF2-40B4-BE49-F238E27FC236}">
-                <a16:creationId xmlns:a16="http://schemas.microsoft.com/office/drawing/2014/main" id="{DBD72DBF-60EC-3901-5BA3-0CE8B5351963}"/>
+                <a16:creationId xmlns:a16="http://schemas.microsoft.com/office/drawing/2014/main" id="{2B1A9B31-304D-EF76-ECEB-BBB90E5EA062}"/>
               </a:ext>
             </a:extLst>
           </p:cNvPr>
@@ -2286,7 +2286,7 @@
           <p:cNvPr id="4" name="텍스트 개체 틀 3">
             <a:extLst>
               <a:ext uri="{FF2B5EF4-FFF2-40B4-BE49-F238E27FC236}">
-                <a16:creationId xmlns:a16="http://schemas.microsoft.com/office/drawing/2014/main" id="{1B463AC2-BC2B-903E-059F-C1A2562CC163}"/>
+                <a16:creationId xmlns:a16="http://schemas.microsoft.com/office/drawing/2014/main" id="{9C409A6B-1F7C-8A17-51F6-7C88ECC54CC1}"/>
               </a:ext>
             </a:extLst>
           </p:cNvPr>
@@ -2357,7 +2357,7 @@
           <p:cNvPr id="5" name="날짜 개체 틀 4">
             <a:extLst>
               <a:ext uri="{FF2B5EF4-FFF2-40B4-BE49-F238E27FC236}">
-                <a16:creationId xmlns:a16="http://schemas.microsoft.com/office/drawing/2014/main" id="{775B75C9-1E11-F779-EE87-DD60DCAA1C53}"/>
+                <a16:creationId xmlns:a16="http://schemas.microsoft.com/office/drawing/2014/main" id="{6FA23BE8-5E13-7D52-F61B-99DB42E46772}"/>
               </a:ext>
             </a:extLst>
           </p:cNvPr>
@@ -2373,9 +2373,9 @@
           <a:bodyPr/>
           <a:lstStyle/>
           <a:p>
-            <a:fld id="{0345C9D7-F6C7-4C02-9146-8B76B3D130D1}" type="datetimeFigureOut">
+            <a:fld id="{EA81C09F-EDF6-4DBB-A73F-92F9C5F671FF}" type="datetimeFigureOut">
               <a:rPr lang="ko-KR" altLang="en-US" smtClean="0"/>
-              <a:t>2026-06-19</a:t>
+              <a:t>2026-06-20</a:t>
             </a:fld>
             <a:endParaRPr lang="ko-KR" altLang="en-US"/>
           </a:p>
@@ -2386,7 +2386,7 @@
           <p:cNvPr id="6" name="바닥글 개체 틀 5">
             <a:extLst>
               <a:ext uri="{FF2B5EF4-FFF2-40B4-BE49-F238E27FC236}">
-                <a16:creationId xmlns:a16="http://schemas.microsoft.com/office/drawing/2014/main" id="{B03FAA6D-D9AB-E082-8B97-743039E3F2CE}"/>
+                <a16:creationId xmlns:a16="http://schemas.microsoft.com/office/drawing/2014/main" id="{18C237A8-4119-4B53-4AC5-6655B1A5124C}"/>
               </a:ext>
             </a:extLst>
           </p:cNvPr>
@@ -2411,7 +2411,7 @@
           <p:cNvPr id="7" name="슬라이드 번호 개체 틀 6">
             <a:extLst>
               <a:ext uri="{FF2B5EF4-FFF2-40B4-BE49-F238E27FC236}">
-                <a16:creationId xmlns:a16="http://schemas.microsoft.com/office/drawing/2014/main" id="{518319C4-4937-D927-2A24-6AD5C8EAFEF9}"/>
+                <a16:creationId xmlns:a16="http://schemas.microsoft.com/office/drawing/2014/main" id="{F833D61E-9114-7391-04F7-2B4B10334562}"/>
               </a:ext>
             </a:extLst>
           </p:cNvPr>
@@ -2427,7 +2427,7 @@
           <a:bodyPr/>
           <a:lstStyle/>
           <a:p>
-            <a:fld id="{A1E2397E-EA6D-4E64-8CFF-2304B77E2C8B}" type="slidenum">
+            <a:fld id="{B4193615-8533-47CD-8C7D-DF261FCA69FC}" type="slidenum">
               <a:rPr lang="ko-KR" altLang="en-US" smtClean="0"/>
               <a:t>‹#›</a:t>
             </a:fld>
@@ -2438,7 +2438,7 @@
     </p:spTree>
     <p:extLst>
       <p:ext uri="{BB962C8B-B14F-4D97-AF65-F5344CB8AC3E}">
-        <p14:creationId xmlns:p14="http://schemas.microsoft.com/office/powerpoint/2010/main" val="972774040"/>
+        <p14:creationId xmlns:p14="http://schemas.microsoft.com/office/powerpoint/2010/main" val="2832889965"/>
       </p:ext>
     </p:extLst>
   </p:cSld>
@@ -2470,7 +2470,7 @@
           <p:cNvPr id="2" name="제목 1">
             <a:extLst>
               <a:ext uri="{FF2B5EF4-FFF2-40B4-BE49-F238E27FC236}">
-                <a16:creationId xmlns:a16="http://schemas.microsoft.com/office/drawing/2014/main" id="{C05D991C-AFE6-5F14-FDCE-EB9F1F2E44AD}"/>
+                <a16:creationId xmlns:a16="http://schemas.microsoft.com/office/drawing/2014/main" id="{43EF15BB-7A74-6894-8467-1ED61FAE5C93}"/>
               </a:ext>
             </a:extLst>
           </p:cNvPr>
@@ -2507,7 +2507,7 @@
           <p:cNvPr id="3" name="그림 개체 틀 2">
             <a:extLst>
               <a:ext uri="{FF2B5EF4-FFF2-40B4-BE49-F238E27FC236}">
-                <a16:creationId xmlns:a16="http://schemas.microsoft.com/office/drawing/2014/main" id="{6B602EC8-0927-7940-6732-371556E3DE26}"/>
+                <a16:creationId xmlns:a16="http://schemas.microsoft.com/office/drawing/2014/main" id="{16602829-7163-9231-FA9B-B3AB36A4F0E9}"/>
               </a:ext>
             </a:extLst>
           </p:cNvPr>
@@ -2574,7 +2574,7 @@
           <p:cNvPr id="4" name="텍스트 개체 틀 3">
             <a:extLst>
               <a:ext uri="{FF2B5EF4-FFF2-40B4-BE49-F238E27FC236}">
-                <a16:creationId xmlns:a16="http://schemas.microsoft.com/office/drawing/2014/main" id="{64AAF59C-ABF9-0675-1534-2EDDF7FD308A}"/>
+                <a16:creationId xmlns:a16="http://schemas.microsoft.com/office/drawing/2014/main" id="{5DEB3448-DC93-AEEA-1DD1-C9F70FE7AD98}"/>
               </a:ext>
             </a:extLst>
           </p:cNvPr>
@@ -2645,7 +2645,7 @@
           <p:cNvPr id="5" name="날짜 개체 틀 4">
             <a:extLst>
               <a:ext uri="{FF2B5EF4-FFF2-40B4-BE49-F238E27FC236}">
-                <a16:creationId xmlns:a16="http://schemas.microsoft.com/office/drawing/2014/main" id="{0C77D225-D41F-D1D4-65E2-5170525A6DBA}"/>
+                <a16:creationId xmlns:a16="http://schemas.microsoft.com/office/drawing/2014/main" id="{E34D3532-2E7A-6E73-D532-E6BB5A1027DE}"/>
               </a:ext>
             </a:extLst>
           </p:cNvPr>
@@ -2661,9 +2661,9 @@
           <a:bodyPr/>
           <a:lstStyle/>
           <a:p>
-            <a:fld id="{0345C9D7-F6C7-4C02-9146-8B76B3D130D1}" type="datetimeFigureOut">
+            <a:fld id="{EA81C09F-EDF6-4DBB-A73F-92F9C5F671FF}" type="datetimeFigureOut">
               <a:rPr lang="ko-KR" altLang="en-US" smtClean="0"/>
-              <a:t>2026-06-19</a:t>
+              <a:t>2026-06-20</a:t>
             </a:fld>
             <a:endParaRPr lang="ko-KR" altLang="en-US"/>
           </a:p>
@@ -2674,7 +2674,7 @@
           <p:cNvPr id="6" name="바닥글 개체 틀 5">
             <a:extLst>
               <a:ext uri="{FF2B5EF4-FFF2-40B4-BE49-F238E27FC236}">
-                <a16:creationId xmlns:a16="http://schemas.microsoft.com/office/drawing/2014/main" id="{1CD99BB4-0650-7C58-7778-CF08867F1F30}"/>
+                <a16:creationId xmlns:a16="http://schemas.microsoft.com/office/drawing/2014/main" id="{DEC333BB-26C5-74A6-3793-E4A2F0E6C677}"/>
               </a:ext>
             </a:extLst>
           </p:cNvPr>
@@ -2699,7 +2699,7 @@
           <p:cNvPr id="7" name="슬라이드 번호 개체 틀 6">
             <a:extLst>
               <a:ext uri="{FF2B5EF4-FFF2-40B4-BE49-F238E27FC236}">
-                <a16:creationId xmlns:a16="http://schemas.microsoft.com/office/drawing/2014/main" id="{E33F7AC9-F502-F0D6-0D96-A4A11B036BC2}"/>
+                <a16:creationId xmlns:a16="http://schemas.microsoft.com/office/drawing/2014/main" id="{4B7423E2-A1C0-87C1-85C9-0FBD01F6995C}"/>
               </a:ext>
             </a:extLst>
           </p:cNvPr>
@@ -2715,7 +2715,7 @@
           <a:bodyPr/>
           <a:lstStyle/>
           <a:p>
-            <a:fld id="{A1E2397E-EA6D-4E64-8CFF-2304B77E2C8B}" type="slidenum">
+            <a:fld id="{B4193615-8533-47CD-8C7D-DF261FCA69FC}" type="slidenum">
               <a:rPr lang="ko-KR" altLang="en-US" smtClean="0"/>
               <a:t>‹#›</a:t>
             </a:fld>
@@ -2726,7 +2726,7 @@
     </p:spTree>
     <p:extLst>
       <p:ext uri="{BB962C8B-B14F-4D97-AF65-F5344CB8AC3E}">
-        <p14:creationId xmlns:p14="http://schemas.microsoft.com/office/powerpoint/2010/main" val="2305672023"/>
+        <p14:creationId xmlns:p14="http://schemas.microsoft.com/office/powerpoint/2010/main" val="755042663"/>
       </p:ext>
     </p:extLst>
   </p:cSld>
@@ -2763,7 +2763,7 @@
           <p:cNvPr id="2" name="제목 개체 틀 1">
             <a:extLst>
               <a:ext uri="{FF2B5EF4-FFF2-40B4-BE49-F238E27FC236}">
-                <a16:creationId xmlns:a16="http://schemas.microsoft.com/office/drawing/2014/main" id="{F53B3FB6-9F32-C600-8EBF-3E5FD15932B1}"/>
+                <a16:creationId xmlns:a16="http://schemas.microsoft.com/office/drawing/2014/main" id="{BE3C2EB9-CBC8-3520-2339-40CE2FCFC819}"/>
               </a:ext>
             </a:extLst>
           </p:cNvPr>
@@ -2801,7 +2801,7 @@
           <p:cNvPr id="3" name="텍스트 개체 틀 2">
             <a:extLst>
               <a:ext uri="{FF2B5EF4-FFF2-40B4-BE49-F238E27FC236}">
-                <a16:creationId xmlns:a16="http://schemas.microsoft.com/office/drawing/2014/main" id="{AC13EFA3-29BD-27E9-6780-72060F705266}"/>
+                <a16:creationId xmlns:a16="http://schemas.microsoft.com/office/drawing/2014/main" id="{196A5F8C-9319-B4F5-A58F-50B7B7CD39FF}"/>
               </a:ext>
             </a:extLst>
           </p:cNvPr>
@@ -2868,7 +2868,7 @@
           <p:cNvPr id="4" name="날짜 개체 틀 3">
             <a:extLst>
               <a:ext uri="{FF2B5EF4-FFF2-40B4-BE49-F238E27FC236}">
-                <a16:creationId xmlns:a16="http://schemas.microsoft.com/office/drawing/2014/main" id="{A7B3EBCF-F71C-F55F-73CC-B7EB3E430547}"/>
+                <a16:creationId xmlns:a16="http://schemas.microsoft.com/office/drawing/2014/main" id="{B5722565-0365-77E5-F6F9-78002834F12A}"/>
               </a:ext>
             </a:extLst>
           </p:cNvPr>
@@ -2902,9 +2902,9 @@
             </a:lvl1pPr>
           </a:lstStyle>
           <a:p>
-            <a:fld id="{0345C9D7-F6C7-4C02-9146-8B76B3D130D1}" type="datetimeFigureOut">
+            <a:fld id="{EA81C09F-EDF6-4DBB-A73F-92F9C5F671FF}" type="datetimeFigureOut">
               <a:rPr lang="ko-KR" altLang="en-US" smtClean="0"/>
-              <a:t>2026-06-19</a:t>
+              <a:t>2026-06-20</a:t>
             </a:fld>
             <a:endParaRPr lang="ko-KR" altLang="en-US"/>
           </a:p>
@@ -2915,7 +2915,7 @@
           <p:cNvPr id="5" name="바닥글 개체 틀 4">
             <a:extLst>
               <a:ext uri="{FF2B5EF4-FFF2-40B4-BE49-F238E27FC236}">
-                <a16:creationId xmlns:a16="http://schemas.microsoft.com/office/drawing/2014/main" id="{1FDD7462-8493-EAA2-EF9C-A461FBB0F5D0}"/>
+                <a16:creationId xmlns:a16="http://schemas.microsoft.com/office/drawing/2014/main" id="{DADC2AE4-D77F-42D5-9853-1CC20398A692}"/>
               </a:ext>
             </a:extLst>
           </p:cNvPr>
@@ -2958,7 +2958,7 @@
           <p:cNvPr id="6" name="슬라이드 번호 개체 틀 5">
             <a:extLst>
               <a:ext uri="{FF2B5EF4-FFF2-40B4-BE49-F238E27FC236}">
-                <a16:creationId xmlns:a16="http://schemas.microsoft.com/office/drawing/2014/main" id="{3ABDA10D-D8A4-5E15-E766-D6AA3D64CB23}"/>
+                <a16:creationId xmlns:a16="http://schemas.microsoft.com/office/drawing/2014/main" id="{96B95AA5-3AB2-66F3-918F-ECBC8C70F415}"/>
               </a:ext>
             </a:extLst>
           </p:cNvPr>
@@ -2992,7 +2992,7 @@
             </a:lvl1pPr>
           </a:lstStyle>
           <a:p>
-            <a:fld id="{A1E2397E-EA6D-4E64-8CFF-2304B77E2C8B}" type="slidenum">
+            <a:fld id="{B4193615-8533-47CD-8C7D-DF261FCA69FC}" type="slidenum">
               <a:rPr lang="ko-KR" altLang="en-US" smtClean="0"/>
               <a:t>‹#›</a:t>
             </a:fld>
@@ -3003,7 +3003,7 @@
     </p:spTree>
     <p:extLst>
       <p:ext uri="{BB962C8B-B14F-4D97-AF65-F5344CB8AC3E}">
-        <p14:creationId xmlns:p14="http://schemas.microsoft.com/office/powerpoint/2010/main" val="2849094936"/>
+        <p14:creationId xmlns:p14="http://schemas.microsoft.com/office/powerpoint/2010/main" val="1399186189"/>
       </p:ext>
     </p:extLst>
   </p:cSld>
@@ -3326,7 +3326,7 @@
           <p:cNvPr id="3" name="pipeline_overview_svg">
             <a:extLst>
               <a:ext uri="{FF2B5EF4-FFF2-40B4-BE49-F238E27FC236}">
-                <a16:creationId xmlns:a16="http://schemas.microsoft.com/office/drawing/2014/main" id="{8B14539C-407E-71C3-84E6-15A86E6B1435}"/>
+                <a16:creationId xmlns:a16="http://schemas.microsoft.com/office/drawing/2014/main" id="{F20A867D-B668-A482-BEE2-0D30CB4A41C6}"/>
               </a:ext>
             </a:extLst>
           </p:cNvPr>
@@ -3367,7 +3367,7 @@
     </p:spTree>
     <p:extLst>
       <p:ext uri="{BB962C8B-B14F-4D97-AF65-F5344CB8AC3E}">
-        <p14:creationId xmlns:p14="http://schemas.microsoft.com/office/powerpoint/2010/main" val="4163678546"/>
+        <p14:creationId xmlns:p14="http://schemas.microsoft.com/office/powerpoint/2010/main" val="1977136356"/>
       </p:ext>
     </p:extLst>
   </p:cSld>

</xml_diff>